<commit_message>
L1: slide leggibili in ogni riquadro, aggiunto PDF
- colori espliciti al posto dei colori del tema (testo scuro su scuro in alcune app)
- contrasto verificato su tutti i riquadri
- slide.pdf accanto a slide.pptx

Co-Authored-By: Claude Opus 5.5 <noreply@anthropic.com>
Claude-Session: https://claude.ai/code/session_014CzWDFXvYNxqLeD99LSN3G
</commit_message>
<xml_diff>
--- a/lezioni/L01_python_calcolatrice/slide.pptx
+++ b/lezioni/L01_python_calcolatrice/slide.pptx
@@ -120,13 +120,13 @@
   <p:extLst>
     <p:ext uri="{521415D9-36F7-43E2-AB2F-B90AF26B5E84}">
       <p14:sectionLst xmlns:p14="http://schemas.microsoft.com/office/powerpoint/2010/main">
-        <p14:section name="Apertura" id="{d92ea577-8ffe-afa4-5ba1-0be0e9673648}">
+        <p14:section name="Apertura" id="{a00e067d-70cf-f660-6c1c-9cff1ddab90a}">
           <p14:sldIdLst>
             <p14:sldId id="256"/>
             <p14:sldId id="257"/>
           </p14:sldIdLst>
         </p14:section>
-        <p14:section name="Spiegazione" id="{06dc164b-4d88-ec56-96a8-af89c6c7dfb4}">
+        <p14:section name="Spiegazione" id="{0f2367dc-010e-712e-2e87-ee106363307e}">
           <p14:sldIdLst>
             <p14:sldId id="258"/>
             <p14:sldId id="259"/>
@@ -135,12 +135,12 @@
             <p14:sldId id="262"/>
           </p14:sldIdLst>
         </p14:section>
-        <p14:section name="Task" id="{aaf10437-5f54-d28b-0c1b-ecd781a1e798}">
+        <p14:section name="Task" id="{2e02af21-7335-edc8-6d32-b622f2b5071d}">
           <p14:sldIdLst>
             <p14:sldId id="263"/>
           </p14:sldIdLst>
         </p14:section>
-        <p14:section name="Debrief" id="{d05a3855-7724-65be-2c0e-c61f482eecac}">
+        <p14:section name="Debrief" id="{04dc3574-f86c-0736-9e9b-3d97c5885e98}">
           <p14:sldIdLst>
             <p14:sldId id="264"/>
             <p14:sldId id="265"/>
@@ -149,7 +149,7 @@
             <p14:sldId id="268"/>
           </p14:sldIdLst>
         </p14:section>
-        <p14:section name="Chiusura" id="{499a3157-3014-0754-f77f-a3ed3249c316}">
+        <p14:section name="Chiusura" id="{6dba7b64-5890-49f7-32dc-697d657d7fbc}">
           <p14:sldIdLst>
             <p14:sldId id="269"/>
           </p14:sldIdLst>
@@ -1780,7 +1780,7 @@
     <p:bg>
       <p:bgPr>
         <a:solidFill>
-          <a:schemeClr val="tx2"/>
+          <a:srgbClr val="0F4C5C"/>
         </a:solidFill>
       </p:bgPr>
     </p:bg>
@@ -1824,7 +1824,7 @@
               <a:buNone/>
               <a:defRPr lang="en-US" sz="4800" b="1" dirty="0">
                 <a:solidFill>
-                  <a:schemeClr val="bg1"/>
+                  <a:srgbClr val="FFFFFF"/>
                 </a:solidFill>
               </a:defRPr>
             </a:lvl1pPr>
@@ -1863,7 +1863,7 @@
               <a:buNone/>
               <a:defRPr lang="en-US" sz="2200" dirty="0">
                 <a:solidFill>
-                  <a:schemeClr val="accent1"/>
+                  <a:srgbClr val="F4C06E"/>
                 </a:solidFill>
               </a:defRPr>
             </a:lvl1pPr>
@@ -1890,7 +1890,7 @@
     <p:bg>
       <p:bgPr>
         <a:solidFill>
-          <a:schemeClr val="tx1"/>
+          <a:srgbClr val="1F2A30"/>
         </a:solidFill>
       </p:bgPr>
     </p:bg>
@@ -1934,7 +1934,7 @@
               <a:buNone/>
               <a:defRPr lang="en-US" sz="5400" b="1" dirty="0">
                 <a:solidFill>
-                  <a:schemeClr val="bg1"/>
+                  <a:srgbClr val="FFFFFF"/>
                 </a:solidFill>
               </a:defRPr>
             </a:lvl1pPr>
@@ -1973,7 +1973,7 @@
               <a:buNone/>
               <a:defRPr lang="en-US" sz="2200" dirty="0">
                 <a:solidFill>
-                  <a:schemeClr val="accent6"/>
+                  <a:srgbClr val="B8C4CB"/>
                 </a:solidFill>
               </a:defRPr>
             </a:lvl1pPr>
@@ -2000,7 +2000,7 @@
     <p:bg>
       <p:bgPr>
         <a:solidFill>
-          <a:schemeClr val="bg1"/>
+          <a:srgbClr val="FFFFFF"/>
         </a:solidFill>
       </p:bgPr>
     </p:bg>
@@ -2044,7 +2044,7 @@
               <a:buNone/>
               <a:defRPr lang="en-US" sz="3600" b="1" dirty="0">
                 <a:solidFill>
-                  <a:schemeClr val="tx2"/>
+                  <a:srgbClr val="0F4C5C"/>
                 </a:solidFill>
               </a:defRPr>
             </a:lvl1pPr>
@@ -2084,7 +2084,7 @@
             <a:r>
               <a:rPr lang="en-US" sz="1000" dirty="0">
                 <a:solidFill>
-                  <a:schemeClr val="accent5"/>
+                  <a:srgbClr val="5C6F7B"/>
                 </a:solidFill>
               </a:rPr>
               <a:t>SIMA 2026 · L1</a:t>
@@ -2123,7 +2123,7 @@
             <a:lvl1pPr>
               <a:defRPr sz="1000">
                 <a:solidFill>
-                  <a:schemeClr val="accent5"/>
+                  <a:srgbClr val="5C6F7B"/>
                 </a:solidFill>
               </a:defRPr>
             </a:lvl1pPr>
@@ -2193,7 +2193,7 @@
             <a:lvl1pPr>
               <a:defRPr sz="1000">
                 <a:solidFill>
-                  <a:schemeClr val="accent5"/>
+                  <a:srgbClr val="5C6F7B"/>
                 </a:solidFill>
               </a:defRPr>
             </a:lvl1pPr>
@@ -2517,7 +2517,7 @@
             <a:r>
               <a:rPr lang="en-US" sz="4800" b="1" dirty="0">
                 <a:solidFill>
-                  <a:schemeClr val="bg1"/>
+                  <a:srgbClr val="FFFFFF"/>
                 </a:solidFill>
               </a:rPr>
               <a:t>Python come calcolatrice intelligente</a:t>
@@ -2555,7 +2555,7 @@
             <a:r>
               <a:rPr lang="en-US" sz="2200" dirty="0">
                 <a:solidFill>
-                  <a:schemeClr val="accent1"/>
+                  <a:srgbClr val="F4C06E"/>
                 </a:solidFill>
               </a:rPr>
               <a:t>L1 · Informatica per economisti · SIMA 2026</a:t>
@@ -2618,7 +2618,7 @@
             <a:r>
               <a:rPr lang="en-US" sz="3600" b="1" dirty="0">
                 <a:solidFill>
-                  <a:schemeClr val="tx2"/>
+                  <a:srgbClr val="0F4C5C"/>
                 </a:solidFill>
               </a:rPr>
               <a:t>Variabili</a:t>
@@ -2644,7 +2644,7 @@
             </a:avLst>
           </a:prstGeom>
           <a:solidFill>
-            <a:schemeClr val="tx1"/>
+            <a:srgbClr val="1F2A30"/>
           </a:solidFill>
           <a:ln/>
         </p:spPr>
@@ -2676,7 +2676,7 @@
             <a:r>
               <a:rPr lang="en-US" sz="1100" b="1" spc="200" kern="0" dirty="0">
                 <a:solidFill>
-                  <a:schemeClr val="accent1"/>
+                  <a:srgbClr val="E09F3E"/>
                 </a:solidFill>
               </a:rPr>
               <a:t>PYTHON</a:t>
@@ -2712,7 +2712,7 @@
             <a:r>
               <a:rPr lang="en-US" sz="2400" dirty="0">
                 <a:solidFill>
-                  <a:schemeClr val="bg1"/>
+                  <a:srgbClr val="FFFFFF"/>
                 </a:solidFill>
                 <a:latin typeface="Courier New" pitchFamily="34" charset="0"/>
                 <a:ea typeface="Courier New" pitchFamily="34" charset="-122"/>
@@ -2741,7 +2741,7 @@
             </a:avLst>
           </a:prstGeom>
           <a:solidFill>
-            <a:schemeClr val="accent1"/>
+            <a:srgbClr val="E09F3E"/>
           </a:solidFill>
           <a:ln/>
         </p:spPr>
@@ -2773,7 +2773,7 @@
             <a:r>
               <a:rPr lang="en-US" sz="2000" b="1" dirty="0">
                 <a:solidFill>
-                  <a:schemeClr val="tx1"/>
+                  <a:srgbClr val="1F2A30"/>
                 </a:solidFill>
                 <a:latin typeface="Courier New" pitchFamily="34" charset="0"/>
                 <a:ea typeface="Courier New" pitchFamily="34" charset="-122"/>
@@ -2802,7 +2802,7 @@
           <a:noFill/>
           <a:ln w="25400">
             <a:solidFill>
-              <a:schemeClr val="accent5"/>
+              <a:srgbClr val="5C6F7B"/>
             </a:solidFill>
             <a:prstDash val="solid"/>
             <a:tailEnd type="triangle"/>
@@ -2826,7 +2826,7 @@
             </a:avLst>
           </a:prstGeom>
           <a:solidFill>
-            <a:schemeClr val="bg2"/>
+            <a:srgbClr val="EEF3F4"/>
           </a:solidFill>
           <a:ln/>
         </p:spPr>
@@ -2858,7 +2858,7 @@
             <a:r>
               <a:rPr lang="en-US" sz="2000" dirty="0">
                 <a:solidFill>
-                  <a:schemeClr val="tx1"/>
+                  <a:srgbClr val="1F2A30"/>
                 </a:solidFill>
                 <a:latin typeface="Courier New" pitchFamily="34" charset="0"/>
                 <a:ea typeface="Courier New" pitchFamily="34" charset="-122"/>
@@ -2897,7 +2897,7 @@
             <a:r>
               <a:rPr lang="en-US" sz="1400" dirty="0">
                 <a:solidFill>
-                  <a:schemeClr val="accent5"/>
+                  <a:srgbClr val="5C6F7B"/>
                 </a:solidFill>
               </a:rPr>
               <a:t>etichetta</a:t>
@@ -2933,7 +2933,7 @@
             <a:r>
               <a:rPr lang="en-US" sz="1400" dirty="0">
                 <a:solidFill>
-                  <a:schemeClr val="accent5"/>
+                  <a:srgbClr val="5C6F7B"/>
                 </a:solidFill>
               </a:rPr>
               <a:t>valore</a:t>
@@ -2973,7 +2973,7 @@
             <a:r>
               <a:rPr lang="en-US" sz="2000" dirty="0">
                 <a:solidFill>
-                  <a:schemeClr val="tx1"/>
+                  <a:srgbClr val="1F2A30"/>
                 </a:solidFill>
               </a:rPr>
               <a:t>Un'etichetta attaccata a un valore</a:t>
@@ -2991,7 +2991,7 @@
             <a:r>
               <a:rPr lang="en-US" sz="2000" dirty="0">
                 <a:solidFill>
-                  <a:schemeClr val="tx1"/>
+                  <a:srgbClr val="1F2A30"/>
                 </a:solidFill>
               </a:rPr>
               <a:t>Il valore si può cambiare quando vuoi</a:t>
@@ -3009,7 +3009,7 @@
             <a:r>
               <a:rPr lang="en-US" sz="2000" dirty="0">
                 <a:solidFill>
-                  <a:schemeClr val="tx1"/>
+                  <a:srgbClr val="1F2A30"/>
                 </a:solidFill>
               </a:rPr>
               <a:t>Il nome lo scegli tu: meglio se dice cosa contiene</a:t>
@@ -3027,7 +3027,7 @@
             <a:r>
               <a:rPr lang="en-US" sz="2000" dirty="0">
                 <a:solidFill>
-                  <a:schemeClr val="tx1"/>
+                  <a:srgbClr val="1F2A30"/>
                 </a:solidFill>
               </a:rPr>
               <a:t>= non è «uguale»: è «metti questo valore qui»</a:t>
@@ -3066,7 +3066,7 @@
             <a:lvl1pPr>
               <a:defRPr sz="1000">
                 <a:solidFill>
-                  <a:schemeClr val="accent5"/>
+                  <a:srgbClr val="5C6F7B"/>
                 </a:solidFill>
               </a:defRPr>
             </a:lvl1pPr>
@@ -3135,7 +3135,7 @@
             <a:r>
               <a:rPr lang="en-US" sz="3600" b="1" dirty="0">
                 <a:solidFill>
-                  <a:schemeClr val="tx2"/>
+                  <a:srgbClr val="0F4C5C"/>
                 </a:solidFill>
               </a:rPr>
               <a:t>Tipi di dato</a:t>
@@ -3183,7 +3183,7 @@
                       <a:r>
                         <a:rPr lang="en-US" sz="1600" b="1" dirty="0">
                           <a:solidFill>
-                            <a:schemeClr val="bg1"/>
+                            <a:srgbClr val="FFFFFF"/>
                           </a:solidFill>
                         </a:rPr>
                         <a:t>Tipo</a:t>
@@ -3205,7 +3205,7 @@
                       <a:noFill/>
                     </a:lnB>
                     <a:solidFill>
-                      <a:schemeClr val="tx2"/>
+                      <a:srgbClr val="0F4C5C"/>
                     </a:solidFill>
                   </a:tcPr>
                 </a:tc>
@@ -3220,7 +3220,7 @@
                       <a:r>
                         <a:rPr lang="en-US" sz="1600" b="1" dirty="0">
                           <a:solidFill>
-                            <a:schemeClr val="bg1"/>
+                            <a:srgbClr val="FFFFFF"/>
                           </a:solidFill>
                         </a:rPr>
                         <a:t>Esempio</a:t>
@@ -3242,7 +3242,7 @@
                       <a:noFill/>
                     </a:lnB>
                     <a:solidFill>
-                      <a:schemeClr val="tx2"/>
+                      <a:srgbClr val="0F4C5C"/>
                     </a:solidFill>
                   </a:tcPr>
                 </a:tc>
@@ -3257,7 +3257,7 @@
                       <a:r>
                         <a:rPr lang="en-US" sz="1600" b="1" dirty="0">
                           <a:solidFill>
-                            <a:schemeClr val="bg1"/>
+                            <a:srgbClr val="FFFFFF"/>
                           </a:solidFill>
                         </a:rPr>
                         <a:t>Cos'è</a:t>
@@ -3279,7 +3279,7 @@
                       <a:noFill/>
                     </a:lnB>
                     <a:solidFill>
-                      <a:schemeClr val="tx2"/>
+                      <a:srgbClr val="0F4C5C"/>
                     </a:solidFill>
                   </a:tcPr>
                 </a:tc>
@@ -3296,7 +3296,7 @@
                       <a:r>
                         <a:rPr lang="en-US" sz="1800" dirty="0">
                           <a:solidFill>
-                            <a:schemeClr val="tx1"/>
+                            <a:srgbClr val="1F2A30"/>
                           </a:solidFill>
                           <a:latin typeface="Courier New" pitchFamily="34" charset="0"/>
                           <a:ea typeface="Courier New" pitchFamily="34" charset="-122"/>
@@ -3325,7 +3325,7 @@
                       <a:noFill/>
                     </a:lnB>
                     <a:solidFill>
-                      <a:schemeClr val="bg1"/>
+                      <a:srgbClr val="FFFFFF"/>
                     </a:solidFill>
                   </a:tcPr>
                 </a:tc>
@@ -3340,7 +3340,7 @@
                       <a:r>
                         <a:rPr lang="en-US" sz="1800" dirty="0">
                           <a:solidFill>
-                            <a:schemeClr val="tx1"/>
+                            <a:srgbClr val="1F2A30"/>
                           </a:solidFill>
                           <a:latin typeface="Courier New" pitchFamily="34" charset="0"/>
                           <a:ea typeface="Courier New" pitchFamily="34" charset="-122"/>
@@ -3369,7 +3369,7 @@
                       <a:noFill/>
                     </a:lnB>
                     <a:solidFill>
-                      <a:schemeClr val="bg1"/>
+                      <a:srgbClr val="FFFFFF"/>
                     </a:solidFill>
                   </a:tcPr>
                 </a:tc>
@@ -3384,7 +3384,7 @@
                       <a:r>
                         <a:rPr lang="en-US" sz="1800" dirty="0">
                           <a:solidFill>
-                            <a:schemeClr val="tx1"/>
+                            <a:srgbClr val="1F2A30"/>
                           </a:solidFill>
                         </a:rPr>
                         <a:t>numero intero</a:t>
@@ -3406,7 +3406,7 @@
                       <a:noFill/>
                     </a:lnB>
                     <a:solidFill>
-                      <a:schemeClr val="bg1"/>
+                      <a:srgbClr val="FFFFFF"/>
                     </a:solidFill>
                   </a:tcPr>
                 </a:tc>
@@ -3423,7 +3423,7 @@
                       <a:r>
                         <a:rPr lang="en-US" sz="1800" dirty="0">
                           <a:solidFill>
-                            <a:schemeClr val="tx1"/>
+                            <a:srgbClr val="1F2A30"/>
                           </a:solidFill>
                           <a:latin typeface="Courier New" pitchFamily="34" charset="0"/>
                           <a:ea typeface="Courier New" pitchFamily="34" charset="-122"/>
@@ -3452,7 +3452,7 @@
                       <a:noFill/>
                     </a:lnB>
                     <a:solidFill>
-                      <a:schemeClr val="bg2"/>
+                      <a:srgbClr val="EEF3F4"/>
                     </a:solidFill>
                   </a:tcPr>
                 </a:tc>
@@ -3467,7 +3467,7 @@
                       <a:r>
                         <a:rPr lang="en-US" sz="1800" dirty="0">
                           <a:solidFill>
-                            <a:schemeClr val="tx1"/>
+                            <a:srgbClr val="1F2A30"/>
                           </a:solidFill>
                           <a:latin typeface="Courier New" pitchFamily="34" charset="0"/>
                           <a:ea typeface="Courier New" pitchFamily="34" charset="-122"/>
@@ -3496,7 +3496,7 @@
                       <a:noFill/>
                     </a:lnB>
                     <a:solidFill>
-                      <a:schemeClr val="bg2"/>
+                      <a:srgbClr val="EEF3F4"/>
                     </a:solidFill>
                   </a:tcPr>
                 </a:tc>
@@ -3511,7 +3511,7 @@
                       <a:r>
                         <a:rPr lang="en-US" sz="1800" dirty="0">
                           <a:solidFill>
-                            <a:schemeClr val="tx1"/>
+                            <a:srgbClr val="1F2A30"/>
                           </a:solidFill>
                         </a:rPr>
                         <a:t>numero decimale</a:t>
@@ -3533,7 +3533,7 @@
                       <a:noFill/>
                     </a:lnB>
                     <a:solidFill>
-                      <a:schemeClr val="bg2"/>
+                      <a:srgbClr val="EEF3F4"/>
                     </a:solidFill>
                   </a:tcPr>
                 </a:tc>
@@ -3550,7 +3550,7 @@
                       <a:r>
                         <a:rPr lang="en-US" sz="1800" dirty="0">
                           <a:solidFill>
-                            <a:schemeClr val="tx1"/>
+                            <a:srgbClr val="1F2A30"/>
                           </a:solidFill>
                           <a:latin typeface="Courier New" pitchFamily="34" charset="0"/>
                           <a:ea typeface="Courier New" pitchFamily="34" charset="-122"/>
@@ -3579,7 +3579,7 @@
                       <a:noFill/>
                     </a:lnB>
                     <a:solidFill>
-                      <a:schemeClr val="bg1"/>
+                      <a:srgbClr val="FFFFFF"/>
                     </a:solidFill>
                   </a:tcPr>
                 </a:tc>
@@ -3594,7 +3594,7 @@
                       <a:r>
                         <a:rPr lang="en-US" sz="1800" dirty="0">
                           <a:solidFill>
-                            <a:schemeClr val="tx1"/>
+                            <a:srgbClr val="1F2A30"/>
                           </a:solidFill>
                           <a:latin typeface="Courier New" pitchFamily="34" charset="0"/>
                           <a:ea typeface="Courier New" pitchFamily="34" charset="-122"/>
@@ -3623,7 +3623,7 @@
                       <a:noFill/>
                     </a:lnB>
                     <a:solidFill>
-                      <a:schemeClr val="bg1"/>
+                      <a:srgbClr val="FFFFFF"/>
                     </a:solidFill>
                   </a:tcPr>
                 </a:tc>
@@ -3638,7 +3638,7 @@
                       <a:r>
                         <a:rPr lang="en-US" sz="1800" dirty="0">
                           <a:solidFill>
-                            <a:schemeClr val="tx1"/>
+                            <a:srgbClr val="1F2A30"/>
                           </a:solidFill>
                         </a:rPr>
                         <a:t>testo, tra virgolette</a:t>
@@ -3660,7 +3660,7 @@
                       <a:noFill/>
                     </a:lnB>
                     <a:solidFill>
-                      <a:schemeClr val="bg1"/>
+                      <a:srgbClr val="FFFFFF"/>
                     </a:solidFill>
                   </a:tcPr>
                 </a:tc>
@@ -3677,7 +3677,7 @@
                       <a:r>
                         <a:rPr lang="en-US" sz="1800" dirty="0">
                           <a:solidFill>
-                            <a:schemeClr val="tx1"/>
+                            <a:srgbClr val="1F2A30"/>
                           </a:solidFill>
                           <a:latin typeface="Courier New" pitchFamily="34" charset="0"/>
                           <a:ea typeface="Courier New" pitchFamily="34" charset="-122"/>
@@ -3706,7 +3706,7 @@
                       <a:noFill/>
                     </a:lnB>
                     <a:solidFill>
-                      <a:schemeClr val="bg2"/>
+                      <a:srgbClr val="EEF3F4"/>
                     </a:solidFill>
                   </a:tcPr>
                 </a:tc>
@@ -3721,7 +3721,7 @@
                       <a:r>
                         <a:rPr lang="en-US" sz="1800" dirty="0">
                           <a:solidFill>
-                            <a:schemeClr val="tx1"/>
+                            <a:srgbClr val="1F2A30"/>
                           </a:solidFill>
                           <a:latin typeface="Courier New" pitchFamily="34" charset="0"/>
                           <a:ea typeface="Courier New" pitchFamily="34" charset="-122"/>
@@ -3750,7 +3750,7 @@
                       <a:noFill/>
                     </a:lnB>
                     <a:solidFill>
-                      <a:schemeClr val="bg2"/>
+                      <a:srgbClr val="EEF3F4"/>
                     </a:solidFill>
                   </a:tcPr>
                 </a:tc>
@@ -3765,7 +3765,7 @@
                       <a:r>
                         <a:rPr lang="en-US" sz="1800" dirty="0">
                           <a:solidFill>
-                            <a:schemeClr val="tx1"/>
+                            <a:srgbClr val="1F2A30"/>
                           </a:solidFill>
                         </a:rPr>
                         <a:t>vero o falso</a:t>
@@ -3787,7 +3787,7 @@
                       <a:noFill/>
                     </a:lnB>
                     <a:solidFill>
-                      <a:schemeClr val="bg2"/>
+                      <a:srgbClr val="EEF3F4"/>
                     </a:solidFill>
                   </a:tcPr>
                 </a:tc>
@@ -3823,7 +3823,7 @@
             <a:r>
               <a:rPr lang="en-US" sz="1800" b="1" dirty="0">
                 <a:solidFill>
-                  <a:schemeClr val="tx1"/>
+                  <a:srgbClr val="1F2A30"/>
                 </a:solidFill>
                 <a:latin typeface="Courier New" pitchFamily="34" charset="0"/>
                 <a:ea typeface="Courier New" pitchFamily="34" charset="-122"/>
@@ -3837,7 +3837,7 @@
             <a:r>
               <a:rPr lang="en-US" sz="1800" dirty="0">
                 <a:solidFill>
-                  <a:schemeClr val="tx1"/>
+                  <a:srgbClr val="1F2A30"/>
                 </a:solidFill>
               </a:rPr>
               <a:t> ti dice il tipo di x</a:t>
@@ -3863,7 +3863,7 @@
             </a:avLst>
           </a:prstGeom>
           <a:solidFill>
-            <a:schemeClr val="bg2"/>
+            <a:srgbClr val="EEF3F4"/>
           </a:solidFill>
           <a:ln/>
         </p:spPr>
@@ -3895,7 +3895,7 @@
             <a:r>
               <a:rPr lang="en-US" sz="1300" b="1" spc="200" kern="0" dirty="0">
                 <a:solidFill>
-                  <a:schemeClr val="accent1"/>
+                  <a:srgbClr val="8F5308"/>
                 </a:solidFill>
               </a:rPr>
               <a:t>ATTENZIONE</a:t>
@@ -3934,7 +3934,7 @@
             <a:r>
               <a:rPr lang="en-US" sz="2000" dirty="0">
                 <a:solidFill>
-                  <a:schemeClr val="tx1"/>
+                  <a:srgbClr val="1F2A30"/>
                 </a:solidFill>
               </a:rPr>
               <a:t>I decimali si scrivono con il punto</a:t>
@@ -3951,7 +3951,7 @@
             <a:r>
               <a:rPr lang="en-US" sz="2000" b="1" dirty="0">
                 <a:solidFill>
-                  <a:schemeClr val="accent4"/>
+                  <a:srgbClr val="2E6B37"/>
                 </a:solidFill>
                 <a:latin typeface="Courier New" pitchFamily="34" charset="0"/>
                 <a:ea typeface="Courier New" pitchFamily="34" charset="-122"/>
@@ -3968,7 +3968,7 @@
             <a:r>
               <a:rPr lang="en-US" sz="2000" dirty="0">
                 <a:solidFill>
-                  <a:schemeClr val="tx1"/>
+                  <a:srgbClr val="1F2A30"/>
                 </a:solidFill>
               </a:rPr>
               <a:t>  e non  </a:t>
@@ -3982,7 +3982,7 @@
             <a:r>
               <a:rPr lang="en-US" sz="2000" b="1" dirty="0">
                 <a:solidFill>
-                  <a:schemeClr val="accent3"/>
+                  <a:srgbClr val="9E2A2B"/>
                 </a:solidFill>
                 <a:latin typeface="Courier New" pitchFamily="34" charset="0"/>
                 <a:ea typeface="Courier New" pitchFamily="34" charset="-122"/>
@@ -4024,7 +4024,7 @@
             <a:lvl1pPr>
               <a:defRPr sz="1000">
                 <a:solidFill>
-                  <a:schemeClr val="accent5"/>
+                  <a:srgbClr val="5C6F7B"/>
                 </a:solidFill>
               </a:defRPr>
             </a:lvl1pPr>
@@ -4093,7 +4093,7 @@
             <a:r>
               <a:rPr lang="en-US" sz="3600" b="1" dirty="0">
                 <a:solidFill>
-                  <a:schemeClr val="tx2"/>
+                  <a:srgbClr val="0F4C5C"/>
                 </a:solidFill>
               </a:rPr>
               <a:t>La trappola del passo 6</a:t>
@@ -4119,7 +4119,7 @@
             </a:avLst>
           </a:prstGeom>
           <a:solidFill>
-            <a:schemeClr val="tx1"/>
+            <a:srgbClr val="1F2A30"/>
           </a:solidFill>
           <a:ln/>
         </p:spPr>
@@ -4151,7 +4151,7 @@
             <a:r>
               <a:rPr lang="en-US" sz="1100" b="1" spc="200" kern="0" dirty="0">
                 <a:solidFill>
-                  <a:schemeClr val="accent1"/>
+                  <a:srgbClr val="E09F3E"/>
                 </a:solidFill>
               </a:rPr>
               <a:t>PYTHON</a:t>
@@ -4187,7 +4187,7 @@
             <a:r>
               <a:rPr lang="en-US" sz="2000" dirty="0">
                 <a:solidFill>
-                  <a:schemeClr val="bg1"/>
+                  <a:srgbClr val="FFFFFF"/>
                 </a:solidFill>
                 <a:latin typeface="Courier New" pitchFamily="34" charset="0"/>
                 <a:ea typeface="Courier New" pitchFamily="34" charset="-122"/>
@@ -4204,7 +4204,7 @@
             <a:r>
               <a:rPr lang="en-US" sz="2000" dirty="0">
                 <a:solidFill>
-                  <a:schemeClr val="bg1"/>
+                  <a:srgbClr val="FFFFFF"/>
                 </a:solidFill>
                 <a:latin typeface="Courier New" pitchFamily="34" charset="0"/>
                 <a:ea typeface="Courier New" pitchFamily="34" charset="-122"/>
@@ -4233,7 +4233,7 @@
             </a:avLst>
           </a:prstGeom>
           <a:solidFill>
-            <a:schemeClr val="bg2"/>
+            <a:srgbClr val="EEF3F4"/>
           </a:solidFill>
           <a:ln/>
         </p:spPr>
@@ -4265,7 +4265,7 @@
             <a:r>
               <a:rPr lang="en-US" sz="1100" b="1" spc="200" kern="0" dirty="0">
                 <a:solidFill>
-                  <a:schemeClr val="accent5"/>
+                  <a:srgbClr val="5C6F7B"/>
                 </a:solidFill>
               </a:rPr>
               <a:t>OUTPUT</a:t>
@@ -4301,7 +4301,7 @@
             <a:r>
               <a:rPr lang="en-US" sz="2400" dirty="0">
                 <a:solidFill>
-                  <a:schemeClr val="tx1"/>
+                  <a:srgbClr val="1F2A30"/>
                 </a:solidFill>
                 <a:latin typeface="Courier New" pitchFamily="34" charset="0"/>
                 <a:ea typeface="Courier New" pitchFamily="34" charset="-122"/>
@@ -4340,7 +4340,7 @@
             <a:r>
               <a:rPr lang="en-US" sz="3200" b="1" dirty="0">
                 <a:solidFill>
-                  <a:schemeClr val="accent3"/>
+                  <a:srgbClr val="9E2A2B"/>
                 </a:solidFill>
               </a:rPr>
               <a:t>Nessun errore.</a:t>
@@ -4354,7 +4354,7 @@
             <a:r>
               <a:rPr lang="en-US" sz="3200" b="1" dirty="0">
                 <a:solidFill>
-                  <a:schemeClr val="accent3"/>
+                  <a:srgbClr val="9E2A2B"/>
                 </a:solidFill>
               </a:rPr>
               <a:t>Risultato sbagliato.</a:t>
@@ -4390,7 +4390,7 @@
             <a:r>
               <a:rPr lang="en-US" sz="2000" dirty="0">
                 <a:solidFill>
-                  <a:schemeClr val="tx1"/>
+                  <a:srgbClr val="1F2A30"/>
                 </a:solidFill>
               </a:rPr>
               <a:t>Python ha ripetuto il testo due volte. Il codice che gira non è per forza giusto: è la lezione più importante del corso.</a:t>
@@ -4429,7 +4429,7 @@
             <a:lvl1pPr>
               <a:defRPr sz="1000">
                 <a:solidFill>
-                  <a:schemeClr val="accent5"/>
+                  <a:srgbClr val="5C6F7B"/>
                 </a:solidFill>
               </a:defRPr>
             </a:lvl1pPr>
@@ -4498,7 +4498,7 @@
             <a:r>
               <a:rPr lang="en-US" sz="3600" b="1" dirty="0">
                 <a:solidFill>
-                  <a:schemeClr val="tx2"/>
+                  <a:srgbClr val="0F4C5C"/>
                 </a:solidFill>
               </a:rPr>
               <a:t>Testo più numero</a:t>
@@ -4524,7 +4524,7 @@
             </a:avLst>
           </a:prstGeom>
           <a:solidFill>
-            <a:schemeClr val="tx1"/>
+            <a:srgbClr val="1F2A30"/>
           </a:solidFill>
           <a:ln/>
         </p:spPr>
@@ -4556,7 +4556,7 @@
             <a:r>
               <a:rPr lang="en-US" sz="1100" b="1" spc="200" kern="0" dirty="0">
                 <a:solidFill>
-                  <a:schemeClr val="accent1"/>
+                  <a:srgbClr val="E09F3E"/>
                 </a:solidFill>
               </a:rPr>
               <a:t>PYTHON</a:t>
@@ -4592,7 +4592,7 @@
             <a:r>
               <a:rPr lang="en-US" sz="1700" dirty="0">
                 <a:solidFill>
-                  <a:schemeClr val="bg1"/>
+                  <a:srgbClr val="FFFFFF"/>
                 </a:solidFill>
                 <a:latin typeface="Courier New" pitchFamily="34" charset="0"/>
                 <a:ea typeface="Courier New" pitchFamily="34" charset="-122"/>
@@ -4653,7 +4653,7 @@
             <a:r>
               <a:rPr lang="en-US" sz="1100" b="1" spc="200" kern="0" dirty="0">
                 <a:solidFill>
-                  <a:schemeClr val="accent3"/>
+                  <a:srgbClr val="9E2A2B"/>
                 </a:solidFill>
               </a:rPr>
               <a:t>ERRORE</a:t>
@@ -4689,7 +4689,7 @@
             <a:r>
               <a:rPr lang="en-US" sz="1700" dirty="0">
                 <a:solidFill>
-                  <a:schemeClr val="accent3"/>
+                  <a:srgbClr val="9E2A2B"/>
                 </a:solidFill>
                 <a:latin typeface="Courier New" pitchFamily="34" charset="0"/>
                 <a:ea typeface="Courier New" pitchFamily="34" charset="-122"/>
@@ -4706,7 +4706,7 @@
             <a:r>
               <a:rPr lang="en-US" sz="1700" dirty="0">
                 <a:solidFill>
-                  <a:schemeClr val="accent3"/>
+                  <a:srgbClr val="9E2A2B"/>
                 </a:solidFill>
                 <a:latin typeface="Courier New" pitchFamily="34" charset="0"/>
                 <a:ea typeface="Courier New" pitchFamily="34" charset="-122"/>
@@ -4745,7 +4745,7 @@
             <a:r>
               <a:rPr lang="en-US" sz="2200" b="1" dirty="0">
                 <a:solidFill>
-                  <a:schemeClr val="tx1"/>
+                  <a:srgbClr val="1F2A30"/>
                 </a:solidFill>
               </a:rPr>
               <a:t>Due modi per correggere</a:t>
@@ -4771,7 +4771,7 @@
             </a:avLst>
           </a:prstGeom>
           <a:solidFill>
-            <a:schemeClr val="tx1"/>
+            <a:srgbClr val="1F2A30"/>
           </a:solidFill>
           <a:ln/>
         </p:spPr>
@@ -4803,7 +4803,7 @@
             <a:r>
               <a:rPr lang="en-US" sz="1100" b="1" spc="200" kern="0" dirty="0">
                 <a:solidFill>
-                  <a:schemeClr val="accent1"/>
+                  <a:srgbClr val="E09F3E"/>
                 </a:solidFill>
               </a:rPr>
               <a:t>PYTHON</a:t>
@@ -4839,7 +4839,7 @@
             <a:r>
               <a:rPr lang="en-US" sz="1500" dirty="0">
                 <a:solidFill>
-                  <a:schemeClr val="bg1"/>
+                  <a:srgbClr val="FFFFFF"/>
                 </a:solidFill>
                 <a:latin typeface="Courier New" pitchFamily="34" charset="0"/>
                 <a:ea typeface="Courier New" pitchFamily="34" charset="-122"/>
@@ -4868,7 +4868,7 @@
             </a:avLst>
           </a:prstGeom>
           <a:solidFill>
-            <a:schemeClr val="tx1"/>
+            <a:srgbClr val="1F2A30"/>
           </a:solidFill>
           <a:ln/>
         </p:spPr>
@@ -4900,7 +4900,7 @@
             <a:r>
               <a:rPr lang="en-US" sz="1100" b="1" spc="200" kern="0" dirty="0">
                 <a:solidFill>
-                  <a:schemeClr val="accent1"/>
+                  <a:srgbClr val="E09F3E"/>
                 </a:solidFill>
               </a:rPr>
               <a:t>PYTHON</a:t>
@@ -4936,7 +4936,7 @@
             <a:r>
               <a:rPr lang="en-US" sz="1500" dirty="0">
                 <a:solidFill>
-                  <a:schemeClr val="bg1"/>
+                  <a:srgbClr val="FFFFFF"/>
                 </a:solidFill>
                 <a:latin typeface="Courier New" pitchFamily="34" charset="0"/>
                 <a:ea typeface="Courier New" pitchFamily="34" charset="-122"/>
@@ -4975,7 +4975,7 @@
             <a:r>
               <a:rPr lang="en-US" sz="1800" i="1" dirty="0">
                 <a:solidFill>
-                  <a:schemeClr val="tx2"/>
+                  <a:srgbClr val="0F4C5C"/>
                 </a:solidFill>
               </a:rPr>
               <a:t>Python non indovina: testo e numeri vanno trattati in modo esplicito.</a:t>
@@ -5014,7 +5014,7 @@
             <a:lvl1pPr>
               <a:defRPr sz="1000">
                 <a:solidFill>
-                  <a:schemeClr val="accent5"/>
+                  <a:srgbClr val="5C6F7B"/>
                 </a:solidFill>
               </a:defRPr>
             </a:lvl1pPr>
@@ -5083,7 +5083,7 @@
             <a:r>
               <a:rPr lang="en-US" sz="4800" b="1" dirty="0">
                 <a:solidFill>
-                  <a:schemeClr val="bg1"/>
+                  <a:srgbClr val="FFFFFF"/>
                 </a:solidFill>
               </a:rPr>
               <a:t>Prossima volta: un file Excel</a:t>
@@ -5121,7 +5121,7 @@
             <a:r>
               <a:rPr lang="en-US" sz="2200" dirty="0">
                 <a:solidFill>
-                  <a:schemeClr val="accent1"/>
+                  <a:srgbClr val="F4C06E"/>
                 </a:solidFill>
               </a:rPr>
               <a:t>Compito: Kaggle Learn – Python, lezione «Hello, Python» (~30 min)</a:t>
@@ -5184,7 +5184,7 @@
             <a:r>
               <a:rPr lang="en-US" sz="3600" b="1" dirty="0">
                 <a:solidFill>
-                  <a:schemeClr val="tx2"/>
+                  <a:srgbClr val="0F4C5C"/>
                 </a:solidFill>
               </a:rPr>
               <a:t>Oggi</a:t>
@@ -5210,7 +5210,7 @@
             </a:avLst>
           </a:prstGeom>
           <a:solidFill>
-            <a:schemeClr val="bg2"/>
+            <a:srgbClr val="EEF3F4"/>
           </a:solidFill>
           <a:ln/>
         </p:spPr>
@@ -5230,7 +5230,7 @@
             <a:avLst/>
           </a:prstGeom>
           <a:solidFill>
-            <a:schemeClr val="accent1"/>
+            <a:srgbClr val="E09F3E"/>
           </a:solidFill>
           <a:ln/>
         </p:spPr>
@@ -5262,7 +5262,7 @@
             <a:r>
               <a:rPr lang="en-US" sz="2080" b="1" dirty="0">
                 <a:solidFill>
-                  <a:schemeClr val="tx1"/>
+                  <a:srgbClr val="1F2A30"/>
                 </a:solidFill>
               </a:rPr>
               <a:t>1</a:t>
@@ -5298,7 +5298,7 @@
             <a:r>
               <a:rPr lang="en-US" sz="2600" b="1" dirty="0">
                 <a:solidFill>
-                  <a:schemeClr val="tx1"/>
+                  <a:srgbClr val="1F2A30"/>
                 </a:solidFill>
               </a:rPr>
               <a:t>Spiegazione e demo</a:t>
@@ -5334,7 +5334,7 @@
             <a:r>
               <a:rPr lang="en-US" sz="2000" b="1" dirty="0">
                 <a:solidFill>
-                  <a:schemeClr val="accent1"/>
+                  <a:srgbClr val="8F5308"/>
                 </a:solidFill>
               </a:rPr>
               <a:t>25 min</a:t>
@@ -5370,7 +5370,7 @@
             <a:r>
               <a:rPr lang="en-US" sz="1600" dirty="0">
                 <a:solidFill>
-                  <a:schemeClr val="tx1"/>
+                  <a:srgbClr val="1F2A30"/>
                 </a:solidFill>
               </a:rPr>
               <a:t>Programmi, Colab, Gemini, errori</a:t>
@@ -5396,7 +5396,7 @@
             </a:avLst>
           </a:prstGeom>
           <a:solidFill>
-            <a:schemeClr val="tx2"/>
+            <a:srgbClr val="0F4C5C"/>
           </a:solidFill>
           <a:ln/>
         </p:spPr>
@@ -5416,7 +5416,7 @@
             <a:avLst/>
           </a:prstGeom>
           <a:solidFill>
-            <a:schemeClr val="accent1"/>
+            <a:srgbClr val="E09F3E"/>
           </a:solidFill>
           <a:ln/>
         </p:spPr>
@@ -5448,7 +5448,7 @@
             <a:r>
               <a:rPr lang="en-US" sz="2080" b="1" dirty="0">
                 <a:solidFill>
-                  <a:schemeClr val="tx1"/>
+                  <a:srgbClr val="1F2A30"/>
                 </a:solidFill>
               </a:rPr>
               <a:t>2</a:t>
@@ -5484,7 +5484,7 @@
             <a:r>
               <a:rPr lang="en-US" sz="2600" b="1" dirty="0">
                 <a:solidFill>
-                  <a:schemeClr val="bg1"/>
+                  <a:srgbClr val="FFFFFF"/>
                 </a:solidFill>
               </a:rPr>
               <a:t>Task</a:t>
@@ -5520,7 +5520,7 @@
             <a:r>
               <a:rPr lang="en-US" sz="2000" b="1" dirty="0">
                 <a:solidFill>
-                  <a:schemeClr val="accent1"/>
+                  <a:srgbClr val="F4C06E"/>
                 </a:solidFill>
               </a:rPr>
               <a:t>60 min</a:t>
@@ -5556,7 +5556,7 @@
             <a:r>
               <a:rPr lang="en-US" sz="1600" dirty="0">
                 <a:solidFill>
-                  <a:schemeClr val="bg1"/>
+                  <a:srgbClr val="FFFFFF"/>
                 </a:solidFill>
               </a:rPr>
               <a:t>Il risparmio di Marco, a piccoli passi</a:t>
@@ -5582,7 +5582,7 @@
             </a:avLst>
           </a:prstGeom>
           <a:solidFill>
-            <a:schemeClr val="bg2"/>
+            <a:srgbClr val="EEF3F4"/>
           </a:solidFill>
           <a:ln/>
         </p:spPr>
@@ -5602,7 +5602,7 @@
             <a:avLst/>
           </a:prstGeom>
           <a:solidFill>
-            <a:schemeClr val="accent1"/>
+            <a:srgbClr val="E09F3E"/>
           </a:solidFill>
           <a:ln/>
         </p:spPr>
@@ -5634,7 +5634,7 @@
             <a:r>
               <a:rPr lang="en-US" sz="2080" b="1" dirty="0">
                 <a:solidFill>
-                  <a:schemeClr val="tx1"/>
+                  <a:srgbClr val="1F2A30"/>
                 </a:solidFill>
               </a:rPr>
               <a:t>3</a:t>
@@ -5670,7 +5670,7 @@
             <a:r>
               <a:rPr lang="en-US" sz="2600" b="1" dirty="0">
                 <a:solidFill>
-                  <a:schemeClr val="tx1"/>
+                  <a:srgbClr val="1F2A30"/>
                 </a:solidFill>
               </a:rPr>
               <a:t>Debrief</a:t>
@@ -5706,7 +5706,7 @@
             <a:r>
               <a:rPr lang="en-US" sz="2000" b="1" dirty="0">
                 <a:solidFill>
-                  <a:schemeClr val="accent1"/>
+                  <a:srgbClr val="8F5308"/>
                 </a:solidFill>
               </a:rPr>
               <a:t>25 min</a:t>
@@ -5742,7 +5742,7 @@
             <a:r>
               <a:rPr lang="en-US" sz="1600" dirty="0">
                 <a:solidFill>
-                  <a:schemeClr val="tx1"/>
+                  <a:srgbClr val="1F2A30"/>
                 </a:solidFill>
               </a:rPr>
               <a:t>Variabili, tipi, la prima trappola</a:t>
@@ -5781,7 +5781,7 @@
             <a:lvl1pPr>
               <a:defRPr sz="1000">
                 <a:solidFill>
-                  <a:schemeClr val="accent5"/>
+                  <a:srgbClr val="5C6F7B"/>
                 </a:solidFill>
               </a:defRPr>
             </a:lvl1pPr>
@@ -5850,7 +5850,7 @@
             <a:r>
               <a:rPr lang="en-US" sz="3600" b="1" dirty="0">
                 <a:solidFill>
-                  <a:schemeClr val="tx2"/>
+                  <a:srgbClr val="0F4C5C"/>
                 </a:solidFill>
               </a:rPr>
               <a:t>Cos'è un programma</a:t>
@@ -5889,7 +5889,7 @@
             <a:r>
               <a:rPr lang="en-US" sz="2200" dirty="0">
                 <a:solidFill>
-                  <a:schemeClr val="tx1"/>
+                  <a:srgbClr val="1F2A30"/>
                 </a:solidFill>
               </a:rPr>
               <a:t>Una lista di istruzioni, eseguite in ordine, una dopo l'altra.</a:t>
@@ -5906,7 +5906,7 @@
             <a:r>
               <a:rPr lang="en-US" sz="2200" b="1" dirty="0">
                 <a:solidFill>
-                  <a:schemeClr val="tx2"/>
+                  <a:srgbClr val="0F4C5C"/>
                 </a:solidFill>
               </a:rPr>
               <a:t>Il computer non capisce: esegue. Esattamente quello che scrivi.</a:t>
@@ -5932,7 +5932,7 @@
             </a:avLst>
           </a:prstGeom>
           <a:solidFill>
-            <a:schemeClr val="tx1"/>
+            <a:srgbClr val="1F2A30"/>
           </a:solidFill>
           <a:ln/>
         </p:spPr>
@@ -5964,7 +5964,7 @@
             <a:r>
               <a:rPr lang="en-US" sz="1100" b="1" spc="200" kern="0" dirty="0">
                 <a:solidFill>
-                  <a:schemeClr val="accent1"/>
+                  <a:srgbClr val="E09F3E"/>
                 </a:solidFill>
               </a:rPr>
               <a:t>PYTHON</a:t>
@@ -6000,7 +6000,7 @@
             <a:r>
               <a:rPr lang="en-US" sz="2000" dirty="0">
                 <a:solidFill>
-                  <a:schemeClr val="bg1"/>
+                  <a:srgbClr val="FFFFFF"/>
                 </a:solidFill>
                 <a:latin typeface="Courier New" pitchFamily="34" charset="0"/>
                 <a:ea typeface="Courier New" pitchFamily="34" charset="-122"/>
@@ -6017,7 +6017,7 @@
             <a:r>
               <a:rPr lang="en-US" sz="2000" dirty="0">
                 <a:solidFill>
-                  <a:schemeClr val="bg1"/>
+                  <a:srgbClr val="FFFFFF"/>
                 </a:solidFill>
                 <a:latin typeface="Courier New" pitchFamily="34" charset="0"/>
                 <a:ea typeface="Courier New" pitchFamily="34" charset="-122"/>
@@ -6034,7 +6034,7 @@
             <a:r>
               <a:rPr lang="en-US" sz="2000" dirty="0">
                 <a:solidFill>
-                  <a:schemeClr val="bg1"/>
+                  <a:srgbClr val="FFFFFF"/>
                 </a:solidFill>
                 <a:latin typeface="Courier New" pitchFamily="34" charset="0"/>
                 <a:ea typeface="Courier New" pitchFamily="34" charset="-122"/>
@@ -6063,7 +6063,7 @@
             </a:avLst>
           </a:prstGeom>
           <a:solidFill>
-            <a:schemeClr val="bg2"/>
+            <a:srgbClr val="EEF3F4"/>
           </a:solidFill>
           <a:ln/>
         </p:spPr>
@@ -6095,7 +6095,7 @@
             <a:r>
               <a:rPr lang="en-US" sz="1100" b="1" spc="200" kern="0" dirty="0">
                 <a:solidFill>
-                  <a:schemeClr val="accent5"/>
+                  <a:srgbClr val="5C6F7B"/>
                 </a:solidFill>
               </a:rPr>
               <a:t>OUTPUT</a:t>
@@ -6131,7 +6131,7 @@
             <a:r>
               <a:rPr lang="en-US" sz="2000" dirty="0">
                 <a:solidFill>
-                  <a:schemeClr val="tx1"/>
+                  <a:srgbClr val="1F2A30"/>
                 </a:solidFill>
                 <a:latin typeface="Courier New" pitchFamily="34" charset="0"/>
                 <a:ea typeface="Courier New" pitchFamily="34" charset="-122"/>
@@ -6173,7 +6173,7 @@
             <a:lvl1pPr>
               <a:defRPr sz="1000">
                 <a:solidFill>
-                  <a:schemeClr val="accent5"/>
+                  <a:srgbClr val="5C6F7B"/>
                 </a:solidFill>
               </a:defRPr>
             </a:lvl1pPr>
@@ -6242,7 +6242,7 @@
             <a:r>
               <a:rPr lang="en-US" sz="3600" b="1" dirty="0">
                 <a:solidFill>
-                  <a:schemeClr val="tx2"/>
+                  <a:srgbClr val="0F4C5C"/>
                 </a:solidFill>
               </a:rPr>
               <a:t>Colab: il nostro ambiente</a:t>
@@ -6266,7 +6266,7 @@
             <a:avLst/>
           </a:prstGeom>
           <a:solidFill>
-            <a:schemeClr val="bg2"/>
+            <a:srgbClr val="EEF3F4"/>
           </a:solidFill>
           <a:ln/>
         </p:spPr>
@@ -6322,7 +6322,7 @@
             <a:r>
               <a:rPr lang="en-US" sz="2200" b="1" dirty="0">
                 <a:solidFill>
-                  <a:schemeClr val="tx1"/>
+                  <a:srgbClr val="1F2A30"/>
                 </a:solidFill>
               </a:rPr>
               <a:t>Nel browser</a:t>
@@ -6358,7 +6358,7 @@
             <a:r>
               <a:rPr lang="en-US" sz="1600" dirty="0">
                 <a:solidFill>
-                  <a:schemeClr val="accent5"/>
+                  <a:srgbClr val="5C6F7B"/>
                 </a:solidFill>
               </a:rPr>
               <a:t>Gratis, niente da installare</a:t>
@@ -6382,7 +6382,7 @@
             <a:avLst/>
           </a:prstGeom>
           <a:solidFill>
-            <a:schemeClr val="bg2"/>
+            <a:srgbClr val="EEF3F4"/>
           </a:solidFill>
           <a:ln/>
         </p:spPr>
@@ -6438,7 +6438,7 @@
             <a:r>
               <a:rPr lang="en-US" sz="2200" b="1" dirty="0">
                 <a:solidFill>
-                  <a:schemeClr val="tx1"/>
+                  <a:srgbClr val="1F2A30"/>
                 </a:solidFill>
               </a:rPr>
               <a:t>Account Google</a:t>
@@ -6474,7 +6474,7 @@
             <a:r>
               <a:rPr lang="en-US" sz="1600" dirty="0">
                 <a:solidFill>
-                  <a:schemeClr val="accent5"/>
+                  <a:srgbClr val="5C6F7B"/>
                 </a:solidFill>
               </a:rPr>
               <a:t>L'unica cosa che serve</a:t>
@@ -6498,7 +6498,7 @@
             <a:avLst/>
           </a:prstGeom>
           <a:solidFill>
-            <a:schemeClr val="bg2"/>
+            <a:srgbClr val="EEF3F4"/>
           </a:solidFill>
           <a:ln/>
         </p:spPr>
@@ -6554,7 +6554,7 @@
             <a:r>
               <a:rPr lang="en-US" sz="2200" b="1" dirty="0">
                 <a:solidFill>
-                  <a:schemeClr val="tx1"/>
+                  <a:srgbClr val="1F2A30"/>
                 </a:solidFill>
               </a:rPr>
               <a:t>Celle</a:t>
@@ -6590,7 +6590,7 @@
             <a:r>
               <a:rPr lang="en-US" sz="1600" dirty="0">
                 <a:solidFill>
-                  <a:schemeClr val="accent5"/>
+                  <a:srgbClr val="5C6F7B"/>
                 </a:solidFill>
               </a:rPr>
               <a:t>Testo e codice, alternati</a:t>
@@ -6614,7 +6614,7 @@
             <a:avLst/>
           </a:prstGeom>
           <a:solidFill>
-            <a:schemeClr val="bg2"/>
+            <a:srgbClr val="EEF3F4"/>
           </a:solidFill>
           <a:ln/>
         </p:spPr>
@@ -6670,7 +6670,7 @@
             <a:r>
               <a:rPr lang="en-US" sz="2200" b="1" dirty="0">
                 <a:solidFill>
-                  <a:schemeClr val="tx1"/>
+                  <a:srgbClr val="1F2A30"/>
                 </a:solidFill>
               </a:rPr>
               <a:t>Shift + Invio</a:t>
@@ -6706,7 +6706,7 @@
             <a:r>
               <a:rPr lang="en-US" sz="1600" dirty="0">
                 <a:solidFill>
-                  <a:schemeClr val="accent5"/>
+                  <a:srgbClr val="5C6F7B"/>
                 </a:solidFill>
               </a:rPr>
               <a:t>Esegue la cella selezionata</a:t>
@@ -6732,7 +6732,7 @@
             </a:avLst>
           </a:prstGeom>
           <a:solidFill>
-            <a:schemeClr val="bg2"/>
+            <a:srgbClr val="EEF3F4"/>
           </a:solidFill>
           <a:ln/>
         </p:spPr>
@@ -6764,7 +6764,7 @@
             <a:r>
               <a:rPr lang="en-US" sz="2000" b="1" dirty="0">
                 <a:solidFill>
-                  <a:schemeClr val="accent1"/>
+                  <a:srgbClr val="8F5308"/>
                 </a:solidFill>
               </a:rPr>
               <a:t>Demo  </a:t>
@@ -6775,7 +6775,7 @@
             <a:r>
               <a:rPr lang="en-US" sz="2000" dirty="0">
                 <a:solidFill>
-                  <a:schemeClr val="tx1"/>
+                  <a:srgbClr val="1F2A30"/>
                 </a:solidFill>
               </a:rPr>
               <a:t>apriamo il notebook dal pulsante «Open in Colab» nel README del corso</a:t>
@@ -6814,7 +6814,7 @@
             <a:lvl1pPr>
               <a:defRPr sz="1000">
                 <a:solidFill>
-                  <a:schemeClr val="accent5"/>
+                  <a:srgbClr val="5C6F7B"/>
                 </a:solidFill>
               </a:defRPr>
             </a:lvl1pPr>
@@ -6883,7 +6883,7 @@
             <a:r>
               <a:rPr lang="en-US" sz="3600" b="1" dirty="0">
                 <a:solidFill>
-                  <a:schemeClr val="tx2"/>
+                  <a:srgbClr val="0F4C5C"/>
                 </a:solidFill>
               </a:rPr>
               <a:t>Gemini: l'assistente</a:t>
@@ -6907,7 +6907,7 @@
             <a:avLst/>
           </a:prstGeom>
           <a:solidFill>
-            <a:schemeClr val="bg2"/>
+            <a:srgbClr val="EEF3F4"/>
           </a:solidFill>
           <a:ln/>
         </p:spPr>
@@ -6939,7 +6939,7 @@
             <a:r>
               <a:rPr lang="en-US" sz="1820" b="1" dirty="0">
                 <a:solidFill>
-                  <a:schemeClr val="tx2"/>
+                  <a:srgbClr val="0F4C5C"/>
                 </a:solidFill>
               </a:rPr>
               <a:t>1</a:t>
@@ -6975,7 +6975,7 @@
             <a:r>
               <a:rPr lang="en-US" sz="2200" dirty="0">
                 <a:solidFill>
-                  <a:schemeClr val="tx1"/>
+                  <a:srgbClr val="1F2A30"/>
                 </a:solidFill>
               </a:rPr>
               <a:t>Chiedi cosa vuoi, con precisione</a:t>
@@ -6999,7 +6999,7 @@
             <a:avLst/>
           </a:prstGeom>
           <a:solidFill>
-            <a:schemeClr val="bg2"/>
+            <a:srgbClr val="EEF3F4"/>
           </a:solidFill>
           <a:ln/>
         </p:spPr>
@@ -7031,7 +7031,7 @@
             <a:r>
               <a:rPr lang="en-US" sz="1820" b="1" dirty="0">
                 <a:solidFill>
-                  <a:schemeClr val="tx2"/>
+                  <a:srgbClr val="0F4C5C"/>
                 </a:solidFill>
               </a:rPr>
               <a:t>2</a:t>
@@ -7067,7 +7067,7 @@
             <a:r>
               <a:rPr lang="en-US" sz="2200" dirty="0">
                 <a:solidFill>
-                  <a:schemeClr val="tx1"/>
+                  <a:srgbClr val="1F2A30"/>
                 </a:solidFill>
               </a:rPr>
               <a:t>Leggi il codice che propone</a:t>
@@ -7091,7 +7091,7 @@
             <a:avLst/>
           </a:prstGeom>
           <a:solidFill>
-            <a:schemeClr val="bg2"/>
+            <a:srgbClr val="EEF3F4"/>
           </a:solidFill>
           <a:ln/>
         </p:spPr>
@@ -7123,7 +7123,7 @@
             <a:r>
               <a:rPr lang="en-US" sz="1820" b="1" dirty="0">
                 <a:solidFill>
-                  <a:schemeClr val="tx2"/>
+                  <a:srgbClr val="0F4C5C"/>
                 </a:solidFill>
               </a:rPr>
               <a:t>3</a:t>
@@ -7159,7 +7159,7 @@
             <a:r>
               <a:rPr lang="en-US" sz="2200" dirty="0">
                 <a:solidFill>
-                  <a:schemeClr val="tx1"/>
+                  <a:srgbClr val="1F2A30"/>
                 </a:solidFill>
               </a:rPr>
               <a:t>Verifica il risultato</a:t>
@@ -7185,7 +7185,7 @@
             </a:avLst>
           </a:prstGeom>
           <a:solidFill>
-            <a:schemeClr val="tx2"/>
+            <a:srgbClr val="0F4C5C"/>
           </a:solidFill>
           <a:ln/>
         </p:spPr>
@@ -7217,7 +7217,7 @@
             <a:r>
               <a:rPr lang="en-US" sz="1300" b="1" spc="200" kern="0" dirty="0">
                 <a:solidFill>
-                  <a:schemeClr val="accent1"/>
+                  <a:srgbClr val="F4C06E"/>
                 </a:solidFill>
               </a:rPr>
               <a:t>REGOLA DEL CORSO</a:t>
@@ -7253,7 +7253,7 @@
             <a:r>
               <a:rPr lang="en-US" sz="3000" b="1" dirty="0">
                 <a:solidFill>
-                  <a:schemeClr val="bg1"/>
+                  <a:srgbClr val="FFFFFF"/>
                 </a:solidFill>
               </a:rPr>
               <a:t>Che il codice giri non vuol dire che sia giusto.</a:t>
@@ -7289,7 +7289,7 @@
             <a:r>
               <a:rPr lang="en-US" sz="1800" b="1" dirty="0">
                 <a:solidFill>
-                  <a:schemeClr val="accent1"/>
+                  <a:srgbClr val="8F5308"/>
                 </a:solidFill>
               </a:rPr>
               <a:t>Demo  </a:t>
@@ -7300,7 +7300,7 @@
             <a:r>
               <a:rPr lang="en-US" sz="1800" dirty="0">
                 <a:solidFill>
-                  <a:schemeClr val="tx1"/>
+                  <a:srgbClr val="1F2A30"/>
                 </a:solidFill>
               </a:rPr>
               <a:t>«calcola l'interesse composto su 1000 euro al 3% per 10 anni»</a:t>
@@ -7339,7 +7339,7 @@
             <a:lvl1pPr>
               <a:defRPr sz="1000">
                 <a:solidFill>
-                  <a:schemeClr val="accent5"/>
+                  <a:srgbClr val="5C6F7B"/>
                 </a:solidFill>
               </a:defRPr>
             </a:lvl1pPr>
@@ -7408,7 +7408,7 @@
             <a:r>
               <a:rPr lang="en-US" sz="3600" b="1" dirty="0">
                 <a:solidFill>
-                  <a:schemeClr val="tx2"/>
+                  <a:srgbClr val="0F4C5C"/>
                 </a:solidFill>
               </a:rPr>
               <a:t>Gli errori sono amici</a:t>
@@ -7434,7 +7434,7 @@
             </a:avLst>
           </a:prstGeom>
           <a:solidFill>
-            <a:schemeClr val="tx1"/>
+            <a:srgbClr val="1F2A30"/>
           </a:solidFill>
           <a:ln/>
         </p:spPr>
@@ -7466,7 +7466,7 @@
             <a:r>
               <a:rPr lang="en-US" sz="1100" b="1" spc="200" kern="0" dirty="0">
                 <a:solidFill>
-                  <a:schemeClr val="accent1"/>
+                  <a:srgbClr val="E09F3E"/>
                 </a:solidFill>
               </a:rPr>
               <a:t>PYTHON</a:t>
@@ -7502,7 +7502,7 @@
             <a:r>
               <a:rPr lang="en-US" sz="2000" dirty="0">
                 <a:solidFill>
-                  <a:schemeClr val="bg1"/>
+                  <a:srgbClr val="FFFFFF"/>
                 </a:solidFill>
                 <a:latin typeface="Courier New" pitchFamily="34" charset="0"/>
                 <a:ea typeface="Courier New" pitchFamily="34" charset="-122"/>
@@ -7563,7 +7563,7 @@
             <a:r>
               <a:rPr lang="en-US" sz="1100" b="1" spc="200" kern="0" dirty="0">
                 <a:solidFill>
-                  <a:schemeClr val="accent3"/>
+                  <a:srgbClr val="9E2A2B"/>
                 </a:solidFill>
               </a:rPr>
               <a:t>ERRORE</a:t>
@@ -7599,7 +7599,7 @@
             <a:r>
               <a:rPr lang="en-US" sz="1800" dirty="0">
                 <a:solidFill>
-                  <a:schemeClr val="accent3"/>
+                  <a:srgbClr val="9E2A2B"/>
                 </a:solidFill>
                 <a:latin typeface="Courier New" pitchFamily="34" charset="0"/>
                 <a:ea typeface="Courier New" pitchFamily="34" charset="-122"/>
@@ -7626,7 +7626,7 @@
             <a:avLst/>
           </a:prstGeom>
           <a:solidFill>
-            <a:schemeClr val="bg2"/>
+            <a:srgbClr val="EEF3F4"/>
           </a:solidFill>
           <a:ln/>
         </p:spPr>
@@ -7658,7 +7658,7 @@
             <a:r>
               <a:rPr lang="en-US" sz="1820" b="1" dirty="0">
                 <a:solidFill>
-                  <a:schemeClr val="tx2"/>
+                  <a:srgbClr val="0F4C5C"/>
                 </a:solidFill>
               </a:rPr>
               <a:t>1</a:t>
@@ -7694,7 +7694,7 @@
             <a:r>
               <a:rPr lang="en-US" sz="2000" b="1" dirty="0">
                 <a:solidFill>
-                  <a:schemeClr val="tx1"/>
+                  <a:srgbClr val="1F2A30"/>
                 </a:solidFill>
               </a:rPr>
               <a:t>Leggi l'ultima riga</a:t>
@@ -7730,7 +7730,7 @@
             <a:r>
               <a:rPr lang="en-US" sz="1600" dirty="0">
                 <a:solidFill>
-                  <a:schemeClr val="accent5"/>
+                  <a:srgbClr val="5C6F7B"/>
                 </a:solidFill>
               </a:rPr>
               <a:t>dice il tipo di errore e la causa</a:t>
@@ -7754,7 +7754,7 @@
             <a:avLst/>
           </a:prstGeom>
           <a:solidFill>
-            <a:schemeClr val="bg2"/>
+            <a:srgbClr val="EEF3F4"/>
           </a:solidFill>
           <a:ln/>
         </p:spPr>
@@ -7786,7 +7786,7 @@
             <a:r>
               <a:rPr lang="en-US" sz="1820" b="1" dirty="0">
                 <a:solidFill>
-                  <a:schemeClr val="tx2"/>
+                  <a:srgbClr val="0F4C5C"/>
                 </a:solidFill>
               </a:rPr>
               <a:t>2</a:t>
@@ -7822,7 +7822,7 @@
             <a:r>
               <a:rPr lang="en-US" sz="2000" b="1" dirty="0">
                 <a:solidFill>
-                  <a:schemeClr val="tx1"/>
+                  <a:srgbClr val="1F2A30"/>
                 </a:solidFill>
               </a:rPr>
               <a:t>Copiala su Google</a:t>
@@ -7858,7 +7858,7 @@
             <a:r>
               <a:rPr lang="en-US" sz="1600" dirty="0">
                 <a:solidFill>
-                  <a:schemeClr val="accent5"/>
+                  <a:srgbClr val="5C6F7B"/>
                 </a:solidFill>
               </a:rPr>
               <a:t>così com'è, senza modificarla</a:t>
@@ -7882,7 +7882,7 @@
             <a:avLst/>
           </a:prstGeom>
           <a:solidFill>
-            <a:schemeClr val="bg2"/>
+            <a:srgbClr val="EEF3F4"/>
           </a:solidFill>
           <a:ln/>
         </p:spPr>
@@ -7914,7 +7914,7 @@
             <a:r>
               <a:rPr lang="en-US" sz="1820" b="1" dirty="0">
                 <a:solidFill>
-                  <a:schemeClr val="tx2"/>
+                  <a:srgbClr val="0F4C5C"/>
                 </a:solidFill>
               </a:rPr>
               <a:t>3</a:t>
@@ -7950,7 +7950,7 @@
             <a:r>
               <a:rPr lang="en-US" sz="2000" b="1" dirty="0">
                 <a:solidFill>
-                  <a:schemeClr val="tx1"/>
+                  <a:srgbClr val="1F2A30"/>
                 </a:solidFill>
               </a:rPr>
               <a:t>Qualcuno l'ha già risolto</a:t>
@@ -7986,7 +7986,7 @@
             <a:r>
               <a:rPr lang="en-US" sz="1600" dirty="0">
                 <a:solidFill>
-                  <a:schemeClr val="accent5"/>
+                  <a:srgbClr val="5C6F7B"/>
                 </a:solidFill>
               </a:rPr>
               <a:t>di solito su Stack Overflow</a:t>
@@ -8025,7 +8025,7 @@
             <a:lvl1pPr>
               <a:defRPr sz="1000">
                 <a:solidFill>
-                  <a:schemeClr val="accent5"/>
+                  <a:srgbClr val="5C6F7B"/>
                 </a:solidFill>
               </a:defRPr>
             </a:lvl1pPr>
@@ -8094,7 +8094,7 @@
             <a:r>
               <a:rPr lang="en-US" sz="3600" b="1" dirty="0">
                 <a:solidFill>
-                  <a:schemeClr val="tx2"/>
+                  <a:srgbClr val="0F4C5C"/>
                 </a:solidFill>
               </a:rPr>
               <a:t>Come si lavora nel task</a:t>
@@ -8120,7 +8120,7 @@
             </a:avLst>
           </a:prstGeom>
           <a:solidFill>
-            <a:schemeClr val="bg2"/>
+            <a:srgbClr val="EEF3F4"/>
           </a:solidFill>
           <a:ln/>
         </p:spPr>
@@ -8140,7 +8140,7 @@
             <a:avLst/>
           </a:prstGeom>
           <a:solidFill>
-            <a:schemeClr val="bg1"/>
+            <a:srgbClr val="FFFFFF"/>
           </a:solidFill>
           <a:ln/>
         </p:spPr>
@@ -8196,7 +8196,7 @@
             <a:r>
               <a:rPr lang="en-US" sz="2200" b="1" dirty="0">
                 <a:solidFill>
-                  <a:schemeClr val="tx1"/>
+                  <a:srgbClr val="1F2A30"/>
                 </a:solidFill>
               </a:rPr>
               <a:t>Passi piccoli</a:t>
@@ -8232,7 +8232,7 @@
             <a:r>
               <a:rPr lang="en-US" sz="1600" dirty="0">
                 <a:solidFill>
-                  <a:schemeClr val="accent5"/>
+                  <a:srgbClr val="5C6F7B"/>
                 </a:solidFill>
               </a:rPr>
               <a:t>Uno alla volta, nell'ordine</a:t>
@@ -8258,7 +8258,7 @@
             </a:avLst>
           </a:prstGeom>
           <a:solidFill>
-            <a:schemeClr val="bg2"/>
+            <a:srgbClr val="EEF3F4"/>
           </a:solidFill>
           <a:ln/>
         </p:spPr>
@@ -8278,7 +8278,7 @@
             <a:avLst/>
           </a:prstGeom>
           <a:solidFill>
-            <a:schemeClr val="bg1"/>
+            <a:srgbClr val="FFFFFF"/>
           </a:solidFill>
           <a:ln/>
         </p:spPr>
@@ -8334,7 +8334,7 @@
             <a:r>
               <a:rPr lang="en-US" sz="2200" b="1" dirty="0">
                 <a:solidFill>
-                  <a:schemeClr val="tx1"/>
+                  <a:srgbClr val="1F2A30"/>
                 </a:solidFill>
               </a:rPr>
               <a:t>Cosa cercare</a:t>
@@ -8370,7 +8370,7 @@
             <a:r>
               <a:rPr lang="en-US" sz="1600" dirty="0">
                 <a:solidFill>
-                  <a:schemeClr val="accent5"/>
+                  <a:srgbClr val="5C6F7B"/>
                 </a:solidFill>
               </a:rPr>
               <a:t>Per ogni passo trovi le parole chiave</a:t>
@@ -8396,7 +8396,7 @@
             </a:avLst>
           </a:prstGeom>
           <a:solidFill>
-            <a:schemeClr val="bg2"/>
+            <a:srgbClr val="EEF3F4"/>
           </a:solidFill>
           <a:ln/>
         </p:spPr>
@@ -8416,7 +8416,7 @@
             <a:avLst/>
           </a:prstGeom>
           <a:solidFill>
-            <a:schemeClr val="bg1"/>
+            <a:srgbClr val="FFFFFF"/>
           </a:solidFill>
           <a:ln/>
         </p:spPr>
@@ -8472,7 +8472,7 @@
             <a:r>
               <a:rPr lang="en-US" sz="2200" b="1" dirty="0">
                 <a:solidFill>
-                  <a:schemeClr val="tx1"/>
+                  <a:srgbClr val="1F2A30"/>
                 </a:solidFill>
               </a:rPr>
               <a:t>Gemini c'è</a:t>
@@ -8508,7 +8508,7 @@
             <a:r>
               <a:rPr lang="en-US" sz="1600" dirty="0">
                 <a:solidFill>
-                  <a:schemeClr val="accent5"/>
+                  <a:srgbClr val="5C6F7B"/>
                 </a:solidFill>
               </a:rPr>
               <a:t>Ma prima prova a capire cosa ti serve</a:t>
@@ -8534,7 +8534,7 @@
             </a:avLst>
           </a:prstGeom>
           <a:solidFill>
-            <a:schemeClr val="bg2"/>
+            <a:srgbClr val="EEF3F4"/>
           </a:solidFill>
           <a:ln/>
         </p:spPr>
@@ -8554,7 +8554,7 @@
             <a:avLst/>
           </a:prstGeom>
           <a:solidFill>
-            <a:schemeClr val="bg1"/>
+            <a:srgbClr val="FFFFFF"/>
           </a:solidFill>
           <a:ln/>
         </p:spPr>
@@ -8610,7 +8610,7 @@
             <a:r>
               <a:rPr lang="en-US" sz="2200" b="1" dirty="0">
                 <a:solidFill>
-                  <a:schemeClr val="tx1"/>
+                  <a:srgbClr val="1F2A30"/>
                 </a:solidFill>
               </a:rPr>
               <a:t>10 minuti</a:t>
@@ -8646,7 +8646,7 @@
             <a:r>
               <a:rPr lang="en-US" sz="1600" dirty="0">
                 <a:solidFill>
-                  <a:schemeClr val="accent5"/>
+                  <a:srgbClr val="5C6F7B"/>
                 </a:solidFill>
               </a:rPr>
               <a:t>Bloccato più a lungo? Chiedi</a:t>
@@ -8682,7 +8682,7 @@
             <a:r>
               <a:rPr lang="en-US" sz="1800" i="1" dirty="0">
                 <a:solidFill>
-                  <a:schemeClr val="tx2"/>
+                  <a:srgbClr val="0F4C5C"/>
                 </a:solidFill>
               </a:rPr>
               <a:t>Saper cercare è metà del mestiere di programmare.</a:t>
@@ -8721,7 +8721,7 @@
             <a:lvl1pPr>
               <a:defRPr sz="1000">
                 <a:solidFill>
-                  <a:schemeClr val="accent5"/>
+                  <a:srgbClr val="5C6F7B"/>
                 </a:solidFill>
               </a:defRPr>
             </a:lvl1pPr>
@@ -8790,7 +8790,7 @@
             <a:r>
               <a:rPr lang="en-US" sz="5400" b="1" dirty="0">
                 <a:solidFill>
-                  <a:schemeClr val="bg1"/>
+                  <a:srgbClr val="FFFFFF"/>
                 </a:solidFill>
               </a:rPr>
               <a:t>Task: il risparmio di Marco</a:t>
@@ -8828,7 +8828,7 @@
             <a:r>
               <a:rPr lang="en-US" sz="2200" dirty="0">
                 <a:solidFill>
-                  <a:schemeClr val="accent6"/>
+                  <a:srgbClr val="B8C4CB"/>
                 </a:solidFill>
               </a:rPr>
               <a:t>Marco ha 5.000 € e li investe al 2,5% annuo.</a:t>
@@ -8842,7 +8842,7 @@
             <a:r>
               <a:rPr lang="en-US" sz="2200" dirty="0">
                 <a:solidFill>
-                  <a:schemeClr val="accent6"/>
+                  <a:srgbClr val="B8C4CB"/>
                 </a:solidFill>
               </a:rPr>
               <a:t>60 minuti · apri il notebook dal README</a:t>
@@ -8905,7 +8905,7 @@
             <a:r>
               <a:rPr lang="en-US" sz="5400" b="1" dirty="0">
                 <a:solidFill>
-                  <a:schemeClr val="bg1"/>
+                  <a:srgbClr val="FFFFFF"/>
                 </a:solidFill>
               </a:rPr>
               <a:t>Debrief</a:t>
@@ -8943,7 +8943,7 @@
             <a:r>
               <a:rPr lang="en-US" sz="2200" dirty="0">
                 <a:solidFill>
-                  <a:schemeClr val="accent6"/>
+                  <a:srgbClr val="B8C4CB"/>
                 </a:solidFill>
               </a:rPr>
               <a:t>Come ha funzionato, e perché</a:t>

</xml_diff>

<commit_message>
Soluzioni spostate nel branch soluzioni
- dispense L1 e L2 senza risposte, con una sfida
- slide per studenti senza il debrief
- README: link alle soluzioni per ogni lezione

Co-Authored-By: Claude Opus 5.5 <noreply@anthropic.com>
Claude-Session: https://claude.ai/code/session_014CzWDFXvYNxqLeD99LSN3G
</commit_message>
<xml_diff>
--- a/lezioni/L01_python_calcolatrice/slide.pptx
+++ b/lezioni/L01_python_calcolatrice/slide.pptx
@@ -14,14 +14,9 @@
     <p:sldId id="262" r:id="rId8"/>
     <p:sldId id="263" r:id="rId9"/>
     <p:sldId id="264" r:id="rId10"/>
-    <p:sldId id="265" r:id="rId11"/>
-    <p:sldId id="266" r:id="rId12"/>
-    <p:sldId id="267" r:id="rId13"/>
-    <p:sldId id="268" r:id="rId14"/>
-    <p:sldId id="269" r:id="rId15"/>
   </p:sldIdLst>
   <p:notesMasterIdLst>
-    <p:notesMasterId r:id="rId16"/>
+    <p:notesMasterId r:id="rId11"/>
   </p:notesMasterIdLst>
   <p:sldSz cx="12192000" cy="6858000"/>
   <p:notesSz cx="6858000" cy="12192000"/>
@@ -120,13 +115,13 @@
   <p:extLst>
     <p:ext uri="{521415D9-36F7-43E2-AB2F-B90AF26B5E84}">
       <p14:sectionLst xmlns:p14="http://schemas.microsoft.com/office/powerpoint/2010/main">
-        <p14:section name="Apertura" id="{a00e067d-70cf-f660-6c1c-9cff1ddab90a}">
+        <p14:section name="Apertura" id="{b7f29b63-0837-0277-9fbd-e398b99a01ef}">
           <p14:sldIdLst>
             <p14:sldId id="256"/>
             <p14:sldId id="257"/>
           </p14:sldIdLst>
         </p14:section>
-        <p14:section name="Spiegazione" id="{0f2367dc-010e-712e-2e87-ee106363307e}">
+        <p14:section name="Spiegazione" id="{2576292b-0989-bdf1-0b74-9a987f623421}">
           <p14:sldIdLst>
             <p14:sldId id="258"/>
             <p14:sldId id="259"/>
@@ -135,23 +130,14 @@
             <p14:sldId id="262"/>
           </p14:sldIdLst>
         </p14:section>
-        <p14:section name="Task" id="{2e02af21-7335-edc8-6d32-b622f2b5071d}">
+        <p14:section name="Task" id="{e8831d7d-5c54-a08a-9be9-c7fe214780a4}">
           <p14:sldIdLst>
             <p14:sldId id="263"/>
           </p14:sldIdLst>
         </p14:section>
-        <p14:section name="Debrief" id="{04dc3574-f86c-0736-9e9b-3d97c5885e98}">
+        <p14:section name="Chiusura" id="{c0dd33b1-9b1a-d619-f6c0-86adc56323c7}">
           <p14:sldIdLst>
             <p14:sldId id="264"/>
-            <p14:sldId id="265"/>
-            <p14:sldId id="266"/>
-            <p14:sldId id="267"/>
-            <p14:sldId id="268"/>
-          </p14:sldIdLst>
-        </p14:section>
-        <p14:section name="Chiusura" id="{6dba7b64-5890-49f7-32dc-697d657d7fbc}">
-          <p14:sldIdLst>
-            <p14:sldId id="269"/>
           </p14:sldIdLst>
         </p14:section>
       </p14:sectionLst>
@@ -600,446 +586,6 @@
 </p:notes>
 </file>
 
-<file path=ppt/notesSlides/notesSlide10.xml><?xml version="1.0" encoding="utf-8"?>
-<p:notes xmlns:a="http://schemas.openxmlformats.org/drawingml/2006/main" xmlns:r="http://schemas.openxmlformats.org/officeDocument/2006/relationships" xmlns:p="http://schemas.openxmlformats.org/presentationml/2006/main">
-  <p:cSld>
-    <p:spTree>
-      <p:nvGrpSpPr>
-        <p:cNvPr id="1" name=""/>
-        <p:cNvGrpSpPr/>
-        <p:nvPr/>
-      </p:nvGrpSpPr>
-      <p:grpSpPr>
-        <a:xfrm>
-          <a:off x="0" y="0"/>
-          <a:ext cx="0" cy="0"/>
-          <a:chOff x="0" y="0"/>
-          <a:chExt cx="0" cy="0"/>
-        </a:xfrm>
-      </p:grpSpPr>
-      <p:sp>
-        <p:nvSpPr>
-          <p:cNvPr id="2" name="Slide Image Placeholder 1"/>
-          <p:cNvSpPr>
-            <a:spLocks noGrp="1" noRot="1" noChangeAspect="1"/>
-          </p:cNvSpPr>
-          <p:nvPr>
-            <p:ph type="sldImg"/>
-          </p:nvPr>
-        </p:nvSpPr>
-        <p:spPr/>
-      </p:sp>
-      <p:sp>
-        <p:nvSpPr>
-          <p:cNvPr id="3" name="Notes Placeholder 2"/>
-          <p:cNvSpPr>
-            <a:spLocks noGrp="1"/>
-          </p:cNvSpPr>
-          <p:nvPr>
-            <p:ph type="body" idx="1"/>
-          </p:nvPr>
-        </p:nvSpPr>
-        <p:spPr/>
-        <p:txBody>
-          <a:bodyPr/>
-          <a:lstStyle/>
-          <a:p>
-            <a:r>
-              <a:rPr lang="en-US" dirty="0"/>
-              <a:t>Mostrare: capitale = 6000 e poi print(capitale). L'etichetta ora punta a un altro valore.</a:t>
-            </a:r>
-            <a:endParaRPr lang="en-US" dirty="0"/>
-          </a:p>
-        </p:txBody>
-      </p:sp>
-      <p:sp>
-        <p:nvSpPr>
-          <p:cNvPr id="4" name="Slide Number Placeholder 3"/>
-          <p:cNvSpPr>
-            <a:spLocks noGrp="1"/>
-          </p:cNvSpPr>
-          <p:nvPr>
-            <p:ph type="sldNum" sz="quarter" idx="10"/>
-          </p:nvPr>
-        </p:nvSpPr>
-        <p:spPr/>
-        <p:txBody>
-          <a:bodyPr/>
-          <a:lstStyle/>
-          <a:p>
-            <a:fld id="{F7021451-1387-4CA6-816F-3879F97B5CBC}" type="slidenum">
-              <a:rPr lang="en-US"/>
-              <a:t>10</a:t>
-            </a:fld>
-            <a:endParaRPr lang="en-US"/>
-          </a:p>
-        </p:txBody>
-      </p:sp>
-    </p:spTree>
-    <p:extLst>
-      <p:ext uri="{BB962C8B-B14F-4D97-AF65-F5344CB8AC3E}">
-        <p14:creationId xmlns:p14="http://schemas.microsoft.com/office/powerpoint/2010/main" val="1024086991"/>
-      </p:ext>
-    </p:extLst>
-  </p:cSld>
-  <p:clrMapOvr>
-    <a:masterClrMapping/>
-  </p:clrMapOvr>
-</p:notes>
-</file>
-
-<file path=ppt/notesSlides/notesSlide11.xml><?xml version="1.0" encoding="utf-8"?>
-<p:notes xmlns:a="http://schemas.openxmlformats.org/drawingml/2006/main" xmlns:r="http://schemas.openxmlformats.org/officeDocument/2006/relationships" xmlns:p="http://schemas.openxmlformats.org/presentationml/2006/main">
-  <p:cSld>
-    <p:spTree>
-      <p:nvGrpSpPr>
-        <p:cNvPr id="1" name=""/>
-        <p:cNvGrpSpPr/>
-        <p:nvPr/>
-      </p:nvGrpSpPr>
-      <p:grpSpPr>
-        <a:xfrm>
-          <a:off x="0" y="0"/>
-          <a:ext cx="0" cy="0"/>
-          <a:chOff x="0" y="0"/>
-          <a:chExt cx="0" cy="0"/>
-        </a:xfrm>
-      </p:grpSpPr>
-      <p:sp>
-        <p:nvSpPr>
-          <p:cNvPr id="2" name="Slide Image Placeholder 1"/>
-          <p:cNvSpPr>
-            <a:spLocks noGrp="1" noRot="1" noChangeAspect="1"/>
-          </p:cNvSpPr>
-          <p:nvPr>
-            <p:ph type="sldImg"/>
-          </p:nvPr>
-        </p:nvSpPr>
-        <p:spPr/>
-      </p:sp>
-      <p:sp>
-        <p:nvSpPr>
-          <p:cNvPr id="3" name="Notes Placeholder 2"/>
-          <p:cNvSpPr>
-            <a:spLocks noGrp="1"/>
-          </p:cNvSpPr>
-          <p:nvPr>
-            <p:ph type="body" idx="1"/>
-          </p:nvPr>
-        </p:nvSpPr>
-        <p:spPr/>
-        <p:txBody>
-          <a:bodyPr/>
-          <a:lstStyle/>
-          <a:p>
-            <a:r>
-              <a:rPr lang="en-US" dirty="0"/>
-              <a:t>La virgola decimale tornerà fuori con l'Excel (L2-L3): anticiparlo qui.</a:t>
-            </a:r>
-            <a:endParaRPr lang="en-US" dirty="0"/>
-          </a:p>
-        </p:txBody>
-      </p:sp>
-      <p:sp>
-        <p:nvSpPr>
-          <p:cNvPr id="4" name="Slide Number Placeholder 3"/>
-          <p:cNvSpPr>
-            <a:spLocks noGrp="1"/>
-          </p:cNvSpPr>
-          <p:nvPr>
-            <p:ph type="sldNum" sz="quarter" idx="10"/>
-          </p:nvPr>
-        </p:nvSpPr>
-        <p:spPr/>
-        <p:txBody>
-          <a:bodyPr/>
-          <a:lstStyle/>
-          <a:p>
-            <a:fld id="{F7021451-1387-4CA6-816F-3879F97B5CBC}" type="slidenum">
-              <a:rPr lang="en-US"/>
-              <a:t>11</a:t>
-            </a:fld>
-            <a:endParaRPr lang="en-US"/>
-          </a:p>
-        </p:txBody>
-      </p:sp>
-    </p:spTree>
-    <p:extLst>
-      <p:ext uri="{BB962C8B-B14F-4D97-AF65-F5344CB8AC3E}">
-        <p14:creationId xmlns:p14="http://schemas.microsoft.com/office/powerpoint/2010/main" val="1024086991"/>
-      </p:ext>
-    </p:extLst>
-  </p:cSld>
-  <p:clrMapOvr>
-    <a:masterClrMapping/>
-  </p:clrMapOvr>
-</p:notes>
-</file>
-
-<file path=ppt/notesSlides/notesSlide12.xml><?xml version="1.0" encoding="utf-8"?>
-<p:notes xmlns:a="http://schemas.openxmlformats.org/drawingml/2006/main" xmlns:r="http://schemas.openxmlformats.org/officeDocument/2006/relationships" xmlns:p="http://schemas.openxmlformats.org/presentationml/2006/main">
-  <p:cSld>
-    <p:spTree>
-      <p:nvGrpSpPr>
-        <p:cNvPr id="1" name=""/>
-        <p:cNvGrpSpPr/>
-        <p:nvPr/>
-      </p:nvGrpSpPr>
-      <p:grpSpPr>
-        <a:xfrm>
-          <a:off x="0" y="0"/>
-          <a:ext cx="0" cy="0"/>
-          <a:chOff x="0" y="0"/>
-          <a:chExt cx="0" cy="0"/>
-        </a:xfrm>
-      </p:grpSpPr>
-      <p:sp>
-        <p:nvSpPr>
-          <p:cNvPr id="2" name="Slide Image Placeholder 1"/>
-          <p:cNvSpPr>
-            <a:spLocks noGrp="1" noRot="1" noChangeAspect="1"/>
-          </p:cNvSpPr>
-          <p:nvPr>
-            <p:ph type="sldImg"/>
-          </p:nvPr>
-        </p:nvSpPr>
-        <p:spPr/>
-      </p:sp>
-      <p:sp>
-        <p:nvSpPr>
-          <p:cNvPr id="3" name="Notes Placeholder 2"/>
-          <p:cNvSpPr>
-            <a:spLocks noGrp="1"/>
-          </p:cNvSpPr>
-          <p:nvPr>
-            <p:ph type="body" idx="1"/>
-          </p:nvPr>
-        </p:nvSpPr>
-        <p:spPr/>
-        <p:txBody>
-          <a:bodyPr/>
-          <a:lstStyle/>
-          <a:p>
-            <a:r>
-              <a:rPr lang="en-US" dirty="0"/>
-              <a:t>Chiedere: chi se n'è accorto? Chi ha pensato che fosse giusto? Collegare a Gemini: anche il codice generato può fare esattamente questo.</a:t>
-            </a:r>
-            <a:endParaRPr lang="en-US" dirty="0"/>
-          </a:p>
-        </p:txBody>
-      </p:sp>
-      <p:sp>
-        <p:nvSpPr>
-          <p:cNvPr id="4" name="Slide Number Placeholder 3"/>
-          <p:cNvSpPr>
-            <a:spLocks noGrp="1"/>
-          </p:cNvSpPr>
-          <p:nvPr>
-            <p:ph type="sldNum" sz="quarter" idx="10"/>
-          </p:nvPr>
-        </p:nvSpPr>
-        <p:spPr/>
-        <p:txBody>
-          <a:bodyPr/>
-          <a:lstStyle/>
-          <a:p>
-            <a:fld id="{F7021451-1387-4CA6-816F-3879F97B5CBC}" type="slidenum">
-              <a:rPr lang="en-US"/>
-              <a:t>12</a:t>
-            </a:fld>
-            <a:endParaRPr lang="en-US"/>
-          </a:p>
-        </p:txBody>
-      </p:sp>
-    </p:spTree>
-    <p:extLst>
-      <p:ext uri="{BB962C8B-B14F-4D97-AF65-F5344CB8AC3E}">
-        <p14:creationId xmlns:p14="http://schemas.microsoft.com/office/powerpoint/2010/main" val="1024086991"/>
-      </p:ext>
-    </p:extLst>
-  </p:cSld>
-  <p:clrMapOvr>
-    <a:masterClrMapping/>
-  </p:clrMapOvr>
-</p:notes>
-</file>
-
-<file path=ppt/notesSlides/notesSlide13.xml><?xml version="1.0" encoding="utf-8"?>
-<p:notes xmlns:a="http://schemas.openxmlformats.org/drawingml/2006/main" xmlns:r="http://schemas.openxmlformats.org/officeDocument/2006/relationships" xmlns:p="http://schemas.openxmlformats.org/presentationml/2006/main">
-  <p:cSld>
-    <p:spTree>
-      <p:nvGrpSpPr>
-        <p:cNvPr id="1" name=""/>
-        <p:cNvGrpSpPr/>
-        <p:nvPr/>
-      </p:nvGrpSpPr>
-      <p:grpSpPr>
-        <a:xfrm>
-          <a:off x="0" y="0"/>
-          <a:ext cx="0" cy="0"/>
-          <a:chOff x="0" y="0"/>
-          <a:chExt cx="0" cy="0"/>
-        </a:xfrm>
-      </p:grpSpPr>
-      <p:sp>
-        <p:nvSpPr>
-          <p:cNvPr id="2" name="Slide Image Placeholder 1"/>
-          <p:cNvSpPr>
-            <a:spLocks noGrp="1" noRot="1" noChangeAspect="1"/>
-          </p:cNvSpPr>
-          <p:nvPr>
-            <p:ph type="sldImg"/>
-          </p:nvPr>
-        </p:nvSpPr>
-        <p:spPr/>
-      </p:sp>
-      <p:sp>
-        <p:nvSpPr>
-          <p:cNvPr id="3" name="Notes Placeholder 2"/>
-          <p:cNvSpPr>
-            <a:spLocks noGrp="1"/>
-          </p:cNvSpPr>
-          <p:nvPr>
-            <p:ph type="body" idx="1"/>
-          </p:nvPr>
-        </p:nvSpPr>
-        <p:spPr/>
-        <p:txBody>
-          <a:bodyPr/>
-          <a:lstStyle/>
-          <a:p>
-            <a:r>
-              <a:rPr lang="en-US" dirty="0"/>
-              <a:t>Chi l'ha risolto cercando l'errore su Google? Chi con Gemini? Le soluzioni erano uguali?</a:t>
-            </a:r>
-            <a:endParaRPr lang="en-US" dirty="0"/>
-          </a:p>
-        </p:txBody>
-      </p:sp>
-      <p:sp>
-        <p:nvSpPr>
-          <p:cNvPr id="4" name="Slide Number Placeholder 3"/>
-          <p:cNvSpPr>
-            <a:spLocks noGrp="1"/>
-          </p:cNvSpPr>
-          <p:nvPr>
-            <p:ph type="sldNum" sz="quarter" idx="10"/>
-          </p:nvPr>
-        </p:nvSpPr>
-        <p:spPr/>
-        <p:txBody>
-          <a:bodyPr/>
-          <a:lstStyle/>
-          <a:p>
-            <a:fld id="{F7021451-1387-4CA6-816F-3879F97B5CBC}" type="slidenum">
-              <a:rPr lang="en-US"/>
-              <a:t>13</a:t>
-            </a:fld>
-            <a:endParaRPr lang="en-US"/>
-          </a:p>
-        </p:txBody>
-      </p:sp>
-    </p:spTree>
-    <p:extLst>
-      <p:ext uri="{BB962C8B-B14F-4D97-AF65-F5344CB8AC3E}">
-        <p14:creationId xmlns:p14="http://schemas.microsoft.com/office/powerpoint/2010/main" val="1024086991"/>
-      </p:ext>
-    </p:extLst>
-  </p:cSld>
-  <p:clrMapOvr>
-    <a:masterClrMapping/>
-  </p:clrMapOvr>
-</p:notes>
-</file>
-
-<file path=ppt/notesSlides/notesSlide14.xml><?xml version="1.0" encoding="utf-8"?>
-<p:notes xmlns:a="http://schemas.openxmlformats.org/drawingml/2006/main" xmlns:r="http://schemas.openxmlformats.org/officeDocument/2006/relationships" xmlns:p="http://schemas.openxmlformats.org/presentationml/2006/main">
-  <p:cSld>
-    <p:spTree>
-      <p:nvGrpSpPr>
-        <p:cNvPr id="1" name=""/>
-        <p:cNvGrpSpPr/>
-        <p:nvPr/>
-      </p:nvGrpSpPr>
-      <p:grpSpPr>
-        <a:xfrm>
-          <a:off x="0" y="0"/>
-          <a:ext cx="0" cy="0"/>
-          <a:chOff x="0" y="0"/>
-          <a:chExt cx="0" cy="0"/>
-        </a:xfrm>
-      </p:grpSpPr>
-      <p:sp>
-        <p:nvSpPr>
-          <p:cNvPr id="2" name="Slide Image Placeholder 1"/>
-          <p:cNvSpPr>
-            <a:spLocks noGrp="1" noRot="1" noChangeAspect="1"/>
-          </p:cNvSpPr>
-          <p:nvPr>
-            <p:ph type="sldImg"/>
-          </p:nvPr>
-        </p:nvSpPr>
-        <p:spPr/>
-      </p:sp>
-      <p:sp>
-        <p:nvSpPr>
-          <p:cNvPr id="3" name="Notes Placeholder 2"/>
-          <p:cNvSpPr>
-            <a:spLocks noGrp="1"/>
-          </p:cNvSpPr>
-          <p:nvPr>
-            <p:ph type="body" idx="1"/>
-          </p:nvPr>
-        </p:nvSpPr>
-        <p:spPr/>
-        <p:txBody>
-          <a:bodyPr/>
-          <a:lstStyle/>
-          <a:p>
-            <a:r>
-              <a:rPr lang="en-US" dirty="0"/>
-              <a:t>Il problema dei tipi tornerà con l'Excel. Ricordare di creare l'account Kaggle.</a:t>
-            </a:r>
-            <a:endParaRPr lang="en-US" dirty="0"/>
-          </a:p>
-        </p:txBody>
-      </p:sp>
-      <p:sp>
-        <p:nvSpPr>
-          <p:cNvPr id="4" name="Slide Number Placeholder 3"/>
-          <p:cNvSpPr>
-            <a:spLocks noGrp="1"/>
-          </p:cNvSpPr>
-          <p:nvPr>
-            <p:ph type="sldNum" sz="quarter" idx="10"/>
-          </p:nvPr>
-        </p:nvSpPr>
-        <p:spPr/>
-        <p:txBody>
-          <a:bodyPr/>
-          <a:lstStyle/>
-          <a:p>
-            <a:fld id="{F7021451-1387-4CA6-816F-3879F97B5CBC}" type="slidenum">
-              <a:rPr lang="en-US"/>
-              <a:t>14</a:t>
-            </a:fld>
-            <a:endParaRPr lang="en-US"/>
-          </a:p>
-        </p:txBody>
-      </p:sp>
-    </p:spTree>
-    <p:extLst>
-      <p:ext uri="{BB962C8B-B14F-4D97-AF65-F5344CB8AC3E}">
-        <p14:creationId xmlns:p14="http://schemas.microsoft.com/office/powerpoint/2010/main" val="1024086991"/>
-      </p:ext>
-    </p:extLst>
-  </p:cSld>
-  <p:clrMapOvr>
-    <a:masterClrMapping/>
-  </p:clrMapOvr>
-</p:notes>
-</file>
-
 <file path=ppt/notesSlides/notesSlide2.xml><?xml version="1.0" encoding="utf-8"?>
 <p:notes xmlns:a="http://schemas.openxmlformats.org/drawingml/2006/main" xmlns:r="http://schemas.openxmlformats.org/officeDocument/2006/relationships" xmlns:p="http://schemas.openxmlformats.org/presentationml/2006/main">
   <p:cSld>
@@ -1702,7 +1248,7 @@
           <a:p>
             <a:r>
               <a:rPr lang="en-US" dirty="0"/>
-              <a:t>Mostrare 2-3 soluzioni degli studenti prima di passare ai concetti.</a:t>
+              <a:t>Il problema dei tipi tornerà con l'Excel. Ricordare di creare l'account Kaggle.</a:t>
             </a:r>
             <a:endParaRPr lang="en-US" dirty="0"/>
           </a:p>
@@ -2572,2572 +2118,6 @@
 </p:sld>
 </file>
 
-<file path=ppt/slides/slide10.xml><?xml version="1.0" encoding="utf-8"?>
-<p:sld xmlns:a="http://schemas.openxmlformats.org/drawingml/2006/main" xmlns:r="http://schemas.openxmlformats.org/officeDocument/2006/relationships" xmlns:p="http://schemas.openxmlformats.org/presentationml/2006/main">
-  <p:cSld name="Slide 10">
-    <p:spTree>
-      <p:nvGrpSpPr>
-        <p:cNvPr id="1" name=""/>
-        <p:cNvGrpSpPr/>
-        <p:nvPr/>
-      </p:nvGrpSpPr>
-      <p:grpSpPr>
-        <a:xfrm>
-          <a:off x="0" y="0"/>
-          <a:ext cx="0" cy="0"/>
-          <a:chOff x="0" y="0"/>
-          <a:chExt cx="0" cy="0"/>
-        </a:xfrm>
-      </p:grpSpPr>
-      <p:sp>
-        <p:nvSpPr>
-          <p:cNvPr id="2" name="Text 0"/>
-          <p:cNvSpPr/>
-          <p:nvPr>
-            <p:ph idx="100" type="title" hasCustomPrompt="1"/>
-          </p:nvPr>
-        </p:nvSpPr>
-        <p:spPr>
-          <a:xfrm>
-            <a:off x="548640" y="365760"/>
-            <a:ext cx="11064240" cy="822960"/>
-          </a:xfrm>
-          <a:prstGeom prst="rect">
-            <a:avLst/>
-          </a:prstGeom>
-          <a:noFill/>
-          <a:ln/>
-        </p:spPr>
-        <p:txBody>
-          <a:bodyPr wrap="square" lIns="0" tIns="0" rIns="0" bIns="0" rtlCol="0" anchor="ctr"/>
-          <a:lstStyle/>
-          <a:p>
-            <a:pPr algn="l" indent="0" marL="0">
-              <a:buNone/>
-            </a:pPr>
-            <a:r>
-              <a:rPr lang="en-US" sz="3600" b="1" dirty="0">
-                <a:solidFill>
-                  <a:srgbClr val="0F4C5C"/>
-                </a:solidFill>
-              </a:rPr>
-              <a:t>Variabili</a:t>
-            </a:r>
-            <a:endParaRPr lang="en-US" sz="3600" dirty="0"/>
-          </a:p>
-        </p:txBody>
-      </p:sp>
-      <p:sp>
-        <p:nvSpPr>
-          <p:cNvPr id="3" name="card-code"/>
-          <p:cNvSpPr/>
-          <p:nvPr/>
-        </p:nvSpPr>
-        <p:spPr>
-          <a:xfrm>
-            <a:off x="548640" y="1737360"/>
-            <a:ext cx="5120640" cy="1371600"/>
-          </a:xfrm>
-          <a:prstGeom prst="roundRect">
-            <a:avLst>
-              <a:gd name="adj" fmla="val 8000"/>
-            </a:avLst>
-          </a:prstGeom>
-          <a:solidFill>
-            <a:srgbClr val="1F2A30"/>
-          </a:solidFill>
-          <a:ln/>
-        </p:spPr>
-      </p:sp>
-      <p:sp>
-        <p:nvSpPr>
-          <p:cNvPr id="4" name="Text 2"/>
-          <p:cNvSpPr txBox="1"/>
-          <p:nvPr/>
-        </p:nvSpPr>
-        <p:spPr>
-          <a:xfrm>
-            <a:off x="777240" y="1874520"/>
-            <a:ext cx="1828800" cy="274320"/>
-          </a:xfrm>
-          <a:prstGeom prst="rect">
-            <a:avLst/>
-          </a:prstGeom>
-          <a:noFill/>
-          <a:ln/>
-        </p:spPr>
-        <p:txBody>
-          <a:bodyPr wrap="square" lIns="0" tIns="0" rIns="0" bIns="0" rtlCol="0" anchor="ctr"/>
-          <a:lstStyle/>
-          <a:p>
-            <a:pPr indent="0" marL="0">
-              <a:buNone/>
-            </a:pPr>
-            <a:r>
-              <a:rPr lang="en-US" sz="1100" b="1" spc="200" kern="0" dirty="0">
-                <a:solidFill>
-                  <a:srgbClr val="E09F3E"/>
-                </a:solidFill>
-              </a:rPr>
-              <a:t>PYTHON</a:t>
-            </a:r>
-            <a:endParaRPr lang="en-US" sz="1100" dirty="0"/>
-          </a:p>
-        </p:txBody>
-      </p:sp>
-      <p:sp>
-        <p:nvSpPr>
-          <p:cNvPr id="5" name="Text 3"/>
-          <p:cNvSpPr txBox="1"/>
-          <p:nvPr/>
-        </p:nvSpPr>
-        <p:spPr>
-          <a:xfrm>
-            <a:off x="777240" y="2194560"/>
-            <a:ext cx="4663440" cy="777240"/>
-          </a:xfrm>
-          <a:prstGeom prst="rect">
-            <a:avLst/>
-          </a:prstGeom>
-          <a:noFill/>
-          <a:ln/>
-        </p:spPr>
-        <p:txBody>
-          <a:bodyPr wrap="square" lIns="0" tIns="0" rIns="0" bIns="0" rtlCol="0" anchor="t"/>
-          <a:lstStyle/>
-          <a:p>
-            <a:pPr indent="0" marL="0">
-              <a:buNone/>
-            </a:pPr>
-            <a:r>
-              <a:rPr lang="en-US" sz="2400" dirty="0">
-                <a:solidFill>
-                  <a:srgbClr val="FFFFFF"/>
-                </a:solidFill>
-                <a:latin typeface="Courier New" pitchFamily="34" charset="0"/>
-                <a:ea typeface="Courier New" pitchFamily="34" charset="-122"/>
-                <a:cs typeface="Courier New" pitchFamily="34" charset="-120"/>
-              </a:rPr>
-              <a:t>capitale = 5000</a:t>
-            </a:r>
-            <a:endParaRPr lang="en-US" sz="2400" dirty="0"/>
-          </a:p>
-        </p:txBody>
-      </p:sp>
-      <p:sp>
-        <p:nvSpPr>
-          <p:cNvPr id="6" name="Shape 4"/>
-          <p:cNvSpPr/>
-          <p:nvPr/>
-        </p:nvSpPr>
-        <p:spPr>
-          <a:xfrm>
-            <a:off x="548640" y="3749040"/>
-            <a:ext cx="2194560" cy="914400"/>
-          </a:xfrm>
-          <a:prstGeom prst="roundRect">
-            <a:avLst>
-              <a:gd name="adj" fmla="val 12000"/>
-            </a:avLst>
-          </a:prstGeom>
-          <a:solidFill>
-            <a:srgbClr val="E09F3E"/>
-          </a:solidFill>
-          <a:ln/>
-        </p:spPr>
-      </p:sp>
-      <p:sp>
-        <p:nvSpPr>
-          <p:cNvPr id="7" name="Text 5"/>
-          <p:cNvSpPr txBox="1"/>
-          <p:nvPr/>
-        </p:nvSpPr>
-        <p:spPr>
-          <a:xfrm>
-            <a:off x="548640" y="3749040"/>
-            <a:ext cx="2194560" cy="914400"/>
-          </a:xfrm>
-          <a:prstGeom prst="rect">
-            <a:avLst/>
-          </a:prstGeom>
-          <a:noFill/>
-          <a:ln/>
-        </p:spPr>
-        <p:txBody>
-          <a:bodyPr wrap="square" lIns="0" tIns="0" rIns="0" bIns="0" rtlCol="0" anchor="ctr"/>
-          <a:lstStyle/>
-          <a:p>
-            <a:pPr algn="ctr" indent="0" marL="0">
-              <a:buNone/>
-            </a:pPr>
-            <a:r>
-              <a:rPr lang="en-US" sz="2000" b="1" dirty="0">
-                <a:solidFill>
-                  <a:srgbClr val="1F2A30"/>
-                </a:solidFill>
-                <a:latin typeface="Courier New" pitchFamily="34" charset="0"/>
-                <a:ea typeface="Courier New" pitchFamily="34" charset="-122"/>
-                <a:cs typeface="Courier New" pitchFamily="34" charset="-120"/>
-              </a:rPr>
-              <a:t>capitale</a:t>
-            </a:r>
-            <a:endParaRPr lang="en-US" sz="2000" dirty="0"/>
-          </a:p>
-        </p:txBody>
-      </p:sp>
-      <p:sp>
-        <p:nvSpPr>
-          <p:cNvPr id="8" name="Shape 6"/>
-          <p:cNvSpPr/>
-          <p:nvPr/>
-        </p:nvSpPr>
-        <p:spPr>
-          <a:xfrm>
-            <a:off x="2834640" y="4206240"/>
-            <a:ext cx="822960" cy="0"/>
-          </a:xfrm>
-          <a:prstGeom prst="line">
-            <a:avLst/>
-          </a:prstGeom>
-          <a:noFill/>
-          <a:ln w="25400">
-            <a:solidFill>
-              <a:srgbClr val="5C6F7B"/>
-            </a:solidFill>
-            <a:prstDash val="solid"/>
-            <a:tailEnd type="triangle"/>
-          </a:ln>
-        </p:spPr>
-      </p:sp>
-      <p:sp>
-        <p:nvSpPr>
-          <p:cNvPr id="9" name="Shape 7"/>
-          <p:cNvSpPr/>
-          <p:nvPr/>
-        </p:nvSpPr>
-        <p:spPr>
-          <a:xfrm>
-            <a:off x="3749040" y="3749040"/>
-            <a:ext cx="1920240" cy="914400"/>
-          </a:xfrm>
-          <a:prstGeom prst="roundRect">
-            <a:avLst>
-              <a:gd name="adj" fmla="val 12000"/>
-            </a:avLst>
-          </a:prstGeom>
-          <a:solidFill>
-            <a:srgbClr val="EEF3F4"/>
-          </a:solidFill>
-          <a:ln/>
-        </p:spPr>
-      </p:sp>
-      <p:sp>
-        <p:nvSpPr>
-          <p:cNvPr id="10" name="Text 8"/>
-          <p:cNvSpPr txBox="1"/>
-          <p:nvPr/>
-        </p:nvSpPr>
-        <p:spPr>
-          <a:xfrm>
-            <a:off x="3749040" y="3749040"/>
-            <a:ext cx="1920240" cy="914400"/>
-          </a:xfrm>
-          <a:prstGeom prst="rect">
-            <a:avLst/>
-          </a:prstGeom>
-          <a:noFill/>
-          <a:ln/>
-        </p:spPr>
-        <p:txBody>
-          <a:bodyPr wrap="square" lIns="0" tIns="0" rIns="0" bIns="0" rtlCol="0" anchor="ctr"/>
-          <a:lstStyle/>
-          <a:p>
-            <a:pPr algn="ctr" indent="0" marL="0">
-              <a:buNone/>
-            </a:pPr>
-            <a:r>
-              <a:rPr lang="en-US" sz="2000" dirty="0">
-                <a:solidFill>
-                  <a:srgbClr val="1F2A30"/>
-                </a:solidFill>
-                <a:latin typeface="Courier New" pitchFamily="34" charset="0"/>
-                <a:ea typeface="Courier New" pitchFamily="34" charset="-122"/>
-                <a:cs typeface="Courier New" pitchFamily="34" charset="-120"/>
-              </a:rPr>
-              <a:t>5000</a:t>
-            </a:r>
-            <a:endParaRPr lang="en-US" sz="2000" dirty="0"/>
-          </a:p>
-        </p:txBody>
-      </p:sp>
-      <p:sp>
-        <p:nvSpPr>
-          <p:cNvPr id="11" name="Text 9"/>
-          <p:cNvSpPr txBox="1"/>
-          <p:nvPr/>
-        </p:nvSpPr>
-        <p:spPr>
-          <a:xfrm>
-            <a:off x="548640" y="4754880"/>
-            <a:ext cx="2194560" cy="365760"/>
-          </a:xfrm>
-          <a:prstGeom prst="rect">
-            <a:avLst/>
-          </a:prstGeom>
-          <a:noFill/>
-          <a:ln/>
-        </p:spPr>
-        <p:txBody>
-          <a:bodyPr wrap="square" lIns="0" tIns="0" rIns="0" bIns="0" rtlCol="0" anchor="ctr"/>
-          <a:lstStyle/>
-          <a:p>
-            <a:pPr algn="ctr" indent="0" marL="0">
-              <a:buNone/>
-            </a:pPr>
-            <a:r>
-              <a:rPr lang="en-US" sz="1400" dirty="0">
-                <a:solidFill>
-                  <a:srgbClr val="5C6F7B"/>
-                </a:solidFill>
-              </a:rPr>
-              <a:t>etichetta</a:t>
-            </a:r>
-            <a:endParaRPr lang="en-US" sz="1400" dirty="0"/>
-          </a:p>
-        </p:txBody>
-      </p:sp>
-      <p:sp>
-        <p:nvSpPr>
-          <p:cNvPr id="12" name="Text 10"/>
-          <p:cNvSpPr txBox="1"/>
-          <p:nvPr/>
-        </p:nvSpPr>
-        <p:spPr>
-          <a:xfrm>
-            <a:off x="3749040" y="4754880"/>
-            <a:ext cx="1920240" cy="365760"/>
-          </a:xfrm>
-          <a:prstGeom prst="rect">
-            <a:avLst/>
-          </a:prstGeom>
-          <a:noFill/>
-          <a:ln/>
-        </p:spPr>
-        <p:txBody>
-          <a:bodyPr wrap="square" lIns="0" tIns="0" rIns="0" bIns="0" rtlCol="0" anchor="ctr"/>
-          <a:lstStyle/>
-          <a:p>
-            <a:pPr algn="ctr" indent="0" marL="0">
-              <a:buNone/>
-            </a:pPr>
-            <a:r>
-              <a:rPr lang="en-US" sz="1400" dirty="0">
-                <a:solidFill>
-                  <a:srgbClr val="5C6F7B"/>
-                </a:solidFill>
-              </a:rPr>
-              <a:t>valore</a:t>
-            </a:r>
-            <a:endParaRPr lang="en-US" sz="1400" dirty="0"/>
-          </a:p>
-        </p:txBody>
-      </p:sp>
-      <p:sp>
-        <p:nvSpPr>
-          <p:cNvPr id="13" name="Text 11"/>
-          <p:cNvSpPr txBox="1"/>
-          <p:nvPr/>
-        </p:nvSpPr>
-        <p:spPr>
-          <a:xfrm>
-            <a:off x="6400800" y="1828800"/>
-            <a:ext cx="5212080" cy="3657600"/>
-          </a:xfrm>
-          <a:prstGeom prst="rect">
-            <a:avLst/>
-          </a:prstGeom>
-          <a:noFill/>
-          <a:ln/>
-        </p:spPr>
-        <p:txBody>
-          <a:bodyPr wrap="square" lIns="0" tIns="0" rIns="0" bIns="0" rtlCol="0" anchor="t"/>
-          <a:lstStyle/>
-          <a:p>
-            <a:pPr marL="342900" indent="-342900">
-              <a:spcAft>
-                <a:spcPts val="1000"/>
-              </a:spcAft>
-              <a:buSzPct val="100000"/>
-              <a:buChar char="•"/>
-            </a:pPr>
-            <a:r>
-              <a:rPr lang="en-US" sz="2000" dirty="0">
-                <a:solidFill>
-                  <a:srgbClr val="1F2A30"/>
-                </a:solidFill>
-              </a:rPr>
-              <a:t>Un'etichetta attaccata a un valore</a:t>
-            </a:r>
-            <a:endParaRPr lang="en-US" sz="2000" dirty="0"/>
-          </a:p>
-          <a:p>
-            <a:pPr marL="342900" indent="-342900">
-              <a:spcAft>
-                <a:spcPts val="1000"/>
-              </a:spcAft>
-              <a:buSzPct val="100000"/>
-              <a:buChar char="•"/>
-            </a:pPr>
-            <a:r>
-              <a:rPr lang="en-US" sz="2000" dirty="0">
-                <a:solidFill>
-                  <a:srgbClr val="1F2A30"/>
-                </a:solidFill>
-              </a:rPr>
-              <a:t>Il valore si può cambiare quando vuoi</a:t>
-            </a:r>
-            <a:endParaRPr lang="en-US" sz="2000" dirty="0"/>
-          </a:p>
-          <a:p>
-            <a:pPr marL="342900" indent="-342900">
-              <a:spcAft>
-                <a:spcPts val="1000"/>
-              </a:spcAft>
-              <a:buSzPct val="100000"/>
-              <a:buChar char="•"/>
-            </a:pPr>
-            <a:r>
-              <a:rPr lang="en-US" sz="2000" dirty="0">
-                <a:solidFill>
-                  <a:srgbClr val="1F2A30"/>
-                </a:solidFill>
-              </a:rPr>
-              <a:t>Il nome lo scegli tu: meglio se dice cosa contiene</a:t>
-            </a:r>
-            <a:endParaRPr lang="en-US" sz="2000" dirty="0"/>
-          </a:p>
-          <a:p>
-            <a:pPr marL="342900" indent="-342900">
-              <a:spcAft>
-                <a:spcPts val="1000"/>
-              </a:spcAft>
-              <a:buSzPct val="100000"/>
-              <a:buChar char="•"/>
-            </a:pPr>
-            <a:r>
-              <a:rPr lang="en-US" sz="2000" dirty="0">
-                <a:solidFill>
-                  <a:srgbClr val="1F2A30"/>
-                </a:solidFill>
-              </a:rPr>
-              <a:t>= non è «uguale»: è «metti questo valore qui»</a:t>
-            </a:r>
-            <a:endParaRPr lang="en-US" sz="2000" dirty="0"/>
-          </a:p>
-        </p:txBody>
-      </p:sp>
-      <p:sp>
-        <p:nvSpPr>
-          <p:cNvPr id="25" name="Slide Number Placeholder 0"/>
-          <p:cNvSpPr>
-            <a:spLocks noGrp="1"/>
-          </p:cNvSpPr>
-          <p:nvPr>
-            <p:ph type="sldNum" sz="quarter" idx="4294967295"/>
-          </p:nvPr>
-        </p:nvSpPr>
-        <p:spPr>
-          <a:xfrm>
-            <a:off x="11155680" y="6400800"/>
-            <a:ext cx="457200" cy="274320"/>
-          </a:xfrm>
-          <a:prstGeom prst="rect">
-            <a:avLst/>
-          </a:prstGeom>
-          <a:extLst>
-            <a:ext uri="{C572A759-6A51-4108-AA02-DFA0A04FC94B}">
-              <ma14:wrappingTextBoxFlag xmlns:ma14="http://schemas.microsoft.com/office/mac/drawingml/2011/main" val="0"/>
-            </a:ext>
-          </a:extLst>
-        </p:spPr>
-        <p:txBody>
-          <a:bodyPr/>
-          <a:lstStyle>
-            <a:lvl1pPr>
-              <a:defRPr sz="1000">
-                <a:solidFill>
-                  <a:srgbClr val="5C6F7B"/>
-                </a:solidFill>
-              </a:defRPr>
-            </a:lvl1pPr>
-          </a:lstStyle>
-          <a:p>
-            <a:pPr algn="r"/>
-            <a:fld id="{F7021451-1387-4CA6-816F-3879F97B5CBC}" type="slidenum">
-              <a:rPr b="0" lang="en-US"/>
-              <a:t>10</a:t>
-            </a:fld>
-            <a:endParaRPr lang="en-US"/>
-          </a:p>
-        </p:txBody>
-      </p:sp>
-    </p:spTree>
-  </p:cSld>
-  <p:clrMapOvr>
-    <a:masterClrMapping/>
-  </p:clrMapOvr>
-</p:sld>
-</file>
-
-<file path=ppt/slides/slide11.xml><?xml version="1.0" encoding="utf-8"?>
-<p:sld xmlns:a="http://schemas.openxmlformats.org/drawingml/2006/main" xmlns:r="http://schemas.openxmlformats.org/officeDocument/2006/relationships" xmlns:p="http://schemas.openxmlformats.org/presentationml/2006/main">
-  <p:cSld name="Slide 11">
-    <p:spTree>
-      <p:nvGrpSpPr>
-        <p:cNvPr id="1" name=""/>
-        <p:cNvGrpSpPr/>
-        <p:nvPr/>
-      </p:nvGrpSpPr>
-      <p:grpSpPr>
-        <a:xfrm>
-          <a:off x="0" y="0"/>
-          <a:ext cx="0" cy="0"/>
-          <a:chOff x="0" y="0"/>
-          <a:chExt cx="0" cy="0"/>
-        </a:xfrm>
-      </p:grpSpPr>
-      <p:sp>
-        <p:nvSpPr>
-          <p:cNvPr id="2" name="Text 0"/>
-          <p:cNvSpPr/>
-          <p:nvPr>
-            <p:ph idx="100" type="title" hasCustomPrompt="1"/>
-          </p:nvPr>
-        </p:nvSpPr>
-        <p:spPr>
-          <a:xfrm>
-            <a:off x="548640" y="365760"/>
-            <a:ext cx="11064240" cy="822960"/>
-          </a:xfrm>
-          <a:prstGeom prst="rect">
-            <a:avLst/>
-          </a:prstGeom>
-          <a:noFill/>
-          <a:ln/>
-        </p:spPr>
-        <p:txBody>
-          <a:bodyPr wrap="square" lIns="0" tIns="0" rIns="0" bIns="0" rtlCol="0" anchor="ctr"/>
-          <a:lstStyle/>
-          <a:p>
-            <a:pPr algn="l" indent="0" marL="0">
-              <a:buNone/>
-            </a:pPr>
-            <a:r>
-              <a:rPr lang="en-US" sz="3600" b="1" dirty="0">
-                <a:solidFill>
-                  <a:srgbClr val="0F4C5C"/>
-                </a:solidFill>
-              </a:rPr>
-              <a:t>Tipi di dato</a:t>
-            </a:r>
-            <a:endParaRPr lang="en-US" sz="3600" dirty="0"/>
-          </a:p>
-        </p:txBody>
-      </p:sp>
-      <p:graphicFrame>
-        <p:nvGraphicFramePr>
-          <p:cNvPr id="12" name="Table 0"/>
-          <p:cNvGraphicFramePr>
-            <a:graphicFrameLocks noGrp="1"/>
-          </p:cNvGraphicFramePr>
-          <p:nvPr>
-            <p:extLst>
-              <p:ext uri="{D42A27DB-BD31-4B8C-83A1-F6EECF244321}">
-                <p14:modId xmlns:p14="http://schemas.microsoft.com/office/powerpoint/2010/main" val="1579011935"/>
-              </p:ext>
-            </p:extLst>
-          </p:nvPr>
-        </p:nvGraphicFramePr>
-        <p:xfrm>
-          <a:off x="548640" y="1737360"/>
-          <a:ext cx="6583680" cy="914400"/>
-        </p:xfrm>
-        <a:graphic>
-          <a:graphicData uri="http://schemas.openxmlformats.org/drawingml/2006/table">
-            <a:tbl>
-              <a:tblPr/>
-              <a:tblGrid>
-                <a:gridCol w="1645920"/>
-                <a:gridCol w="2011680"/>
-                <a:gridCol w="2926080"/>
-              </a:tblGrid>
-              <a:tr h="566928">
-                <a:tc>
-                  <a:txBody>
-                    <a:bodyPr/>
-                    <a:lstStyle/>
-                    <a:p>
-                      <a:pPr indent="0" marL="0">
-                        <a:buNone/>
-                      </a:pPr>
-                      <a:r>
-                        <a:rPr lang="en-US" sz="1600" b="1" dirty="0">
-                          <a:solidFill>
-                            <a:srgbClr val="FFFFFF"/>
-                          </a:solidFill>
-                        </a:rPr>
-                        <a:t>Tipo</a:t>
-                      </a:r>
-                      <a:endParaRPr lang="en-US" sz="1600" dirty="0"/>
-                    </a:p>
-                  </a:txBody>
-                  <a:tcPr marL="109728" marR="109728" marT="109728" marB="109728">
-                    <a:lnL w="0" cap="flat" cmpd="sng" algn="ctr">
-                      <a:noFill/>
-                    </a:lnL>
-                    <a:lnR w="0" cap="flat" cmpd="sng" algn="ctr">
-                      <a:noFill/>
-                    </a:lnR>
-                    <a:lnT w="0" cap="flat" cmpd="sng" algn="ctr">
-                      <a:noFill/>
-                    </a:lnT>
-                    <a:lnB w="0" cap="flat" cmpd="sng" algn="ctr">
-                      <a:noFill/>
-                    </a:lnB>
-                    <a:solidFill>
-                      <a:srgbClr val="0F4C5C"/>
-                    </a:solidFill>
-                  </a:tcPr>
-                </a:tc>
-                <a:tc>
-                  <a:txBody>
-                    <a:bodyPr/>
-                    <a:lstStyle/>
-                    <a:p>
-                      <a:pPr indent="0" marL="0">
-                        <a:buNone/>
-                      </a:pPr>
-                      <a:r>
-                        <a:rPr lang="en-US" sz="1600" b="1" dirty="0">
-                          <a:solidFill>
-                            <a:srgbClr val="FFFFFF"/>
-                          </a:solidFill>
-                        </a:rPr>
-                        <a:t>Esempio</a:t>
-                      </a:r>
-                      <a:endParaRPr lang="en-US" sz="1600" dirty="0"/>
-                    </a:p>
-                  </a:txBody>
-                  <a:tcPr marL="109728" marR="109728" marT="109728" marB="109728">
-                    <a:lnL w="0" cap="flat" cmpd="sng" algn="ctr">
-                      <a:noFill/>
-                    </a:lnL>
-                    <a:lnR w="0" cap="flat" cmpd="sng" algn="ctr">
-                      <a:noFill/>
-                    </a:lnR>
-                    <a:lnT w="0" cap="flat" cmpd="sng" algn="ctr">
-                      <a:noFill/>
-                    </a:lnT>
-                    <a:lnB w="0" cap="flat" cmpd="sng" algn="ctr">
-                      <a:noFill/>
-                    </a:lnB>
-                    <a:solidFill>
-                      <a:srgbClr val="0F4C5C"/>
-                    </a:solidFill>
-                  </a:tcPr>
-                </a:tc>
-                <a:tc>
-                  <a:txBody>
-                    <a:bodyPr/>
-                    <a:lstStyle/>
-                    <a:p>
-                      <a:pPr indent="0" marL="0">
-                        <a:buNone/>
-                      </a:pPr>
-                      <a:r>
-                        <a:rPr lang="en-US" sz="1600" b="1" dirty="0">
-                          <a:solidFill>
-                            <a:srgbClr val="FFFFFF"/>
-                          </a:solidFill>
-                        </a:rPr>
-                        <a:t>Cos'è</a:t>
-                      </a:r>
-                      <a:endParaRPr lang="en-US" sz="1600" dirty="0"/>
-                    </a:p>
-                  </a:txBody>
-                  <a:tcPr marL="109728" marR="109728" marT="109728" marB="109728">
-                    <a:lnL w="0" cap="flat" cmpd="sng" algn="ctr">
-                      <a:noFill/>
-                    </a:lnL>
-                    <a:lnR w="0" cap="flat" cmpd="sng" algn="ctr">
-                      <a:noFill/>
-                    </a:lnR>
-                    <a:lnT w="0" cap="flat" cmpd="sng" algn="ctr">
-                      <a:noFill/>
-                    </a:lnT>
-                    <a:lnB w="0" cap="flat" cmpd="sng" algn="ctr">
-                      <a:noFill/>
-                    </a:lnB>
-                    <a:solidFill>
-                      <a:srgbClr val="0F4C5C"/>
-                    </a:solidFill>
-                  </a:tcPr>
-                </a:tc>
-              </a:tr>
-              <a:tr h="566928">
-                <a:tc>
-                  <a:txBody>
-                    <a:bodyPr/>
-                    <a:lstStyle/>
-                    <a:p>
-                      <a:pPr indent="0" marL="0">
-                        <a:buNone/>
-                      </a:pPr>
-                      <a:r>
-                        <a:rPr lang="en-US" sz="1800" dirty="0">
-                          <a:solidFill>
-                            <a:srgbClr val="1F2A30"/>
-                          </a:solidFill>
-                          <a:latin typeface="Courier New" pitchFamily="34" charset="0"/>
-                          <a:ea typeface="Courier New" pitchFamily="34" charset="-122"/>
-                          <a:cs typeface="Courier New" pitchFamily="34" charset="-120"/>
-                        </a:rPr>
-                        <a:t>int</a:t>
-                      </a:r>
-                      <a:endParaRPr lang="en-US" sz="1800" dirty="0">
-                        <a:latin typeface="Courier New" charset="0"/>
-                        <a:ea typeface="Courier New" charset="0"/>
-                        <a:cs typeface="Courier New" charset="0"/>
-                      </a:endParaRPr>
-                    </a:p>
-                  </a:txBody>
-                  <a:tcPr marL="109728" marR="109728" marT="109728" marB="109728">
-                    <a:lnL w="0" cap="flat" cmpd="sng" algn="ctr">
-                      <a:noFill/>
-                    </a:lnL>
-                    <a:lnR w="0" cap="flat" cmpd="sng" algn="ctr">
-                      <a:noFill/>
-                    </a:lnR>
-                    <a:lnT w="0" cap="flat" cmpd="sng" algn="ctr">
-                      <a:noFill/>
-                    </a:lnT>
-                    <a:lnB w="0" cap="flat" cmpd="sng" algn="ctr">
-                      <a:noFill/>
-                    </a:lnB>
-                    <a:solidFill>
-                      <a:srgbClr val="FFFFFF"/>
-                    </a:solidFill>
-                  </a:tcPr>
-                </a:tc>
-                <a:tc>
-                  <a:txBody>
-                    <a:bodyPr/>
-                    <a:lstStyle/>
-                    <a:p>
-                      <a:pPr indent="0" marL="0">
-                        <a:buNone/>
-                      </a:pPr>
-                      <a:r>
-                        <a:rPr lang="en-US" sz="1800" dirty="0">
-                          <a:solidFill>
-                            <a:srgbClr val="1F2A30"/>
-                          </a:solidFill>
-                          <a:latin typeface="Courier New" pitchFamily="34" charset="0"/>
-                          <a:ea typeface="Courier New" pitchFamily="34" charset="-122"/>
-                          <a:cs typeface="Courier New" pitchFamily="34" charset="-120"/>
-                        </a:rPr>
-                        <a:t>5000</a:t>
-                      </a:r>
-                      <a:endParaRPr lang="en-US" sz="1800" dirty="0">
-                        <a:latin typeface="Courier New" charset="0"/>
-                        <a:ea typeface="Courier New" charset="0"/>
-                        <a:cs typeface="Courier New" charset="0"/>
-                      </a:endParaRPr>
-                    </a:p>
-                  </a:txBody>
-                  <a:tcPr marL="109728" marR="109728" marT="109728" marB="109728">
-                    <a:lnL w="0" cap="flat" cmpd="sng" algn="ctr">
-                      <a:noFill/>
-                    </a:lnL>
-                    <a:lnR w="0" cap="flat" cmpd="sng" algn="ctr">
-                      <a:noFill/>
-                    </a:lnR>
-                    <a:lnT w="0" cap="flat" cmpd="sng" algn="ctr">
-                      <a:noFill/>
-                    </a:lnT>
-                    <a:lnB w="0" cap="flat" cmpd="sng" algn="ctr">
-                      <a:noFill/>
-                    </a:lnB>
-                    <a:solidFill>
-                      <a:srgbClr val="FFFFFF"/>
-                    </a:solidFill>
-                  </a:tcPr>
-                </a:tc>
-                <a:tc>
-                  <a:txBody>
-                    <a:bodyPr/>
-                    <a:lstStyle/>
-                    <a:p>
-                      <a:pPr indent="0" marL="0">
-                        <a:buNone/>
-                      </a:pPr>
-                      <a:r>
-                        <a:rPr lang="en-US" sz="1800" dirty="0">
-                          <a:solidFill>
-                            <a:srgbClr val="1F2A30"/>
-                          </a:solidFill>
-                        </a:rPr>
-                        <a:t>numero intero</a:t>
-                      </a:r>
-                      <a:endParaRPr lang="en-US" sz="1800" dirty="0"/>
-                    </a:p>
-                  </a:txBody>
-                  <a:tcPr marL="109728" marR="109728" marT="109728" marB="109728">
-                    <a:lnL w="0" cap="flat" cmpd="sng" algn="ctr">
-                      <a:noFill/>
-                    </a:lnL>
-                    <a:lnR w="0" cap="flat" cmpd="sng" algn="ctr">
-                      <a:noFill/>
-                    </a:lnR>
-                    <a:lnT w="0" cap="flat" cmpd="sng" algn="ctr">
-                      <a:noFill/>
-                    </a:lnT>
-                    <a:lnB w="0" cap="flat" cmpd="sng" algn="ctr">
-                      <a:noFill/>
-                    </a:lnB>
-                    <a:solidFill>
-                      <a:srgbClr val="FFFFFF"/>
-                    </a:solidFill>
-                  </a:tcPr>
-                </a:tc>
-              </a:tr>
-              <a:tr h="566928">
-                <a:tc>
-                  <a:txBody>
-                    <a:bodyPr/>
-                    <a:lstStyle/>
-                    <a:p>
-                      <a:pPr indent="0" marL="0">
-                        <a:buNone/>
-                      </a:pPr>
-                      <a:r>
-                        <a:rPr lang="en-US" sz="1800" dirty="0">
-                          <a:solidFill>
-                            <a:srgbClr val="1F2A30"/>
-                          </a:solidFill>
-                          <a:latin typeface="Courier New" pitchFamily="34" charset="0"/>
-                          <a:ea typeface="Courier New" pitchFamily="34" charset="-122"/>
-                          <a:cs typeface="Courier New" pitchFamily="34" charset="-120"/>
-                        </a:rPr>
-                        <a:t>float</a:t>
-                      </a:r>
-                      <a:endParaRPr lang="en-US" sz="1800" dirty="0">
-                        <a:latin typeface="Courier New" charset="0"/>
-                        <a:ea typeface="Courier New" charset="0"/>
-                        <a:cs typeface="Courier New" charset="0"/>
-                      </a:endParaRPr>
-                    </a:p>
-                  </a:txBody>
-                  <a:tcPr marL="109728" marR="109728" marT="109728" marB="109728">
-                    <a:lnL w="0" cap="flat" cmpd="sng" algn="ctr">
-                      <a:noFill/>
-                    </a:lnL>
-                    <a:lnR w="0" cap="flat" cmpd="sng" algn="ctr">
-                      <a:noFill/>
-                    </a:lnR>
-                    <a:lnT w="0" cap="flat" cmpd="sng" algn="ctr">
-                      <a:noFill/>
-                    </a:lnT>
-                    <a:lnB w="0" cap="flat" cmpd="sng" algn="ctr">
-                      <a:noFill/>
-                    </a:lnB>
-                    <a:solidFill>
-                      <a:srgbClr val="EEF3F4"/>
-                    </a:solidFill>
-                  </a:tcPr>
-                </a:tc>
-                <a:tc>
-                  <a:txBody>
-                    <a:bodyPr/>
-                    <a:lstStyle/>
-                    <a:p>
-                      <a:pPr indent="0" marL="0">
-                        <a:buNone/>
-                      </a:pPr>
-                      <a:r>
-                        <a:rPr lang="en-US" sz="1800" dirty="0">
-                          <a:solidFill>
-                            <a:srgbClr val="1F2A30"/>
-                          </a:solidFill>
-                          <a:latin typeface="Courier New" pitchFamily="34" charset="0"/>
-                          <a:ea typeface="Courier New" pitchFamily="34" charset="-122"/>
-                          <a:cs typeface="Courier New" pitchFamily="34" charset="-120"/>
-                        </a:rPr>
-                        <a:t>0.025</a:t>
-                      </a:r>
-                      <a:endParaRPr lang="en-US" sz="1800" dirty="0">
-                        <a:latin typeface="Courier New" charset="0"/>
-                        <a:ea typeface="Courier New" charset="0"/>
-                        <a:cs typeface="Courier New" charset="0"/>
-                      </a:endParaRPr>
-                    </a:p>
-                  </a:txBody>
-                  <a:tcPr marL="109728" marR="109728" marT="109728" marB="109728">
-                    <a:lnL w="0" cap="flat" cmpd="sng" algn="ctr">
-                      <a:noFill/>
-                    </a:lnL>
-                    <a:lnR w="0" cap="flat" cmpd="sng" algn="ctr">
-                      <a:noFill/>
-                    </a:lnR>
-                    <a:lnT w="0" cap="flat" cmpd="sng" algn="ctr">
-                      <a:noFill/>
-                    </a:lnT>
-                    <a:lnB w="0" cap="flat" cmpd="sng" algn="ctr">
-                      <a:noFill/>
-                    </a:lnB>
-                    <a:solidFill>
-                      <a:srgbClr val="EEF3F4"/>
-                    </a:solidFill>
-                  </a:tcPr>
-                </a:tc>
-                <a:tc>
-                  <a:txBody>
-                    <a:bodyPr/>
-                    <a:lstStyle/>
-                    <a:p>
-                      <a:pPr indent="0" marL="0">
-                        <a:buNone/>
-                      </a:pPr>
-                      <a:r>
-                        <a:rPr lang="en-US" sz="1800" dirty="0">
-                          <a:solidFill>
-                            <a:srgbClr val="1F2A30"/>
-                          </a:solidFill>
-                        </a:rPr>
-                        <a:t>numero decimale</a:t>
-                      </a:r>
-                      <a:endParaRPr lang="en-US" sz="1800" dirty="0"/>
-                    </a:p>
-                  </a:txBody>
-                  <a:tcPr marL="109728" marR="109728" marT="109728" marB="109728">
-                    <a:lnL w="0" cap="flat" cmpd="sng" algn="ctr">
-                      <a:noFill/>
-                    </a:lnL>
-                    <a:lnR w="0" cap="flat" cmpd="sng" algn="ctr">
-                      <a:noFill/>
-                    </a:lnR>
-                    <a:lnT w="0" cap="flat" cmpd="sng" algn="ctr">
-                      <a:noFill/>
-                    </a:lnT>
-                    <a:lnB w="0" cap="flat" cmpd="sng" algn="ctr">
-                      <a:noFill/>
-                    </a:lnB>
-                    <a:solidFill>
-                      <a:srgbClr val="EEF3F4"/>
-                    </a:solidFill>
-                  </a:tcPr>
-                </a:tc>
-              </a:tr>
-              <a:tr h="566928">
-                <a:tc>
-                  <a:txBody>
-                    <a:bodyPr/>
-                    <a:lstStyle/>
-                    <a:p>
-                      <a:pPr indent="0" marL="0">
-                        <a:buNone/>
-                      </a:pPr>
-                      <a:r>
-                        <a:rPr lang="en-US" sz="1800" dirty="0">
-                          <a:solidFill>
-                            <a:srgbClr val="1F2A30"/>
-                          </a:solidFill>
-                          <a:latin typeface="Courier New" pitchFamily="34" charset="0"/>
-                          <a:ea typeface="Courier New" pitchFamily="34" charset="-122"/>
-                          <a:cs typeface="Courier New" pitchFamily="34" charset="-120"/>
-                        </a:rPr>
-                        <a:t>str</a:t>
-                      </a:r>
-                      <a:endParaRPr lang="en-US" sz="1800" dirty="0">
-                        <a:latin typeface="Courier New" charset="0"/>
-                        <a:ea typeface="Courier New" charset="0"/>
-                        <a:cs typeface="Courier New" charset="0"/>
-                      </a:endParaRPr>
-                    </a:p>
-                  </a:txBody>
-                  <a:tcPr marL="109728" marR="109728" marT="109728" marB="109728">
-                    <a:lnL w="0" cap="flat" cmpd="sng" algn="ctr">
-                      <a:noFill/>
-                    </a:lnL>
-                    <a:lnR w="0" cap="flat" cmpd="sng" algn="ctr">
-                      <a:noFill/>
-                    </a:lnR>
-                    <a:lnT w="0" cap="flat" cmpd="sng" algn="ctr">
-                      <a:noFill/>
-                    </a:lnT>
-                    <a:lnB w="0" cap="flat" cmpd="sng" algn="ctr">
-                      <a:noFill/>
-                    </a:lnB>
-                    <a:solidFill>
-                      <a:srgbClr val="FFFFFF"/>
-                    </a:solidFill>
-                  </a:tcPr>
-                </a:tc>
-                <a:tc>
-                  <a:txBody>
-                    <a:bodyPr/>
-                    <a:lstStyle/>
-                    <a:p>
-                      <a:pPr indent="0" marL="0">
-                        <a:buNone/>
-                      </a:pPr>
-                      <a:r>
-                        <a:rPr lang="en-US" sz="1800" dirty="0">
-                          <a:solidFill>
-                            <a:srgbClr val="1F2A30"/>
-                          </a:solidFill>
-                          <a:latin typeface="Courier New" pitchFamily="34" charset="0"/>
-                          <a:ea typeface="Courier New" pitchFamily="34" charset="-122"/>
-                          <a:cs typeface="Courier New" pitchFamily="34" charset="-120"/>
-                        </a:rPr>
-                        <a:t>"5000"</a:t>
-                      </a:r>
-                      <a:endParaRPr lang="en-US" sz="1800" dirty="0">
-                        <a:latin typeface="Courier New" charset="0"/>
-                        <a:ea typeface="Courier New" charset="0"/>
-                        <a:cs typeface="Courier New" charset="0"/>
-                      </a:endParaRPr>
-                    </a:p>
-                  </a:txBody>
-                  <a:tcPr marL="109728" marR="109728" marT="109728" marB="109728">
-                    <a:lnL w="0" cap="flat" cmpd="sng" algn="ctr">
-                      <a:noFill/>
-                    </a:lnL>
-                    <a:lnR w="0" cap="flat" cmpd="sng" algn="ctr">
-                      <a:noFill/>
-                    </a:lnR>
-                    <a:lnT w="0" cap="flat" cmpd="sng" algn="ctr">
-                      <a:noFill/>
-                    </a:lnT>
-                    <a:lnB w="0" cap="flat" cmpd="sng" algn="ctr">
-                      <a:noFill/>
-                    </a:lnB>
-                    <a:solidFill>
-                      <a:srgbClr val="FFFFFF"/>
-                    </a:solidFill>
-                  </a:tcPr>
-                </a:tc>
-                <a:tc>
-                  <a:txBody>
-                    <a:bodyPr/>
-                    <a:lstStyle/>
-                    <a:p>
-                      <a:pPr indent="0" marL="0">
-                        <a:buNone/>
-                      </a:pPr>
-                      <a:r>
-                        <a:rPr lang="en-US" sz="1800" dirty="0">
-                          <a:solidFill>
-                            <a:srgbClr val="1F2A30"/>
-                          </a:solidFill>
-                        </a:rPr>
-                        <a:t>testo, tra virgolette</a:t>
-                      </a:r>
-                      <a:endParaRPr lang="en-US" sz="1800" dirty="0"/>
-                    </a:p>
-                  </a:txBody>
-                  <a:tcPr marL="109728" marR="109728" marT="109728" marB="109728">
-                    <a:lnL w="0" cap="flat" cmpd="sng" algn="ctr">
-                      <a:noFill/>
-                    </a:lnL>
-                    <a:lnR w="0" cap="flat" cmpd="sng" algn="ctr">
-                      <a:noFill/>
-                    </a:lnR>
-                    <a:lnT w="0" cap="flat" cmpd="sng" algn="ctr">
-                      <a:noFill/>
-                    </a:lnT>
-                    <a:lnB w="0" cap="flat" cmpd="sng" algn="ctr">
-                      <a:noFill/>
-                    </a:lnB>
-                    <a:solidFill>
-                      <a:srgbClr val="FFFFFF"/>
-                    </a:solidFill>
-                  </a:tcPr>
-                </a:tc>
-              </a:tr>
-              <a:tr h="566928">
-                <a:tc>
-                  <a:txBody>
-                    <a:bodyPr/>
-                    <a:lstStyle/>
-                    <a:p>
-                      <a:pPr indent="0" marL="0">
-                        <a:buNone/>
-                      </a:pPr>
-                      <a:r>
-                        <a:rPr lang="en-US" sz="1800" dirty="0">
-                          <a:solidFill>
-                            <a:srgbClr val="1F2A30"/>
-                          </a:solidFill>
-                          <a:latin typeface="Courier New" pitchFamily="34" charset="0"/>
-                          <a:ea typeface="Courier New" pitchFamily="34" charset="-122"/>
-                          <a:cs typeface="Courier New" pitchFamily="34" charset="-120"/>
-                        </a:rPr>
-                        <a:t>bool</a:t>
-                      </a:r>
-                      <a:endParaRPr lang="en-US" sz="1800" dirty="0">
-                        <a:latin typeface="Courier New" charset="0"/>
-                        <a:ea typeface="Courier New" charset="0"/>
-                        <a:cs typeface="Courier New" charset="0"/>
-                      </a:endParaRPr>
-                    </a:p>
-                  </a:txBody>
-                  <a:tcPr marL="109728" marR="109728" marT="109728" marB="109728">
-                    <a:lnL w="0" cap="flat" cmpd="sng" algn="ctr">
-                      <a:noFill/>
-                    </a:lnL>
-                    <a:lnR w="0" cap="flat" cmpd="sng" algn="ctr">
-                      <a:noFill/>
-                    </a:lnR>
-                    <a:lnT w="0" cap="flat" cmpd="sng" algn="ctr">
-                      <a:noFill/>
-                    </a:lnT>
-                    <a:lnB w="0" cap="flat" cmpd="sng" algn="ctr">
-                      <a:noFill/>
-                    </a:lnB>
-                    <a:solidFill>
-                      <a:srgbClr val="EEF3F4"/>
-                    </a:solidFill>
-                  </a:tcPr>
-                </a:tc>
-                <a:tc>
-                  <a:txBody>
-                    <a:bodyPr/>
-                    <a:lstStyle/>
-                    <a:p>
-                      <a:pPr indent="0" marL="0">
-                        <a:buNone/>
-                      </a:pPr>
-                      <a:r>
-                        <a:rPr lang="en-US" sz="1800" dirty="0">
-                          <a:solidFill>
-                            <a:srgbClr val="1F2A30"/>
-                          </a:solidFill>
-                          <a:latin typeface="Courier New" pitchFamily="34" charset="0"/>
-                          <a:ea typeface="Courier New" pitchFamily="34" charset="-122"/>
-                          <a:cs typeface="Courier New" pitchFamily="34" charset="-120"/>
-                        </a:rPr>
-                        <a:t>True</a:t>
-                      </a:r>
-                      <a:endParaRPr lang="en-US" sz="1800" dirty="0">
-                        <a:latin typeface="Courier New" charset="0"/>
-                        <a:ea typeface="Courier New" charset="0"/>
-                        <a:cs typeface="Courier New" charset="0"/>
-                      </a:endParaRPr>
-                    </a:p>
-                  </a:txBody>
-                  <a:tcPr marL="109728" marR="109728" marT="109728" marB="109728">
-                    <a:lnL w="0" cap="flat" cmpd="sng" algn="ctr">
-                      <a:noFill/>
-                    </a:lnL>
-                    <a:lnR w="0" cap="flat" cmpd="sng" algn="ctr">
-                      <a:noFill/>
-                    </a:lnR>
-                    <a:lnT w="0" cap="flat" cmpd="sng" algn="ctr">
-                      <a:noFill/>
-                    </a:lnT>
-                    <a:lnB w="0" cap="flat" cmpd="sng" algn="ctr">
-                      <a:noFill/>
-                    </a:lnB>
-                    <a:solidFill>
-                      <a:srgbClr val="EEF3F4"/>
-                    </a:solidFill>
-                  </a:tcPr>
-                </a:tc>
-                <a:tc>
-                  <a:txBody>
-                    <a:bodyPr/>
-                    <a:lstStyle/>
-                    <a:p>
-                      <a:pPr indent="0" marL="0">
-                        <a:buNone/>
-                      </a:pPr>
-                      <a:r>
-                        <a:rPr lang="en-US" sz="1800" dirty="0">
-                          <a:solidFill>
-                            <a:srgbClr val="1F2A30"/>
-                          </a:solidFill>
-                        </a:rPr>
-                        <a:t>vero o falso</a:t>
-                      </a:r>
-                      <a:endParaRPr lang="en-US" sz="1800" dirty="0"/>
-                    </a:p>
-                  </a:txBody>
-                  <a:tcPr marL="109728" marR="109728" marT="109728" marB="109728">
-                    <a:lnL w="0" cap="flat" cmpd="sng" algn="ctr">
-                      <a:noFill/>
-                    </a:lnL>
-                    <a:lnR w="0" cap="flat" cmpd="sng" algn="ctr">
-                      <a:noFill/>
-                    </a:lnR>
-                    <a:lnT w="0" cap="flat" cmpd="sng" algn="ctr">
-                      <a:noFill/>
-                    </a:lnT>
-                    <a:lnB w="0" cap="flat" cmpd="sng" algn="ctr">
-                      <a:noFill/>
-                    </a:lnB>
-                    <a:solidFill>
-                      <a:srgbClr val="EEF3F4"/>
-                    </a:solidFill>
-                  </a:tcPr>
-                </a:tc>
-              </a:tr>
-            </a:tbl>
-          </a:graphicData>
-        </a:graphic>
-      </p:graphicFrame>
-      <p:sp>
-        <p:nvSpPr>
-          <p:cNvPr id="4" name="Text 1"/>
-          <p:cNvSpPr txBox="1"/>
-          <p:nvPr/>
-        </p:nvSpPr>
-        <p:spPr>
-          <a:xfrm>
-            <a:off x="548640" y="4846320"/>
-            <a:ext cx="6583680" cy="457200"/>
-          </a:xfrm>
-          <a:prstGeom prst="rect">
-            <a:avLst/>
-          </a:prstGeom>
-          <a:noFill/>
-          <a:ln/>
-        </p:spPr>
-        <p:txBody>
-          <a:bodyPr wrap="square" lIns="0" tIns="0" rIns="0" bIns="0" rtlCol="0" anchor="ctr"/>
-          <a:lstStyle/>
-          <a:p>
-            <a:pPr indent="0" marL="0">
-              <a:buNone/>
-            </a:pPr>
-            <a:r>
-              <a:rPr lang="en-US" sz="1800" b="1" dirty="0">
-                <a:solidFill>
-                  <a:srgbClr val="1F2A30"/>
-                </a:solidFill>
-                <a:latin typeface="Courier New" pitchFamily="34" charset="0"/>
-                <a:ea typeface="Courier New" pitchFamily="34" charset="-122"/>
-                <a:cs typeface="Courier New" pitchFamily="34" charset="-120"/>
-              </a:rPr>
-              <a:t>type(x)</a:t>
-            </a:r>
-            <a:pPr indent="0" marL="0">
-              <a:buNone/>
-            </a:pPr>
-            <a:r>
-              <a:rPr lang="en-US" sz="1800" dirty="0">
-                <a:solidFill>
-                  <a:srgbClr val="1F2A30"/>
-                </a:solidFill>
-              </a:rPr>
-              <a:t> ti dice il tipo di x</a:t>
-            </a:r>
-            <a:endParaRPr lang="en-US" sz="1800" dirty="0"/>
-          </a:p>
-        </p:txBody>
-      </p:sp>
-      <p:sp>
-        <p:nvSpPr>
-          <p:cNvPr id="5" name="Shape 2"/>
-          <p:cNvSpPr/>
-          <p:nvPr/>
-        </p:nvSpPr>
-        <p:spPr>
-          <a:xfrm>
-            <a:off x="7589520" y="1737360"/>
-            <a:ext cx="4023360" cy="2834640"/>
-          </a:xfrm>
-          <a:prstGeom prst="roundRect">
-            <a:avLst>
-              <a:gd name="adj" fmla="val 3871"/>
-            </a:avLst>
-          </a:prstGeom>
-          <a:solidFill>
-            <a:srgbClr val="EEF3F4"/>
-          </a:solidFill>
-          <a:ln/>
-        </p:spPr>
-      </p:sp>
-      <p:sp>
-        <p:nvSpPr>
-          <p:cNvPr id="6" name="Text 3"/>
-          <p:cNvSpPr txBox="1"/>
-          <p:nvPr/>
-        </p:nvSpPr>
-        <p:spPr>
-          <a:xfrm>
-            <a:off x="7863840" y="1965960"/>
-            <a:ext cx="3474720" cy="365760"/>
-          </a:xfrm>
-          <a:prstGeom prst="rect">
-            <a:avLst/>
-          </a:prstGeom>
-          <a:noFill/>
-          <a:ln/>
-        </p:spPr>
-        <p:txBody>
-          <a:bodyPr wrap="square" lIns="0" tIns="0" rIns="0" bIns="0" rtlCol="0" anchor="ctr"/>
-          <a:lstStyle/>
-          <a:p>
-            <a:pPr indent="0" marL="0">
-              <a:buNone/>
-            </a:pPr>
-            <a:r>
-              <a:rPr lang="en-US" sz="1300" b="1" spc="200" kern="0" dirty="0">
-                <a:solidFill>
-                  <a:srgbClr val="8F5308"/>
-                </a:solidFill>
-              </a:rPr>
-              <a:t>ATTENZIONE</a:t>
-            </a:r>
-            <a:endParaRPr lang="en-US" sz="1300" dirty="0"/>
-          </a:p>
-        </p:txBody>
-      </p:sp>
-      <p:sp>
-        <p:nvSpPr>
-          <p:cNvPr id="7" name="Text 4"/>
-          <p:cNvSpPr txBox="1"/>
-          <p:nvPr/>
-        </p:nvSpPr>
-        <p:spPr>
-          <a:xfrm>
-            <a:off x="7863840" y="2423160"/>
-            <a:ext cx="3474720" cy="1920240"/>
-          </a:xfrm>
-          <a:prstGeom prst="rect">
-            <a:avLst/>
-          </a:prstGeom>
-          <a:noFill/>
-          <a:ln/>
-        </p:spPr>
-        <p:txBody>
-          <a:bodyPr wrap="square" lIns="0" tIns="0" rIns="0" bIns="0" rtlCol="0" anchor="t"/>
-          <a:lstStyle/>
-          <a:p>
-            <a:pPr indent="0" marL="0">
-              <a:spcAft>
-                <a:spcPts val="1200"/>
-              </a:spcAft>
-              <a:buNone/>
-            </a:pPr>
-            <a:r>
-              <a:rPr lang="en-US" sz="2000" dirty="0">
-                <a:solidFill>
-                  <a:srgbClr val="1F2A30"/>
-                </a:solidFill>
-              </a:rPr>
-              <a:t>I decimali si scrivono con il punto</a:t>
-            </a:r>
-            <a:endParaRPr lang="en-US" sz="2000" dirty="0"/>
-          </a:p>
-          <a:p>
-            <a:pPr indent="0" marL="0">
-              <a:spcAft>
-                <a:spcPts val="1200"/>
-              </a:spcAft>
-              <a:buNone/>
-            </a:pPr>
-            <a:r>
-              <a:rPr lang="en-US" sz="2000" b="1" dirty="0">
-                <a:solidFill>
-                  <a:srgbClr val="2E6B37"/>
-                </a:solidFill>
-                <a:latin typeface="Courier New" pitchFamily="34" charset="0"/>
-                <a:ea typeface="Courier New" pitchFamily="34" charset="-122"/>
-                <a:cs typeface="Courier New" pitchFamily="34" charset="-120"/>
-              </a:rPr>
-              <a:t>0.025</a:t>
-            </a:r>
-            <a:pPr indent="0" marL="0">
-              <a:spcAft>
-                <a:spcPts val="1200"/>
-              </a:spcAft>
-              <a:buNone/>
-            </a:pPr>
-            <a:r>
-              <a:rPr lang="en-US" sz="2000" dirty="0">
-                <a:solidFill>
-                  <a:srgbClr val="1F2A30"/>
-                </a:solidFill>
-              </a:rPr>
-              <a:t>  e non  </a:t>
-            </a:r>
-            <a:pPr indent="0" marL="0">
-              <a:spcAft>
-                <a:spcPts val="1200"/>
-              </a:spcAft>
-              <a:buNone/>
-            </a:pPr>
-            <a:r>
-              <a:rPr lang="en-US" sz="2000" b="1" dirty="0">
-                <a:solidFill>
-                  <a:srgbClr val="9E2A2B"/>
-                </a:solidFill>
-                <a:latin typeface="Courier New" pitchFamily="34" charset="0"/>
-                <a:ea typeface="Courier New" pitchFamily="34" charset="-122"/>
-                <a:cs typeface="Courier New" pitchFamily="34" charset="-120"/>
-              </a:rPr>
-              <a:t>0,025</a:t>
-            </a:r>
-            <a:endParaRPr lang="en-US" sz="2000" dirty="0"/>
-          </a:p>
-        </p:txBody>
-      </p:sp>
-      <p:sp>
-        <p:nvSpPr>
-          <p:cNvPr id="25" name="Slide Number Placeholder 0"/>
-          <p:cNvSpPr>
-            <a:spLocks noGrp="1"/>
-          </p:cNvSpPr>
-          <p:nvPr>
-            <p:ph type="sldNum" sz="quarter" idx="4294967295"/>
-          </p:nvPr>
-        </p:nvSpPr>
-        <p:spPr>
-          <a:xfrm>
-            <a:off x="11155680" y="6400800"/>
-            <a:ext cx="457200" cy="274320"/>
-          </a:xfrm>
-          <a:prstGeom prst="rect">
-            <a:avLst/>
-          </a:prstGeom>
-          <a:extLst>
-            <a:ext uri="{C572A759-6A51-4108-AA02-DFA0A04FC94B}">
-              <ma14:wrappingTextBoxFlag xmlns:ma14="http://schemas.microsoft.com/office/mac/drawingml/2011/main" val="0"/>
-            </a:ext>
-          </a:extLst>
-        </p:spPr>
-        <p:txBody>
-          <a:bodyPr/>
-          <a:lstStyle>
-            <a:lvl1pPr>
-              <a:defRPr sz="1000">
-                <a:solidFill>
-                  <a:srgbClr val="5C6F7B"/>
-                </a:solidFill>
-              </a:defRPr>
-            </a:lvl1pPr>
-          </a:lstStyle>
-          <a:p>
-            <a:pPr algn="r"/>
-            <a:fld id="{F7021451-1387-4CA6-816F-3879F97B5CBC}" type="slidenum">
-              <a:rPr b="0" lang="en-US"/>
-              <a:t>11</a:t>
-            </a:fld>
-            <a:endParaRPr lang="en-US"/>
-          </a:p>
-        </p:txBody>
-      </p:sp>
-    </p:spTree>
-  </p:cSld>
-  <p:clrMapOvr>
-    <a:masterClrMapping/>
-  </p:clrMapOvr>
-</p:sld>
-</file>
-
-<file path=ppt/slides/slide12.xml><?xml version="1.0" encoding="utf-8"?>
-<p:sld xmlns:a="http://schemas.openxmlformats.org/drawingml/2006/main" xmlns:r="http://schemas.openxmlformats.org/officeDocument/2006/relationships" xmlns:p="http://schemas.openxmlformats.org/presentationml/2006/main">
-  <p:cSld name="Slide 12">
-    <p:spTree>
-      <p:nvGrpSpPr>
-        <p:cNvPr id="1" name=""/>
-        <p:cNvGrpSpPr/>
-        <p:nvPr/>
-      </p:nvGrpSpPr>
-      <p:grpSpPr>
-        <a:xfrm>
-          <a:off x="0" y="0"/>
-          <a:ext cx="0" cy="0"/>
-          <a:chOff x="0" y="0"/>
-          <a:chExt cx="0" cy="0"/>
-        </a:xfrm>
-      </p:grpSpPr>
-      <p:sp>
-        <p:nvSpPr>
-          <p:cNvPr id="2" name="Text 0"/>
-          <p:cNvSpPr/>
-          <p:nvPr>
-            <p:ph idx="100" type="title" hasCustomPrompt="1"/>
-          </p:nvPr>
-        </p:nvSpPr>
-        <p:spPr>
-          <a:xfrm>
-            <a:off x="548640" y="365760"/>
-            <a:ext cx="11064240" cy="822960"/>
-          </a:xfrm>
-          <a:prstGeom prst="rect">
-            <a:avLst/>
-          </a:prstGeom>
-          <a:noFill/>
-          <a:ln/>
-        </p:spPr>
-        <p:txBody>
-          <a:bodyPr wrap="square" lIns="0" tIns="0" rIns="0" bIns="0" rtlCol="0" anchor="ctr"/>
-          <a:lstStyle/>
-          <a:p>
-            <a:pPr algn="l" indent="0" marL="0">
-              <a:buNone/>
-            </a:pPr>
-            <a:r>
-              <a:rPr lang="en-US" sz="3600" b="1" dirty="0">
-                <a:solidFill>
-                  <a:srgbClr val="0F4C5C"/>
-                </a:solidFill>
-              </a:rPr>
-              <a:t>La trappola del passo 6</a:t>
-            </a:r>
-            <a:endParaRPr lang="en-US" sz="3600" dirty="0"/>
-          </a:p>
-        </p:txBody>
-      </p:sp>
-      <p:sp>
-        <p:nvSpPr>
-          <p:cNvPr id="3" name="card-code"/>
-          <p:cNvSpPr/>
-          <p:nvPr/>
-        </p:nvSpPr>
-        <p:spPr>
-          <a:xfrm>
-            <a:off x="548640" y="1737360"/>
-            <a:ext cx="5577840" cy="1645920"/>
-          </a:xfrm>
-          <a:prstGeom prst="roundRect">
-            <a:avLst>
-              <a:gd name="adj" fmla="val 6667"/>
-            </a:avLst>
-          </a:prstGeom>
-          <a:solidFill>
-            <a:srgbClr val="1F2A30"/>
-          </a:solidFill>
-          <a:ln/>
-        </p:spPr>
-      </p:sp>
-      <p:sp>
-        <p:nvSpPr>
-          <p:cNvPr id="4" name="Text 2"/>
-          <p:cNvSpPr txBox="1"/>
-          <p:nvPr/>
-        </p:nvSpPr>
-        <p:spPr>
-          <a:xfrm>
-            <a:off x="777240" y="1874520"/>
-            <a:ext cx="1828800" cy="274320"/>
-          </a:xfrm>
-          <a:prstGeom prst="rect">
-            <a:avLst/>
-          </a:prstGeom>
-          <a:noFill/>
-          <a:ln/>
-        </p:spPr>
-        <p:txBody>
-          <a:bodyPr wrap="square" lIns="0" tIns="0" rIns="0" bIns="0" rtlCol="0" anchor="ctr"/>
-          <a:lstStyle/>
-          <a:p>
-            <a:pPr indent="0" marL="0">
-              <a:buNone/>
-            </a:pPr>
-            <a:r>
-              <a:rPr lang="en-US" sz="1100" b="1" spc="200" kern="0" dirty="0">
-                <a:solidFill>
-                  <a:srgbClr val="E09F3E"/>
-                </a:solidFill>
-              </a:rPr>
-              <a:t>PYTHON</a:t>
-            </a:r>
-            <a:endParaRPr lang="en-US" sz="1100" dirty="0"/>
-          </a:p>
-        </p:txBody>
-      </p:sp>
-      <p:sp>
-        <p:nvSpPr>
-          <p:cNvPr id="5" name="Text 3"/>
-          <p:cNvSpPr txBox="1"/>
-          <p:nvPr/>
-        </p:nvSpPr>
-        <p:spPr>
-          <a:xfrm>
-            <a:off x="777240" y="2194560"/>
-            <a:ext cx="5120640" cy="1051560"/>
-          </a:xfrm>
-          <a:prstGeom prst="rect">
-            <a:avLst/>
-          </a:prstGeom>
-          <a:noFill/>
-          <a:ln/>
-        </p:spPr>
-        <p:txBody>
-          <a:bodyPr wrap="square" lIns="0" tIns="0" rIns="0" bIns="0" rtlCol="0" anchor="t"/>
-          <a:lstStyle/>
-          <a:p>
-            <a:pPr indent="0" marL="0">
-              <a:buNone/>
-            </a:pPr>
-            <a:r>
-              <a:rPr lang="en-US" sz="2000" dirty="0">
-                <a:solidFill>
-                  <a:srgbClr val="FFFFFF"/>
-                </a:solidFill>
-                <a:latin typeface="Courier New" pitchFamily="34" charset="0"/>
-                <a:ea typeface="Courier New" pitchFamily="34" charset="-122"/>
-                <a:cs typeface="Courier New" pitchFamily="34" charset="-120"/>
-              </a:rPr>
-              <a:t>capitale_testo = "5000"</a:t>
-            </a:r>
-            <a:endParaRPr lang="en-US" sz="2000" dirty="0"/>
-          </a:p>
-          <a:p>
-            <a:pPr indent="0" marL="0">
-              <a:buNone/>
-            </a:pPr>
-            <a:r>
-              <a:rPr lang="en-US" sz="2000" dirty="0">
-                <a:solidFill>
-                  <a:srgbClr val="FFFFFF"/>
-                </a:solidFill>
-                <a:latin typeface="Courier New" pitchFamily="34" charset="0"/>
-                <a:ea typeface="Courier New" pitchFamily="34" charset="-122"/>
-                <a:cs typeface="Courier New" pitchFamily="34" charset="-120"/>
-              </a:rPr>
-              <a:t>print(capitale_testo * 2)</a:t>
-            </a:r>
-            <a:endParaRPr lang="en-US" sz="2000" dirty="0"/>
-          </a:p>
-        </p:txBody>
-      </p:sp>
-      <p:sp>
-        <p:nvSpPr>
-          <p:cNvPr id="6" name="card-out"/>
-          <p:cNvSpPr/>
-          <p:nvPr/>
-        </p:nvSpPr>
-        <p:spPr>
-          <a:xfrm>
-            <a:off x="548640" y="3657600"/>
-            <a:ext cx="5577840" cy="1280160"/>
-          </a:xfrm>
-          <a:prstGeom prst="roundRect">
-            <a:avLst>
-              <a:gd name="adj" fmla="val 8571"/>
-            </a:avLst>
-          </a:prstGeom>
-          <a:solidFill>
-            <a:srgbClr val="EEF3F4"/>
-          </a:solidFill>
-          <a:ln/>
-        </p:spPr>
-      </p:sp>
-      <p:sp>
-        <p:nvSpPr>
-          <p:cNvPr id="7" name="Text 5"/>
-          <p:cNvSpPr txBox="1"/>
-          <p:nvPr/>
-        </p:nvSpPr>
-        <p:spPr>
-          <a:xfrm>
-            <a:off x="777240" y="3794760"/>
-            <a:ext cx="1828800" cy="274320"/>
-          </a:xfrm>
-          <a:prstGeom prst="rect">
-            <a:avLst/>
-          </a:prstGeom>
-          <a:noFill/>
-          <a:ln/>
-        </p:spPr>
-        <p:txBody>
-          <a:bodyPr wrap="square" lIns="0" tIns="0" rIns="0" bIns="0" rtlCol="0" anchor="ctr"/>
-          <a:lstStyle/>
-          <a:p>
-            <a:pPr indent="0" marL="0">
-              <a:buNone/>
-            </a:pPr>
-            <a:r>
-              <a:rPr lang="en-US" sz="1100" b="1" spc="200" kern="0" dirty="0">
-                <a:solidFill>
-                  <a:srgbClr val="5C6F7B"/>
-                </a:solidFill>
-              </a:rPr>
-              <a:t>OUTPUT</a:t>
-            </a:r>
-            <a:endParaRPr lang="en-US" sz="1100" dirty="0"/>
-          </a:p>
-        </p:txBody>
-      </p:sp>
-      <p:sp>
-        <p:nvSpPr>
-          <p:cNvPr id="8" name="Text 6"/>
-          <p:cNvSpPr txBox="1"/>
-          <p:nvPr/>
-        </p:nvSpPr>
-        <p:spPr>
-          <a:xfrm>
-            <a:off x="777240" y="4114800"/>
-            <a:ext cx="5120640" cy="685800"/>
-          </a:xfrm>
-          <a:prstGeom prst="rect">
-            <a:avLst/>
-          </a:prstGeom>
-          <a:noFill/>
-          <a:ln/>
-        </p:spPr>
-        <p:txBody>
-          <a:bodyPr wrap="square" lIns="0" tIns="0" rIns="0" bIns="0" rtlCol="0" anchor="t"/>
-          <a:lstStyle/>
-          <a:p>
-            <a:pPr indent="0" marL="0">
-              <a:buNone/>
-            </a:pPr>
-            <a:r>
-              <a:rPr lang="en-US" sz="2400" dirty="0">
-                <a:solidFill>
-                  <a:srgbClr val="1F2A30"/>
-                </a:solidFill>
-                <a:latin typeface="Courier New" pitchFamily="34" charset="0"/>
-                <a:ea typeface="Courier New" pitchFamily="34" charset="-122"/>
-                <a:cs typeface="Courier New" pitchFamily="34" charset="-120"/>
-              </a:rPr>
-              <a:t>50005000</a:t>
-            </a:r>
-            <a:endParaRPr lang="en-US" sz="2400" dirty="0"/>
-          </a:p>
-        </p:txBody>
-      </p:sp>
-      <p:sp>
-        <p:nvSpPr>
-          <p:cNvPr id="9" name="Text 7"/>
-          <p:cNvSpPr txBox="1"/>
-          <p:nvPr/>
-        </p:nvSpPr>
-        <p:spPr>
-          <a:xfrm>
-            <a:off x="6675120" y="1737360"/>
-            <a:ext cx="4937760" cy="1645920"/>
-          </a:xfrm>
-          <a:prstGeom prst="rect">
-            <a:avLst/>
-          </a:prstGeom>
-          <a:noFill/>
-          <a:ln/>
-        </p:spPr>
-        <p:txBody>
-          <a:bodyPr wrap="square" lIns="0" tIns="0" rIns="0" bIns="0" rtlCol="0" anchor="t"/>
-          <a:lstStyle/>
-          <a:p>
-            <a:pPr indent="0" marL="0">
-              <a:buNone/>
-            </a:pPr>
-            <a:r>
-              <a:rPr lang="en-US" sz="3200" b="1" dirty="0">
-                <a:solidFill>
-                  <a:srgbClr val="9E2A2B"/>
-                </a:solidFill>
-              </a:rPr>
-              <a:t>Nessun errore.</a:t>
-            </a:r>
-            <a:endParaRPr lang="en-US" sz="3200" dirty="0"/>
-          </a:p>
-          <a:p>
-            <a:pPr indent="0" marL="0">
-              <a:buNone/>
-            </a:pPr>
-            <a:r>
-              <a:rPr lang="en-US" sz="3200" b="1" dirty="0">
-                <a:solidFill>
-                  <a:srgbClr val="9E2A2B"/>
-                </a:solidFill>
-              </a:rPr>
-              <a:t>Risultato sbagliato.</a:t>
-            </a:r>
-            <a:endParaRPr lang="en-US" sz="3200" dirty="0"/>
-          </a:p>
-        </p:txBody>
-      </p:sp>
-      <p:sp>
-        <p:nvSpPr>
-          <p:cNvPr id="10" name="Text 8"/>
-          <p:cNvSpPr txBox="1"/>
-          <p:nvPr/>
-        </p:nvSpPr>
-        <p:spPr>
-          <a:xfrm>
-            <a:off x="6675120" y="3566160"/>
-            <a:ext cx="4937760" cy="1463040"/>
-          </a:xfrm>
-          <a:prstGeom prst="rect">
-            <a:avLst/>
-          </a:prstGeom>
-          <a:noFill/>
-          <a:ln/>
-        </p:spPr>
-        <p:txBody>
-          <a:bodyPr wrap="square" lIns="0" tIns="0" rIns="0" bIns="0" rtlCol="0" anchor="t"/>
-          <a:lstStyle/>
-          <a:p>
-            <a:pPr indent="0" marL="0">
-              <a:buNone/>
-            </a:pPr>
-            <a:r>
-              <a:rPr lang="en-US" sz="2000" dirty="0">
-                <a:solidFill>
-                  <a:srgbClr val="1F2A30"/>
-                </a:solidFill>
-              </a:rPr>
-              <a:t>Python ha ripetuto il testo due volte. Il codice che gira non è per forza giusto: è la lezione più importante del corso.</a:t>
-            </a:r>
-            <a:endParaRPr lang="en-US" sz="2000" dirty="0"/>
-          </a:p>
-        </p:txBody>
-      </p:sp>
-      <p:sp>
-        <p:nvSpPr>
-          <p:cNvPr id="25" name="Slide Number Placeholder 0"/>
-          <p:cNvSpPr>
-            <a:spLocks noGrp="1"/>
-          </p:cNvSpPr>
-          <p:nvPr>
-            <p:ph type="sldNum" sz="quarter" idx="4294967295"/>
-          </p:nvPr>
-        </p:nvSpPr>
-        <p:spPr>
-          <a:xfrm>
-            <a:off x="11155680" y="6400800"/>
-            <a:ext cx="457200" cy="274320"/>
-          </a:xfrm>
-          <a:prstGeom prst="rect">
-            <a:avLst/>
-          </a:prstGeom>
-          <a:extLst>
-            <a:ext uri="{C572A759-6A51-4108-AA02-DFA0A04FC94B}">
-              <ma14:wrappingTextBoxFlag xmlns:ma14="http://schemas.microsoft.com/office/mac/drawingml/2011/main" val="0"/>
-            </a:ext>
-          </a:extLst>
-        </p:spPr>
-        <p:txBody>
-          <a:bodyPr/>
-          <a:lstStyle>
-            <a:lvl1pPr>
-              <a:defRPr sz="1000">
-                <a:solidFill>
-                  <a:srgbClr val="5C6F7B"/>
-                </a:solidFill>
-              </a:defRPr>
-            </a:lvl1pPr>
-          </a:lstStyle>
-          <a:p>
-            <a:pPr algn="r"/>
-            <a:fld id="{F7021451-1387-4CA6-816F-3879F97B5CBC}" type="slidenum">
-              <a:rPr b="0" lang="en-US"/>
-              <a:t>12</a:t>
-            </a:fld>
-            <a:endParaRPr lang="en-US"/>
-          </a:p>
-        </p:txBody>
-      </p:sp>
-    </p:spTree>
-  </p:cSld>
-  <p:clrMapOvr>
-    <a:masterClrMapping/>
-  </p:clrMapOvr>
-</p:sld>
-</file>
-
-<file path=ppt/slides/slide13.xml><?xml version="1.0" encoding="utf-8"?>
-<p:sld xmlns:a="http://schemas.openxmlformats.org/drawingml/2006/main" xmlns:r="http://schemas.openxmlformats.org/officeDocument/2006/relationships" xmlns:p="http://schemas.openxmlformats.org/presentationml/2006/main">
-  <p:cSld name="Slide 13">
-    <p:spTree>
-      <p:nvGrpSpPr>
-        <p:cNvPr id="1" name=""/>
-        <p:cNvGrpSpPr/>
-        <p:nvPr/>
-      </p:nvGrpSpPr>
-      <p:grpSpPr>
-        <a:xfrm>
-          <a:off x="0" y="0"/>
-          <a:ext cx="0" cy="0"/>
-          <a:chOff x="0" y="0"/>
-          <a:chExt cx="0" cy="0"/>
-        </a:xfrm>
-      </p:grpSpPr>
-      <p:sp>
-        <p:nvSpPr>
-          <p:cNvPr id="2" name="Text 0"/>
-          <p:cNvSpPr/>
-          <p:nvPr>
-            <p:ph idx="100" type="title" hasCustomPrompt="1"/>
-          </p:nvPr>
-        </p:nvSpPr>
-        <p:spPr>
-          <a:xfrm>
-            <a:off x="548640" y="365760"/>
-            <a:ext cx="11064240" cy="822960"/>
-          </a:xfrm>
-          <a:prstGeom prst="rect">
-            <a:avLst/>
-          </a:prstGeom>
-          <a:noFill/>
-          <a:ln/>
-        </p:spPr>
-        <p:txBody>
-          <a:bodyPr wrap="square" lIns="0" tIns="0" rIns="0" bIns="0" rtlCol="0" anchor="ctr"/>
-          <a:lstStyle/>
-          <a:p>
-            <a:pPr algn="l" indent="0" marL="0">
-              <a:buNone/>
-            </a:pPr>
-            <a:r>
-              <a:rPr lang="en-US" sz="3600" b="1" dirty="0">
-                <a:solidFill>
-                  <a:srgbClr val="0F4C5C"/>
-                </a:solidFill>
-              </a:rPr>
-              <a:t>Testo più numero</a:t>
-            </a:r>
-            <a:endParaRPr lang="en-US" sz="3600" dirty="0"/>
-          </a:p>
-        </p:txBody>
-      </p:sp>
-      <p:sp>
-        <p:nvSpPr>
-          <p:cNvPr id="3" name="card-code"/>
-          <p:cNvSpPr/>
-          <p:nvPr/>
-        </p:nvSpPr>
-        <p:spPr>
-          <a:xfrm>
-            <a:off x="548640" y="1737360"/>
-            <a:ext cx="5577840" cy="1188720"/>
-          </a:xfrm>
-          <a:prstGeom prst="roundRect">
-            <a:avLst>
-              <a:gd name="adj" fmla="val 9231"/>
-            </a:avLst>
-          </a:prstGeom>
-          <a:solidFill>
-            <a:srgbClr val="1F2A30"/>
-          </a:solidFill>
-          <a:ln/>
-        </p:spPr>
-      </p:sp>
-      <p:sp>
-        <p:nvSpPr>
-          <p:cNvPr id="4" name="Text 2"/>
-          <p:cNvSpPr txBox="1"/>
-          <p:nvPr/>
-        </p:nvSpPr>
-        <p:spPr>
-          <a:xfrm>
-            <a:off x="777240" y="1874520"/>
-            <a:ext cx="1828800" cy="274320"/>
-          </a:xfrm>
-          <a:prstGeom prst="rect">
-            <a:avLst/>
-          </a:prstGeom>
-          <a:noFill/>
-          <a:ln/>
-        </p:spPr>
-        <p:txBody>
-          <a:bodyPr wrap="square" lIns="0" tIns="0" rIns="0" bIns="0" rtlCol="0" anchor="ctr"/>
-          <a:lstStyle/>
-          <a:p>
-            <a:pPr indent="0" marL="0">
-              <a:buNone/>
-            </a:pPr>
-            <a:r>
-              <a:rPr lang="en-US" sz="1100" b="1" spc="200" kern="0" dirty="0">
-                <a:solidFill>
-                  <a:srgbClr val="E09F3E"/>
-                </a:solidFill>
-              </a:rPr>
-              <a:t>PYTHON</a:t>
-            </a:r>
-            <a:endParaRPr lang="en-US" sz="1100" dirty="0"/>
-          </a:p>
-        </p:txBody>
-      </p:sp>
-      <p:sp>
-        <p:nvSpPr>
-          <p:cNvPr id="5" name="Text 3"/>
-          <p:cNvSpPr txBox="1"/>
-          <p:nvPr/>
-        </p:nvSpPr>
-        <p:spPr>
-          <a:xfrm>
-            <a:off x="777240" y="2194560"/>
-            <a:ext cx="5120640" cy="594360"/>
-          </a:xfrm>
-          <a:prstGeom prst="rect">
-            <a:avLst/>
-          </a:prstGeom>
-          <a:noFill/>
-          <a:ln/>
-        </p:spPr>
-        <p:txBody>
-          <a:bodyPr wrap="square" lIns="0" tIns="0" rIns="0" bIns="0" rtlCol="0" anchor="t"/>
-          <a:lstStyle/>
-          <a:p>
-            <a:pPr indent="0" marL="0">
-              <a:buNone/>
-            </a:pPr>
-            <a:r>
-              <a:rPr lang="en-US" sz="1700" dirty="0">
-                <a:solidFill>
-                  <a:srgbClr val="FFFFFF"/>
-                </a:solidFill>
-                <a:latin typeface="Courier New" pitchFamily="34" charset="0"/>
-                <a:ea typeface="Courier New" pitchFamily="34" charset="-122"/>
-                <a:cs typeface="Courier New" pitchFamily="34" charset="-120"/>
-              </a:rPr>
-              <a:t>print("Il capitale è " + capitale)</a:t>
-            </a:r>
-            <a:endParaRPr lang="en-US" sz="1700" dirty="0"/>
-          </a:p>
-        </p:txBody>
-      </p:sp>
-      <p:sp>
-        <p:nvSpPr>
-          <p:cNvPr id="6" name="card-err"/>
-          <p:cNvSpPr/>
-          <p:nvPr/>
-        </p:nvSpPr>
-        <p:spPr>
-          <a:xfrm>
-            <a:off x="548640" y="3154680"/>
-            <a:ext cx="5577840" cy="1463040"/>
-          </a:xfrm>
-          <a:prstGeom prst="roundRect">
-            <a:avLst>
-              <a:gd name="adj" fmla="val 7500"/>
-            </a:avLst>
-          </a:prstGeom>
-          <a:solidFill>
-            <a:srgbClr val="FBEAEA"/>
-          </a:solidFill>
-          <a:ln/>
-        </p:spPr>
-      </p:sp>
-      <p:sp>
-        <p:nvSpPr>
-          <p:cNvPr id="7" name="Text 5"/>
-          <p:cNvSpPr txBox="1"/>
-          <p:nvPr/>
-        </p:nvSpPr>
-        <p:spPr>
-          <a:xfrm>
-            <a:off x="777240" y="3291840"/>
-            <a:ext cx="1828800" cy="274320"/>
-          </a:xfrm>
-          <a:prstGeom prst="rect">
-            <a:avLst/>
-          </a:prstGeom>
-          <a:noFill/>
-          <a:ln/>
-        </p:spPr>
-        <p:txBody>
-          <a:bodyPr wrap="square" lIns="0" tIns="0" rIns="0" bIns="0" rtlCol="0" anchor="ctr"/>
-          <a:lstStyle/>
-          <a:p>
-            <a:pPr indent="0" marL="0">
-              <a:buNone/>
-            </a:pPr>
-            <a:r>
-              <a:rPr lang="en-US" sz="1100" b="1" spc="200" kern="0" dirty="0">
-                <a:solidFill>
-                  <a:srgbClr val="9E2A2B"/>
-                </a:solidFill>
-              </a:rPr>
-              <a:t>ERRORE</a:t>
-            </a:r>
-            <a:endParaRPr lang="en-US" sz="1100" dirty="0"/>
-          </a:p>
-        </p:txBody>
-      </p:sp>
-      <p:sp>
-        <p:nvSpPr>
-          <p:cNvPr id="8" name="Text 6"/>
-          <p:cNvSpPr txBox="1"/>
-          <p:nvPr/>
-        </p:nvSpPr>
-        <p:spPr>
-          <a:xfrm>
-            <a:off x="777240" y="3611880"/>
-            <a:ext cx="5120640" cy="868680"/>
-          </a:xfrm>
-          <a:prstGeom prst="rect">
-            <a:avLst/>
-          </a:prstGeom>
-          <a:noFill/>
-          <a:ln/>
-        </p:spPr>
-        <p:txBody>
-          <a:bodyPr wrap="square" lIns="0" tIns="0" rIns="0" bIns="0" rtlCol="0" anchor="t"/>
-          <a:lstStyle/>
-          <a:p>
-            <a:pPr indent="0" marL="0">
-              <a:buNone/>
-            </a:pPr>
-            <a:r>
-              <a:rPr lang="en-US" sz="1700" dirty="0">
-                <a:solidFill>
-                  <a:srgbClr val="9E2A2B"/>
-                </a:solidFill>
-                <a:latin typeface="Courier New" pitchFamily="34" charset="0"/>
-                <a:ea typeface="Courier New" pitchFamily="34" charset="-122"/>
-                <a:cs typeface="Courier New" pitchFamily="34" charset="-120"/>
-              </a:rPr>
-              <a:t>TypeError: can only concatenate</a:t>
-            </a:r>
-            <a:endParaRPr lang="en-US" sz="1700" dirty="0"/>
-          </a:p>
-          <a:p>
-            <a:pPr indent="0" marL="0">
-              <a:buNone/>
-            </a:pPr>
-            <a:r>
-              <a:rPr lang="en-US" sz="1700" dirty="0">
-                <a:solidFill>
-                  <a:srgbClr val="9E2A2B"/>
-                </a:solidFill>
-                <a:latin typeface="Courier New" pitchFamily="34" charset="0"/>
-                <a:ea typeface="Courier New" pitchFamily="34" charset="-122"/>
-                <a:cs typeface="Courier New" pitchFamily="34" charset="-120"/>
-              </a:rPr>
-              <a:t>str (not "int") to str</a:t>
-            </a:r>
-            <a:endParaRPr lang="en-US" sz="1700" dirty="0"/>
-          </a:p>
-        </p:txBody>
-      </p:sp>
-      <p:sp>
-        <p:nvSpPr>
-          <p:cNvPr id="9" name="Text 7"/>
-          <p:cNvSpPr txBox="1"/>
-          <p:nvPr/>
-        </p:nvSpPr>
-        <p:spPr>
-          <a:xfrm>
-            <a:off x="6675120" y="1737360"/>
-            <a:ext cx="4937760" cy="457200"/>
-          </a:xfrm>
-          <a:prstGeom prst="rect">
-            <a:avLst/>
-          </a:prstGeom>
-          <a:noFill/>
-          <a:ln/>
-        </p:spPr>
-        <p:txBody>
-          <a:bodyPr wrap="square" lIns="0" tIns="0" rIns="0" bIns="0" rtlCol="0" anchor="ctr"/>
-          <a:lstStyle/>
-          <a:p>
-            <a:pPr indent="0" marL="0">
-              <a:buNone/>
-            </a:pPr>
-            <a:r>
-              <a:rPr lang="en-US" sz="2200" b="1" dirty="0">
-                <a:solidFill>
-                  <a:srgbClr val="1F2A30"/>
-                </a:solidFill>
-              </a:rPr>
-              <a:t>Due modi per correggere</a:t>
-            </a:r>
-            <a:endParaRPr lang="en-US" sz="2200" dirty="0"/>
-          </a:p>
-        </p:txBody>
-      </p:sp>
-      <p:sp>
-        <p:nvSpPr>
-          <p:cNvPr id="10" name="card-code"/>
-          <p:cNvSpPr/>
-          <p:nvPr/>
-        </p:nvSpPr>
-        <p:spPr>
-          <a:xfrm>
-            <a:off x="6675120" y="2377440"/>
-            <a:ext cx="4937760" cy="1097280"/>
-          </a:xfrm>
-          <a:prstGeom prst="roundRect">
-            <a:avLst>
-              <a:gd name="adj" fmla="val 10000"/>
-            </a:avLst>
-          </a:prstGeom>
-          <a:solidFill>
-            <a:srgbClr val="1F2A30"/>
-          </a:solidFill>
-          <a:ln/>
-        </p:spPr>
-      </p:sp>
-      <p:sp>
-        <p:nvSpPr>
-          <p:cNvPr id="11" name="Text 9"/>
-          <p:cNvSpPr txBox="1"/>
-          <p:nvPr/>
-        </p:nvSpPr>
-        <p:spPr>
-          <a:xfrm>
-            <a:off x="6903720" y="2514600"/>
-            <a:ext cx="1828800" cy="274320"/>
-          </a:xfrm>
-          <a:prstGeom prst="rect">
-            <a:avLst/>
-          </a:prstGeom>
-          <a:noFill/>
-          <a:ln/>
-        </p:spPr>
-        <p:txBody>
-          <a:bodyPr wrap="square" lIns="0" tIns="0" rIns="0" bIns="0" rtlCol="0" anchor="ctr"/>
-          <a:lstStyle/>
-          <a:p>
-            <a:pPr indent="0" marL="0">
-              <a:buNone/>
-            </a:pPr>
-            <a:r>
-              <a:rPr lang="en-US" sz="1100" b="1" spc="200" kern="0" dirty="0">
-                <a:solidFill>
-                  <a:srgbClr val="E09F3E"/>
-                </a:solidFill>
-              </a:rPr>
-              <a:t>PYTHON</a:t>
-            </a:r>
-            <a:endParaRPr lang="en-US" sz="1100" dirty="0"/>
-          </a:p>
-        </p:txBody>
-      </p:sp>
-      <p:sp>
-        <p:nvSpPr>
-          <p:cNvPr id="12" name="Text 10"/>
-          <p:cNvSpPr txBox="1"/>
-          <p:nvPr/>
-        </p:nvSpPr>
-        <p:spPr>
-          <a:xfrm>
-            <a:off x="6903720" y="2834640"/>
-            <a:ext cx="4480560" cy="502920"/>
-          </a:xfrm>
-          <a:prstGeom prst="rect">
-            <a:avLst/>
-          </a:prstGeom>
-          <a:noFill/>
-          <a:ln/>
-        </p:spPr>
-        <p:txBody>
-          <a:bodyPr wrap="square" lIns="0" tIns="0" rIns="0" bIns="0" rtlCol="0" anchor="t"/>
-          <a:lstStyle/>
-          <a:p>
-            <a:pPr indent="0" marL="0">
-              <a:buNone/>
-            </a:pPr>
-            <a:r>
-              <a:rPr lang="en-US" sz="1500" dirty="0">
-                <a:solidFill>
-                  <a:srgbClr val="FFFFFF"/>
-                </a:solidFill>
-                <a:latin typeface="Courier New" pitchFamily="34" charset="0"/>
-                <a:ea typeface="Courier New" pitchFamily="34" charset="-122"/>
-                <a:cs typeface="Courier New" pitchFamily="34" charset="-120"/>
-              </a:rPr>
-              <a:t>"Il capitale è " + str(capitale)</a:t>
-            </a:r>
-            <a:endParaRPr lang="en-US" sz="1500" dirty="0"/>
-          </a:p>
-        </p:txBody>
-      </p:sp>
-      <p:sp>
-        <p:nvSpPr>
-          <p:cNvPr id="13" name="card-code"/>
-          <p:cNvSpPr/>
-          <p:nvPr/>
-        </p:nvSpPr>
-        <p:spPr>
-          <a:xfrm>
-            <a:off x="6675120" y="3657600"/>
-            <a:ext cx="4937760" cy="1097280"/>
-          </a:xfrm>
-          <a:prstGeom prst="roundRect">
-            <a:avLst>
-              <a:gd name="adj" fmla="val 10000"/>
-            </a:avLst>
-          </a:prstGeom>
-          <a:solidFill>
-            <a:srgbClr val="1F2A30"/>
-          </a:solidFill>
-          <a:ln/>
-        </p:spPr>
-      </p:sp>
-      <p:sp>
-        <p:nvSpPr>
-          <p:cNvPr id="14" name="Text 12"/>
-          <p:cNvSpPr txBox="1"/>
-          <p:nvPr/>
-        </p:nvSpPr>
-        <p:spPr>
-          <a:xfrm>
-            <a:off x="6903720" y="3794760"/>
-            <a:ext cx="1828800" cy="274320"/>
-          </a:xfrm>
-          <a:prstGeom prst="rect">
-            <a:avLst/>
-          </a:prstGeom>
-          <a:noFill/>
-          <a:ln/>
-        </p:spPr>
-        <p:txBody>
-          <a:bodyPr wrap="square" lIns="0" tIns="0" rIns="0" bIns="0" rtlCol="0" anchor="ctr"/>
-          <a:lstStyle/>
-          <a:p>
-            <a:pPr indent="0" marL="0">
-              <a:buNone/>
-            </a:pPr>
-            <a:r>
-              <a:rPr lang="en-US" sz="1100" b="1" spc="200" kern="0" dirty="0">
-                <a:solidFill>
-                  <a:srgbClr val="E09F3E"/>
-                </a:solidFill>
-              </a:rPr>
-              <a:t>PYTHON</a:t>
-            </a:r>
-            <a:endParaRPr lang="en-US" sz="1100" dirty="0"/>
-          </a:p>
-        </p:txBody>
-      </p:sp>
-      <p:sp>
-        <p:nvSpPr>
-          <p:cNvPr id="15" name="Text 13"/>
-          <p:cNvSpPr txBox="1"/>
-          <p:nvPr/>
-        </p:nvSpPr>
-        <p:spPr>
-          <a:xfrm>
-            <a:off x="6903720" y="4114800"/>
-            <a:ext cx="4480560" cy="502920"/>
-          </a:xfrm>
-          <a:prstGeom prst="rect">
-            <a:avLst/>
-          </a:prstGeom>
-          <a:noFill/>
-          <a:ln/>
-        </p:spPr>
-        <p:txBody>
-          <a:bodyPr wrap="square" lIns="0" tIns="0" rIns="0" bIns="0" rtlCol="0" anchor="t"/>
-          <a:lstStyle/>
-          <a:p>
-            <a:pPr indent="0" marL="0">
-              <a:buNone/>
-            </a:pPr>
-            <a:r>
-              <a:rPr lang="en-US" sz="1500" dirty="0">
-                <a:solidFill>
-                  <a:srgbClr val="FFFFFF"/>
-                </a:solidFill>
-                <a:latin typeface="Courier New" pitchFamily="34" charset="0"/>
-                <a:ea typeface="Courier New" pitchFamily="34" charset="-122"/>
-                <a:cs typeface="Courier New" pitchFamily="34" charset="-120"/>
-              </a:rPr>
-              <a:t>f"Il capitale è {capitale}"</a:t>
-            </a:r>
-            <a:endParaRPr lang="en-US" sz="1500" dirty="0"/>
-          </a:p>
-        </p:txBody>
-      </p:sp>
-      <p:sp>
-        <p:nvSpPr>
-          <p:cNvPr id="16" name="Text 14"/>
-          <p:cNvSpPr txBox="1"/>
-          <p:nvPr/>
-        </p:nvSpPr>
-        <p:spPr>
-          <a:xfrm>
-            <a:off x="548640" y="5120640"/>
-            <a:ext cx="11064240" cy="548640"/>
-          </a:xfrm>
-          <a:prstGeom prst="rect">
-            <a:avLst/>
-          </a:prstGeom>
-          <a:noFill/>
-          <a:ln/>
-        </p:spPr>
-        <p:txBody>
-          <a:bodyPr wrap="square" lIns="0" tIns="0" rIns="0" bIns="0" rtlCol="0" anchor="ctr"/>
-          <a:lstStyle/>
-          <a:p>
-            <a:pPr indent="0" marL="0">
-              <a:buNone/>
-            </a:pPr>
-            <a:r>
-              <a:rPr lang="en-US" sz="1800" i="1" dirty="0">
-                <a:solidFill>
-                  <a:srgbClr val="0F4C5C"/>
-                </a:solidFill>
-              </a:rPr>
-              <a:t>Python non indovina: testo e numeri vanno trattati in modo esplicito.</a:t>
-            </a:r>
-            <a:endParaRPr lang="en-US" sz="1800" dirty="0"/>
-          </a:p>
-        </p:txBody>
-      </p:sp>
-      <p:sp>
-        <p:nvSpPr>
-          <p:cNvPr id="25" name="Slide Number Placeholder 0"/>
-          <p:cNvSpPr>
-            <a:spLocks noGrp="1"/>
-          </p:cNvSpPr>
-          <p:nvPr>
-            <p:ph type="sldNum" sz="quarter" idx="4294967295"/>
-          </p:nvPr>
-        </p:nvSpPr>
-        <p:spPr>
-          <a:xfrm>
-            <a:off x="11155680" y="6400800"/>
-            <a:ext cx="457200" cy="274320"/>
-          </a:xfrm>
-          <a:prstGeom prst="rect">
-            <a:avLst/>
-          </a:prstGeom>
-          <a:extLst>
-            <a:ext uri="{C572A759-6A51-4108-AA02-DFA0A04FC94B}">
-              <ma14:wrappingTextBoxFlag xmlns:ma14="http://schemas.microsoft.com/office/mac/drawingml/2011/main" val="0"/>
-            </a:ext>
-          </a:extLst>
-        </p:spPr>
-        <p:txBody>
-          <a:bodyPr/>
-          <a:lstStyle>
-            <a:lvl1pPr>
-              <a:defRPr sz="1000">
-                <a:solidFill>
-                  <a:srgbClr val="5C6F7B"/>
-                </a:solidFill>
-              </a:defRPr>
-            </a:lvl1pPr>
-          </a:lstStyle>
-          <a:p>
-            <a:pPr algn="r"/>
-            <a:fld id="{F7021451-1387-4CA6-816F-3879F97B5CBC}" type="slidenum">
-              <a:rPr b="0" lang="en-US"/>
-              <a:t>13</a:t>
-            </a:fld>
-            <a:endParaRPr lang="en-US"/>
-          </a:p>
-        </p:txBody>
-      </p:sp>
-    </p:spTree>
-  </p:cSld>
-  <p:clrMapOvr>
-    <a:masterClrMapping/>
-  </p:clrMapOvr>
-</p:sld>
-</file>
-
-<file path=ppt/slides/slide14.xml><?xml version="1.0" encoding="utf-8"?>
-<p:sld xmlns:a="http://schemas.openxmlformats.org/drawingml/2006/main" xmlns:r="http://schemas.openxmlformats.org/officeDocument/2006/relationships" xmlns:p="http://schemas.openxmlformats.org/presentationml/2006/main">
-  <p:cSld name="Slide 14">
-    <p:spTree>
-      <p:nvGrpSpPr>
-        <p:cNvPr id="1" name=""/>
-        <p:cNvGrpSpPr/>
-        <p:nvPr/>
-      </p:nvGrpSpPr>
-      <p:grpSpPr>
-        <a:xfrm>
-          <a:off x="0" y="0"/>
-          <a:ext cx="0" cy="0"/>
-          <a:chOff x="0" y="0"/>
-          <a:chExt cx="0" cy="0"/>
-        </a:xfrm>
-      </p:grpSpPr>
-      <p:sp>
-        <p:nvSpPr>
-          <p:cNvPr id="2" name="Text 0"/>
-          <p:cNvSpPr/>
-          <p:nvPr>
-            <p:ph idx="100" type="title" hasCustomPrompt="1"/>
-          </p:nvPr>
-        </p:nvSpPr>
-        <p:spPr>
-          <a:xfrm>
-            <a:off x="731520" y="2103120"/>
-            <a:ext cx="10698480" cy="1463040"/>
-          </a:xfrm>
-          <a:prstGeom prst="rect">
-            <a:avLst/>
-          </a:prstGeom>
-          <a:noFill/>
-          <a:ln/>
-        </p:spPr>
-        <p:txBody>
-          <a:bodyPr wrap="square" lIns="0" tIns="0" rIns="0" bIns="0" rtlCol="0" anchor="b"/>
-          <a:lstStyle/>
-          <a:p>
-            <a:pPr algn="l" indent="0" marL="0">
-              <a:buNone/>
-            </a:pPr>
-            <a:r>
-              <a:rPr lang="en-US" sz="4800" b="1" dirty="0">
-                <a:solidFill>
-                  <a:srgbClr val="FFFFFF"/>
-                </a:solidFill>
-              </a:rPr>
-              <a:t>Prossima volta: un file Excel</a:t>
-            </a:r>
-            <a:endParaRPr lang="en-US" sz="4800" dirty="0"/>
-          </a:p>
-        </p:txBody>
-      </p:sp>
-      <p:sp>
-        <p:nvSpPr>
-          <p:cNvPr id="3" name="Text 0"/>
-          <p:cNvSpPr/>
-          <p:nvPr>
-            <p:ph idx="101" type="body" hasCustomPrompt="1"/>
-          </p:nvPr>
-        </p:nvSpPr>
-        <p:spPr>
-          <a:xfrm>
-            <a:off x="731520" y="3749040"/>
-            <a:ext cx="10698480" cy="914400"/>
-          </a:xfrm>
-          <a:prstGeom prst="rect">
-            <a:avLst/>
-          </a:prstGeom>
-          <a:noFill/>
-          <a:ln/>
-        </p:spPr>
-        <p:txBody>
-          <a:bodyPr wrap="square" lIns="0" tIns="0" rIns="0" bIns="0" rtlCol="0" anchor="t"/>
-          <a:lstStyle/>
-          <a:p>
-            <a:pPr indent="0" marL="0">
-              <a:buNone/>
-            </a:pPr>
-            <a:r>
-              <a:rPr lang="en-US" sz="2200" dirty="0">
-                <a:solidFill>
-                  <a:srgbClr val="F4C06E"/>
-                </a:solidFill>
-              </a:rPr>
-              <a:t>Compito: Kaggle Learn – Python, lezione «Hello, Python» (~30 min)</a:t>
-            </a:r>
-            <a:endParaRPr lang="en-US" sz="2200" dirty="0"/>
-          </a:p>
-        </p:txBody>
-      </p:sp>
-    </p:spTree>
-  </p:cSld>
-  <p:clrMapOvr>
-    <a:masterClrMapping/>
-  </p:clrMapOvr>
-</p:sld>
-</file>
-
 <file path=ppt/slides/slide2.xml><?xml version="1.0" encoding="utf-8"?>
 <p:sld xmlns:a="http://schemas.openxmlformats.org/drawingml/2006/main" xmlns:r="http://schemas.openxmlformats.org/officeDocument/2006/relationships" xmlns:p="http://schemas.openxmlformats.org/presentationml/2006/main">
   <p:cSld name="Slide 2">
@@ -8886,8 +5866,8 @@
         </p:nvSpPr>
         <p:spPr>
           <a:xfrm>
-            <a:off x="731520" y="2194560"/>
-            <a:ext cx="10698480" cy="1280160"/>
+            <a:off x="731520" y="2103120"/>
+            <a:ext cx="10698480" cy="1463040"/>
           </a:xfrm>
           <a:prstGeom prst="rect">
             <a:avLst/>
@@ -8903,14 +5883,14 @@
               <a:buNone/>
             </a:pPr>
             <a:r>
-              <a:rPr lang="en-US" sz="5400" b="1" dirty="0">
+              <a:rPr lang="en-US" sz="4800" b="1" dirty="0">
                 <a:solidFill>
                   <a:srgbClr val="FFFFFF"/>
                 </a:solidFill>
               </a:rPr>
-              <a:t>Debrief</a:t>
-            </a:r>
-            <a:endParaRPr lang="en-US" sz="5400" dirty="0"/>
+              <a:t>Prossima volta: un file Excel</a:t>
+            </a:r>
+            <a:endParaRPr lang="en-US" sz="4800" dirty="0"/>
           </a:p>
         </p:txBody>
       </p:sp>
@@ -8924,8 +5904,8 @@
         </p:nvSpPr>
         <p:spPr>
           <a:xfrm>
-            <a:off x="731520" y="3657600"/>
-            <a:ext cx="10698480" cy="1463040"/>
+            <a:off x="731520" y="3749040"/>
+            <a:ext cx="10698480" cy="914400"/>
           </a:xfrm>
           <a:prstGeom prst="rect">
             <a:avLst/>
@@ -8943,10 +5923,10 @@
             <a:r>
               <a:rPr lang="en-US" sz="2200" dirty="0">
                 <a:solidFill>
-                  <a:srgbClr val="B8C4CB"/>
-                </a:solidFill>
-              </a:rPr>
-              <a:t>Come ha funzionato, e perché</a:t>
+                  <a:srgbClr val="F4C06E"/>
+                </a:solidFill>
+              </a:rPr>
+              <a:t>Compito: Kaggle Learn – Python, lezione «Hello, Python» (~30 min)</a:t>
             </a:r>
             <a:endParaRPr lang="en-US" sz="2200" dirty="0"/>
           </a:p>

</xml_diff>

<commit_message>
Differenza tra = e ==
- L1: nuovo passo del task con i confronti (>, ==) e la trappola di = al posto di ==
- L1 e L2: dispense aggiornate; L2: richiamo a == nella slide sulla selezione

Co-Authored-By: Claude Opus 5.5 <noreply@anthropic.com>
Claude-Session: https://claude.ai/code/session_014CzWDFXvYNxqLeD99LSN3G
</commit_message>
<xml_diff>
--- a/lezioni/L01_python_calcolatrice/slide.pptx
+++ b/lezioni/L01_python_calcolatrice/slide.pptx
@@ -115,13 +115,13 @@
   <p:extLst>
     <p:ext uri="{521415D9-36F7-43E2-AB2F-B90AF26B5E84}">
       <p14:sectionLst xmlns:p14="http://schemas.microsoft.com/office/powerpoint/2010/main">
-        <p14:section name="Apertura" id="{b7f29b63-0837-0277-9fbd-e398b99a01ef}">
+        <p14:section name="Apertura" id="{b5fcd563-9295-dd21-28ac-30ac824356ad}">
           <p14:sldIdLst>
             <p14:sldId id="256"/>
             <p14:sldId id="257"/>
           </p14:sldIdLst>
         </p14:section>
-        <p14:section name="Spiegazione" id="{2576292b-0989-bdf1-0b74-9a987f623421}">
+        <p14:section name="Spiegazione" id="{831267dc-b483-3446-5b72-0cb977ad3e1b}">
           <p14:sldIdLst>
             <p14:sldId id="258"/>
             <p14:sldId id="259"/>
@@ -130,12 +130,12 @@
             <p14:sldId id="262"/>
           </p14:sldIdLst>
         </p14:section>
-        <p14:section name="Task" id="{e8831d7d-5c54-a08a-9be9-c7fe214780a4}">
+        <p14:section name="Task" id="{fdb70ecc-9df3-e6a7-893d-b2d5efab9110}">
           <p14:sldIdLst>
             <p14:sldId id="263"/>
           </p14:sldIdLst>
         </p14:section>
-        <p14:section name="Chiusura" id="{c0dd33b1-9b1a-d619-f6c0-86adc56323c7}">
+        <p14:section name="Chiusura" id="{931a190d-e0ab-c66d-f50c-7be8f262319f}">
           <p14:sldIdLst>
             <p14:sldId id="264"/>
           </p14:sldIdLst>
@@ -1160,7 +1160,7 @@
           <a:p>
             <a:r>
               <a:rPr lang="en-US" dirty="0"/>
-              <a:t>Durante il task: girare tra i banchi, segnarsi le soluzioni interessanti (anche sbagliate) da mostrare nel debrief. Al passo 6 molti non capiranno: è voluto.</a:t>
+              <a:t>Durante il task: girare tra i banchi, segnarsi le soluzioni interessanti (anche sbagliate) da mostrare nel debrief. Al passo 7 molti non capiranno: è voluto.</a:t>
             </a:r>
             <a:endParaRPr lang="en-US" dirty="0"/>
           </a:p>

</xml_diff>

<commit_message>
L1: slide su come fare un fork del repository
Co-Authored-By: Claude Opus 5.5 <noreply@anthropic.com>
Claude-Session: https://claude.ai/code/session_014CzWDFXvYNxqLeD99LSN3G
</commit_message>
<xml_diff>
--- a/lezioni/L01_python_calcolatrice/slide.pptx
+++ b/lezioni/L01_python_calcolatrice/slide.pptx
@@ -14,9 +14,10 @@
     <p:sldId id="262" r:id="rId8"/>
     <p:sldId id="263" r:id="rId9"/>
     <p:sldId id="264" r:id="rId10"/>
+    <p:sldId id="265" r:id="rId11"/>
   </p:sldIdLst>
   <p:notesMasterIdLst>
-    <p:notesMasterId r:id="rId11"/>
+    <p:notesMasterId r:id="rId12"/>
   </p:notesMasterIdLst>
   <p:sldSz cx="12192000" cy="6858000"/>
   <p:notesSz cx="6858000" cy="12192000"/>
@@ -115,13 +116,13 @@
   <p:extLst>
     <p:ext uri="{521415D9-36F7-43E2-AB2F-B90AF26B5E84}">
       <p14:sectionLst xmlns:p14="http://schemas.microsoft.com/office/powerpoint/2010/main">
-        <p14:section name="Apertura" id="{b5fcd563-9295-dd21-28ac-30ac824356ad}">
+        <p14:section name="Apertura" id="{0eb30d9b-720f-8a1c-dcff-760a8f253c3f}">
           <p14:sldIdLst>
             <p14:sldId id="256"/>
             <p14:sldId id="257"/>
           </p14:sldIdLst>
         </p14:section>
-        <p14:section name="Spiegazione" id="{831267dc-b483-3446-5b72-0cb977ad3e1b}">
+        <p14:section name="Spiegazione" id="{b4a461bb-cdad-fd1d-2a68-b1fb2121720c}">
           <p14:sldIdLst>
             <p14:sldId id="258"/>
             <p14:sldId id="259"/>
@@ -130,14 +131,19 @@
             <p14:sldId id="262"/>
           </p14:sldIdLst>
         </p14:section>
-        <p14:section name="Task" id="{fdb70ecc-9df3-e6a7-893d-b2d5efab9110}">
+        <p14:section name="Task" id="{5ffebc4c-5e30-eb93-3d0d-a618bf1ea715}">
           <p14:sldIdLst>
             <p14:sldId id="263"/>
           </p14:sldIdLst>
         </p14:section>
-        <p14:section name="Chiusura" id="{931a190d-e0ab-c66d-f50c-7be8f262319f}">
+        <p14:section name="Extra" id="{848292b6-e6aa-9579-24ff-ca23449c150e}">
           <p14:sldIdLst>
             <p14:sldId id="264"/>
+          </p14:sldIdLst>
+        </p14:section>
+        <p14:section name="Chiusura" id="{7ec1467f-d257-cc07-e7ae-d90a63ea2f00}">
+          <p14:sldIdLst>
+            <p14:sldId id="265"/>
           </p14:sldIdLst>
         </p14:section>
       </p14:sectionLst>
@@ -586,6 +592,94 @@
 </p:notes>
 </file>
 
+<file path=ppt/notesSlides/notesSlide10.xml><?xml version="1.0" encoding="utf-8"?>
+<p:notes xmlns:a="http://schemas.openxmlformats.org/drawingml/2006/main" xmlns:r="http://schemas.openxmlformats.org/officeDocument/2006/relationships" xmlns:p="http://schemas.openxmlformats.org/presentationml/2006/main">
+  <p:cSld>
+    <p:spTree>
+      <p:nvGrpSpPr>
+        <p:cNvPr id="1" name=""/>
+        <p:cNvGrpSpPr/>
+        <p:nvPr/>
+      </p:nvGrpSpPr>
+      <p:grpSpPr>
+        <a:xfrm>
+          <a:off x="0" y="0"/>
+          <a:ext cx="0" cy="0"/>
+          <a:chOff x="0" y="0"/>
+          <a:chExt cx="0" cy="0"/>
+        </a:xfrm>
+      </p:grpSpPr>
+      <p:sp>
+        <p:nvSpPr>
+          <p:cNvPr id="2" name="Slide Image Placeholder 1"/>
+          <p:cNvSpPr>
+            <a:spLocks noGrp="1" noRot="1" noChangeAspect="1"/>
+          </p:cNvSpPr>
+          <p:nvPr>
+            <p:ph type="sldImg"/>
+          </p:nvPr>
+        </p:nvSpPr>
+        <p:spPr/>
+      </p:sp>
+      <p:sp>
+        <p:nvSpPr>
+          <p:cNvPr id="3" name="Notes Placeholder 2"/>
+          <p:cNvSpPr>
+            <a:spLocks noGrp="1"/>
+          </p:cNvSpPr>
+          <p:nvPr>
+            <p:ph type="body" idx="1"/>
+          </p:nvPr>
+        </p:nvSpPr>
+        <p:spPr/>
+        <p:txBody>
+          <a:bodyPr/>
+          <a:lstStyle/>
+          <a:p>
+            <a:r>
+              <a:rPr lang="en-US" dirty="0"/>
+              <a:t>Il problema dei tipi tornerà con l'Excel. Ricordare di creare l'account Kaggle.</a:t>
+            </a:r>
+            <a:endParaRPr lang="en-US" dirty="0"/>
+          </a:p>
+        </p:txBody>
+      </p:sp>
+      <p:sp>
+        <p:nvSpPr>
+          <p:cNvPr id="4" name="Slide Number Placeholder 3"/>
+          <p:cNvSpPr>
+            <a:spLocks noGrp="1"/>
+          </p:cNvSpPr>
+          <p:nvPr>
+            <p:ph type="sldNum" sz="quarter" idx="10"/>
+          </p:nvPr>
+        </p:nvSpPr>
+        <p:spPr/>
+        <p:txBody>
+          <a:bodyPr/>
+          <a:lstStyle/>
+          <a:p>
+            <a:fld id="{F7021451-1387-4CA6-816F-3879F97B5CBC}" type="slidenum">
+              <a:rPr lang="en-US"/>
+              <a:t>10</a:t>
+            </a:fld>
+            <a:endParaRPr lang="en-US"/>
+          </a:p>
+        </p:txBody>
+      </p:sp>
+    </p:spTree>
+    <p:extLst>
+      <p:ext uri="{BB962C8B-B14F-4D97-AF65-F5344CB8AC3E}">
+        <p14:creationId xmlns:p14="http://schemas.microsoft.com/office/powerpoint/2010/main" val="1024086991"/>
+      </p:ext>
+    </p:extLst>
+  </p:cSld>
+  <p:clrMapOvr>
+    <a:masterClrMapping/>
+  </p:clrMapOvr>
+</p:notes>
+</file>
+
 <file path=ppt/notesSlides/notesSlide2.xml><?xml version="1.0" encoding="utf-8"?>
 <p:notes xmlns:a="http://schemas.openxmlformats.org/drawingml/2006/main" xmlns:r="http://schemas.openxmlformats.org/officeDocument/2006/relationships" xmlns:p="http://schemas.openxmlformats.org/presentationml/2006/main">
   <p:cSld>
@@ -1248,7 +1342,7 @@
           <a:p>
             <a:r>
               <a:rPr lang="en-US" dirty="0"/>
-              <a:t>Il problema dei tipi tornerà con l'Excel. Ricordare di creare l'account Kaggle.</a:t>
+              <a:t>Facoltativo: chi non vuole un account GitHub può continuare a salvare su Drive. Il fork è utile anche dopo il corso, come archivio personale del proprio lavoro. Di default il fork copia solo il branch principale, quindi niente soluzioni: vanno lette dal link nel README.</a:t>
             </a:r>
             <a:endParaRPr lang="en-US" dirty="0"/>
           </a:p>
@@ -2118,6 +2212,107 @@
 </p:sld>
 </file>
 
+<file path=ppt/slides/slide10.xml><?xml version="1.0" encoding="utf-8"?>
+<p:sld xmlns:a="http://schemas.openxmlformats.org/drawingml/2006/main" xmlns:r="http://schemas.openxmlformats.org/officeDocument/2006/relationships" xmlns:p="http://schemas.openxmlformats.org/presentationml/2006/main">
+  <p:cSld name="Slide 10">
+    <p:spTree>
+      <p:nvGrpSpPr>
+        <p:cNvPr id="1" name=""/>
+        <p:cNvGrpSpPr/>
+        <p:nvPr/>
+      </p:nvGrpSpPr>
+      <p:grpSpPr>
+        <a:xfrm>
+          <a:off x="0" y="0"/>
+          <a:ext cx="0" cy="0"/>
+          <a:chOff x="0" y="0"/>
+          <a:chExt cx="0" cy="0"/>
+        </a:xfrm>
+      </p:grpSpPr>
+      <p:sp>
+        <p:nvSpPr>
+          <p:cNvPr id="2" name="Text 0"/>
+          <p:cNvSpPr/>
+          <p:nvPr>
+            <p:ph idx="100" type="title" hasCustomPrompt="1"/>
+          </p:nvPr>
+        </p:nvSpPr>
+        <p:spPr>
+          <a:xfrm>
+            <a:off x="731520" y="2103120"/>
+            <a:ext cx="10698480" cy="1463040"/>
+          </a:xfrm>
+          <a:prstGeom prst="rect">
+            <a:avLst/>
+          </a:prstGeom>
+          <a:noFill/>
+          <a:ln/>
+        </p:spPr>
+        <p:txBody>
+          <a:bodyPr wrap="square" lIns="0" tIns="0" rIns="0" bIns="0" rtlCol="0" anchor="b"/>
+          <a:lstStyle/>
+          <a:p>
+            <a:pPr algn="l" indent="0" marL="0">
+              <a:buNone/>
+            </a:pPr>
+            <a:r>
+              <a:rPr lang="en-US" sz="4800" b="1" dirty="0">
+                <a:solidFill>
+                  <a:srgbClr val="FFFFFF"/>
+                </a:solidFill>
+              </a:rPr>
+              <a:t>Prossima volta: un file Excel</a:t>
+            </a:r>
+            <a:endParaRPr lang="en-US" sz="4800" dirty="0"/>
+          </a:p>
+        </p:txBody>
+      </p:sp>
+      <p:sp>
+        <p:nvSpPr>
+          <p:cNvPr id="3" name="Text 0"/>
+          <p:cNvSpPr/>
+          <p:nvPr>
+            <p:ph idx="101" type="body" hasCustomPrompt="1"/>
+          </p:nvPr>
+        </p:nvSpPr>
+        <p:spPr>
+          <a:xfrm>
+            <a:off x="731520" y="3749040"/>
+            <a:ext cx="10698480" cy="914400"/>
+          </a:xfrm>
+          <a:prstGeom prst="rect">
+            <a:avLst/>
+          </a:prstGeom>
+          <a:noFill/>
+          <a:ln/>
+        </p:spPr>
+        <p:txBody>
+          <a:bodyPr wrap="square" lIns="0" tIns="0" rIns="0" bIns="0" rtlCol="0" anchor="t"/>
+          <a:lstStyle/>
+          <a:p>
+            <a:pPr indent="0" marL="0">
+              <a:buNone/>
+            </a:pPr>
+            <a:r>
+              <a:rPr lang="en-US" sz="2200" dirty="0">
+                <a:solidFill>
+                  <a:srgbClr val="F4C06E"/>
+                </a:solidFill>
+              </a:rPr>
+              <a:t>Compito: Kaggle Learn – Python, lezione «Hello, Python» (~30 min)</a:t>
+            </a:r>
+            <a:endParaRPr lang="en-US" sz="2200" dirty="0"/>
+          </a:p>
+        </p:txBody>
+      </p:sp>
+    </p:spTree>
+  </p:cSld>
+  <p:clrMapOvr>
+    <a:masterClrMapping/>
+  </p:clrMapOvr>
+</p:sld>
+</file>
+
 <file path=ppt/slides/slide2.xml><?xml version="1.0" encoding="utf-8"?>
 <p:sld xmlns:a="http://schemas.openxmlformats.org/drawingml/2006/main" xmlns:r="http://schemas.openxmlformats.org/officeDocument/2006/relationships" xmlns:p="http://schemas.openxmlformats.org/presentationml/2006/main">
   <p:cSld name="Slide 2">
@@ -5866,69 +6061,752 @@
         </p:nvSpPr>
         <p:spPr>
           <a:xfrm>
-            <a:off x="731520" y="2103120"/>
-            <a:ext cx="10698480" cy="1463040"/>
-          </a:xfrm>
-          <a:prstGeom prst="rect">
-            <a:avLst/>
-          </a:prstGeom>
-          <a:noFill/>
-          <a:ln/>
-        </p:spPr>
-        <p:txBody>
-          <a:bodyPr wrap="square" lIns="0" tIns="0" rIns="0" bIns="0" rtlCol="0" anchor="b"/>
+            <a:off x="548640" y="365760"/>
+            <a:ext cx="11064240" cy="822960"/>
+          </a:xfrm>
+          <a:prstGeom prst="rect">
+            <a:avLst/>
+          </a:prstGeom>
+          <a:noFill/>
+          <a:ln/>
+        </p:spPr>
+        <p:txBody>
+          <a:bodyPr wrap="square" lIns="0" tIns="0" rIns="0" bIns="0" rtlCol="0" anchor="ctr"/>
           <a:lstStyle/>
           <a:p>
             <a:pPr algn="l" indent="0" marL="0">
               <a:buNone/>
             </a:pPr>
             <a:r>
-              <a:rPr lang="en-US" sz="4800" b="1" dirty="0">
+              <a:rPr lang="en-US" sz="3600" b="1" dirty="0">
+                <a:solidFill>
+                  <a:srgbClr val="0F4C5C"/>
+                </a:solidFill>
+              </a:rPr>
+              <a:t>Extra: una copia del corso tutta tua</a:t>
+            </a:r>
+            <a:endParaRPr lang="en-US" sz="3600" dirty="0"/>
+          </a:p>
+        </p:txBody>
+      </p:sp>
+      <p:sp>
+        <p:nvSpPr>
+          <p:cNvPr id="3" name="Shape 1"/>
+          <p:cNvSpPr/>
+          <p:nvPr/>
+        </p:nvSpPr>
+        <p:spPr>
+          <a:xfrm>
+            <a:off x="548640" y="1737360"/>
+            <a:ext cx="2606040" cy="2194560"/>
+          </a:xfrm>
+          <a:prstGeom prst="roundRect">
+            <a:avLst>
+              <a:gd name="adj" fmla="val 5000"/>
+            </a:avLst>
+          </a:prstGeom>
+          <a:solidFill>
+            <a:srgbClr val="EEF3F4"/>
+          </a:solidFill>
+          <a:ln/>
+        </p:spPr>
+      </p:sp>
+      <p:sp>
+        <p:nvSpPr>
+          <p:cNvPr id="4" name="Shape 2"/>
+          <p:cNvSpPr/>
+          <p:nvPr/>
+        </p:nvSpPr>
+        <p:spPr>
+          <a:xfrm>
+            <a:off x="822960" y="2011680"/>
+            <a:ext cx="640080" cy="640080"/>
+          </a:xfrm>
+          <a:prstGeom prst="ellipse">
+            <a:avLst/>
+          </a:prstGeom>
+          <a:solidFill>
+            <a:srgbClr val="E09F3E"/>
+          </a:solidFill>
+          <a:ln/>
+        </p:spPr>
+      </p:sp>
+      <p:sp>
+        <p:nvSpPr>
+          <p:cNvPr id="5" name="Text 3"/>
+          <p:cNvSpPr txBox="1"/>
+          <p:nvPr/>
+        </p:nvSpPr>
+        <p:spPr>
+          <a:xfrm>
+            <a:off x="822960" y="2011680"/>
+            <a:ext cx="640080" cy="640080"/>
+          </a:xfrm>
+          <a:prstGeom prst="rect">
+            <a:avLst/>
+          </a:prstGeom>
+          <a:noFill/>
+          <a:ln/>
+        </p:spPr>
+        <p:txBody>
+          <a:bodyPr wrap="square" lIns="0" tIns="0" rIns="0" bIns="0" rtlCol="0" anchor="ctr"/>
+          <a:lstStyle/>
+          <a:p>
+            <a:pPr algn="ctr" indent="0" marL="0">
+              <a:buNone/>
+            </a:pPr>
+            <a:r>
+              <a:rPr lang="en-US" sz="1820" b="1" dirty="0">
+                <a:solidFill>
+                  <a:srgbClr val="1F2A30"/>
+                </a:solidFill>
+              </a:rPr>
+              <a:t>1</a:t>
+            </a:r>
+            <a:endParaRPr lang="en-US" sz="1820" dirty="0"/>
+          </a:p>
+        </p:txBody>
+      </p:sp>
+      <p:sp>
+        <p:nvSpPr>
+          <p:cNvPr id="6" name="Text 4"/>
+          <p:cNvSpPr txBox="1"/>
+          <p:nvPr/>
+        </p:nvSpPr>
+        <p:spPr>
+          <a:xfrm>
+            <a:off x="822960" y="2788920"/>
+            <a:ext cx="2148840" cy="457200"/>
+          </a:xfrm>
+          <a:prstGeom prst="rect">
+            <a:avLst/>
+          </a:prstGeom>
+          <a:noFill/>
+          <a:ln/>
+        </p:spPr>
+        <p:txBody>
+          <a:bodyPr wrap="square" lIns="0" tIns="0" rIns="0" bIns="0" rtlCol="0" anchor="ctr"/>
+          <a:lstStyle/>
+          <a:p>
+            <a:pPr indent="0" marL="0">
+              <a:buNone/>
+            </a:pPr>
+            <a:r>
+              <a:rPr lang="en-US" sz="1900" b="1" dirty="0">
+                <a:solidFill>
+                  <a:srgbClr val="1F2A30"/>
+                </a:solidFill>
+              </a:rPr>
+              <a:t>Crea un account</a:t>
+            </a:r>
+            <a:endParaRPr lang="en-US" sz="1900" dirty="0"/>
+          </a:p>
+        </p:txBody>
+      </p:sp>
+      <p:sp>
+        <p:nvSpPr>
+          <p:cNvPr id="7" name="Text 5"/>
+          <p:cNvSpPr txBox="1"/>
+          <p:nvPr/>
+        </p:nvSpPr>
+        <p:spPr>
+          <a:xfrm>
+            <a:off x="822960" y="3246120"/>
+            <a:ext cx="2148840" cy="594360"/>
+          </a:xfrm>
+          <a:prstGeom prst="rect">
+            <a:avLst/>
+          </a:prstGeom>
+          <a:noFill/>
+          <a:ln/>
+        </p:spPr>
+        <p:txBody>
+          <a:bodyPr wrap="square" lIns="0" tIns="0" rIns="0" bIns="0" rtlCol="0" anchor="t"/>
+          <a:lstStyle/>
+          <a:p>
+            <a:pPr indent="0" marL="0">
+              <a:buNone/>
+            </a:pPr>
+            <a:r>
+              <a:rPr lang="en-US" sz="1300" dirty="0">
+                <a:solidFill>
+                  <a:srgbClr val="5C6F7B"/>
+                </a:solidFill>
+              </a:rPr>
+              <a:t>su github.com, gratuito</a:t>
+            </a:r>
+            <a:endParaRPr lang="en-US" sz="1300" dirty="0"/>
+          </a:p>
+        </p:txBody>
+      </p:sp>
+      <p:sp>
+        <p:nvSpPr>
+          <p:cNvPr id="8" name="Shape 6"/>
+          <p:cNvSpPr/>
+          <p:nvPr/>
+        </p:nvSpPr>
+        <p:spPr>
+          <a:xfrm>
+            <a:off x="3383280" y="1737360"/>
+            <a:ext cx="2606040" cy="2194560"/>
+          </a:xfrm>
+          <a:prstGeom prst="roundRect">
+            <a:avLst>
+              <a:gd name="adj" fmla="val 5000"/>
+            </a:avLst>
+          </a:prstGeom>
+          <a:solidFill>
+            <a:srgbClr val="EEF3F4"/>
+          </a:solidFill>
+          <a:ln/>
+        </p:spPr>
+      </p:sp>
+      <p:sp>
+        <p:nvSpPr>
+          <p:cNvPr id="9" name="Shape 7"/>
+          <p:cNvSpPr/>
+          <p:nvPr/>
+        </p:nvSpPr>
+        <p:spPr>
+          <a:xfrm>
+            <a:off x="3657600" y="2011680"/>
+            <a:ext cx="640080" cy="640080"/>
+          </a:xfrm>
+          <a:prstGeom prst="ellipse">
+            <a:avLst/>
+          </a:prstGeom>
+          <a:solidFill>
+            <a:srgbClr val="E09F3E"/>
+          </a:solidFill>
+          <a:ln/>
+        </p:spPr>
+      </p:sp>
+      <p:sp>
+        <p:nvSpPr>
+          <p:cNvPr id="10" name="Text 8"/>
+          <p:cNvSpPr txBox="1"/>
+          <p:nvPr/>
+        </p:nvSpPr>
+        <p:spPr>
+          <a:xfrm>
+            <a:off x="3657600" y="2011680"/>
+            <a:ext cx="640080" cy="640080"/>
+          </a:xfrm>
+          <a:prstGeom prst="rect">
+            <a:avLst/>
+          </a:prstGeom>
+          <a:noFill/>
+          <a:ln/>
+        </p:spPr>
+        <p:txBody>
+          <a:bodyPr wrap="square" lIns="0" tIns="0" rIns="0" bIns="0" rtlCol="0" anchor="ctr"/>
+          <a:lstStyle/>
+          <a:p>
+            <a:pPr algn="ctr" indent="0" marL="0">
+              <a:buNone/>
+            </a:pPr>
+            <a:r>
+              <a:rPr lang="en-US" sz="1820" b="1" dirty="0">
+                <a:solidFill>
+                  <a:srgbClr val="1F2A30"/>
+                </a:solidFill>
+              </a:rPr>
+              <a:t>2</a:t>
+            </a:r>
+            <a:endParaRPr lang="en-US" sz="1820" dirty="0"/>
+          </a:p>
+        </p:txBody>
+      </p:sp>
+      <p:sp>
+        <p:nvSpPr>
+          <p:cNvPr id="11" name="Text 9"/>
+          <p:cNvSpPr txBox="1"/>
+          <p:nvPr/>
+        </p:nvSpPr>
+        <p:spPr>
+          <a:xfrm>
+            <a:off x="3657600" y="2788920"/>
+            <a:ext cx="2148840" cy="457200"/>
+          </a:xfrm>
+          <a:prstGeom prst="rect">
+            <a:avLst/>
+          </a:prstGeom>
+          <a:noFill/>
+          <a:ln/>
+        </p:spPr>
+        <p:txBody>
+          <a:bodyPr wrap="square" lIns="0" tIns="0" rIns="0" bIns="0" rtlCol="0" anchor="ctr"/>
+          <a:lstStyle/>
+          <a:p>
+            <a:pPr indent="0" marL="0">
+              <a:buNone/>
+            </a:pPr>
+            <a:r>
+              <a:rPr lang="en-US" sz="1900" b="1" dirty="0">
+                <a:solidFill>
+                  <a:srgbClr val="1F2A30"/>
+                </a:solidFill>
+              </a:rPr>
+              <a:t>Apri il repository</a:t>
+            </a:r>
+            <a:endParaRPr lang="en-US" sz="1900" dirty="0"/>
+          </a:p>
+        </p:txBody>
+      </p:sp>
+      <p:sp>
+        <p:nvSpPr>
+          <p:cNvPr id="12" name="Text 10"/>
+          <p:cNvSpPr txBox="1"/>
+          <p:nvPr/>
+        </p:nvSpPr>
+        <p:spPr>
+          <a:xfrm>
+            <a:off x="3657600" y="3246120"/>
+            <a:ext cx="2148840" cy="594360"/>
+          </a:xfrm>
+          <a:prstGeom prst="rect">
+            <a:avLst/>
+          </a:prstGeom>
+          <a:noFill/>
+          <a:ln/>
+        </p:spPr>
+        <p:txBody>
+          <a:bodyPr wrap="square" lIns="0" tIns="0" rIns="0" bIns="0" rtlCol="0" anchor="t"/>
+          <a:lstStyle/>
+          <a:p>
+            <a:pPr indent="0" marL="0">
+              <a:buNone/>
+            </a:pPr>
+            <a:r>
+              <a:rPr lang="en-US" sz="1300" dirty="0">
+                <a:solidFill>
+                  <a:srgbClr val="5C6F7B"/>
+                </a:solidFill>
+              </a:rPr>
+              <a:t>github.com/andrealorenzon/SIMA2026</a:t>
+            </a:r>
+            <a:endParaRPr lang="en-US" sz="1300" dirty="0"/>
+          </a:p>
+        </p:txBody>
+      </p:sp>
+      <p:sp>
+        <p:nvSpPr>
+          <p:cNvPr id="13" name="Shape 11"/>
+          <p:cNvSpPr/>
+          <p:nvPr/>
+        </p:nvSpPr>
+        <p:spPr>
+          <a:xfrm>
+            <a:off x="6217920" y="1737360"/>
+            <a:ext cx="2606040" cy="2194560"/>
+          </a:xfrm>
+          <a:prstGeom prst="roundRect">
+            <a:avLst>
+              <a:gd name="adj" fmla="val 5000"/>
+            </a:avLst>
+          </a:prstGeom>
+          <a:solidFill>
+            <a:srgbClr val="EEF3F4"/>
+          </a:solidFill>
+          <a:ln/>
+        </p:spPr>
+      </p:sp>
+      <p:sp>
+        <p:nvSpPr>
+          <p:cNvPr id="14" name="Shape 12"/>
+          <p:cNvSpPr/>
+          <p:nvPr/>
+        </p:nvSpPr>
+        <p:spPr>
+          <a:xfrm>
+            <a:off x="6492240" y="2011680"/>
+            <a:ext cx="640080" cy="640080"/>
+          </a:xfrm>
+          <a:prstGeom prst="ellipse">
+            <a:avLst/>
+          </a:prstGeom>
+          <a:solidFill>
+            <a:srgbClr val="E09F3E"/>
+          </a:solidFill>
+          <a:ln/>
+        </p:spPr>
+      </p:sp>
+      <p:sp>
+        <p:nvSpPr>
+          <p:cNvPr id="15" name="Text 13"/>
+          <p:cNvSpPr txBox="1"/>
+          <p:nvPr/>
+        </p:nvSpPr>
+        <p:spPr>
+          <a:xfrm>
+            <a:off x="6492240" y="2011680"/>
+            <a:ext cx="640080" cy="640080"/>
+          </a:xfrm>
+          <a:prstGeom prst="rect">
+            <a:avLst/>
+          </a:prstGeom>
+          <a:noFill/>
+          <a:ln/>
+        </p:spPr>
+        <p:txBody>
+          <a:bodyPr wrap="square" lIns="0" tIns="0" rIns="0" bIns="0" rtlCol="0" anchor="ctr"/>
+          <a:lstStyle/>
+          <a:p>
+            <a:pPr algn="ctr" indent="0" marL="0">
+              <a:buNone/>
+            </a:pPr>
+            <a:r>
+              <a:rPr lang="en-US" sz="1820" b="1" dirty="0">
+                <a:solidFill>
+                  <a:srgbClr val="1F2A30"/>
+                </a:solidFill>
+              </a:rPr>
+              <a:t>3</a:t>
+            </a:r>
+            <a:endParaRPr lang="en-US" sz="1820" dirty="0"/>
+          </a:p>
+        </p:txBody>
+      </p:sp>
+      <p:sp>
+        <p:nvSpPr>
+          <p:cNvPr id="16" name="Text 14"/>
+          <p:cNvSpPr txBox="1"/>
+          <p:nvPr/>
+        </p:nvSpPr>
+        <p:spPr>
+          <a:xfrm>
+            <a:off x="6492240" y="2788920"/>
+            <a:ext cx="2148840" cy="457200"/>
+          </a:xfrm>
+          <a:prstGeom prst="rect">
+            <a:avLst/>
+          </a:prstGeom>
+          <a:noFill/>
+          <a:ln/>
+        </p:spPr>
+        <p:txBody>
+          <a:bodyPr wrap="square" lIns="0" tIns="0" rIns="0" bIns="0" rtlCol="0" anchor="ctr"/>
+          <a:lstStyle/>
+          <a:p>
+            <a:pPr indent="0" marL="0">
+              <a:buNone/>
+            </a:pPr>
+            <a:r>
+              <a:rPr lang="en-US" sz="1900" b="1" dirty="0">
+                <a:solidFill>
+                  <a:srgbClr val="1F2A30"/>
+                </a:solidFill>
+              </a:rPr>
+              <a:t>Clicca «Fork»</a:t>
+            </a:r>
+            <a:endParaRPr lang="en-US" sz="1900" dirty="0"/>
+          </a:p>
+        </p:txBody>
+      </p:sp>
+      <p:sp>
+        <p:nvSpPr>
+          <p:cNvPr id="17" name="Text 15"/>
+          <p:cNvSpPr txBox="1"/>
+          <p:nvPr/>
+        </p:nvSpPr>
+        <p:spPr>
+          <a:xfrm>
+            <a:off x="6492240" y="3246120"/>
+            <a:ext cx="2148840" cy="594360"/>
+          </a:xfrm>
+          <a:prstGeom prst="rect">
+            <a:avLst/>
+          </a:prstGeom>
+          <a:noFill/>
+          <a:ln/>
+        </p:spPr>
+        <p:txBody>
+          <a:bodyPr wrap="square" lIns="0" tIns="0" rIns="0" bIns="0" rtlCol="0" anchor="t"/>
+          <a:lstStyle/>
+          <a:p>
+            <a:pPr indent="0" marL="0">
+              <a:buNone/>
+            </a:pPr>
+            <a:r>
+              <a:rPr lang="en-US" sz="1300" dirty="0">
+                <a:solidFill>
+                  <a:srgbClr val="5C6F7B"/>
+                </a:solidFill>
+              </a:rPr>
+              <a:t>in alto a destra, poi «Create fork»</a:t>
+            </a:r>
+            <a:endParaRPr lang="en-US" sz="1300" dirty="0"/>
+          </a:p>
+        </p:txBody>
+      </p:sp>
+      <p:sp>
+        <p:nvSpPr>
+          <p:cNvPr id="18" name="Shape 16"/>
+          <p:cNvSpPr/>
+          <p:nvPr/>
+        </p:nvSpPr>
+        <p:spPr>
+          <a:xfrm>
+            <a:off x="9052560" y="1737360"/>
+            <a:ext cx="2606040" cy="2194560"/>
+          </a:xfrm>
+          <a:prstGeom prst="roundRect">
+            <a:avLst>
+              <a:gd name="adj" fmla="val 5000"/>
+            </a:avLst>
+          </a:prstGeom>
+          <a:solidFill>
+            <a:srgbClr val="0F4C5C"/>
+          </a:solidFill>
+          <a:ln/>
+        </p:spPr>
+      </p:sp>
+      <p:sp>
+        <p:nvSpPr>
+          <p:cNvPr id="19" name="Shape 17"/>
+          <p:cNvSpPr/>
+          <p:nvPr/>
+        </p:nvSpPr>
+        <p:spPr>
+          <a:xfrm>
+            <a:off x="9326880" y="2011680"/>
+            <a:ext cx="640080" cy="640080"/>
+          </a:xfrm>
+          <a:prstGeom prst="ellipse">
+            <a:avLst/>
+          </a:prstGeom>
+          <a:solidFill>
+            <a:srgbClr val="E09F3E"/>
+          </a:solidFill>
+          <a:ln/>
+        </p:spPr>
+      </p:sp>
+      <p:sp>
+        <p:nvSpPr>
+          <p:cNvPr id="20" name="Text 18"/>
+          <p:cNvSpPr txBox="1"/>
+          <p:nvPr/>
+        </p:nvSpPr>
+        <p:spPr>
+          <a:xfrm>
+            <a:off x="9326880" y="2011680"/>
+            <a:ext cx="640080" cy="640080"/>
+          </a:xfrm>
+          <a:prstGeom prst="rect">
+            <a:avLst/>
+          </a:prstGeom>
+          <a:noFill/>
+          <a:ln/>
+        </p:spPr>
+        <p:txBody>
+          <a:bodyPr wrap="square" lIns="0" tIns="0" rIns="0" bIns="0" rtlCol="0" anchor="ctr"/>
+          <a:lstStyle/>
+          <a:p>
+            <a:pPr algn="ctr" indent="0" marL="0">
+              <a:buNone/>
+            </a:pPr>
+            <a:r>
+              <a:rPr lang="en-US" sz="1820" b="1" dirty="0">
+                <a:solidFill>
+                  <a:srgbClr val="1F2A30"/>
+                </a:solidFill>
+              </a:rPr>
+              <a:t>4</a:t>
+            </a:r>
+            <a:endParaRPr lang="en-US" sz="1820" dirty="0"/>
+          </a:p>
+        </p:txBody>
+      </p:sp>
+      <p:sp>
+        <p:nvSpPr>
+          <p:cNvPr id="21" name="Text 19"/>
+          <p:cNvSpPr txBox="1"/>
+          <p:nvPr/>
+        </p:nvSpPr>
+        <p:spPr>
+          <a:xfrm>
+            <a:off x="9326880" y="2788920"/>
+            <a:ext cx="2148840" cy="457200"/>
+          </a:xfrm>
+          <a:prstGeom prst="rect">
+            <a:avLst/>
+          </a:prstGeom>
+          <a:noFill/>
+          <a:ln/>
+        </p:spPr>
+        <p:txBody>
+          <a:bodyPr wrap="square" lIns="0" tIns="0" rIns="0" bIns="0" rtlCol="0" anchor="ctr"/>
+          <a:lstStyle/>
+          <a:p>
+            <a:pPr indent="0" marL="0">
+              <a:buNone/>
+            </a:pPr>
+            <a:r>
+              <a:rPr lang="en-US" sz="1900" b="1" dirty="0">
                 <a:solidFill>
                   <a:srgbClr val="FFFFFF"/>
                 </a:solidFill>
               </a:rPr>
-              <a:t>Prossima volta: un file Excel</a:t>
-            </a:r>
-            <a:endParaRPr lang="en-US" sz="4800" dirty="0"/>
-          </a:p>
-        </p:txBody>
-      </p:sp>
-      <p:sp>
-        <p:nvSpPr>
-          <p:cNvPr id="3" name="Text 0"/>
-          <p:cNvSpPr/>
+              <a:t>È tuo</a:t>
+            </a:r>
+            <a:endParaRPr lang="en-US" sz="1900" dirty="0"/>
+          </a:p>
+        </p:txBody>
+      </p:sp>
+      <p:sp>
+        <p:nvSpPr>
+          <p:cNvPr id="22" name="Text 20"/>
+          <p:cNvSpPr txBox="1"/>
+          <p:nvPr/>
+        </p:nvSpPr>
+        <p:spPr>
+          <a:xfrm>
+            <a:off x="9326880" y="3246120"/>
+            <a:ext cx="2148840" cy="594360"/>
+          </a:xfrm>
+          <a:prstGeom prst="rect">
+            <a:avLst/>
+          </a:prstGeom>
+          <a:noFill/>
+          <a:ln/>
+        </p:spPr>
+        <p:txBody>
+          <a:bodyPr wrap="square" lIns="0" tIns="0" rIns="0" bIns="0" rtlCol="0" anchor="t"/>
+          <a:lstStyle/>
+          <a:p>
+            <a:pPr indent="0" marL="0">
+              <a:buNone/>
+            </a:pPr>
+            <a:r>
+              <a:rPr lang="en-US" sz="1300" dirty="0">
+                <a:solidFill>
+                  <a:srgbClr val="B8C4CB"/>
+                </a:solidFill>
+              </a:rPr>
+              <a:t>github.com/&lt;tuo-nome&gt;/SIMA2026</a:t>
+            </a:r>
+            <a:endParaRPr lang="en-US" sz="1300" dirty="0"/>
+          </a:p>
+        </p:txBody>
+      </p:sp>
+      <p:sp>
+        <p:nvSpPr>
+          <p:cNvPr id="23" name="Text 21"/>
+          <p:cNvSpPr txBox="1"/>
+          <p:nvPr/>
+        </p:nvSpPr>
+        <p:spPr>
+          <a:xfrm>
+            <a:off x="548640" y="4251960"/>
+            <a:ext cx="11064240" cy="1554480"/>
+          </a:xfrm>
+          <a:prstGeom prst="rect">
+            <a:avLst/>
+          </a:prstGeom>
+          <a:noFill/>
+          <a:ln/>
+        </p:spPr>
+        <p:txBody>
+          <a:bodyPr wrap="square" lIns="0" tIns="0" rIns="0" bIns="0" rtlCol="0" anchor="t"/>
+          <a:lstStyle/>
+          <a:p>
+            <a:pPr marL="342900" indent="-342900">
+              <a:spcAft>
+                <a:spcPts val="1000"/>
+              </a:spcAft>
+              <a:buSzPct val="100000"/>
+              <a:buChar char="•"/>
+            </a:pPr>
+            <a:r>
+              <a:rPr lang="en-US" sz="1700" dirty="0">
+                <a:solidFill>
+                  <a:srgbClr val="1F2A30"/>
+                </a:solidFill>
+              </a:rPr>
+              <a:t>Un fork è una copia del repository nel tuo account: puoi modificarla senza toccare l'originale.</a:t>
+            </a:r>
+            <a:endParaRPr lang="en-US" sz="1700" dirty="0"/>
+          </a:p>
+          <a:p>
+            <a:pPr marL="342900" indent="-342900">
+              <a:spcAft>
+                <a:spcPts val="1000"/>
+              </a:spcAft>
+              <a:buSzPct val="100000"/>
+              <a:buChar char="•"/>
+            </a:pPr>
+            <a:r>
+              <a:rPr lang="en-US" sz="1700" dirty="0">
+                <a:solidFill>
+                  <a:srgbClr val="1F2A30"/>
+                </a:solidFill>
+              </a:rPr>
+              <a:t>Da Colab salvi i notebook direttamente lì: File → Salva una copia in GitHub.</a:t>
+            </a:r>
+            <a:endParaRPr lang="en-US" sz="1700" dirty="0"/>
+          </a:p>
+          <a:p>
+            <a:pPr marL="342900" indent="-342900">
+              <a:spcAft>
+                <a:spcPts val="1000"/>
+              </a:spcAft>
+              <a:buSzPct val="100000"/>
+              <a:buChar char="•"/>
+            </a:pPr>
+            <a:r>
+              <a:rPr lang="en-US" sz="1700" dirty="0">
+                <a:solidFill>
+                  <a:srgbClr val="1F2A30"/>
+                </a:solidFill>
+              </a:rPr>
+              <a:t>Quando il corso si aggiorna, sul tuo fork clicca «Sync fork» per ricevere le novità.</a:t>
+            </a:r>
+            <a:endParaRPr lang="en-US" sz="1700" dirty="0"/>
+          </a:p>
+        </p:txBody>
+      </p:sp>
+      <p:sp>
+        <p:nvSpPr>
+          <p:cNvPr id="25" name="Slide Number Placeholder 0"/>
+          <p:cNvSpPr>
+            <a:spLocks noGrp="1"/>
+          </p:cNvSpPr>
           <p:nvPr>
-            <p:ph idx="101" type="body" hasCustomPrompt="1"/>
+            <p:ph type="sldNum" sz="quarter" idx="4294967295"/>
           </p:nvPr>
         </p:nvSpPr>
         <p:spPr>
           <a:xfrm>
-            <a:off x="731520" y="3749040"/>
-            <a:ext cx="10698480" cy="914400"/>
-          </a:xfrm>
-          <a:prstGeom prst="rect">
-            <a:avLst/>
-          </a:prstGeom>
-          <a:noFill/>
-          <a:ln/>
-        </p:spPr>
-        <p:txBody>
-          <a:bodyPr wrap="square" lIns="0" tIns="0" rIns="0" bIns="0" rtlCol="0" anchor="t"/>
-          <a:lstStyle/>
-          <a:p>
-            <a:pPr indent="0" marL="0">
-              <a:buNone/>
-            </a:pPr>
-            <a:r>
-              <a:rPr lang="en-US" sz="2200" dirty="0">
-                <a:solidFill>
-                  <a:srgbClr val="F4C06E"/>
-                </a:solidFill>
-              </a:rPr>
-              <a:t>Compito: Kaggle Learn – Python, lezione «Hello, Python» (~30 min)</a:t>
-            </a:r>
-            <a:endParaRPr lang="en-US" sz="2200" dirty="0"/>
+            <a:off x="11155680" y="6400800"/>
+            <a:ext cx="457200" cy="274320"/>
+          </a:xfrm>
+          <a:prstGeom prst="rect">
+            <a:avLst/>
+          </a:prstGeom>
+          <a:extLst>
+            <a:ext uri="{C572A759-6A51-4108-AA02-DFA0A04FC94B}">
+              <ma14:wrappingTextBoxFlag xmlns:ma14="http://schemas.microsoft.com/office/mac/drawingml/2011/main" val="0"/>
+            </a:ext>
+          </a:extLst>
+        </p:spPr>
+        <p:txBody>
+          <a:bodyPr/>
+          <a:lstStyle>
+            <a:lvl1pPr>
+              <a:defRPr sz="1000">
+                <a:solidFill>
+                  <a:srgbClr val="5C6F7B"/>
+                </a:solidFill>
+              </a:defRPr>
+            </a:lvl1pPr>
+          </a:lstStyle>
+          <a:p>
+            <a:pPr algn="r"/>
+            <a:fld id="{F7021451-1387-4CA6-816F-3879F97B5CBC}" type="slidenum">
+              <a:rPr b="0" lang="en-US"/>
+              <a:t>9</a:t>
+            </a:fld>
+            <a:endParaRPr lang="en-US"/>
           </a:p>
         </p:txBody>
       </p:sp>

</xml_diff>

<commit_message>
Gruppi da 3 con ruoli e tutorial su Gemini
- notebook, README e slide L1: si lavora in gruppi da 3 con ruoli a rotazione (scrive, cerca, controlla)
- preparazione/00_gemini_colab.ipynb: mini tutorial autonomo su Gemini in Colab, da fare prima del corso

Co-Authored-By: Claude Opus 5.5 <noreply@anthropic.com>
Claude-Session: https://claude.ai/code/session_014CzWDFXvYNxqLeD99LSN3G
</commit_message>
<xml_diff>
--- a/lezioni/L01_python_calcolatrice/slide.pptx
+++ b/lezioni/L01_python_calcolatrice/slide.pptx
@@ -15,9 +15,10 @@
     <p:sldId id="263" r:id="rId9"/>
     <p:sldId id="264" r:id="rId10"/>
     <p:sldId id="265" r:id="rId11"/>
+    <p:sldId id="266" r:id="rId12"/>
   </p:sldIdLst>
   <p:notesMasterIdLst>
-    <p:notesMasterId r:id="rId12"/>
+    <p:notesMasterId r:id="rId13"/>
   </p:notesMasterIdLst>
   <p:sldSz cx="12192000" cy="6858000"/>
   <p:notesSz cx="6858000" cy="12192000"/>
@@ -116,34 +117,35 @@
   <p:extLst>
     <p:ext uri="{521415D9-36F7-43E2-AB2F-B90AF26B5E84}">
       <p14:sectionLst xmlns:p14="http://schemas.microsoft.com/office/powerpoint/2010/main">
-        <p14:section name="Apertura" id="{0eb30d9b-720f-8a1c-dcff-760a8f253c3f}">
+        <p14:section name="Apertura" id="{3de83e26-b3e9-cd6e-0448-7738dd636257}">
           <p14:sldIdLst>
             <p14:sldId id="256"/>
             <p14:sldId id="257"/>
           </p14:sldIdLst>
         </p14:section>
-        <p14:section name="Spiegazione" id="{b4a461bb-cdad-fd1d-2a68-b1fb2121720c}">
+        <p14:section name="Spiegazione" id="{fa95151e-c72c-3f8c-1d5e-b1d458ad9b11}">
           <p14:sldIdLst>
             <p14:sldId id="258"/>
             <p14:sldId id="259"/>
             <p14:sldId id="260"/>
             <p14:sldId id="261"/>
             <p14:sldId id="262"/>
-          </p14:sldIdLst>
-        </p14:section>
-        <p14:section name="Task" id="{5ffebc4c-5e30-eb93-3d0d-a618bf1ea715}">
-          <p14:sldIdLst>
             <p14:sldId id="263"/>
           </p14:sldIdLst>
         </p14:section>
-        <p14:section name="Extra" id="{848292b6-e6aa-9579-24ff-ca23449c150e}">
+        <p14:section name="Task" id="{bbe39a02-933e-b3de-6383-3db956dc324c}">
           <p14:sldIdLst>
             <p14:sldId id="264"/>
           </p14:sldIdLst>
         </p14:section>
-        <p14:section name="Chiusura" id="{7ec1467f-d257-cc07-e7ae-d90a63ea2f00}">
+        <p14:section name="Extra" id="{d57e19fc-0073-5eed-42c7-fad39828ffa5}">
           <p14:sldIdLst>
             <p14:sldId id="265"/>
+          </p14:sldIdLst>
+        </p14:section>
+        <p14:section name="Chiusura" id="{1a974cb9-a08a-a633-da87-e0717f2f3f47}">
+          <p14:sldIdLst>
+            <p14:sldId id="266"/>
           </p14:sldIdLst>
         </p14:section>
       </p14:sectionLst>
@@ -638,7 +640,7 @@
           <a:p>
             <a:r>
               <a:rPr lang="en-US" dirty="0"/>
-              <a:t>Il problema dei tipi tornerà con l'Excel. Ricordare di creare l'account Kaggle.</a:t>
+              <a:t>Facoltativo: chi non vuole un account GitHub può continuare a salvare su Drive. Il fork è utile anche dopo il corso, come archivio personale del proprio lavoro. Di default il fork copia solo il branch principale, quindi niente soluzioni: vanno lette dal link nel README.</a:t>
             </a:r>
             <a:endParaRPr lang="en-US" dirty="0"/>
           </a:p>
@@ -662,6 +664,94 @@
             <a:fld id="{F7021451-1387-4CA6-816F-3879F97B5CBC}" type="slidenum">
               <a:rPr lang="en-US"/>
               <a:t>10</a:t>
+            </a:fld>
+            <a:endParaRPr lang="en-US"/>
+          </a:p>
+        </p:txBody>
+      </p:sp>
+    </p:spTree>
+    <p:extLst>
+      <p:ext uri="{BB962C8B-B14F-4D97-AF65-F5344CB8AC3E}">
+        <p14:creationId xmlns:p14="http://schemas.microsoft.com/office/powerpoint/2010/main" val="1024086991"/>
+      </p:ext>
+    </p:extLst>
+  </p:cSld>
+  <p:clrMapOvr>
+    <a:masterClrMapping/>
+  </p:clrMapOvr>
+</p:notes>
+</file>
+
+<file path=ppt/notesSlides/notesSlide11.xml><?xml version="1.0" encoding="utf-8"?>
+<p:notes xmlns:a="http://schemas.openxmlformats.org/drawingml/2006/main" xmlns:r="http://schemas.openxmlformats.org/officeDocument/2006/relationships" xmlns:p="http://schemas.openxmlformats.org/presentationml/2006/main">
+  <p:cSld>
+    <p:spTree>
+      <p:nvGrpSpPr>
+        <p:cNvPr id="1" name=""/>
+        <p:cNvGrpSpPr/>
+        <p:nvPr/>
+      </p:nvGrpSpPr>
+      <p:grpSpPr>
+        <a:xfrm>
+          <a:off x="0" y="0"/>
+          <a:ext cx="0" cy="0"/>
+          <a:chOff x="0" y="0"/>
+          <a:chExt cx="0" cy="0"/>
+        </a:xfrm>
+      </p:grpSpPr>
+      <p:sp>
+        <p:nvSpPr>
+          <p:cNvPr id="2" name="Slide Image Placeholder 1"/>
+          <p:cNvSpPr>
+            <a:spLocks noGrp="1" noRot="1" noChangeAspect="1"/>
+          </p:cNvSpPr>
+          <p:nvPr>
+            <p:ph type="sldImg"/>
+          </p:nvPr>
+        </p:nvSpPr>
+        <p:spPr/>
+      </p:sp>
+      <p:sp>
+        <p:nvSpPr>
+          <p:cNvPr id="3" name="Notes Placeholder 2"/>
+          <p:cNvSpPr>
+            <a:spLocks noGrp="1"/>
+          </p:cNvSpPr>
+          <p:nvPr>
+            <p:ph type="body" idx="1"/>
+          </p:nvPr>
+        </p:nvSpPr>
+        <p:spPr/>
+        <p:txBody>
+          <a:bodyPr/>
+          <a:lstStyle/>
+          <a:p>
+            <a:r>
+              <a:rPr lang="en-US" dirty="0"/>
+              <a:t>Il problema dei tipi tornerà con l'Excel. Ricordare di creare l'account Kaggle.</a:t>
+            </a:r>
+            <a:endParaRPr lang="en-US" dirty="0"/>
+          </a:p>
+        </p:txBody>
+      </p:sp>
+      <p:sp>
+        <p:nvSpPr>
+          <p:cNvPr id="4" name="Slide Number Placeholder 3"/>
+          <p:cNvSpPr>
+            <a:spLocks noGrp="1"/>
+          </p:cNvSpPr>
+          <p:nvPr>
+            <p:ph type="sldNum" sz="quarter" idx="10"/>
+          </p:nvPr>
+        </p:nvSpPr>
+        <p:spPr/>
+        <p:txBody>
+          <a:bodyPr/>
+          <a:lstStyle/>
+          <a:p>
+            <a:fld id="{F7021451-1387-4CA6-816F-3879F97B5CBC}" type="slidenum">
+              <a:rPr lang="en-US"/>
+              <a:t>11</a:t>
             </a:fld>
             <a:endParaRPr lang="en-US"/>
           </a:p>
@@ -1254,7 +1344,7 @@
           <a:p>
             <a:r>
               <a:rPr lang="en-US" dirty="0"/>
-              <a:t>Durante il task: girare tra i banchi, segnarsi le soluzioni interessanti (anche sbagliate) da mostrare nel debrief. Al passo 7 molti non capiranno: è voluto.</a:t>
+              <a:t>Su Zoom: stanze separate da 3. Comporre i gruppi mescolando chi ha già qualche esperienza (Stata, R, Excel avanzato) con chi parte da zero. Gruppi fissi per qualche settimana aiutano.</a:t>
             </a:r>
             <a:endParaRPr lang="en-US" dirty="0"/>
           </a:p>
@@ -1342,7 +1432,7 @@
           <a:p>
             <a:r>
               <a:rPr lang="en-US" dirty="0"/>
-              <a:t>Facoltativo: chi non vuole un account GitHub può continuare a salvare su Drive. Il fork è utile anche dopo il corso, come archivio personale del proprio lavoro. Di default il fork copia solo il branch principale, quindi niente soluzioni: vanno lette dal link nel README.</a:t>
+              <a:t>Durante il task: girare tra i banchi, segnarsi le soluzioni interessanti (anche sbagliate) da mostrare nel debrief. Al passo 7 molti non capiranno: è voluto.</a:t>
             </a:r>
             <a:endParaRPr lang="en-US" dirty="0"/>
           </a:p>
@@ -2239,6 +2329,790 @@
         </p:nvSpPr>
         <p:spPr>
           <a:xfrm>
+            <a:off x="548640" y="365760"/>
+            <a:ext cx="11064240" cy="822960"/>
+          </a:xfrm>
+          <a:prstGeom prst="rect">
+            <a:avLst/>
+          </a:prstGeom>
+          <a:noFill/>
+          <a:ln/>
+        </p:spPr>
+        <p:txBody>
+          <a:bodyPr wrap="square" lIns="0" tIns="0" rIns="0" bIns="0" rtlCol="0" anchor="ctr"/>
+          <a:lstStyle/>
+          <a:p>
+            <a:pPr algn="l" indent="0" marL="0">
+              <a:buNone/>
+            </a:pPr>
+            <a:r>
+              <a:rPr lang="en-US" sz="3600" b="1" dirty="0">
+                <a:solidFill>
+                  <a:srgbClr val="0F4C5C"/>
+                </a:solidFill>
+              </a:rPr>
+              <a:t>Extra: una copia del corso tutta tua</a:t>
+            </a:r>
+            <a:endParaRPr lang="en-US" sz="3600" dirty="0"/>
+          </a:p>
+        </p:txBody>
+      </p:sp>
+      <p:sp>
+        <p:nvSpPr>
+          <p:cNvPr id="3" name="Shape 1"/>
+          <p:cNvSpPr/>
+          <p:nvPr/>
+        </p:nvSpPr>
+        <p:spPr>
+          <a:xfrm>
+            <a:off x="548640" y="1737360"/>
+            <a:ext cx="2606040" cy="2194560"/>
+          </a:xfrm>
+          <a:prstGeom prst="roundRect">
+            <a:avLst>
+              <a:gd name="adj" fmla="val 5000"/>
+            </a:avLst>
+          </a:prstGeom>
+          <a:solidFill>
+            <a:srgbClr val="EEF3F4"/>
+          </a:solidFill>
+          <a:ln/>
+        </p:spPr>
+      </p:sp>
+      <p:sp>
+        <p:nvSpPr>
+          <p:cNvPr id="4" name="Shape 2"/>
+          <p:cNvSpPr/>
+          <p:nvPr/>
+        </p:nvSpPr>
+        <p:spPr>
+          <a:xfrm>
+            <a:off x="822960" y="2011680"/>
+            <a:ext cx="640080" cy="640080"/>
+          </a:xfrm>
+          <a:prstGeom prst="ellipse">
+            <a:avLst/>
+          </a:prstGeom>
+          <a:solidFill>
+            <a:srgbClr val="E09F3E"/>
+          </a:solidFill>
+          <a:ln/>
+        </p:spPr>
+      </p:sp>
+      <p:sp>
+        <p:nvSpPr>
+          <p:cNvPr id="5" name="Text 3"/>
+          <p:cNvSpPr txBox="1"/>
+          <p:nvPr/>
+        </p:nvSpPr>
+        <p:spPr>
+          <a:xfrm>
+            <a:off x="822960" y="2011680"/>
+            <a:ext cx="640080" cy="640080"/>
+          </a:xfrm>
+          <a:prstGeom prst="rect">
+            <a:avLst/>
+          </a:prstGeom>
+          <a:noFill/>
+          <a:ln/>
+        </p:spPr>
+        <p:txBody>
+          <a:bodyPr wrap="square" lIns="0" tIns="0" rIns="0" bIns="0" rtlCol="0" anchor="ctr"/>
+          <a:lstStyle/>
+          <a:p>
+            <a:pPr algn="ctr" indent="0" marL="0">
+              <a:buNone/>
+            </a:pPr>
+            <a:r>
+              <a:rPr lang="en-US" sz="1820" b="1" dirty="0">
+                <a:solidFill>
+                  <a:srgbClr val="1F2A30"/>
+                </a:solidFill>
+              </a:rPr>
+              <a:t>1</a:t>
+            </a:r>
+            <a:endParaRPr lang="en-US" sz="1820" dirty="0"/>
+          </a:p>
+        </p:txBody>
+      </p:sp>
+      <p:sp>
+        <p:nvSpPr>
+          <p:cNvPr id="6" name="Text 4"/>
+          <p:cNvSpPr txBox="1"/>
+          <p:nvPr/>
+        </p:nvSpPr>
+        <p:spPr>
+          <a:xfrm>
+            <a:off x="822960" y="2788920"/>
+            <a:ext cx="2148840" cy="457200"/>
+          </a:xfrm>
+          <a:prstGeom prst="rect">
+            <a:avLst/>
+          </a:prstGeom>
+          <a:noFill/>
+          <a:ln/>
+        </p:spPr>
+        <p:txBody>
+          <a:bodyPr wrap="square" lIns="0" tIns="0" rIns="0" bIns="0" rtlCol="0" anchor="ctr"/>
+          <a:lstStyle/>
+          <a:p>
+            <a:pPr indent="0" marL="0">
+              <a:buNone/>
+            </a:pPr>
+            <a:r>
+              <a:rPr lang="en-US" sz="1900" b="1" dirty="0">
+                <a:solidFill>
+                  <a:srgbClr val="1F2A30"/>
+                </a:solidFill>
+              </a:rPr>
+              <a:t>Crea un account</a:t>
+            </a:r>
+            <a:endParaRPr lang="en-US" sz="1900" dirty="0"/>
+          </a:p>
+        </p:txBody>
+      </p:sp>
+      <p:sp>
+        <p:nvSpPr>
+          <p:cNvPr id="7" name="Text 5"/>
+          <p:cNvSpPr txBox="1"/>
+          <p:nvPr/>
+        </p:nvSpPr>
+        <p:spPr>
+          <a:xfrm>
+            <a:off x="822960" y="3246120"/>
+            <a:ext cx="2148840" cy="594360"/>
+          </a:xfrm>
+          <a:prstGeom prst="rect">
+            <a:avLst/>
+          </a:prstGeom>
+          <a:noFill/>
+          <a:ln/>
+        </p:spPr>
+        <p:txBody>
+          <a:bodyPr wrap="square" lIns="0" tIns="0" rIns="0" bIns="0" rtlCol="0" anchor="t"/>
+          <a:lstStyle/>
+          <a:p>
+            <a:pPr indent="0" marL="0">
+              <a:buNone/>
+            </a:pPr>
+            <a:r>
+              <a:rPr lang="en-US" sz="1300" dirty="0">
+                <a:solidFill>
+                  <a:srgbClr val="5C6F7B"/>
+                </a:solidFill>
+              </a:rPr>
+              <a:t>su github.com, gratuito</a:t>
+            </a:r>
+            <a:endParaRPr lang="en-US" sz="1300" dirty="0"/>
+          </a:p>
+        </p:txBody>
+      </p:sp>
+      <p:sp>
+        <p:nvSpPr>
+          <p:cNvPr id="8" name="Shape 6"/>
+          <p:cNvSpPr/>
+          <p:nvPr/>
+        </p:nvSpPr>
+        <p:spPr>
+          <a:xfrm>
+            <a:off x="3383280" y="1737360"/>
+            <a:ext cx="2606040" cy="2194560"/>
+          </a:xfrm>
+          <a:prstGeom prst="roundRect">
+            <a:avLst>
+              <a:gd name="adj" fmla="val 5000"/>
+            </a:avLst>
+          </a:prstGeom>
+          <a:solidFill>
+            <a:srgbClr val="EEF3F4"/>
+          </a:solidFill>
+          <a:ln/>
+        </p:spPr>
+      </p:sp>
+      <p:sp>
+        <p:nvSpPr>
+          <p:cNvPr id="9" name="Shape 7"/>
+          <p:cNvSpPr/>
+          <p:nvPr/>
+        </p:nvSpPr>
+        <p:spPr>
+          <a:xfrm>
+            <a:off x="3657600" y="2011680"/>
+            <a:ext cx="640080" cy="640080"/>
+          </a:xfrm>
+          <a:prstGeom prst="ellipse">
+            <a:avLst/>
+          </a:prstGeom>
+          <a:solidFill>
+            <a:srgbClr val="E09F3E"/>
+          </a:solidFill>
+          <a:ln/>
+        </p:spPr>
+      </p:sp>
+      <p:sp>
+        <p:nvSpPr>
+          <p:cNvPr id="10" name="Text 8"/>
+          <p:cNvSpPr txBox="1"/>
+          <p:nvPr/>
+        </p:nvSpPr>
+        <p:spPr>
+          <a:xfrm>
+            <a:off x="3657600" y="2011680"/>
+            <a:ext cx="640080" cy="640080"/>
+          </a:xfrm>
+          <a:prstGeom prst="rect">
+            <a:avLst/>
+          </a:prstGeom>
+          <a:noFill/>
+          <a:ln/>
+        </p:spPr>
+        <p:txBody>
+          <a:bodyPr wrap="square" lIns="0" tIns="0" rIns="0" bIns="0" rtlCol="0" anchor="ctr"/>
+          <a:lstStyle/>
+          <a:p>
+            <a:pPr algn="ctr" indent="0" marL="0">
+              <a:buNone/>
+            </a:pPr>
+            <a:r>
+              <a:rPr lang="en-US" sz="1820" b="1" dirty="0">
+                <a:solidFill>
+                  <a:srgbClr val="1F2A30"/>
+                </a:solidFill>
+              </a:rPr>
+              <a:t>2</a:t>
+            </a:r>
+            <a:endParaRPr lang="en-US" sz="1820" dirty="0"/>
+          </a:p>
+        </p:txBody>
+      </p:sp>
+      <p:sp>
+        <p:nvSpPr>
+          <p:cNvPr id="11" name="Text 9"/>
+          <p:cNvSpPr txBox="1"/>
+          <p:nvPr/>
+        </p:nvSpPr>
+        <p:spPr>
+          <a:xfrm>
+            <a:off x="3657600" y="2788920"/>
+            <a:ext cx="2148840" cy="457200"/>
+          </a:xfrm>
+          <a:prstGeom prst="rect">
+            <a:avLst/>
+          </a:prstGeom>
+          <a:noFill/>
+          <a:ln/>
+        </p:spPr>
+        <p:txBody>
+          <a:bodyPr wrap="square" lIns="0" tIns="0" rIns="0" bIns="0" rtlCol="0" anchor="ctr"/>
+          <a:lstStyle/>
+          <a:p>
+            <a:pPr indent="0" marL="0">
+              <a:buNone/>
+            </a:pPr>
+            <a:r>
+              <a:rPr lang="en-US" sz="1900" b="1" dirty="0">
+                <a:solidFill>
+                  <a:srgbClr val="1F2A30"/>
+                </a:solidFill>
+              </a:rPr>
+              <a:t>Apri il repository</a:t>
+            </a:r>
+            <a:endParaRPr lang="en-US" sz="1900" dirty="0"/>
+          </a:p>
+        </p:txBody>
+      </p:sp>
+      <p:sp>
+        <p:nvSpPr>
+          <p:cNvPr id="12" name="Text 10"/>
+          <p:cNvSpPr txBox="1"/>
+          <p:nvPr/>
+        </p:nvSpPr>
+        <p:spPr>
+          <a:xfrm>
+            <a:off x="3657600" y="3246120"/>
+            <a:ext cx="2148840" cy="594360"/>
+          </a:xfrm>
+          <a:prstGeom prst="rect">
+            <a:avLst/>
+          </a:prstGeom>
+          <a:noFill/>
+          <a:ln/>
+        </p:spPr>
+        <p:txBody>
+          <a:bodyPr wrap="square" lIns="0" tIns="0" rIns="0" bIns="0" rtlCol="0" anchor="t"/>
+          <a:lstStyle/>
+          <a:p>
+            <a:pPr indent="0" marL="0">
+              <a:buNone/>
+            </a:pPr>
+            <a:r>
+              <a:rPr lang="en-US" sz="1300" dirty="0">
+                <a:solidFill>
+                  <a:srgbClr val="5C6F7B"/>
+                </a:solidFill>
+              </a:rPr>
+              <a:t>github.com/andrealorenzon/SIMA2026</a:t>
+            </a:r>
+            <a:endParaRPr lang="en-US" sz="1300" dirty="0"/>
+          </a:p>
+        </p:txBody>
+      </p:sp>
+      <p:sp>
+        <p:nvSpPr>
+          <p:cNvPr id="13" name="Shape 11"/>
+          <p:cNvSpPr/>
+          <p:nvPr/>
+        </p:nvSpPr>
+        <p:spPr>
+          <a:xfrm>
+            <a:off x="6217920" y="1737360"/>
+            <a:ext cx="2606040" cy="2194560"/>
+          </a:xfrm>
+          <a:prstGeom prst="roundRect">
+            <a:avLst>
+              <a:gd name="adj" fmla="val 5000"/>
+            </a:avLst>
+          </a:prstGeom>
+          <a:solidFill>
+            <a:srgbClr val="EEF3F4"/>
+          </a:solidFill>
+          <a:ln/>
+        </p:spPr>
+      </p:sp>
+      <p:sp>
+        <p:nvSpPr>
+          <p:cNvPr id="14" name="Shape 12"/>
+          <p:cNvSpPr/>
+          <p:nvPr/>
+        </p:nvSpPr>
+        <p:spPr>
+          <a:xfrm>
+            <a:off x="6492240" y="2011680"/>
+            <a:ext cx="640080" cy="640080"/>
+          </a:xfrm>
+          <a:prstGeom prst="ellipse">
+            <a:avLst/>
+          </a:prstGeom>
+          <a:solidFill>
+            <a:srgbClr val="E09F3E"/>
+          </a:solidFill>
+          <a:ln/>
+        </p:spPr>
+      </p:sp>
+      <p:sp>
+        <p:nvSpPr>
+          <p:cNvPr id="15" name="Text 13"/>
+          <p:cNvSpPr txBox="1"/>
+          <p:nvPr/>
+        </p:nvSpPr>
+        <p:spPr>
+          <a:xfrm>
+            <a:off x="6492240" y="2011680"/>
+            <a:ext cx="640080" cy="640080"/>
+          </a:xfrm>
+          <a:prstGeom prst="rect">
+            <a:avLst/>
+          </a:prstGeom>
+          <a:noFill/>
+          <a:ln/>
+        </p:spPr>
+        <p:txBody>
+          <a:bodyPr wrap="square" lIns="0" tIns="0" rIns="0" bIns="0" rtlCol="0" anchor="ctr"/>
+          <a:lstStyle/>
+          <a:p>
+            <a:pPr algn="ctr" indent="0" marL="0">
+              <a:buNone/>
+            </a:pPr>
+            <a:r>
+              <a:rPr lang="en-US" sz="1820" b="1" dirty="0">
+                <a:solidFill>
+                  <a:srgbClr val="1F2A30"/>
+                </a:solidFill>
+              </a:rPr>
+              <a:t>3</a:t>
+            </a:r>
+            <a:endParaRPr lang="en-US" sz="1820" dirty="0"/>
+          </a:p>
+        </p:txBody>
+      </p:sp>
+      <p:sp>
+        <p:nvSpPr>
+          <p:cNvPr id="16" name="Text 14"/>
+          <p:cNvSpPr txBox="1"/>
+          <p:nvPr/>
+        </p:nvSpPr>
+        <p:spPr>
+          <a:xfrm>
+            <a:off x="6492240" y="2788920"/>
+            <a:ext cx="2148840" cy="457200"/>
+          </a:xfrm>
+          <a:prstGeom prst="rect">
+            <a:avLst/>
+          </a:prstGeom>
+          <a:noFill/>
+          <a:ln/>
+        </p:spPr>
+        <p:txBody>
+          <a:bodyPr wrap="square" lIns="0" tIns="0" rIns="0" bIns="0" rtlCol="0" anchor="ctr"/>
+          <a:lstStyle/>
+          <a:p>
+            <a:pPr indent="0" marL="0">
+              <a:buNone/>
+            </a:pPr>
+            <a:r>
+              <a:rPr lang="en-US" sz="1900" b="1" dirty="0">
+                <a:solidFill>
+                  <a:srgbClr val="1F2A30"/>
+                </a:solidFill>
+              </a:rPr>
+              <a:t>Clicca «Fork»</a:t>
+            </a:r>
+            <a:endParaRPr lang="en-US" sz="1900" dirty="0"/>
+          </a:p>
+        </p:txBody>
+      </p:sp>
+      <p:sp>
+        <p:nvSpPr>
+          <p:cNvPr id="17" name="Text 15"/>
+          <p:cNvSpPr txBox="1"/>
+          <p:nvPr/>
+        </p:nvSpPr>
+        <p:spPr>
+          <a:xfrm>
+            <a:off x="6492240" y="3246120"/>
+            <a:ext cx="2148840" cy="594360"/>
+          </a:xfrm>
+          <a:prstGeom prst="rect">
+            <a:avLst/>
+          </a:prstGeom>
+          <a:noFill/>
+          <a:ln/>
+        </p:spPr>
+        <p:txBody>
+          <a:bodyPr wrap="square" lIns="0" tIns="0" rIns="0" bIns="0" rtlCol="0" anchor="t"/>
+          <a:lstStyle/>
+          <a:p>
+            <a:pPr indent="0" marL="0">
+              <a:buNone/>
+            </a:pPr>
+            <a:r>
+              <a:rPr lang="en-US" sz="1300" dirty="0">
+                <a:solidFill>
+                  <a:srgbClr val="5C6F7B"/>
+                </a:solidFill>
+              </a:rPr>
+              <a:t>in alto a destra, poi «Create fork»</a:t>
+            </a:r>
+            <a:endParaRPr lang="en-US" sz="1300" dirty="0"/>
+          </a:p>
+        </p:txBody>
+      </p:sp>
+      <p:sp>
+        <p:nvSpPr>
+          <p:cNvPr id="18" name="Shape 16"/>
+          <p:cNvSpPr/>
+          <p:nvPr/>
+        </p:nvSpPr>
+        <p:spPr>
+          <a:xfrm>
+            <a:off x="9052560" y="1737360"/>
+            <a:ext cx="2606040" cy="2194560"/>
+          </a:xfrm>
+          <a:prstGeom prst="roundRect">
+            <a:avLst>
+              <a:gd name="adj" fmla="val 5000"/>
+            </a:avLst>
+          </a:prstGeom>
+          <a:solidFill>
+            <a:srgbClr val="0F4C5C"/>
+          </a:solidFill>
+          <a:ln/>
+        </p:spPr>
+      </p:sp>
+      <p:sp>
+        <p:nvSpPr>
+          <p:cNvPr id="19" name="Shape 17"/>
+          <p:cNvSpPr/>
+          <p:nvPr/>
+        </p:nvSpPr>
+        <p:spPr>
+          <a:xfrm>
+            <a:off x="9326880" y="2011680"/>
+            <a:ext cx="640080" cy="640080"/>
+          </a:xfrm>
+          <a:prstGeom prst="ellipse">
+            <a:avLst/>
+          </a:prstGeom>
+          <a:solidFill>
+            <a:srgbClr val="E09F3E"/>
+          </a:solidFill>
+          <a:ln/>
+        </p:spPr>
+      </p:sp>
+      <p:sp>
+        <p:nvSpPr>
+          <p:cNvPr id="20" name="Text 18"/>
+          <p:cNvSpPr txBox="1"/>
+          <p:nvPr/>
+        </p:nvSpPr>
+        <p:spPr>
+          <a:xfrm>
+            <a:off x="9326880" y="2011680"/>
+            <a:ext cx="640080" cy="640080"/>
+          </a:xfrm>
+          <a:prstGeom prst="rect">
+            <a:avLst/>
+          </a:prstGeom>
+          <a:noFill/>
+          <a:ln/>
+        </p:spPr>
+        <p:txBody>
+          <a:bodyPr wrap="square" lIns="0" tIns="0" rIns="0" bIns="0" rtlCol="0" anchor="ctr"/>
+          <a:lstStyle/>
+          <a:p>
+            <a:pPr algn="ctr" indent="0" marL="0">
+              <a:buNone/>
+            </a:pPr>
+            <a:r>
+              <a:rPr lang="en-US" sz="1820" b="1" dirty="0">
+                <a:solidFill>
+                  <a:srgbClr val="1F2A30"/>
+                </a:solidFill>
+              </a:rPr>
+              <a:t>4</a:t>
+            </a:r>
+            <a:endParaRPr lang="en-US" sz="1820" dirty="0"/>
+          </a:p>
+        </p:txBody>
+      </p:sp>
+      <p:sp>
+        <p:nvSpPr>
+          <p:cNvPr id="21" name="Text 19"/>
+          <p:cNvSpPr txBox="1"/>
+          <p:nvPr/>
+        </p:nvSpPr>
+        <p:spPr>
+          <a:xfrm>
+            <a:off x="9326880" y="2788920"/>
+            <a:ext cx="2148840" cy="457200"/>
+          </a:xfrm>
+          <a:prstGeom prst="rect">
+            <a:avLst/>
+          </a:prstGeom>
+          <a:noFill/>
+          <a:ln/>
+        </p:spPr>
+        <p:txBody>
+          <a:bodyPr wrap="square" lIns="0" tIns="0" rIns="0" bIns="0" rtlCol="0" anchor="ctr"/>
+          <a:lstStyle/>
+          <a:p>
+            <a:pPr indent="0" marL="0">
+              <a:buNone/>
+            </a:pPr>
+            <a:r>
+              <a:rPr lang="en-US" sz="1900" b="1" dirty="0">
+                <a:solidFill>
+                  <a:srgbClr val="FFFFFF"/>
+                </a:solidFill>
+              </a:rPr>
+              <a:t>È tuo</a:t>
+            </a:r>
+            <a:endParaRPr lang="en-US" sz="1900" dirty="0"/>
+          </a:p>
+        </p:txBody>
+      </p:sp>
+      <p:sp>
+        <p:nvSpPr>
+          <p:cNvPr id="22" name="Text 20"/>
+          <p:cNvSpPr txBox="1"/>
+          <p:nvPr/>
+        </p:nvSpPr>
+        <p:spPr>
+          <a:xfrm>
+            <a:off x="9326880" y="3246120"/>
+            <a:ext cx="2148840" cy="594360"/>
+          </a:xfrm>
+          <a:prstGeom prst="rect">
+            <a:avLst/>
+          </a:prstGeom>
+          <a:noFill/>
+          <a:ln/>
+        </p:spPr>
+        <p:txBody>
+          <a:bodyPr wrap="square" lIns="0" tIns="0" rIns="0" bIns="0" rtlCol="0" anchor="t"/>
+          <a:lstStyle/>
+          <a:p>
+            <a:pPr indent="0" marL="0">
+              <a:buNone/>
+            </a:pPr>
+            <a:r>
+              <a:rPr lang="en-US" sz="1300" dirty="0">
+                <a:solidFill>
+                  <a:srgbClr val="B8C4CB"/>
+                </a:solidFill>
+              </a:rPr>
+              <a:t>github.com/&lt;tuo-nome&gt;/SIMA2026</a:t>
+            </a:r>
+            <a:endParaRPr lang="en-US" sz="1300" dirty="0"/>
+          </a:p>
+        </p:txBody>
+      </p:sp>
+      <p:sp>
+        <p:nvSpPr>
+          <p:cNvPr id="23" name="Text 21"/>
+          <p:cNvSpPr txBox="1"/>
+          <p:nvPr/>
+        </p:nvSpPr>
+        <p:spPr>
+          <a:xfrm>
+            <a:off x="548640" y="4251960"/>
+            <a:ext cx="11064240" cy="1554480"/>
+          </a:xfrm>
+          <a:prstGeom prst="rect">
+            <a:avLst/>
+          </a:prstGeom>
+          <a:noFill/>
+          <a:ln/>
+        </p:spPr>
+        <p:txBody>
+          <a:bodyPr wrap="square" lIns="0" tIns="0" rIns="0" bIns="0" rtlCol="0" anchor="t"/>
+          <a:lstStyle/>
+          <a:p>
+            <a:pPr marL="342900" indent="-342900">
+              <a:spcAft>
+                <a:spcPts val="1000"/>
+              </a:spcAft>
+              <a:buSzPct val="100000"/>
+              <a:buChar char="•"/>
+            </a:pPr>
+            <a:r>
+              <a:rPr lang="en-US" sz="1700" dirty="0">
+                <a:solidFill>
+                  <a:srgbClr val="1F2A30"/>
+                </a:solidFill>
+              </a:rPr>
+              <a:t>Un fork è una copia del repository nel tuo account: puoi modificarla senza toccare l'originale.</a:t>
+            </a:r>
+            <a:endParaRPr lang="en-US" sz="1700" dirty="0"/>
+          </a:p>
+          <a:p>
+            <a:pPr marL="342900" indent="-342900">
+              <a:spcAft>
+                <a:spcPts val="1000"/>
+              </a:spcAft>
+              <a:buSzPct val="100000"/>
+              <a:buChar char="•"/>
+            </a:pPr>
+            <a:r>
+              <a:rPr lang="en-US" sz="1700" dirty="0">
+                <a:solidFill>
+                  <a:srgbClr val="1F2A30"/>
+                </a:solidFill>
+              </a:rPr>
+              <a:t>Da Colab salvi i notebook direttamente lì: File → Salva una copia in GitHub.</a:t>
+            </a:r>
+            <a:endParaRPr lang="en-US" sz="1700" dirty="0"/>
+          </a:p>
+          <a:p>
+            <a:pPr marL="342900" indent="-342900">
+              <a:spcAft>
+                <a:spcPts val="1000"/>
+              </a:spcAft>
+              <a:buSzPct val="100000"/>
+              <a:buChar char="•"/>
+            </a:pPr>
+            <a:r>
+              <a:rPr lang="en-US" sz="1700" dirty="0">
+                <a:solidFill>
+                  <a:srgbClr val="1F2A30"/>
+                </a:solidFill>
+              </a:rPr>
+              <a:t>Quando il corso si aggiorna, sul tuo fork clicca «Sync fork» per ricevere le novità.</a:t>
+            </a:r>
+            <a:endParaRPr lang="en-US" sz="1700" dirty="0"/>
+          </a:p>
+        </p:txBody>
+      </p:sp>
+      <p:sp>
+        <p:nvSpPr>
+          <p:cNvPr id="25" name="Slide Number Placeholder 0"/>
+          <p:cNvSpPr>
+            <a:spLocks noGrp="1"/>
+          </p:cNvSpPr>
+          <p:nvPr>
+            <p:ph type="sldNum" sz="quarter" idx="4294967295"/>
+          </p:nvPr>
+        </p:nvSpPr>
+        <p:spPr>
+          <a:xfrm>
+            <a:off x="11155680" y="6400800"/>
+            <a:ext cx="457200" cy="274320"/>
+          </a:xfrm>
+          <a:prstGeom prst="rect">
+            <a:avLst/>
+          </a:prstGeom>
+          <a:extLst>
+            <a:ext uri="{C572A759-6A51-4108-AA02-DFA0A04FC94B}">
+              <ma14:wrappingTextBoxFlag xmlns:ma14="http://schemas.microsoft.com/office/mac/drawingml/2011/main" val="0"/>
+            </a:ext>
+          </a:extLst>
+        </p:spPr>
+        <p:txBody>
+          <a:bodyPr/>
+          <a:lstStyle>
+            <a:lvl1pPr>
+              <a:defRPr sz="1000">
+                <a:solidFill>
+                  <a:srgbClr val="5C6F7B"/>
+                </a:solidFill>
+              </a:defRPr>
+            </a:lvl1pPr>
+          </a:lstStyle>
+          <a:p>
+            <a:pPr algn="r"/>
+            <a:fld id="{F7021451-1387-4CA6-816F-3879F97B5CBC}" type="slidenum">
+              <a:rPr b="0" lang="en-US"/>
+              <a:t>10</a:t>
+            </a:fld>
+            <a:endParaRPr lang="en-US"/>
+          </a:p>
+        </p:txBody>
+      </p:sp>
+    </p:spTree>
+  </p:cSld>
+  <p:clrMapOvr>
+    <a:masterClrMapping/>
+  </p:clrMapOvr>
+</p:sld>
+</file>
+
+<file path=ppt/slides/slide11.xml><?xml version="1.0" encoding="utf-8"?>
+<p:sld xmlns:a="http://schemas.openxmlformats.org/drawingml/2006/main" xmlns:r="http://schemas.openxmlformats.org/officeDocument/2006/relationships" xmlns:p="http://schemas.openxmlformats.org/presentationml/2006/main">
+  <p:cSld name="Slide 11">
+    <p:spTree>
+      <p:nvGrpSpPr>
+        <p:cNvPr id="1" name=""/>
+        <p:cNvGrpSpPr/>
+        <p:nvPr/>
+      </p:nvGrpSpPr>
+      <p:grpSpPr>
+        <a:xfrm>
+          <a:off x="0" y="0"/>
+          <a:ext cx="0" cy="0"/>
+          <a:chOff x="0" y="0"/>
+          <a:chExt cx="0" cy="0"/>
+        </a:xfrm>
+      </p:grpSpPr>
+      <p:sp>
+        <p:nvSpPr>
+          <p:cNvPr id="2" name="Text 0"/>
+          <p:cNvSpPr/>
+          <p:nvPr>
+            <p:ph idx="100" type="title" hasCustomPrompt="1"/>
+          </p:nvPr>
+        </p:nvSpPr>
+        <p:spPr>
+          <a:xfrm>
             <a:off x="731520" y="2103120"/>
             <a:ext cx="10698480" cy="1463040"/>
           </a:xfrm>
@@ -5946,83 +6820,526 @@
         </p:nvSpPr>
         <p:spPr>
           <a:xfrm>
-            <a:off x="731520" y="2194560"/>
-            <a:ext cx="10698480" cy="1280160"/>
-          </a:xfrm>
-          <a:prstGeom prst="rect">
-            <a:avLst/>
-          </a:prstGeom>
-          <a:noFill/>
-          <a:ln/>
-        </p:spPr>
-        <p:txBody>
-          <a:bodyPr wrap="square" lIns="0" tIns="0" rIns="0" bIns="0" rtlCol="0" anchor="b"/>
+            <a:off x="548640" y="365760"/>
+            <a:ext cx="11064240" cy="822960"/>
+          </a:xfrm>
+          <a:prstGeom prst="rect">
+            <a:avLst/>
+          </a:prstGeom>
+          <a:noFill/>
+          <a:ln/>
+        </p:spPr>
+        <p:txBody>
+          <a:bodyPr wrap="square" lIns="0" tIns="0" rIns="0" bIns="0" rtlCol="0" anchor="ctr"/>
           <a:lstStyle/>
           <a:p>
             <a:pPr algn="l" indent="0" marL="0">
               <a:buNone/>
             </a:pPr>
             <a:r>
-              <a:rPr lang="en-US" sz="5400" b="1" dirty="0">
+              <a:rPr lang="en-US" sz="3600" b="1" dirty="0">
+                <a:solidFill>
+                  <a:srgbClr val="0F4C5C"/>
+                </a:solidFill>
+              </a:rPr>
+              <a:t>In gruppi da 3, con tre ruoli</a:t>
+            </a:r>
+            <a:endParaRPr lang="en-US" sz="3600" dirty="0"/>
+          </a:p>
+        </p:txBody>
+      </p:sp>
+      <p:sp>
+        <p:nvSpPr>
+          <p:cNvPr id="3" name="Shape 1"/>
+          <p:cNvSpPr/>
+          <p:nvPr/>
+        </p:nvSpPr>
+        <p:spPr>
+          <a:xfrm>
+            <a:off x="548640" y="1737360"/>
+            <a:ext cx="3474720" cy="2926080"/>
+          </a:xfrm>
+          <a:prstGeom prst="roundRect">
+            <a:avLst>
+              <a:gd name="adj" fmla="val 3750"/>
+            </a:avLst>
+          </a:prstGeom>
+          <a:solidFill>
+            <a:srgbClr val="EEF3F4"/>
+          </a:solidFill>
+          <a:ln/>
+        </p:spPr>
+      </p:sp>
+      <p:sp>
+        <p:nvSpPr>
+          <p:cNvPr id="4" name="Shape 2"/>
+          <p:cNvSpPr/>
+          <p:nvPr/>
+        </p:nvSpPr>
+        <p:spPr>
+          <a:xfrm>
+            <a:off x="868680" y="2057400"/>
+            <a:ext cx="914400" cy="914400"/>
+          </a:xfrm>
+          <a:prstGeom prst="ellipse">
+            <a:avLst/>
+          </a:prstGeom>
+          <a:solidFill>
+            <a:srgbClr val="FFFFFF"/>
+          </a:solidFill>
+          <a:ln/>
+        </p:spPr>
+      </p:sp>
+      <p:pic>
+        <p:nvPicPr>
+          <p:cNvPr id="5" name="Image 0" descr="preencoded.png">    </p:cNvPr>
+          <p:cNvPicPr>
+            <a:picLocks noChangeAspect="1"/>
+          </p:cNvPicPr>
+          <p:nvPr/>
+        </p:nvPicPr>
+        <p:blipFill>
+          <a:blip r:embed="rId1"/>
+          <a:stretch>
+            <a:fillRect/>
+          </a:stretch>
+        </p:blipFill>
+        <p:spPr>
+          <a:xfrm>
+            <a:off x="1115568" y="2304288"/>
+            <a:ext cx="420624" cy="420624"/>
+          </a:xfrm>
+          <a:prstGeom prst="rect">
+            <a:avLst/>
+          </a:prstGeom>
+        </p:spPr>
+      </p:pic>
+      <p:sp>
+        <p:nvSpPr>
+          <p:cNvPr id="6" name="Text 3"/>
+          <p:cNvSpPr txBox="1"/>
+          <p:nvPr/>
+        </p:nvSpPr>
+        <p:spPr>
+          <a:xfrm>
+            <a:off x="868680" y="3200400"/>
+            <a:ext cx="2834640" cy="502920"/>
+          </a:xfrm>
+          <a:prstGeom prst="rect">
+            <a:avLst/>
+          </a:prstGeom>
+          <a:noFill/>
+          <a:ln/>
+        </p:spPr>
+        <p:txBody>
+          <a:bodyPr wrap="square" lIns="0" tIns="0" rIns="0" bIns="0" rtlCol="0" anchor="ctr"/>
+          <a:lstStyle/>
+          <a:p>
+            <a:pPr indent="0" marL="0">
+              <a:buNone/>
+            </a:pPr>
+            <a:r>
+              <a:rPr lang="en-US" sz="2400" b="1" dirty="0">
+                <a:solidFill>
+                  <a:srgbClr val="1F2A30"/>
+                </a:solidFill>
+              </a:rPr>
+              <a:t>Chi scrive</a:t>
+            </a:r>
+            <a:endParaRPr lang="en-US" sz="2400" dirty="0"/>
+          </a:p>
+        </p:txBody>
+      </p:sp>
+      <p:sp>
+        <p:nvSpPr>
+          <p:cNvPr id="7" name="Text 4"/>
+          <p:cNvSpPr txBox="1"/>
+          <p:nvPr/>
+        </p:nvSpPr>
+        <p:spPr>
+          <a:xfrm>
+            <a:off x="868680" y="3749040"/>
+            <a:ext cx="2834640" cy="731520"/>
+          </a:xfrm>
+          <a:prstGeom prst="rect">
+            <a:avLst/>
+          </a:prstGeom>
+          <a:noFill/>
+          <a:ln/>
+        </p:spPr>
+        <p:txBody>
+          <a:bodyPr wrap="square" lIns="0" tIns="0" rIns="0" bIns="0" rtlCol="0" anchor="t"/>
+          <a:lstStyle/>
+          <a:p>
+            <a:pPr indent="0" marL="0">
+              <a:buNone/>
+            </a:pPr>
+            <a:r>
+              <a:rPr lang="en-US" sz="1600" dirty="0">
+                <a:solidFill>
+                  <a:srgbClr val="5C6F7B"/>
+                </a:solidFill>
+              </a:rPr>
+              <a:t>condivide lo schermo e scrive il codice</a:t>
+            </a:r>
+            <a:endParaRPr lang="en-US" sz="1600" dirty="0"/>
+          </a:p>
+        </p:txBody>
+      </p:sp>
+      <p:sp>
+        <p:nvSpPr>
+          <p:cNvPr id="8" name="Shape 5"/>
+          <p:cNvSpPr/>
+          <p:nvPr/>
+        </p:nvSpPr>
+        <p:spPr>
+          <a:xfrm>
+            <a:off x="4343400" y="1737360"/>
+            <a:ext cx="3474720" cy="2926080"/>
+          </a:xfrm>
+          <a:prstGeom prst="roundRect">
+            <a:avLst>
+              <a:gd name="adj" fmla="val 3750"/>
+            </a:avLst>
+          </a:prstGeom>
+          <a:solidFill>
+            <a:srgbClr val="EEF3F4"/>
+          </a:solidFill>
+          <a:ln/>
+        </p:spPr>
+      </p:sp>
+      <p:sp>
+        <p:nvSpPr>
+          <p:cNvPr id="9" name="Shape 6"/>
+          <p:cNvSpPr/>
+          <p:nvPr/>
+        </p:nvSpPr>
+        <p:spPr>
+          <a:xfrm>
+            <a:off x="4663440" y="2057400"/>
+            <a:ext cx="914400" cy="914400"/>
+          </a:xfrm>
+          <a:prstGeom prst="ellipse">
+            <a:avLst/>
+          </a:prstGeom>
+          <a:solidFill>
+            <a:srgbClr val="FFFFFF"/>
+          </a:solidFill>
+          <a:ln/>
+        </p:spPr>
+      </p:sp>
+      <p:pic>
+        <p:nvPicPr>
+          <p:cNvPr id="10" name="Image 1" descr="preencoded.png">    </p:cNvPr>
+          <p:cNvPicPr>
+            <a:picLocks noChangeAspect="1"/>
+          </p:cNvPicPr>
+          <p:nvPr/>
+        </p:nvPicPr>
+        <p:blipFill>
+          <a:blip r:embed="rId2"/>
+          <a:stretch>
+            <a:fillRect/>
+          </a:stretch>
+        </p:blipFill>
+        <p:spPr>
+          <a:xfrm>
+            <a:off x="4910328" y="2304288"/>
+            <a:ext cx="420624" cy="420624"/>
+          </a:xfrm>
+          <a:prstGeom prst="rect">
+            <a:avLst/>
+          </a:prstGeom>
+        </p:spPr>
+      </p:pic>
+      <p:sp>
+        <p:nvSpPr>
+          <p:cNvPr id="11" name="Text 7"/>
+          <p:cNvSpPr txBox="1"/>
+          <p:nvPr/>
+        </p:nvSpPr>
+        <p:spPr>
+          <a:xfrm>
+            <a:off x="4663440" y="3200400"/>
+            <a:ext cx="2834640" cy="502920"/>
+          </a:xfrm>
+          <a:prstGeom prst="rect">
+            <a:avLst/>
+          </a:prstGeom>
+          <a:noFill/>
+          <a:ln/>
+        </p:spPr>
+        <p:txBody>
+          <a:bodyPr wrap="square" lIns="0" tIns="0" rIns="0" bIns="0" rtlCol="0" anchor="ctr"/>
+          <a:lstStyle/>
+          <a:p>
+            <a:pPr indent="0" marL="0">
+              <a:buNone/>
+            </a:pPr>
+            <a:r>
+              <a:rPr lang="en-US" sz="2400" b="1" dirty="0">
+                <a:solidFill>
+                  <a:srgbClr val="1F2A30"/>
+                </a:solidFill>
+              </a:rPr>
+              <a:t>Chi cerca</a:t>
+            </a:r>
+            <a:endParaRPr lang="en-US" sz="2400" dirty="0"/>
+          </a:p>
+        </p:txBody>
+      </p:sp>
+      <p:sp>
+        <p:nvSpPr>
+          <p:cNvPr id="12" name="Text 8"/>
+          <p:cNvSpPr txBox="1"/>
+          <p:nvPr/>
+        </p:nvSpPr>
+        <p:spPr>
+          <a:xfrm>
+            <a:off x="4663440" y="3749040"/>
+            <a:ext cx="2834640" cy="731520"/>
+          </a:xfrm>
+          <a:prstGeom prst="rect">
+            <a:avLst/>
+          </a:prstGeom>
+          <a:noFill/>
+          <a:ln/>
+        </p:spPr>
+        <p:txBody>
+          <a:bodyPr wrap="square" lIns="0" tIns="0" rIns="0" bIns="0" rtlCol="0" anchor="t"/>
+          <a:lstStyle/>
+          <a:p>
+            <a:pPr indent="0" marL="0">
+              <a:buNone/>
+            </a:pPr>
+            <a:r>
+              <a:rPr lang="en-US" sz="1600" dirty="0">
+                <a:solidFill>
+                  <a:srgbClr val="5C6F7B"/>
+                </a:solidFill>
+              </a:rPr>
+              <a:t>Google, Gemini, dispense: trova cosa serve</a:t>
+            </a:r>
+            <a:endParaRPr lang="en-US" sz="1600" dirty="0"/>
+          </a:p>
+        </p:txBody>
+      </p:sp>
+      <p:sp>
+        <p:nvSpPr>
+          <p:cNvPr id="13" name="Shape 9"/>
+          <p:cNvSpPr/>
+          <p:nvPr/>
+        </p:nvSpPr>
+        <p:spPr>
+          <a:xfrm>
+            <a:off x="8138160" y="1737360"/>
+            <a:ext cx="3474720" cy="2926080"/>
+          </a:xfrm>
+          <a:prstGeom prst="roundRect">
+            <a:avLst>
+              <a:gd name="adj" fmla="val 3750"/>
+            </a:avLst>
+          </a:prstGeom>
+          <a:solidFill>
+            <a:srgbClr val="0F4C5C"/>
+          </a:solidFill>
+          <a:ln/>
+        </p:spPr>
+      </p:sp>
+      <p:sp>
+        <p:nvSpPr>
+          <p:cNvPr id="14" name="Shape 10"/>
+          <p:cNvSpPr/>
+          <p:nvPr/>
+        </p:nvSpPr>
+        <p:spPr>
+          <a:xfrm>
+            <a:off x="8458200" y="2057400"/>
+            <a:ext cx="914400" cy="914400"/>
+          </a:xfrm>
+          <a:prstGeom prst="ellipse">
+            <a:avLst/>
+          </a:prstGeom>
+          <a:solidFill>
+            <a:srgbClr val="FFFFFF"/>
+          </a:solidFill>
+          <a:ln/>
+        </p:spPr>
+      </p:sp>
+      <p:pic>
+        <p:nvPicPr>
+          <p:cNvPr id="15" name="Image 2" descr="preencoded.png">    </p:cNvPr>
+          <p:cNvPicPr>
+            <a:picLocks noChangeAspect="1"/>
+          </p:cNvPicPr>
+          <p:nvPr/>
+        </p:nvPicPr>
+        <p:blipFill>
+          <a:blip r:embed="rId3"/>
+          <a:stretch>
+            <a:fillRect/>
+          </a:stretch>
+        </p:blipFill>
+        <p:spPr>
+          <a:xfrm>
+            <a:off x="8705088" y="2304288"/>
+            <a:ext cx="420624" cy="420624"/>
+          </a:xfrm>
+          <a:prstGeom prst="rect">
+            <a:avLst/>
+          </a:prstGeom>
+        </p:spPr>
+      </p:pic>
+      <p:sp>
+        <p:nvSpPr>
+          <p:cNvPr id="16" name="Text 11"/>
+          <p:cNvSpPr txBox="1"/>
+          <p:nvPr/>
+        </p:nvSpPr>
+        <p:spPr>
+          <a:xfrm>
+            <a:off x="8458200" y="3200400"/>
+            <a:ext cx="2834640" cy="502920"/>
+          </a:xfrm>
+          <a:prstGeom prst="rect">
+            <a:avLst/>
+          </a:prstGeom>
+          <a:noFill/>
+          <a:ln/>
+        </p:spPr>
+        <p:txBody>
+          <a:bodyPr wrap="square" lIns="0" tIns="0" rIns="0" bIns="0" rtlCol="0" anchor="ctr"/>
+          <a:lstStyle/>
+          <a:p>
+            <a:pPr indent="0" marL="0">
+              <a:buNone/>
+            </a:pPr>
+            <a:r>
+              <a:rPr lang="en-US" sz="2400" b="1" dirty="0">
                 <a:solidFill>
                   <a:srgbClr val="FFFFFF"/>
                 </a:solidFill>
               </a:rPr>
-              <a:t>Task: il risparmio di Marco</a:t>
-            </a:r>
-            <a:endParaRPr lang="en-US" sz="5400" dirty="0"/>
-          </a:p>
-        </p:txBody>
-      </p:sp>
-      <p:sp>
-        <p:nvSpPr>
-          <p:cNvPr id="3" name="Text 0"/>
-          <p:cNvSpPr/>
+              <a:t>Chi controlla</a:t>
+            </a:r>
+            <a:endParaRPr lang="en-US" sz="2400" dirty="0"/>
+          </a:p>
+        </p:txBody>
+      </p:sp>
+      <p:sp>
+        <p:nvSpPr>
+          <p:cNvPr id="17" name="Text 12"/>
+          <p:cNvSpPr txBox="1"/>
+          <p:nvPr/>
+        </p:nvSpPr>
+        <p:spPr>
+          <a:xfrm>
+            <a:off x="8458200" y="3749040"/>
+            <a:ext cx="2834640" cy="731520"/>
+          </a:xfrm>
+          <a:prstGeom prst="rect">
+            <a:avLst/>
+          </a:prstGeom>
+          <a:noFill/>
+          <a:ln/>
+        </p:spPr>
+        <p:txBody>
+          <a:bodyPr wrap="square" lIns="0" tIns="0" rIns="0" bIns="0" rtlCol="0" anchor="t"/>
+          <a:lstStyle/>
+          <a:p>
+            <a:pPr indent="0" marL="0">
+              <a:buNone/>
+            </a:pPr>
+            <a:r>
+              <a:rPr lang="en-US" sz="1600" dirty="0">
+                <a:solidFill>
+                  <a:srgbClr val="B8C4CB"/>
+                </a:solidFill>
+              </a:rPr>
+              <a:t>il risultato ha senso? il numero torna?</a:t>
+            </a:r>
+            <a:endParaRPr lang="en-US" sz="1600" dirty="0"/>
+          </a:p>
+        </p:txBody>
+      </p:sp>
+      <p:sp>
+        <p:nvSpPr>
+          <p:cNvPr id="18" name="Text 13"/>
+          <p:cNvSpPr txBox="1"/>
+          <p:nvPr/>
+        </p:nvSpPr>
+        <p:spPr>
+          <a:xfrm>
+            <a:off x="548640" y="5029200"/>
+            <a:ext cx="11064240" cy="731520"/>
+          </a:xfrm>
+          <a:prstGeom prst="rect">
+            <a:avLst/>
+          </a:prstGeom>
+          <a:noFill/>
+          <a:ln/>
+        </p:spPr>
+        <p:txBody>
+          <a:bodyPr wrap="square" lIns="0" tIns="0" rIns="0" bIns="0" rtlCol="0" anchor="t"/>
+          <a:lstStyle/>
+          <a:p>
+            <a:pPr indent="0" marL="0">
+              <a:buNone/>
+            </a:pPr>
+            <a:r>
+              <a:rPr lang="en-US" sz="1800" i="1" dirty="0">
+                <a:solidFill>
+                  <a:srgbClr val="0F4C5C"/>
+                </a:solidFill>
+              </a:rPr>
+              <a:t>I ruoli ruotano a ogni passo. Il più importante è chi controlla: è il mestiere che il corso vuole allenare.</a:t>
+            </a:r>
+            <a:endParaRPr lang="en-US" sz="1800" dirty="0"/>
+          </a:p>
+        </p:txBody>
+      </p:sp>
+      <p:sp>
+        <p:nvSpPr>
+          <p:cNvPr id="25" name="Slide Number Placeholder 0"/>
+          <p:cNvSpPr>
+            <a:spLocks noGrp="1"/>
+          </p:cNvSpPr>
           <p:nvPr>
-            <p:ph idx="101" type="body" hasCustomPrompt="1"/>
+            <p:ph type="sldNum" sz="quarter" idx="4294967295"/>
           </p:nvPr>
         </p:nvSpPr>
         <p:spPr>
           <a:xfrm>
-            <a:off x="731520" y="3657600"/>
-            <a:ext cx="10698480" cy="1463040"/>
-          </a:xfrm>
-          <a:prstGeom prst="rect">
-            <a:avLst/>
-          </a:prstGeom>
-          <a:noFill/>
-          <a:ln/>
-        </p:spPr>
-        <p:txBody>
-          <a:bodyPr wrap="square" lIns="0" tIns="0" rIns="0" bIns="0" rtlCol="0" anchor="t"/>
-          <a:lstStyle/>
-          <a:p>
-            <a:pPr indent="0" marL="0">
-              <a:buNone/>
-            </a:pPr>
-            <a:r>
-              <a:rPr lang="en-US" sz="2200" dirty="0">
-                <a:solidFill>
-                  <a:srgbClr val="B8C4CB"/>
-                </a:solidFill>
-              </a:rPr>
-              <a:t>Marco ha 5.000 € e li investe al 2,5% annuo.</a:t>
-            </a:r>
-            <a:endParaRPr lang="en-US" sz="2200" dirty="0"/>
-          </a:p>
-          <a:p>
-            <a:pPr indent="0" marL="0">
-              <a:buNone/>
-            </a:pPr>
-            <a:r>
-              <a:rPr lang="en-US" sz="2200" dirty="0">
-                <a:solidFill>
-                  <a:srgbClr val="B8C4CB"/>
-                </a:solidFill>
-              </a:rPr>
-              <a:t>60 minuti · apri il notebook dal README</a:t>
-            </a:r>
-            <a:endParaRPr lang="en-US" sz="2200" dirty="0"/>
+            <a:off x="11155680" y="6400800"/>
+            <a:ext cx="457200" cy="274320"/>
+          </a:xfrm>
+          <a:prstGeom prst="rect">
+            <a:avLst/>
+          </a:prstGeom>
+          <a:extLst>
+            <a:ext uri="{C572A759-6A51-4108-AA02-DFA0A04FC94B}">
+              <ma14:wrappingTextBoxFlag xmlns:ma14="http://schemas.microsoft.com/office/mac/drawingml/2011/main" val="0"/>
+            </a:ext>
+          </a:extLst>
+        </p:spPr>
+        <p:txBody>
+          <a:bodyPr/>
+          <a:lstStyle>
+            <a:lvl1pPr>
+              <a:defRPr sz="1000">
+                <a:solidFill>
+                  <a:srgbClr val="5C6F7B"/>
+                </a:solidFill>
+              </a:defRPr>
+            </a:lvl1pPr>
+          </a:lstStyle>
+          <a:p>
+            <a:pPr algn="r"/>
+            <a:fld id="{F7021451-1387-4CA6-816F-3879F97B5CBC}" type="slidenum">
+              <a:rPr b="0" lang="en-US"/>
+              <a:t>8</a:t>
+            </a:fld>
+            <a:endParaRPr lang="en-US"/>
           </a:p>
         </p:txBody>
       </p:sp>
@@ -6061,752 +7378,83 @@
         </p:nvSpPr>
         <p:spPr>
           <a:xfrm>
-            <a:off x="548640" y="365760"/>
-            <a:ext cx="11064240" cy="822960"/>
-          </a:xfrm>
-          <a:prstGeom prst="rect">
-            <a:avLst/>
-          </a:prstGeom>
-          <a:noFill/>
-          <a:ln/>
-        </p:spPr>
-        <p:txBody>
-          <a:bodyPr wrap="square" lIns="0" tIns="0" rIns="0" bIns="0" rtlCol="0" anchor="ctr"/>
+            <a:off x="731520" y="2194560"/>
+            <a:ext cx="10698480" cy="1280160"/>
+          </a:xfrm>
+          <a:prstGeom prst="rect">
+            <a:avLst/>
+          </a:prstGeom>
+          <a:noFill/>
+          <a:ln/>
+        </p:spPr>
+        <p:txBody>
+          <a:bodyPr wrap="square" lIns="0" tIns="0" rIns="0" bIns="0" rtlCol="0" anchor="b"/>
           <a:lstStyle/>
           <a:p>
             <a:pPr algn="l" indent="0" marL="0">
               <a:buNone/>
             </a:pPr>
             <a:r>
-              <a:rPr lang="en-US" sz="3600" b="1" dirty="0">
-                <a:solidFill>
-                  <a:srgbClr val="0F4C5C"/>
-                </a:solidFill>
-              </a:rPr>
-              <a:t>Extra: una copia del corso tutta tua</a:t>
-            </a:r>
-            <a:endParaRPr lang="en-US" sz="3600" dirty="0"/>
-          </a:p>
-        </p:txBody>
-      </p:sp>
-      <p:sp>
-        <p:nvSpPr>
-          <p:cNvPr id="3" name="Shape 1"/>
+              <a:rPr lang="en-US" sz="5400" b="1" dirty="0">
+                <a:solidFill>
+                  <a:srgbClr val="FFFFFF"/>
+                </a:solidFill>
+              </a:rPr>
+              <a:t>Task: il risparmio di Marco</a:t>
+            </a:r>
+            <a:endParaRPr lang="en-US" sz="5400" dirty="0"/>
+          </a:p>
+        </p:txBody>
+      </p:sp>
+      <p:sp>
+        <p:nvSpPr>
+          <p:cNvPr id="3" name="Text 0"/>
           <p:cNvSpPr/>
-          <p:nvPr/>
-        </p:nvSpPr>
-        <p:spPr>
-          <a:xfrm>
-            <a:off x="548640" y="1737360"/>
-            <a:ext cx="2606040" cy="2194560"/>
-          </a:xfrm>
-          <a:prstGeom prst="roundRect">
-            <a:avLst>
-              <a:gd name="adj" fmla="val 5000"/>
-            </a:avLst>
-          </a:prstGeom>
-          <a:solidFill>
-            <a:srgbClr val="EEF3F4"/>
-          </a:solidFill>
-          <a:ln/>
-        </p:spPr>
-      </p:sp>
-      <p:sp>
-        <p:nvSpPr>
-          <p:cNvPr id="4" name="Shape 2"/>
-          <p:cNvSpPr/>
-          <p:nvPr/>
-        </p:nvSpPr>
-        <p:spPr>
-          <a:xfrm>
-            <a:off x="822960" y="2011680"/>
-            <a:ext cx="640080" cy="640080"/>
-          </a:xfrm>
-          <a:prstGeom prst="ellipse">
-            <a:avLst/>
-          </a:prstGeom>
-          <a:solidFill>
-            <a:srgbClr val="E09F3E"/>
-          </a:solidFill>
-          <a:ln/>
-        </p:spPr>
-      </p:sp>
-      <p:sp>
-        <p:nvSpPr>
-          <p:cNvPr id="5" name="Text 3"/>
-          <p:cNvSpPr txBox="1"/>
-          <p:nvPr/>
-        </p:nvSpPr>
-        <p:spPr>
-          <a:xfrm>
-            <a:off x="822960" y="2011680"/>
-            <a:ext cx="640080" cy="640080"/>
-          </a:xfrm>
-          <a:prstGeom prst="rect">
-            <a:avLst/>
-          </a:prstGeom>
-          <a:noFill/>
-          <a:ln/>
-        </p:spPr>
-        <p:txBody>
-          <a:bodyPr wrap="square" lIns="0" tIns="0" rIns="0" bIns="0" rtlCol="0" anchor="ctr"/>
-          <a:lstStyle/>
-          <a:p>
-            <a:pPr algn="ctr" indent="0" marL="0">
-              <a:buNone/>
-            </a:pPr>
-            <a:r>
-              <a:rPr lang="en-US" sz="1820" b="1" dirty="0">
-                <a:solidFill>
-                  <a:srgbClr val="1F2A30"/>
-                </a:solidFill>
-              </a:rPr>
-              <a:t>1</a:t>
-            </a:r>
-            <a:endParaRPr lang="en-US" sz="1820" dirty="0"/>
-          </a:p>
-        </p:txBody>
-      </p:sp>
-      <p:sp>
-        <p:nvSpPr>
-          <p:cNvPr id="6" name="Text 4"/>
-          <p:cNvSpPr txBox="1"/>
-          <p:nvPr/>
-        </p:nvSpPr>
-        <p:spPr>
-          <a:xfrm>
-            <a:off x="822960" y="2788920"/>
-            <a:ext cx="2148840" cy="457200"/>
-          </a:xfrm>
-          <a:prstGeom prst="rect">
-            <a:avLst/>
-          </a:prstGeom>
-          <a:noFill/>
-          <a:ln/>
-        </p:spPr>
-        <p:txBody>
-          <a:bodyPr wrap="square" lIns="0" tIns="0" rIns="0" bIns="0" rtlCol="0" anchor="ctr"/>
+          <p:nvPr>
+            <p:ph idx="101" type="body" hasCustomPrompt="1"/>
+          </p:nvPr>
+        </p:nvSpPr>
+        <p:spPr>
+          <a:xfrm>
+            <a:off x="731520" y="3657600"/>
+            <a:ext cx="10698480" cy="1463040"/>
+          </a:xfrm>
+          <a:prstGeom prst="rect">
+            <a:avLst/>
+          </a:prstGeom>
+          <a:noFill/>
+          <a:ln/>
+        </p:spPr>
+        <p:txBody>
+          <a:bodyPr wrap="square" lIns="0" tIns="0" rIns="0" bIns="0" rtlCol="0" anchor="t"/>
           <a:lstStyle/>
           <a:p>
             <a:pPr indent="0" marL="0">
               <a:buNone/>
             </a:pPr>
             <a:r>
-              <a:rPr lang="en-US" sz="1900" b="1" dirty="0">
-                <a:solidFill>
-                  <a:srgbClr val="1F2A30"/>
-                </a:solidFill>
-              </a:rPr>
-              <a:t>Crea un account</a:t>
-            </a:r>
-            <a:endParaRPr lang="en-US" sz="1900" dirty="0"/>
-          </a:p>
-        </p:txBody>
-      </p:sp>
-      <p:sp>
-        <p:nvSpPr>
-          <p:cNvPr id="7" name="Text 5"/>
-          <p:cNvSpPr txBox="1"/>
-          <p:nvPr/>
-        </p:nvSpPr>
-        <p:spPr>
-          <a:xfrm>
-            <a:off x="822960" y="3246120"/>
-            <a:ext cx="2148840" cy="594360"/>
-          </a:xfrm>
-          <a:prstGeom prst="rect">
-            <a:avLst/>
-          </a:prstGeom>
-          <a:noFill/>
-          <a:ln/>
-        </p:spPr>
-        <p:txBody>
-          <a:bodyPr wrap="square" lIns="0" tIns="0" rIns="0" bIns="0" rtlCol="0" anchor="t"/>
-          <a:lstStyle/>
+              <a:rPr lang="en-US" sz="2200" dirty="0">
+                <a:solidFill>
+                  <a:srgbClr val="B8C4CB"/>
+                </a:solidFill>
+              </a:rPr>
+              <a:t>Marco ha 5.000 € e li investe al 2,5% annuo.</a:t>
+            </a:r>
+            <a:endParaRPr lang="en-US" sz="2200" dirty="0"/>
+          </a:p>
           <a:p>
             <a:pPr indent="0" marL="0">
               <a:buNone/>
             </a:pPr>
             <a:r>
-              <a:rPr lang="en-US" sz="1300" dirty="0">
-                <a:solidFill>
-                  <a:srgbClr val="5C6F7B"/>
-                </a:solidFill>
-              </a:rPr>
-              <a:t>su github.com, gratuito</a:t>
-            </a:r>
-            <a:endParaRPr lang="en-US" sz="1300" dirty="0"/>
-          </a:p>
-        </p:txBody>
-      </p:sp>
-      <p:sp>
-        <p:nvSpPr>
-          <p:cNvPr id="8" name="Shape 6"/>
-          <p:cNvSpPr/>
-          <p:nvPr/>
-        </p:nvSpPr>
-        <p:spPr>
-          <a:xfrm>
-            <a:off x="3383280" y="1737360"/>
-            <a:ext cx="2606040" cy="2194560"/>
-          </a:xfrm>
-          <a:prstGeom prst="roundRect">
-            <a:avLst>
-              <a:gd name="adj" fmla="val 5000"/>
-            </a:avLst>
-          </a:prstGeom>
-          <a:solidFill>
-            <a:srgbClr val="EEF3F4"/>
-          </a:solidFill>
-          <a:ln/>
-        </p:spPr>
-      </p:sp>
-      <p:sp>
-        <p:nvSpPr>
-          <p:cNvPr id="9" name="Shape 7"/>
-          <p:cNvSpPr/>
-          <p:nvPr/>
-        </p:nvSpPr>
-        <p:spPr>
-          <a:xfrm>
-            <a:off x="3657600" y="2011680"/>
-            <a:ext cx="640080" cy="640080"/>
-          </a:xfrm>
-          <a:prstGeom prst="ellipse">
-            <a:avLst/>
-          </a:prstGeom>
-          <a:solidFill>
-            <a:srgbClr val="E09F3E"/>
-          </a:solidFill>
-          <a:ln/>
-        </p:spPr>
-      </p:sp>
-      <p:sp>
-        <p:nvSpPr>
-          <p:cNvPr id="10" name="Text 8"/>
-          <p:cNvSpPr txBox="1"/>
-          <p:nvPr/>
-        </p:nvSpPr>
-        <p:spPr>
-          <a:xfrm>
-            <a:off x="3657600" y="2011680"/>
-            <a:ext cx="640080" cy="640080"/>
-          </a:xfrm>
-          <a:prstGeom prst="rect">
-            <a:avLst/>
-          </a:prstGeom>
-          <a:noFill/>
-          <a:ln/>
-        </p:spPr>
-        <p:txBody>
-          <a:bodyPr wrap="square" lIns="0" tIns="0" rIns="0" bIns="0" rtlCol="0" anchor="ctr"/>
-          <a:lstStyle/>
-          <a:p>
-            <a:pPr algn="ctr" indent="0" marL="0">
-              <a:buNone/>
-            </a:pPr>
-            <a:r>
-              <a:rPr lang="en-US" sz="1820" b="1" dirty="0">
-                <a:solidFill>
-                  <a:srgbClr val="1F2A30"/>
-                </a:solidFill>
-              </a:rPr>
-              <a:t>2</a:t>
-            </a:r>
-            <a:endParaRPr lang="en-US" sz="1820" dirty="0"/>
-          </a:p>
-        </p:txBody>
-      </p:sp>
-      <p:sp>
-        <p:nvSpPr>
-          <p:cNvPr id="11" name="Text 9"/>
-          <p:cNvSpPr txBox="1"/>
-          <p:nvPr/>
-        </p:nvSpPr>
-        <p:spPr>
-          <a:xfrm>
-            <a:off x="3657600" y="2788920"/>
-            <a:ext cx="2148840" cy="457200"/>
-          </a:xfrm>
-          <a:prstGeom prst="rect">
-            <a:avLst/>
-          </a:prstGeom>
-          <a:noFill/>
-          <a:ln/>
-        </p:spPr>
-        <p:txBody>
-          <a:bodyPr wrap="square" lIns="0" tIns="0" rIns="0" bIns="0" rtlCol="0" anchor="ctr"/>
-          <a:lstStyle/>
-          <a:p>
-            <a:pPr indent="0" marL="0">
-              <a:buNone/>
-            </a:pPr>
-            <a:r>
-              <a:rPr lang="en-US" sz="1900" b="1" dirty="0">
-                <a:solidFill>
-                  <a:srgbClr val="1F2A30"/>
-                </a:solidFill>
-              </a:rPr>
-              <a:t>Apri il repository</a:t>
-            </a:r>
-            <a:endParaRPr lang="en-US" sz="1900" dirty="0"/>
-          </a:p>
-        </p:txBody>
-      </p:sp>
-      <p:sp>
-        <p:nvSpPr>
-          <p:cNvPr id="12" name="Text 10"/>
-          <p:cNvSpPr txBox="1"/>
-          <p:nvPr/>
-        </p:nvSpPr>
-        <p:spPr>
-          <a:xfrm>
-            <a:off x="3657600" y="3246120"/>
-            <a:ext cx="2148840" cy="594360"/>
-          </a:xfrm>
-          <a:prstGeom prst="rect">
-            <a:avLst/>
-          </a:prstGeom>
-          <a:noFill/>
-          <a:ln/>
-        </p:spPr>
-        <p:txBody>
-          <a:bodyPr wrap="square" lIns="0" tIns="0" rIns="0" bIns="0" rtlCol="0" anchor="t"/>
-          <a:lstStyle/>
-          <a:p>
-            <a:pPr indent="0" marL="0">
-              <a:buNone/>
-            </a:pPr>
-            <a:r>
-              <a:rPr lang="en-US" sz="1300" dirty="0">
-                <a:solidFill>
-                  <a:srgbClr val="5C6F7B"/>
-                </a:solidFill>
-              </a:rPr>
-              <a:t>github.com/andrealorenzon/SIMA2026</a:t>
-            </a:r>
-            <a:endParaRPr lang="en-US" sz="1300" dirty="0"/>
-          </a:p>
-        </p:txBody>
-      </p:sp>
-      <p:sp>
-        <p:nvSpPr>
-          <p:cNvPr id="13" name="Shape 11"/>
-          <p:cNvSpPr/>
-          <p:nvPr/>
-        </p:nvSpPr>
-        <p:spPr>
-          <a:xfrm>
-            <a:off x="6217920" y="1737360"/>
-            <a:ext cx="2606040" cy="2194560"/>
-          </a:xfrm>
-          <a:prstGeom prst="roundRect">
-            <a:avLst>
-              <a:gd name="adj" fmla="val 5000"/>
-            </a:avLst>
-          </a:prstGeom>
-          <a:solidFill>
-            <a:srgbClr val="EEF3F4"/>
-          </a:solidFill>
-          <a:ln/>
-        </p:spPr>
-      </p:sp>
-      <p:sp>
-        <p:nvSpPr>
-          <p:cNvPr id="14" name="Shape 12"/>
-          <p:cNvSpPr/>
-          <p:nvPr/>
-        </p:nvSpPr>
-        <p:spPr>
-          <a:xfrm>
-            <a:off x="6492240" y="2011680"/>
-            <a:ext cx="640080" cy="640080"/>
-          </a:xfrm>
-          <a:prstGeom prst="ellipse">
-            <a:avLst/>
-          </a:prstGeom>
-          <a:solidFill>
-            <a:srgbClr val="E09F3E"/>
-          </a:solidFill>
-          <a:ln/>
-        </p:spPr>
-      </p:sp>
-      <p:sp>
-        <p:nvSpPr>
-          <p:cNvPr id="15" name="Text 13"/>
-          <p:cNvSpPr txBox="1"/>
-          <p:nvPr/>
-        </p:nvSpPr>
-        <p:spPr>
-          <a:xfrm>
-            <a:off x="6492240" y="2011680"/>
-            <a:ext cx="640080" cy="640080"/>
-          </a:xfrm>
-          <a:prstGeom prst="rect">
-            <a:avLst/>
-          </a:prstGeom>
-          <a:noFill/>
-          <a:ln/>
-        </p:spPr>
-        <p:txBody>
-          <a:bodyPr wrap="square" lIns="0" tIns="0" rIns="0" bIns="0" rtlCol="0" anchor="ctr"/>
-          <a:lstStyle/>
-          <a:p>
-            <a:pPr algn="ctr" indent="0" marL="0">
-              <a:buNone/>
-            </a:pPr>
-            <a:r>
-              <a:rPr lang="en-US" sz="1820" b="1" dirty="0">
-                <a:solidFill>
-                  <a:srgbClr val="1F2A30"/>
-                </a:solidFill>
-              </a:rPr>
-              <a:t>3</a:t>
-            </a:r>
-            <a:endParaRPr lang="en-US" sz="1820" dirty="0"/>
-          </a:p>
-        </p:txBody>
-      </p:sp>
-      <p:sp>
-        <p:nvSpPr>
-          <p:cNvPr id="16" name="Text 14"/>
-          <p:cNvSpPr txBox="1"/>
-          <p:nvPr/>
-        </p:nvSpPr>
-        <p:spPr>
-          <a:xfrm>
-            <a:off x="6492240" y="2788920"/>
-            <a:ext cx="2148840" cy="457200"/>
-          </a:xfrm>
-          <a:prstGeom prst="rect">
-            <a:avLst/>
-          </a:prstGeom>
-          <a:noFill/>
-          <a:ln/>
-        </p:spPr>
-        <p:txBody>
-          <a:bodyPr wrap="square" lIns="0" tIns="0" rIns="0" bIns="0" rtlCol="0" anchor="ctr"/>
-          <a:lstStyle/>
-          <a:p>
-            <a:pPr indent="0" marL="0">
-              <a:buNone/>
-            </a:pPr>
-            <a:r>
-              <a:rPr lang="en-US" sz="1900" b="1" dirty="0">
-                <a:solidFill>
-                  <a:srgbClr val="1F2A30"/>
-                </a:solidFill>
-              </a:rPr>
-              <a:t>Clicca «Fork»</a:t>
-            </a:r>
-            <a:endParaRPr lang="en-US" sz="1900" dirty="0"/>
-          </a:p>
-        </p:txBody>
-      </p:sp>
-      <p:sp>
-        <p:nvSpPr>
-          <p:cNvPr id="17" name="Text 15"/>
-          <p:cNvSpPr txBox="1"/>
-          <p:nvPr/>
-        </p:nvSpPr>
-        <p:spPr>
-          <a:xfrm>
-            <a:off x="6492240" y="3246120"/>
-            <a:ext cx="2148840" cy="594360"/>
-          </a:xfrm>
-          <a:prstGeom prst="rect">
-            <a:avLst/>
-          </a:prstGeom>
-          <a:noFill/>
-          <a:ln/>
-        </p:spPr>
-        <p:txBody>
-          <a:bodyPr wrap="square" lIns="0" tIns="0" rIns="0" bIns="0" rtlCol="0" anchor="t"/>
-          <a:lstStyle/>
-          <a:p>
-            <a:pPr indent="0" marL="0">
-              <a:buNone/>
-            </a:pPr>
-            <a:r>
-              <a:rPr lang="en-US" sz="1300" dirty="0">
-                <a:solidFill>
-                  <a:srgbClr val="5C6F7B"/>
-                </a:solidFill>
-              </a:rPr>
-              <a:t>in alto a destra, poi «Create fork»</a:t>
-            </a:r>
-            <a:endParaRPr lang="en-US" sz="1300" dirty="0"/>
-          </a:p>
-        </p:txBody>
-      </p:sp>
-      <p:sp>
-        <p:nvSpPr>
-          <p:cNvPr id="18" name="Shape 16"/>
-          <p:cNvSpPr/>
-          <p:nvPr/>
-        </p:nvSpPr>
-        <p:spPr>
-          <a:xfrm>
-            <a:off x="9052560" y="1737360"/>
-            <a:ext cx="2606040" cy="2194560"/>
-          </a:xfrm>
-          <a:prstGeom prst="roundRect">
-            <a:avLst>
-              <a:gd name="adj" fmla="val 5000"/>
-            </a:avLst>
-          </a:prstGeom>
-          <a:solidFill>
-            <a:srgbClr val="0F4C5C"/>
-          </a:solidFill>
-          <a:ln/>
-        </p:spPr>
-      </p:sp>
-      <p:sp>
-        <p:nvSpPr>
-          <p:cNvPr id="19" name="Shape 17"/>
-          <p:cNvSpPr/>
-          <p:nvPr/>
-        </p:nvSpPr>
-        <p:spPr>
-          <a:xfrm>
-            <a:off x="9326880" y="2011680"/>
-            <a:ext cx="640080" cy="640080"/>
-          </a:xfrm>
-          <a:prstGeom prst="ellipse">
-            <a:avLst/>
-          </a:prstGeom>
-          <a:solidFill>
-            <a:srgbClr val="E09F3E"/>
-          </a:solidFill>
-          <a:ln/>
-        </p:spPr>
-      </p:sp>
-      <p:sp>
-        <p:nvSpPr>
-          <p:cNvPr id="20" name="Text 18"/>
-          <p:cNvSpPr txBox="1"/>
-          <p:nvPr/>
-        </p:nvSpPr>
-        <p:spPr>
-          <a:xfrm>
-            <a:off x="9326880" y="2011680"/>
-            <a:ext cx="640080" cy="640080"/>
-          </a:xfrm>
-          <a:prstGeom prst="rect">
-            <a:avLst/>
-          </a:prstGeom>
-          <a:noFill/>
-          <a:ln/>
-        </p:spPr>
-        <p:txBody>
-          <a:bodyPr wrap="square" lIns="0" tIns="0" rIns="0" bIns="0" rtlCol="0" anchor="ctr"/>
-          <a:lstStyle/>
-          <a:p>
-            <a:pPr algn="ctr" indent="0" marL="0">
-              <a:buNone/>
-            </a:pPr>
-            <a:r>
-              <a:rPr lang="en-US" sz="1820" b="1" dirty="0">
-                <a:solidFill>
-                  <a:srgbClr val="1F2A30"/>
-                </a:solidFill>
-              </a:rPr>
-              <a:t>4</a:t>
-            </a:r>
-            <a:endParaRPr lang="en-US" sz="1820" dirty="0"/>
-          </a:p>
-        </p:txBody>
-      </p:sp>
-      <p:sp>
-        <p:nvSpPr>
-          <p:cNvPr id="21" name="Text 19"/>
-          <p:cNvSpPr txBox="1"/>
-          <p:nvPr/>
-        </p:nvSpPr>
-        <p:spPr>
-          <a:xfrm>
-            <a:off x="9326880" y="2788920"/>
-            <a:ext cx="2148840" cy="457200"/>
-          </a:xfrm>
-          <a:prstGeom prst="rect">
-            <a:avLst/>
-          </a:prstGeom>
-          <a:noFill/>
-          <a:ln/>
-        </p:spPr>
-        <p:txBody>
-          <a:bodyPr wrap="square" lIns="0" tIns="0" rIns="0" bIns="0" rtlCol="0" anchor="ctr"/>
-          <a:lstStyle/>
-          <a:p>
-            <a:pPr indent="0" marL="0">
-              <a:buNone/>
-            </a:pPr>
-            <a:r>
-              <a:rPr lang="en-US" sz="1900" b="1" dirty="0">
-                <a:solidFill>
-                  <a:srgbClr val="FFFFFF"/>
-                </a:solidFill>
-              </a:rPr>
-              <a:t>È tuo</a:t>
-            </a:r>
-            <a:endParaRPr lang="en-US" sz="1900" dirty="0"/>
-          </a:p>
-        </p:txBody>
-      </p:sp>
-      <p:sp>
-        <p:nvSpPr>
-          <p:cNvPr id="22" name="Text 20"/>
-          <p:cNvSpPr txBox="1"/>
-          <p:nvPr/>
-        </p:nvSpPr>
-        <p:spPr>
-          <a:xfrm>
-            <a:off x="9326880" y="3246120"/>
-            <a:ext cx="2148840" cy="594360"/>
-          </a:xfrm>
-          <a:prstGeom prst="rect">
-            <a:avLst/>
-          </a:prstGeom>
-          <a:noFill/>
-          <a:ln/>
-        </p:spPr>
-        <p:txBody>
-          <a:bodyPr wrap="square" lIns="0" tIns="0" rIns="0" bIns="0" rtlCol="0" anchor="t"/>
-          <a:lstStyle/>
-          <a:p>
-            <a:pPr indent="0" marL="0">
-              <a:buNone/>
-            </a:pPr>
-            <a:r>
-              <a:rPr lang="en-US" sz="1300" dirty="0">
+              <a:rPr lang="en-US" sz="2200" dirty="0">
                 <a:solidFill>
                   <a:srgbClr val="B8C4CB"/>
                 </a:solidFill>
               </a:rPr>
-              <a:t>github.com/&lt;tuo-nome&gt;/SIMA2026</a:t>
-            </a:r>
-            <a:endParaRPr lang="en-US" sz="1300" dirty="0"/>
-          </a:p>
-        </p:txBody>
-      </p:sp>
-      <p:sp>
-        <p:nvSpPr>
-          <p:cNvPr id="23" name="Text 21"/>
-          <p:cNvSpPr txBox="1"/>
-          <p:nvPr/>
-        </p:nvSpPr>
-        <p:spPr>
-          <a:xfrm>
-            <a:off x="548640" y="4251960"/>
-            <a:ext cx="11064240" cy="1554480"/>
-          </a:xfrm>
-          <a:prstGeom prst="rect">
-            <a:avLst/>
-          </a:prstGeom>
-          <a:noFill/>
-          <a:ln/>
-        </p:spPr>
-        <p:txBody>
-          <a:bodyPr wrap="square" lIns="0" tIns="0" rIns="0" bIns="0" rtlCol="0" anchor="t"/>
-          <a:lstStyle/>
-          <a:p>
-            <a:pPr marL="342900" indent="-342900">
-              <a:spcAft>
-                <a:spcPts val="1000"/>
-              </a:spcAft>
-              <a:buSzPct val="100000"/>
-              <a:buChar char="•"/>
-            </a:pPr>
-            <a:r>
-              <a:rPr lang="en-US" sz="1700" dirty="0">
-                <a:solidFill>
-                  <a:srgbClr val="1F2A30"/>
-                </a:solidFill>
-              </a:rPr>
-              <a:t>Un fork è una copia del repository nel tuo account: puoi modificarla senza toccare l'originale.</a:t>
-            </a:r>
-            <a:endParaRPr lang="en-US" sz="1700" dirty="0"/>
-          </a:p>
-          <a:p>
-            <a:pPr marL="342900" indent="-342900">
-              <a:spcAft>
-                <a:spcPts val="1000"/>
-              </a:spcAft>
-              <a:buSzPct val="100000"/>
-              <a:buChar char="•"/>
-            </a:pPr>
-            <a:r>
-              <a:rPr lang="en-US" sz="1700" dirty="0">
-                <a:solidFill>
-                  <a:srgbClr val="1F2A30"/>
-                </a:solidFill>
-              </a:rPr>
-              <a:t>Da Colab salvi i notebook direttamente lì: File → Salva una copia in GitHub.</a:t>
-            </a:r>
-            <a:endParaRPr lang="en-US" sz="1700" dirty="0"/>
-          </a:p>
-          <a:p>
-            <a:pPr marL="342900" indent="-342900">
-              <a:spcAft>
-                <a:spcPts val="1000"/>
-              </a:spcAft>
-              <a:buSzPct val="100000"/>
-              <a:buChar char="•"/>
-            </a:pPr>
-            <a:r>
-              <a:rPr lang="en-US" sz="1700" dirty="0">
-                <a:solidFill>
-                  <a:srgbClr val="1F2A30"/>
-                </a:solidFill>
-              </a:rPr>
-              <a:t>Quando il corso si aggiorna, sul tuo fork clicca «Sync fork» per ricevere le novità.</a:t>
-            </a:r>
-            <a:endParaRPr lang="en-US" sz="1700" dirty="0"/>
-          </a:p>
-        </p:txBody>
-      </p:sp>
-      <p:sp>
-        <p:nvSpPr>
-          <p:cNvPr id="25" name="Slide Number Placeholder 0"/>
-          <p:cNvSpPr>
-            <a:spLocks noGrp="1"/>
-          </p:cNvSpPr>
-          <p:nvPr>
-            <p:ph type="sldNum" sz="quarter" idx="4294967295"/>
-          </p:nvPr>
-        </p:nvSpPr>
-        <p:spPr>
-          <a:xfrm>
-            <a:off x="11155680" y="6400800"/>
-            <a:ext cx="457200" cy="274320"/>
-          </a:xfrm>
-          <a:prstGeom prst="rect">
-            <a:avLst/>
-          </a:prstGeom>
-          <a:extLst>
-            <a:ext uri="{C572A759-6A51-4108-AA02-DFA0A04FC94B}">
-              <ma14:wrappingTextBoxFlag xmlns:ma14="http://schemas.microsoft.com/office/mac/drawingml/2011/main" val="0"/>
-            </a:ext>
-          </a:extLst>
-        </p:spPr>
-        <p:txBody>
-          <a:bodyPr/>
-          <a:lstStyle>
-            <a:lvl1pPr>
-              <a:defRPr sz="1000">
-                <a:solidFill>
-                  <a:srgbClr val="5C6F7B"/>
-                </a:solidFill>
-              </a:defRPr>
-            </a:lvl1pPr>
-          </a:lstStyle>
-          <a:p>
-            <a:pPr algn="r"/>
-            <a:fld id="{F7021451-1387-4CA6-816F-3879F97B5CBC}" type="slidenum">
-              <a:rPr b="0" lang="en-US"/>
-              <a:t>9</a:t>
-            </a:fld>
-            <a:endParaRPr lang="en-US"/>
+              <a:t>60 minuti · apri il notebook dal README</a:t>
+            </a:r>
+            <a:endParaRPr lang="en-US" sz="2200" dirty="0"/>
           </a:p>
         </p:txBody>
       </p:sp>

</xml_diff>

<commit_message>
Colmate le lacune di prerequisiti segnalate nella revisione
- ruoli dei gruppi a rotazione a ogni incontro: il codice sta nel notebook di chi scrive
- E1: come estrarre l'anno da una data
- E2: togliere i valori mancanti prima di dividere in gruppi (dropna)
- E3: True/False come 1/0, quota con mean; tabella unica delle recensioni già scritta
- E4: aiuti per traccia (crescita, tempo, esperimento con intervallo di confidenza); presentazione dal notebook
- L3-L6: quota con mean, indice e reset_index, la barra nei percorsi

Co-Authored-By: Claude Opus 5.5 <noreply@anthropic.com>
Claude-Session: https://claude.ai/code/session_014CzWDFXvYNxqLeD99LSN3G
</commit_message>
<xml_diff>
--- a/lezioni/L01_python_calcolatrice/slide.pptx
+++ b/lezioni/L01_python_calcolatrice/slide.pptx
@@ -117,13 +117,13 @@
   <p:extLst>
     <p:ext uri="{521415D9-36F7-43E2-AB2F-B90AF26B5E84}">
       <p14:sectionLst xmlns:p14="http://schemas.microsoft.com/office/powerpoint/2010/main">
-        <p14:section name="Apertura" id="{3de83e26-b3e9-cd6e-0448-7738dd636257}">
+        <p14:section name="Apertura" id="{adb10b21-b838-5961-5539-d7025c319358}">
           <p14:sldIdLst>
             <p14:sldId id="256"/>
             <p14:sldId id="257"/>
           </p14:sldIdLst>
         </p14:section>
-        <p14:section name="Spiegazione" id="{fa95151e-c72c-3f8c-1d5e-b1d458ad9b11}">
+        <p14:section name="Spiegazione" id="{94f952b7-aa52-487d-cc7c-a2691d3901dc}">
           <p14:sldIdLst>
             <p14:sldId id="258"/>
             <p14:sldId id="259"/>
@@ -133,17 +133,17 @@
             <p14:sldId id="263"/>
           </p14:sldIdLst>
         </p14:section>
-        <p14:section name="Task" id="{bbe39a02-933e-b3de-6383-3db956dc324c}">
+        <p14:section name="Task" id="{3af35d32-966d-f755-6eee-07261d925cb4}">
           <p14:sldIdLst>
             <p14:sldId id="264"/>
           </p14:sldIdLst>
         </p14:section>
-        <p14:section name="Extra" id="{d57e19fc-0073-5eed-42c7-fad39828ffa5}">
+        <p14:section name="Extra" id="{3ab71ce3-2745-c1db-c727-61a3418672c2}">
           <p14:sldIdLst>
             <p14:sldId id="265"/>
           </p14:sldIdLst>
         </p14:section>
-        <p14:section name="Chiusura" id="{1a974cb9-a08a-a633-da87-e0717f2f3f47}">
+        <p14:section name="Chiusura" id="{ac8511fb-5609-aeec-33ab-8398ed68a790}">
           <p14:sldIdLst>
             <p14:sldId id="266"/>
           </p14:sldIdLst>
@@ -1344,7 +1344,7 @@
           <a:p>
             <a:r>
               <a:rPr lang="en-US" dirty="0"/>
-              <a:t>Su Zoom: stanze separate da 3. Comporre i gruppi mescolando chi ha già qualche esperienza (Stata, R, Excel avanzato) con chi parte da zero. Gruppi fissi per qualche settimana aiutano.</a:t>
+              <a:t>Su Zoom: stanze separate da 3. Comporre i gruppi mescolando chi ha già qualche esperienza (Stata, R, Excel avanzato) con chi parte da zero. Gruppi fissi per qualche settimana aiutano. Il codice sta nel notebook di chi scrive: per questo i ruoli ruotano a ogni incontro e non a ogni passo. A fine lezione chi ha scritto condivide il notebook con gli altri due.</a:t>
             </a:r>
             <a:endParaRPr lang="en-US" dirty="0"/>
           </a:p>
@@ -6980,7 +6980,7 @@
                   <a:srgbClr val="5C6F7B"/>
                 </a:solidFill>
               </a:rPr>
-              <a:t>condivide lo schermo e scrive il codice</a:t>
+              <a:t>condivide lo schermo e scrive il codice nel suo notebook</a:t>
             </a:r>
             <a:endParaRPr lang="en-US" sz="1600" dirty="0"/>
           </a:p>
@@ -7292,7 +7292,7 @@
                   <a:srgbClr val="0F4C5C"/>
                 </a:solidFill>
               </a:rPr>
-              <a:t>I ruoli ruotano a ogni passo. Il più importante è chi controlla: è il mestiere che il corso vuole allenare.</a:t>
+              <a:t>I ruoli ruotano a ogni incontro. Il più importante è chi controlla: è il mestiere che il corso vuole allenare.</a:t>
             </a:r>
             <a:endParaRPr lang="en-US" sz="1800" dirty="0"/>
           </a:p>

</xml_diff>

<commit_message>
Note del relatore L1-L3: indicazioni per Zoom al posto di quelle per l'aula
Co-Authored-By: Claude Opus 5.5 <noreply@anthropic.com>
Claude-Session: https://claude.ai/code/session_014CzWDFXvYNxqLeD99LSN3G
</commit_message>
<xml_diff>
--- a/lezioni/L01_python_calcolatrice/slide.pptx
+++ b/lezioni/L01_python_calcolatrice/slide.pptx
@@ -117,13 +117,13 @@
   <p:extLst>
     <p:ext uri="{521415D9-36F7-43E2-AB2F-B90AF26B5E84}">
       <p14:sectionLst xmlns:p14="http://schemas.microsoft.com/office/powerpoint/2010/main">
-        <p14:section name="Apertura" id="{adb10b21-b838-5961-5539-d7025c319358}">
+        <p14:section name="Apertura" id="{e600553c-7475-c6c8-d07b-55cffc8538fd}">
           <p14:sldIdLst>
             <p14:sldId id="256"/>
             <p14:sldId id="257"/>
           </p14:sldIdLst>
         </p14:section>
-        <p14:section name="Spiegazione" id="{94f952b7-aa52-487d-cc7c-a2691d3901dc}">
+        <p14:section name="Spiegazione" id="{6a3c27db-e147-d591-e789-5d028574e3f5}">
           <p14:sldIdLst>
             <p14:sldId id="258"/>
             <p14:sldId id="259"/>
@@ -133,17 +133,17 @@
             <p14:sldId id="263"/>
           </p14:sldIdLst>
         </p14:section>
-        <p14:section name="Task" id="{3af35d32-966d-f755-6eee-07261d925cb4}">
+        <p14:section name="Task" id="{8ba5fe67-74a3-1dfb-0436-66d8bd614f1e}">
           <p14:sldIdLst>
             <p14:sldId id="264"/>
           </p14:sldIdLst>
         </p14:section>
-        <p14:section name="Extra" id="{3ab71ce3-2745-c1db-c727-61a3418672c2}">
+        <p14:section name="Extra" id="{5f5f00af-aedb-fd41-df15-87df07618a8c}">
           <p14:sldIdLst>
             <p14:sldId id="265"/>
           </p14:sldIdLst>
         </p14:section>
-        <p14:section name="Chiusura" id="{ac8511fb-5609-aeec-33ab-8398ed68a790}">
+        <p14:section name="Chiusura" id="{a185dcb6-2d85-428f-b26d-af6527088895}">
           <p14:sldIdLst>
             <p14:sldId id="266"/>
           </p14:sldIdLst>
@@ -1432,7 +1432,7 @@
           <a:p>
             <a:r>
               <a:rPr lang="en-US" dirty="0"/>
-              <a:t>Durante il task: girare tra i banchi, segnarsi le soluzioni interessanti (anche sbagliate) da mostrare nel debrief. Al passo 7 molti non capiranno: è voluto.</a:t>
+              <a:t>Durante il task: entrare a turno nelle stanze separate, segnarsi le soluzioni interessanti (anche sbagliate) da mostrare nel debrief. Al passo 7 molti non capiranno: è voluto.</a:t>
             </a:r>
             <a:endParaRPr lang="en-US" dirty="0"/>
           </a:p>

</xml_diff>

<commit_message>
Come chiedere aiuto fuori dalla lezione: notebook condiviso con il docente
- promemoria in tutti i notebook, sezione nel README, slide nella L1
- l'indirizzo del docente non è nei materiali pubblici: è nella mail di inizio corso

Co-Authored-By: Claude Opus 5.5 <noreply@anthropic.com>
Claude-Session: https://claude.ai/code/session_014CzWDFXvYNxqLeD99LSN3G
</commit_message>
<xml_diff>
--- a/lezioni/L01_python_calcolatrice/slide.pptx
+++ b/lezioni/L01_python_calcolatrice/slide.pptx
@@ -16,9 +16,10 @@
     <p:sldId id="264" r:id="rId10"/>
     <p:sldId id="265" r:id="rId11"/>
     <p:sldId id="266" r:id="rId12"/>
+    <p:sldId id="267" r:id="rId13"/>
   </p:sldIdLst>
   <p:notesMasterIdLst>
-    <p:notesMasterId r:id="rId13"/>
+    <p:notesMasterId r:id="rId14"/>
   </p:notesMasterIdLst>
   <p:sldSz cx="12192000" cy="6858000"/>
   <p:notesSz cx="6858000" cy="12192000"/>
@@ -117,13 +118,13 @@
   <p:extLst>
     <p:ext uri="{521415D9-36F7-43E2-AB2F-B90AF26B5E84}">
       <p14:sectionLst xmlns:p14="http://schemas.microsoft.com/office/powerpoint/2010/main">
-        <p14:section name="Apertura" id="{e600553c-7475-c6c8-d07b-55cffc8538fd}">
+        <p14:section name="Apertura" id="{a6c14c39-b7fb-3912-6f98-b8f250657934}">
           <p14:sldIdLst>
             <p14:sldId id="256"/>
             <p14:sldId id="257"/>
           </p14:sldIdLst>
         </p14:section>
-        <p14:section name="Spiegazione" id="{6a3c27db-e147-d591-e789-5d028574e3f5}">
+        <p14:section name="Spiegazione" id="{a8fdfc7f-1cf9-b850-0ee6-84bd3399be3f}">
           <p14:sldIdLst>
             <p14:sldId id="258"/>
             <p14:sldId id="259"/>
@@ -131,21 +132,22 @@
             <p14:sldId id="261"/>
             <p14:sldId id="262"/>
             <p14:sldId id="263"/>
-          </p14:sldIdLst>
-        </p14:section>
-        <p14:section name="Task" id="{8ba5fe67-74a3-1dfb-0436-66d8bd614f1e}">
-          <p14:sldIdLst>
             <p14:sldId id="264"/>
           </p14:sldIdLst>
         </p14:section>
-        <p14:section name="Extra" id="{5f5f00af-aedb-fd41-df15-87df07618a8c}">
+        <p14:section name="Task" id="{c5c8236b-a038-baa8-0a19-1eb4e175316e}">
           <p14:sldIdLst>
             <p14:sldId id="265"/>
           </p14:sldIdLst>
         </p14:section>
-        <p14:section name="Chiusura" id="{a185dcb6-2d85-428f-b26d-af6527088895}">
+        <p14:section name="Extra" id="{398cbccb-da8e-d17c-a929-8cc6b5162a12}">
           <p14:sldIdLst>
             <p14:sldId id="266"/>
+          </p14:sldIdLst>
+        </p14:section>
+        <p14:section name="Chiusura" id="{7d4144e8-64ae-01dd-8fe6-f27e63ebd15a}">
+          <p14:sldIdLst>
+            <p14:sldId id="267"/>
           </p14:sldIdLst>
         </p14:section>
       </p14:sectionLst>
@@ -640,7 +642,7 @@
           <a:p>
             <a:r>
               <a:rPr lang="en-US" dirty="0"/>
-              <a:t>Facoltativo: chi non vuole un account GitHub può continuare a salvare su Drive. Il fork è utile anche dopo il corso, come archivio personale del proprio lavoro. Di default il fork copia solo il branch principale, quindi niente soluzioni: vanno lette dal link nel README.</a:t>
+              <a:t>Durante il task: entrare a turno nelle stanze separate, segnarsi le soluzioni interessanti (anche sbagliate) da mostrare nel debrief. Al passo 7 molti non capiranno: è voluto.</a:t>
             </a:r>
             <a:endParaRPr lang="en-US" dirty="0"/>
           </a:p>
@@ -728,7 +730,7 @@
           <a:p>
             <a:r>
               <a:rPr lang="en-US" dirty="0"/>
-              <a:t>Il problema dei tipi tornerà con l'Excel. Ricordare di creare l'account Kaggle.</a:t>
+              <a:t>Facoltativo: chi non vuole un account GitHub può continuare a salvare su Drive. Il fork è utile anche dopo il corso, come archivio personale del proprio lavoro. Di default il fork copia solo il branch principale, quindi niente soluzioni: vanno lette dal link nel README.</a:t>
             </a:r>
             <a:endParaRPr lang="en-US" dirty="0"/>
           </a:p>
@@ -752,6 +754,94 @@
             <a:fld id="{F7021451-1387-4CA6-816F-3879F97B5CBC}" type="slidenum">
               <a:rPr lang="en-US"/>
               <a:t>11</a:t>
+            </a:fld>
+            <a:endParaRPr lang="en-US"/>
+          </a:p>
+        </p:txBody>
+      </p:sp>
+    </p:spTree>
+    <p:extLst>
+      <p:ext uri="{BB962C8B-B14F-4D97-AF65-F5344CB8AC3E}">
+        <p14:creationId xmlns:p14="http://schemas.microsoft.com/office/powerpoint/2010/main" val="1024086991"/>
+      </p:ext>
+    </p:extLst>
+  </p:cSld>
+  <p:clrMapOvr>
+    <a:masterClrMapping/>
+  </p:clrMapOvr>
+</p:notes>
+</file>
+
+<file path=ppt/notesSlides/notesSlide12.xml><?xml version="1.0" encoding="utf-8"?>
+<p:notes xmlns:a="http://schemas.openxmlformats.org/drawingml/2006/main" xmlns:r="http://schemas.openxmlformats.org/officeDocument/2006/relationships" xmlns:p="http://schemas.openxmlformats.org/presentationml/2006/main">
+  <p:cSld>
+    <p:spTree>
+      <p:nvGrpSpPr>
+        <p:cNvPr id="1" name=""/>
+        <p:cNvGrpSpPr/>
+        <p:nvPr/>
+      </p:nvGrpSpPr>
+      <p:grpSpPr>
+        <a:xfrm>
+          <a:off x="0" y="0"/>
+          <a:ext cx="0" cy="0"/>
+          <a:chOff x="0" y="0"/>
+          <a:chExt cx="0" cy="0"/>
+        </a:xfrm>
+      </p:grpSpPr>
+      <p:sp>
+        <p:nvSpPr>
+          <p:cNvPr id="2" name="Slide Image Placeholder 1"/>
+          <p:cNvSpPr>
+            <a:spLocks noGrp="1" noRot="1" noChangeAspect="1"/>
+          </p:cNvSpPr>
+          <p:nvPr>
+            <p:ph type="sldImg"/>
+          </p:nvPr>
+        </p:nvSpPr>
+        <p:spPr/>
+      </p:sp>
+      <p:sp>
+        <p:nvSpPr>
+          <p:cNvPr id="3" name="Notes Placeholder 2"/>
+          <p:cNvSpPr>
+            <a:spLocks noGrp="1"/>
+          </p:cNvSpPr>
+          <p:nvPr>
+            <p:ph type="body" idx="1"/>
+          </p:nvPr>
+        </p:nvSpPr>
+        <p:spPr/>
+        <p:txBody>
+          <a:bodyPr/>
+          <a:lstStyle/>
+          <a:p>
+            <a:r>
+              <a:rPr lang="en-US" dirty="0"/>
+              <a:t>Il problema dei tipi tornerà con l'Excel. Ricordare di creare l'account Kaggle.</a:t>
+            </a:r>
+            <a:endParaRPr lang="en-US" dirty="0"/>
+          </a:p>
+        </p:txBody>
+      </p:sp>
+      <p:sp>
+        <p:nvSpPr>
+          <p:cNvPr id="4" name="Slide Number Placeholder 3"/>
+          <p:cNvSpPr>
+            <a:spLocks noGrp="1"/>
+          </p:cNvSpPr>
+          <p:nvPr>
+            <p:ph type="sldNum" sz="quarter" idx="10"/>
+          </p:nvPr>
+        </p:nvSpPr>
+        <p:spPr/>
+        <p:txBody>
+          <a:bodyPr/>
+          <a:lstStyle/>
+          <a:p>
+            <a:fld id="{F7021451-1387-4CA6-816F-3879F97B5CBC}" type="slidenum">
+              <a:rPr lang="en-US"/>
+              <a:t>12</a:t>
             </a:fld>
             <a:endParaRPr lang="en-US"/>
           </a:p>
@@ -1344,7 +1434,7 @@
           <a:p>
             <a:r>
               <a:rPr lang="en-US" dirty="0"/>
-              <a:t>Su Zoom: stanze separate da 3. Comporre i gruppi mescolando chi ha già qualche esperienza (Stata, R, Excel avanzato) con chi parte da zero. Gruppi fissi per qualche settimana aiutano. Il codice sta nel notebook di chi scrive: per questo i ruoli ruotano a ogni incontro e non a ogni passo. A fine lezione chi ha scritto condivide il notebook con gli altri due.</a:t>
+              <a:t>Mostrare dal vivo: Condividi in alto a destra, aggiungere un indirizzo, scegliere Editor. L'indirizzo vero è solo nella mail, non nei materiali pubblici.</a:t>
             </a:r>
             <a:endParaRPr lang="en-US" dirty="0"/>
           </a:p>
@@ -1432,7 +1522,7 @@
           <a:p>
             <a:r>
               <a:rPr lang="en-US" dirty="0"/>
-              <a:t>Durante il task: entrare a turno nelle stanze separate, segnarsi le soluzioni interessanti (anche sbagliate) da mostrare nel debrief. Al passo 7 molti non capiranno: è voluto.</a:t>
+              <a:t>Su Zoom: stanze separate da 3. Comporre i gruppi mescolando chi ha già qualche esperienza (Stata, R, Excel avanzato) con chi parte da zero. Gruppi fissi per qualche settimana aiutano. Il codice sta nel notebook di chi scrive: per questo i ruoli ruotano a ogni incontro e non a ogni passo. A fine lezione chi ha scritto condivide il notebook con gli altri due.</a:t>
             </a:r>
             <a:endParaRPr lang="en-US" dirty="0"/>
           </a:p>
@@ -2329,752 +2419,83 @@
         </p:nvSpPr>
         <p:spPr>
           <a:xfrm>
-            <a:off x="548640" y="365760"/>
-            <a:ext cx="11064240" cy="822960"/>
-          </a:xfrm>
-          <a:prstGeom prst="rect">
-            <a:avLst/>
-          </a:prstGeom>
-          <a:noFill/>
-          <a:ln/>
-        </p:spPr>
-        <p:txBody>
-          <a:bodyPr wrap="square" lIns="0" tIns="0" rIns="0" bIns="0" rtlCol="0" anchor="ctr"/>
+            <a:off x="731520" y="2194560"/>
+            <a:ext cx="10698480" cy="1280160"/>
+          </a:xfrm>
+          <a:prstGeom prst="rect">
+            <a:avLst/>
+          </a:prstGeom>
+          <a:noFill/>
+          <a:ln/>
+        </p:spPr>
+        <p:txBody>
+          <a:bodyPr wrap="square" lIns="0" tIns="0" rIns="0" bIns="0" rtlCol="0" anchor="b"/>
           <a:lstStyle/>
           <a:p>
             <a:pPr algn="l" indent="0" marL="0">
               <a:buNone/>
             </a:pPr>
             <a:r>
-              <a:rPr lang="en-US" sz="3600" b="1" dirty="0">
-                <a:solidFill>
-                  <a:srgbClr val="0F4C5C"/>
-                </a:solidFill>
-              </a:rPr>
-              <a:t>Extra: una copia del corso tutta tua</a:t>
-            </a:r>
-            <a:endParaRPr lang="en-US" sz="3600" dirty="0"/>
-          </a:p>
-        </p:txBody>
-      </p:sp>
-      <p:sp>
-        <p:nvSpPr>
-          <p:cNvPr id="3" name="Shape 1"/>
+              <a:rPr lang="en-US" sz="5400" b="1" dirty="0">
+                <a:solidFill>
+                  <a:srgbClr val="FFFFFF"/>
+                </a:solidFill>
+              </a:rPr>
+              <a:t>Task: il risparmio di Marco</a:t>
+            </a:r>
+            <a:endParaRPr lang="en-US" sz="5400" dirty="0"/>
+          </a:p>
+        </p:txBody>
+      </p:sp>
+      <p:sp>
+        <p:nvSpPr>
+          <p:cNvPr id="3" name="Text 0"/>
           <p:cNvSpPr/>
-          <p:nvPr/>
-        </p:nvSpPr>
-        <p:spPr>
-          <a:xfrm>
-            <a:off x="548640" y="1737360"/>
-            <a:ext cx="2606040" cy="2194560"/>
-          </a:xfrm>
-          <a:prstGeom prst="roundRect">
-            <a:avLst>
-              <a:gd name="adj" fmla="val 5000"/>
-            </a:avLst>
-          </a:prstGeom>
-          <a:solidFill>
-            <a:srgbClr val="EEF3F4"/>
-          </a:solidFill>
-          <a:ln/>
-        </p:spPr>
-      </p:sp>
-      <p:sp>
-        <p:nvSpPr>
-          <p:cNvPr id="4" name="Shape 2"/>
-          <p:cNvSpPr/>
-          <p:nvPr/>
-        </p:nvSpPr>
-        <p:spPr>
-          <a:xfrm>
-            <a:off x="822960" y="2011680"/>
-            <a:ext cx="640080" cy="640080"/>
-          </a:xfrm>
-          <a:prstGeom prst="ellipse">
-            <a:avLst/>
-          </a:prstGeom>
-          <a:solidFill>
-            <a:srgbClr val="E09F3E"/>
-          </a:solidFill>
-          <a:ln/>
-        </p:spPr>
-      </p:sp>
-      <p:sp>
-        <p:nvSpPr>
-          <p:cNvPr id="5" name="Text 3"/>
-          <p:cNvSpPr txBox="1"/>
-          <p:nvPr/>
-        </p:nvSpPr>
-        <p:spPr>
-          <a:xfrm>
-            <a:off x="822960" y="2011680"/>
-            <a:ext cx="640080" cy="640080"/>
-          </a:xfrm>
-          <a:prstGeom prst="rect">
-            <a:avLst/>
-          </a:prstGeom>
-          <a:noFill/>
-          <a:ln/>
-        </p:spPr>
-        <p:txBody>
-          <a:bodyPr wrap="square" lIns="0" tIns="0" rIns="0" bIns="0" rtlCol="0" anchor="ctr"/>
-          <a:lstStyle/>
-          <a:p>
-            <a:pPr algn="ctr" indent="0" marL="0">
-              <a:buNone/>
-            </a:pPr>
-            <a:r>
-              <a:rPr lang="en-US" sz="1820" b="1" dirty="0">
-                <a:solidFill>
-                  <a:srgbClr val="1F2A30"/>
-                </a:solidFill>
-              </a:rPr>
-              <a:t>1</a:t>
-            </a:r>
-            <a:endParaRPr lang="en-US" sz="1820" dirty="0"/>
-          </a:p>
-        </p:txBody>
-      </p:sp>
-      <p:sp>
-        <p:nvSpPr>
-          <p:cNvPr id="6" name="Text 4"/>
-          <p:cNvSpPr txBox="1"/>
-          <p:nvPr/>
-        </p:nvSpPr>
-        <p:spPr>
-          <a:xfrm>
-            <a:off x="822960" y="2788920"/>
-            <a:ext cx="2148840" cy="457200"/>
-          </a:xfrm>
-          <a:prstGeom prst="rect">
-            <a:avLst/>
-          </a:prstGeom>
-          <a:noFill/>
-          <a:ln/>
-        </p:spPr>
-        <p:txBody>
-          <a:bodyPr wrap="square" lIns="0" tIns="0" rIns="0" bIns="0" rtlCol="0" anchor="ctr"/>
+          <p:nvPr>
+            <p:ph idx="101" type="body" hasCustomPrompt="1"/>
+          </p:nvPr>
+        </p:nvSpPr>
+        <p:spPr>
+          <a:xfrm>
+            <a:off x="731520" y="3657600"/>
+            <a:ext cx="10698480" cy="1463040"/>
+          </a:xfrm>
+          <a:prstGeom prst="rect">
+            <a:avLst/>
+          </a:prstGeom>
+          <a:noFill/>
+          <a:ln/>
+        </p:spPr>
+        <p:txBody>
+          <a:bodyPr wrap="square" lIns="0" tIns="0" rIns="0" bIns="0" rtlCol="0" anchor="t"/>
           <a:lstStyle/>
           <a:p>
             <a:pPr indent="0" marL="0">
               <a:buNone/>
             </a:pPr>
             <a:r>
-              <a:rPr lang="en-US" sz="1900" b="1" dirty="0">
-                <a:solidFill>
-                  <a:srgbClr val="1F2A30"/>
-                </a:solidFill>
-              </a:rPr>
-              <a:t>Crea un account</a:t>
-            </a:r>
-            <a:endParaRPr lang="en-US" sz="1900" dirty="0"/>
-          </a:p>
-        </p:txBody>
-      </p:sp>
-      <p:sp>
-        <p:nvSpPr>
-          <p:cNvPr id="7" name="Text 5"/>
-          <p:cNvSpPr txBox="1"/>
-          <p:nvPr/>
-        </p:nvSpPr>
-        <p:spPr>
-          <a:xfrm>
-            <a:off x="822960" y="3246120"/>
-            <a:ext cx="2148840" cy="594360"/>
-          </a:xfrm>
-          <a:prstGeom prst="rect">
-            <a:avLst/>
-          </a:prstGeom>
-          <a:noFill/>
-          <a:ln/>
-        </p:spPr>
-        <p:txBody>
-          <a:bodyPr wrap="square" lIns="0" tIns="0" rIns="0" bIns="0" rtlCol="0" anchor="t"/>
-          <a:lstStyle/>
+              <a:rPr lang="en-US" sz="2200" dirty="0">
+                <a:solidFill>
+                  <a:srgbClr val="B8C4CB"/>
+                </a:solidFill>
+              </a:rPr>
+              <a:t>Marco ha 5.000 € e li investe al 2,5% annuo.</a:t>
+            </a:r>
+            <a:endParaRPr lang="en-US" sz="2200" dirty="0"/>
+          </a:p>
           <a:p>
             <a:pPr indent="0" marL="0">
               <a:buNone/>
             </a:pPr>
             <a:r>
-              <a:rPr lang="en-US" sz="1300" dirty="0">
-                <a:solidFill>
-                  <a:srgbClr val="5C6F7B"/>
-                </a:solidFill>
-              </a:rPr>
-              <a:t>su github.com, gratuito</a:t>
-            </a:r>
-            <a:endParaRPr lang="en-US" sz="1300" dirty="0"/>
-          </a:p>
-        </p:txBody>
-      </p:sp>
-      <p:sp>
-        <p:nvSpPr>
-          <p:cNvPr id="8" name="Shape 6"/>
-          <p:cNvSpPr/>
-          <p:nvPr/>
-        </p:nvSpPr>
-        <p:spPr>
-          <a:xfrm>
-            <a:off x="3383280" y="1737360"/>
-            <a:ext cx="2606040" cy="2194560"/>
-          </a:xfrm>
-          <a:prstGeom prst="roundRect">
-            <a:avLst>
-              <a:gd name="adj" fmla="val 5000"/>
-            </a:avLst>
-          </a:prstGeom>
-          <a:solidFill>
-            <a:srgbClr val="EEF3F4"/>
-          </a:solidFill>
-          <a:ln/>
-        </p:spPr>
-      </p:sp>
-      <p:sp>
-        <p:nvSpPr>
-          <p:cNvPr id="9" name="Shape 7"/>
-          <p:cNvSpPr/>
-          <p:nvPr/>
-        </p:nvSpPr>
-        <p:spPr>
-          <a:xfrm>
-            <a:off x="3657600" y="2011680"/>
-            <a:ext cx="640080" cy="640080"/>
-          </a:xfrm>
-          <a:prstGeom prst="ellipse">
-            <a:avLst/>
-          </a:prstGeom>
-          <a:solidFill>
-            <a:srgbClr val="E09F3E"/>
-          </a:solidFill>
-          <a:ln/>
-        </p:spPr>
-      </p:sp>
-      <p:sp>
-        <p:nvSpPr>
-          <p:cNvPr id="10" name="Text 8"/>
-          <p:cNvSpPr txBox="1"/>
-          <p:nvPr/>
-        </p:nvSpPr>
-        <p:spPr>
-          <a:xfrm>
-            <a:off x="3657600" y="2011680"/>
-            <a:ext cx="640080" cy="640080"/>
-          </a:xfrm>
-          <a:prstGeom prst="rect">
-            <a:avLst/>
-          </a:prstGeom>
-          <a:noFill/>
-          <a:ln/>
-        </p:spPr>
-        <p:txBody>
-          <a:bodyPr wrap="square" lIns="0" tIns="0" rIns="0" bIns="0" rtlCol="0" anchor="ctr"/>
-          <a:lstStyle/>
-          <a:p>
-            <a:pPr algn="ctr" indent="0" marL="0">
-              <a:buNone/>
-            </a:pPr>
-            <a:r>
-              <a:rPr lang="en-US" sz="1820" b="1" dirty="0">
-                <a:solidFill>
-                  <a:srgbClr val="1F2A30"/>
-                </a:solidFill>
-              </a:rPr>
-              <a:t>2</a:t>
-            </a:r>
-            <a:endParaRPr lang="en-US" sz="1820" dirty="0"/>
-          </a:p>
-        </p:txBody>
-      </p:sp>
-      <p:sp>
-        <p:nvSpPr>
-          <p:cNvPr id="11" name="Text 9"/>
-          <p:cNvSpPr txBox="1"/>
-          <p:nvPr/>
-        </p:nvSpPr>
-        <p:spPr>
-          <a:xfrm>
-            <a:off x="3657600" y="2788920"/>
-            <a:ext cx="2148840" cy="457200"/>
-          </a:xfrm>
-          <a:prstGeom prst="rect">
-            <a:avLst/>
-          </a:prstGeom>
-          <a:noFill/>
-          <a:ln/>
-        </p:spPr>
-        <p:txBody>
-          <a:bodyPr wrap="square" lIns="0" tIns="0" rIns="0" bIns="0" rtlCol="0" anchor="ctr"/>
-          <a:lstStyle/>
-          <a:p>
-            <a:pPr indent="0" marL="0">
-              <a:buNone/>
-            </a:pPr>
-            <a:r>
-              <a:rPr lang="en-US" sz="1900" b="1" dirty="0">
-                <a:solidFill>
-                  <a:srgbClr val="1F2A30"/>
-                </a:solidFill>
-              </a:rPr>
-              <a:t>Apri il repository</a:t>
-            </a:r>
-            <a:endParaRPr lang="en-US" sz="1900" dirty="0"/>
-          </a:p>
-        </p:txBody>
-      </p:sp>
-      <p:sp>
-        <p:nvSpPr>
-          <p:cNvPr id="12" name="Text 10"/>
-          <p:cNvSpPr txBox="1"/>
-          <p:nvPr/>
-        </p:nvSpPr>
-        <p:spPr>
-          <a:xfrm>
-            <a:off x="3657600" y="3246120"/>
-            <a:ext cx="2148840" cy="594360"/>
-          </a:xfrm>
-          <a:prstGeom prst="rect">
-            <a:avLst/>
-          </a:prstGeom>
-          <a:noFill/>
-          <a:ln/>
-        </p:spPr>
-        <p:txBody>
-          <a:bodyPr wrap="square" lIns="0" tIns="0" rIns="0" bIns="0" rtlCol="0" anchor="t"/>
-          <a:lstStyle/>
-          <a:p>
-            <a:pPr indent="0" marL="0">
-              <a:buNone/>
-            </a:pPr>
-            <a:r>
-              <a:rPr lang="en-US" sz="1300" dirty="0">
-                <a:solidFill>
-                  <a:srgbClr val="5C6F7B"/>
-                </a:solidFill>
-              </a:rPr>
-              <a:t>github.com/andrealorenzon/SIMA2026</a:t>
-            </a:r>
-            <a:endParaRPr lang="en-US" sz="1300" dirty="0"/>
-          </a:p>
-        </p:txBody>
-      </p:sp>
-      <p:sp>
-        <p:nvSpPr>
-          <p:cNvPr id="13" name="Shape 11"/>
-          <p:cNvSpPr/>
-          <p:nvPr/>
-        </p:nvSpPr>
-        <p:spPr>
-          <a:xfrm>
-            <a:off x="6217920" y="1737360"/>
-            <a:ext cx="2606040" cy="2194560"/>
-          </a:xfrm>
-          <a:prstGeom prst="roundRect">
-            <a:avLst>
-              <a:gd name="adj" fmla="val 5000"/>
-            </a:avLst>
-          </a:prstGeom>
-          <a:solidFill>
-            <a:srgbClr val="EEF3F4"/>
-          </a:solidFill>
-          <a:ln/>
-        </p:spPr>
-      </p:sp>
-      <p:sp>
-        <p:nvSpPr>
-          <p:cNvPr id="14" name="Shape 12"/>
-          <p:cNvSpPr/>
-          <p:nvPr/>
-        </p:nvSpPr>
-        <p:spPr>
-          <a:xfrm>
-            <a:off x="6492240" y="2011680"/>
-            <a:ext cx="640080" cy="640080"/>
-          </a:xfrm>
-          <a:prstGeom prst="ellipse">
-            <a:avLst/>
-          </a:prstGeom>
-          <a:solidFill>
-            <a:srgbClr val="E09F3E"/>
-          </a:solidFill>
-          <a:ln/>
-        </p:spPr>
-      </p:sp>
-      <p:sp>
-        <p:nvSpPr>
-          <p:cNvPr id="15" name="Text 13"/>
-          <p:cNvSpPr txBox="1"/>
-          <p:nvPr/>
-        </p:nvSpPr>
-        <p:spPr>
-          <a:xfrm>
-            <a:off x="6492240" y="2011680"/>
-            <a:ext cx="640080" cy="640080"/>
-          </a:xfrm>
-          <a:prstGeom prst="rect">
-            <a:avLst/>
-          </a:prstGeom>
-          <a:noFill/>
-          <a:ln/>
-        </p:spPr>
-        <p:txBody>
-          <a:bodyPr wrap="square" lIns="0" tIns="0" rIns="0" bIns="0" rtlCol="0" anchor="ctr"/>
-          <a:lstStyle/>
-          <a:p>
-            <a:pPr algn="ctr" indent="0" marL="0">
-              <a:buNone/>
-            </a:pPr>
-            <a:r>
-              <a:rPr lang="en-US" sz="1820" b="1" dirty="0">
-                <a:solidFill>
-                  <a:srgbClr val="1F2A30"/>
-                </a:solidFill>
-              </a:rPr>
-              <a:t>3</a:t>
-            </a:r>
-            <a:endParaRPr lang="en-US" sz="1820" dirty="0"/>
-          </a:p>
-        </p:txBody>
-      </p:sp>
-      <p:sp>
-        <p:nvSpPr>
-          <p:cNvPr id="16" name="Text 14"/>
-          <p:cNvSpPr txBox="1"/>
-          <p:nvPr/>
-        </p:nvSpPr>
-        <p:spPr>
-          <a:xfrm>
-            <a:off x="6492240" y="2788920"/>
-            <a:ext cx="2148840" cy="457200"/>
-          </a:xfrm>
-          <a:prstGeom prst="rect">
-            <a:avLst/>
-          </a:prstGeom>
-          <a:noFill/>
-          <a:ln/>
-        </p:spPr>
-        <p:txBody>
-          <a:bodyPr wrap="square" lIns="0" tIns="0" rIns="0" bIns="0" rtlCol="0" anchor="ctr"/>
-          <a:lstStyle/>
-          <a:p>
-            <a:pPr indent="0" marL="0">
-              <a:buNone/>
-            </a:pPr>
-            <a:r>
-              <a:rPr lang="en-US" sz="1900" b="1" dirty="0">
-                <a:solidFill>
-                  <a:srgbClr val="1F2A30"/>
-                </a:solidFill>
-              </a:rPr>
-              <a:t>Clicca «Fork»</a:t>
-            </a:r>
-            <a:endParaRPr lang="en-US" sz="1900" dirty="0"/>
-          </a:p>
-        </p:txBody>
-      </p:sp>
-      <p:sp>
-        <p:nvSpPr>
-          <p:cNvPr id="17" name="Text 15"/>
-          <p:cNvSpPr txBox="1"/>
-          <p:nvPr/>
-        </p:nvSpPr>
-        <p:spPr>
-          <a:xfrm>
-            <a:off x="6492240" y="3246120"/>
-            <a:ext cx="2148840" cy="594360"/>
-          </a:xfrm>
-          <a:prstGeom prst="rect">
-            <a:avLst/>
-          </a:prstGeom>
-          <a:noFill/>
-          <a:ln/>
-        </p:spPr>
-        <p:txBody>
-          <a:bodyPr wrap="square" lIns="0" tIns="0" rIns="0" bIns="0" rtlCol="0" anchor="t"/>
-          <a:lstStyle/>
-          <a:p>
-            <a:pPr indent="0" marL="0">
-              <a:buNone/>
-            </a:pPr>
-            <a:r>
-              <a:rPr lang="en-US" sz="1300" dirty="0">
-                <a:solidFill>
-                  <a:srgbClr val="5C6F7B"/>
-                </a:solidFill>
-              </a:rPr>
-              <a:t>in alto a destra, poi «Create fork»</a:t>
-            </a:r>
-            <a:endParaRPr lang="en-US" sz="1300" dirty="0"/>
-          </a:p>
-        </p:txBody>
-      </p:sp>
-      <p:sp>
-        <p:nvSpPr>
-          <p:cNvPr id="18" name="Shape 16"/>
-          <p:cNvSpPr/>
-          <p:nvPr/>
-        </p:nvSpPr>
-        <p:spPr>
-          <a:xfrm>
-            <a:off x="9052560" y="1737360"/>
-            <a:ext cx="2606040" cy="2194560"/>
-          </a:xfrm>
-          <a:prstGeom prst="roundRect">
-            <a:avLst>
-              <a:gd name="adj" fmla="val 5000"/>
-            </a:avLst>
-          </a:prstGeom>
-          <a:solidFill>
-            <a:srgbClr val="0F4C5C"/>
-          </a:solidFill>
-          <a:ln/>
-        </p:spPr>
-      </p:sp>
-      <p:sp>
-        <p:nvSpPr>
-          <p:cNvPr id="19" name="Shape 17"/>
-          <p:cNvSpPr/>
-          <p:nvPr/>
-        </p:nvSpPr>
-        <p:spPr>
-          <a:xfrm>
-            <a:off x="9326880" y="2011680"/>
-            <a:ext cx="640080" cy="640080"/>
-          </a:xfrm>
-          <a:prstGeom prst="ellipse">
-            <a:avLst/>
-          </a:prstGeom>
-          <a:solidFill>
-            <a:srgbClr val="E09F3E"/>
-          </a:solidFill>
-          <a:ln/>
-        </p:spPr>
-      </p:sp>
-      <p:sp>
-        <p:nvSpPr>
-          <p:cNvPr id="20" name="Text 18"/>
-          <p:cNvSpPr txBox="1"/>
-          <p:nvPr/>
-        </p:nvSpPr>
-        <p:spPr>
-          <a:xfrm>
-            <a:off x="9326880" y="2011680"/>
-            <a:ext cx="640080" cy="640080"/>
-          </a:xfrm>
-          <a:prstGeom prst="rect">
-            <a:avLst/>
-          </a:prstGeom>
-          <a:noFill/>
-          <a:ln/>
-        </p:spPr>
-        <p:txBody>
-          <a:bodyPr wrap="square" lIns="0" tIns="0" rIns="0" bIns="0" rtlCol="0" anchor="ctr"/>
-          <a:lstStyle/>
-          <a:p>
-            <a:pPr algn="ctr" indent="0" marL="0">
-              <a:buNone/>
-            </a:pPr>
-            <a:r>
-              <a:rPr lang="en-US" sz="1820" b="1" dirty="0">
-                <a:solidFill>
-                  <a:srgbClr val="1F2A30"/>
-                </a:solidFill>
-              </a:rPr>
-              <a:t>4</a:t>
-            </a:r>
-            <a:endParaRPr lang="en-US" sz="1820" dirty="0"/>
-          </a:p>
-        </p:txBody>
-      </p:sp>
-      <p:sp>
-        <p:nvSpPr>
-          <p:cNvPr id="21" name="Text 19"/>
-          <p:cNvSpPr txBox="1"/>
-          <p:nvPr/>
-        </p:nvSpPr>
-        <p:spPr>
-          <a:xfrm>
-            <a:off x="9326880" y="2788920"/>
-            <a:ext cx="2148840" cy="457200"/>
-          </a:xfrm>
-          <a:prstGeom prst="rect">
-            <a:avLst/>
-          </a:prstGeom>
-          <a:noFill/>
-          <a:ln/>
-        </p:spPr>
-        <p:txBody>
-          <a:bodyPr wrap="square" lIns="0" tIns="0" rIns="0" bIns="0" rtlCol="0" anchor="ctr"/>
-          <a:lstStyle/>
-          <a:p>
-            <a:pPr indent="0" marL="0">
-              <a:buNone/>
-            </a:pPr>
-            <a:r>
-              <a:rPr lang="en-US" sz="1900" b="1" dirty="0">
-                <a:solidFill>
-                  <a:srgbClr val="FFFFFF"/>
-                </a:solidFill>
-              </a:rPr>
-              <a:t>È tuo</a:t>
-            </a:r>
-            <a:endParaRPr lang="en-US" sz="1900" dirty="0"/>
-          </a:p>
-        </p:txBody>
-      </p:sp>
-      <p:sp>
-        <p:nvSpPr>
-          <p:cNvPr id="22" name="Text 20"/>
-          <p:cNvSpPr txBox="1"/>
-          <p:nvPr/>
-        </p:nvSpPr>
-        <p:spPr>
-          <a:xfrm>
-            <a:off x="9326880" y="3246120"/>
-            <a:ext cx="2148840" cy="594360"/>
-          </a:xfrm>
-          <a:prstGeom prst="rect">
-            <a:avLst/>
-          </a:prstGeom>
-          <a:noFill/>
-          <a:ln/>
-        </p:spPr>
-        <p:txBody>
-          <a:bodyPr wrap="square" lIns="0" tIns="0" rIns="0" bIns="0" rtlCol="0" anchor="t"/>
-          <a:lstStyle/>
-          <a:p>
-            <a:pPr indent="0" marL="0">
-              <a:buNone/>
-            </a:pPr>
-            <a:r>
-              <a:rPr lang="en-US" sz="1300" dirty="0">
+              <a:rPr lang="en-US" sz="2200" dirty="0">
                 <a:solidFill>
                   <a:srgbClr val="B8C4CB"/>
                 </a:solidFill>
               </a:rPr>
-              <a:t>github.com/&lt;tuo-nome&gt;/SIMA2026</a:t>
-            </a:r>
-            <a:endParaRPr lang="en-US" sz="1300" dirty="0"/>
-          </a:p>
-        </p:txBody>
-      </p:sp>
-      <p:sp>
-        <p:nvSpPr>
-          <p:cNvPr id="23" name="Text 21"/>
-          <p:cNvSpPr txBox="1"/>
-          <p:nvPr/>
-        </p:nvSpPr>
-        <p:spPr>
-          <a:xfrm>
-            <a:off x="548640" y="4251960"/>
-            <a:ext cx="11064240" cy="1554480"/>
-          </a:xfrm>
-          <a:prstGeom prst="rect">
-            <a:avLst/>
-          </a:prstGeom>
-          <a:noFill/>
-          <a:ln/>
-        </p:spPr>
-        <p:txBody>
-          <a:bodyPr wrap="square" lIns="0" tIns="0" rIns="0" bIns="0" rtlCol="0" anchor="t"/>
-          <a:lstStyle/>
-          <a:p>
-            <a:pPr marL="342900" indent="-342900">
-              <a:spcAft>
-                <a:spcPts val="1000"/>
-              </a:spcAft>
-              <a:buSzPct val="100000"/>
-              <a:buChar char="•"/>
-            </a:pPr>
-            <a:r>
-              <a:rPr lang="en-US" sz="1700" dirty="0">
-                <a:solidFill>
-                  <a:srgbClr val="1F2A30"/>
-                </a:solidFill>
-              </a:rPr>
-              <a:t>Un fork è una copia del repository nel tuo account: puoi modificarla senza toccare l'originale.</a:t>
-            </a:r>
-            <a:endParaRPr lang="en-US" sz="1700" dirty="0"/>
-          </a:p>
-          <a:p>
-            <a:pPr marL="342900" indent="-342900">
-              <a:spcAft>
-                <a:spcPts val="1000"/>
-              </a:spcAft>
-              <a:buSzPct val="100000"/>
-              <a:buChar char="•"/>
-            </a:pPr>
-            <a:r>
-              <a:rPr lang="en-US" sz="1700" dirty="0">
-                <a:solidFill>
-                  <a:srgbClr val="1F2A30"/>
-                </a:solidFill>
-              </a:rPr>
-              <a:t>Da Colab salvi i notebook direttamente lì: File → Salva una copia in GitHub.</a:t>
-            </a:r>
-            <a:endParaRPr lang="en-US" sz="1700" dirty="0"/>
-          </a:p>
-          <a:p>
-            <a:pPr marL="342900" indent="-342900">
-              <a:spcAft>
-                <a:spcPts val="1000"/>
-              </a:spcAft>
-              <a:buSzPct val="100000"/>
-              <a:buChar char="•"/>
-            </a:pPr>
-            <a:r>
-              <a:rPr lang="en-US" sz="1700" dirty="0">
-                <a:solidFill>
-                  <a:srgbClr val="1F2A30"/>
-                </a:solidFill>
-              </a:rPr>
-              <a:t>Quando il corso si aggiorna, sul tuo fork clicca «Sync fork» per ricevere le novità.</a:t>
-            </a:r>
-            <a:endParaRPr lang="en-US" sz="1700" dirty="0"/>
-          </a:p>
-        </p:txBody>
-      </p:sp>
-      <p:sp>
-        <p:nvSpPr>
-          <p:cNvPr id="25" name="Slide Number Placeholder 0"/>
-          <p:cNvSpPr>
-            <a:spLocks noGrp="1"/>
-          </p:cNvSpPr>
-          <p:nvPr>
-            <p:ph type="sldNum" sz="quarter" idx="4294967295"/>
-          </p:nvPr>
-        </p:nvSpPr>
-        <p:spPr>
-          <a:xfrm>
-            <a:off x="11155680" y="6400800"/>
-            <a:ext cx="457200" cy="274320"/>
-          </a:xfrm>
-          <a:prstGeom prst="rect">
-            <a:avLst/>
-          </a:prstGeom>
-          <a:extLst>
-            <a:ext uri="{C572A759-6A51-4108-AA02-DFA0A04FC94B}">
-              <ma14:wrappingTextBoxFlag xmlns:ma14="http://schemas.microsoft.com/office/mac/drawingml/2011/main" val="0"/>
-            </a:ext>
-          </a:extLst>
-        </p:spPr>
-        <p:txBody>
-          <a:bodyPr/>
-          <a:lstStyle>
-            <a:lvl1pPr>
-              <a:defRPr sz="1000">
-                <a:solidFill>
-                  <a:srgbClr val="5C6F7B"/>
-                </a:solidFill>
-              </a:defRPr>
-            </a:lvl1pPr>
-          </a:lstStyle>
-          <a:p>
-            <a:pPr algn="r"/>
-            <a:fld id="{F7021451-1387-4CA6-816F-3879F97B5CBC}" type="slidenum">
-              <a:rPr b="0" lang="en-US"/>
-              <a:t>10</a:t>
-            </a:fld>
-            <a:endParaRPr lang="en-US"/>
+              <a:t>60 minuti · apri il notebook dal README</a:t>
+            </a:r>
+            <a:endParaRPr lang="en-US" sz="2200" dirty="0"/>
           </a:p>
         </p:txBody>
       </p:sp>
@@ -3113,6 +2534,790 @@
         </p:nvSpPr>
         <p:spPr>
           <a:xfrm>
+            <a:off x="548640" y="365760"/>
+            <a:ext cx="11064240" cy="822960"/>
+          </a:xfrm>
+          <a:prstGeom prst="rect">
+            <a:avLst/>
+          </a:prstGeom>
+          <a:noFill/>
+          <a:ln/>
+        </p:spPr>
+        <p:txBody>
+          <a:bodyPr wrap="square" lIns="0" tIns="0" rIns="0" bIns="0" rtlCol="0" anchor="ctr"/>
+          <a:lstStyle/>
+          <a:p>
+            <a:pPr algn="l" indent="0" marL="0">
+              <a:buNone/>
+            </a:pPr>
+            <a:r>
+              <a:rPr lang="en-US" sz="3600" b="1" dirty="0">
+                <a:solidFill>
+                  <a:srgbClr val="0F4C5C"/>
+                </a:solidFill>
+              </a:rPr>
+              <a:t>Extra: una copia del corso tutta tua</a:t>
+            </a:r>
+            <a:endParaRPr lang="en-US" sz="3600" dirty="0"/>
+          </a:p>
+        </p:txBody>
+      </p:sp>
+      <p:sp>
+        <p:nvSpPr>
+          <p:cNvPr id="3" name="Shape 1"/>
+          <p:cNvSpPr/>
+          <p:nvPr/>
+        </p:nvSpPr>
+        <p:spPr>
+          <a:xfrm>
+            <a:off x="548640" y="1737360"/>
+            <a:ext cx="2606040" cy="2194560"/>
+          </a:xfrm>
+          <a:prstGeom prst="roundRect">
+            <a:avLst>
+              <a:gd name="adj" fmla="val 5000"/>
+            </a:avLst>
+          </a:prstGeom>
+          <a:solidFill>
+            <a:srgbClr val="EEF3F4"/>
+          </a:solidFill>
+          <a:ln/>
+        </p:spPr>
+      </p:sp>
+      <p:sp>
+        <p:nvSpPr>
+          <p:cNvPr id="4" name="Shape 2"/>
+          <p:cNvSpPr/>
+          <p:nvPr/>
+        </p:nvSpPr>
+        <p:spPr>
+          <a:xfrm>
+            <a:off x="822960" y="2011680"/>
+            <a:ext cx="640080" cy="640080"/>
+          </a:xfrm>
+          <a:prstGeom prst="ellipse">
+            <a:avLst/>
+          </a:prstGeom>
+          <a:solidFill>
+            <a:srgbClr val="E09F3E"/>
+          </a:solidFill>
+          <a:ln/>
+        </p:spPr>
+      </p:sp>
+      <p:sp>
+        <p:nvSpPr>
+          <p:cNvPr id="5" name="Text 3"/>
+          <p:cNvSpPr txBox="1"/>
+          <p:nvPr/>
+        </p:nvSpPr>
+        <p:spPr>
+          <a:xfrm>
+            <a:off x="822960" y="2011680"/>
+            <a:ext cx="640080" cy="640080"/>
+          </a:xfrm>
+          <a:prstGeom prst="rect">
+            <a:avLst/>
+          </a:prstGeom>
+          <a:noFill/>
+          <a:ln/>
+        </p:spPr>
+        <p:txBody>
+          <a:bodyPr wrap="square" lIns="0" tIns="0" rIns="0" bIns="0" rtlCol="0" anchor="ctr"/>
+          <a:lstStyle/>
+          <a:p>
+            <a:pPr algn="ctr" indent="0" marL="0">
+              <a:buNone/>
+            </a:pPr>
+            <a:r>
+              <a:rPr lang="en-US" sz="1820" b="1" dirty="0">
+                <a:solidFill>
+                  <a:srgbClr val="1F2A30"/>
+                </a:solidFill>
+              </a:rPr>
+              <a:t>1</a:t>
+            </a:r>
+            <a:endParaRPr lang="en-US" sz="1820" dirty="0"/>
+          </a:p>
+        </p:txBody>
+      </p:sp>
+      <p:sp>
+        <p:nvSpPr>
+          <p:cNvPr id="6" name="Text 4"/>
+          <p:cNvSpPr txBox="1"/>
+          <p:nvPr/>
+        </p:nvSpPr>
+        <p:spPr>
+          <a:xfrm>
+            <a:off x="822960" y="2788920"/>
+            <a:ext cx="2148840" cy="457200"/>
+          </a:xfrm>
+          <a:prstGeom prst="rect">
+            <a:avLst/>
+          </a:prstGeom>
+          <a:noFill/>
+          <a:ln/>
+        </p:spPr>
+        <p:txBody>
+          <a:bodyPr wrap="square" lIns="0" tIns="0" rIns="0" bIns="0" rtlCol="0" anchor="ctr"/>
+          <a:lstStyle/>
+          <a:p>
+            <a:pPr indent="0" marL="0">
+              <a:buNone/>
+            </a:pPr>
+            <a:r>
+              <a:rPr lang="en-US" sz="1900" b="1" dirty="0">
+                <a:solidFill>
+                  <a:srgbClr val="1F2A30"/>
+                </a:solidFill>
+              </a:rPr>
+              <a:t>Crea un account</a:t>
+            </a:r>
+            <a:endParaRPr lang="en-US" sz="1900" dirty="0"/>
+          </a:p>
+        </p:txBody>
+      </p:sp>
+      <p:sp>
+        <p:nvSpPr>
+          <p:cNvPr id="7" name="Text 5"/>
+          <p:cNvSpPr txBox="1"/>
+          <p:nvPr/>
+        </p:nvSpPr>
+        <p:spPr>
+          <a:xfrm>
+            <a:off x="822960" y="3246120"/>
+            <a:ext cx="2148840" cy="594360"/>
+          </a:xfrm>
+          <a:prstGeom prst="rect">
+            <a:avLst/>
+          </a:prstGeom>
+          <a:noFill/>
+          <a:ln/>
+        </p:spPr>
+        <p:txBody>
+          <a:bodyPr wrap="square" lIns="0" tIns="0" rIns="0" bIns="0" rtlCol="0" anchor="t"/>
+          <a:lstStyle/>
+          <a:p>
+            <a:pPr indent="0" marL="0">
+              <a:buNone/>
+            </a:pPr>
+            <a:r>
+              <a:rPr lang="en-US" sz="1300" dirty="0">
+                <a:solidFill>
+                  <a:srgbClr val="5C6F7B"/>
+                </a:solidFill>
+              </a:rPr>
+              <a:t>su github.com, gratuito</a:t>
+            </a:r>
+            <a:endParaRPr lang="en-US" sz="1300" dirty="0"/>
+          </a:p>
+        </p:txBody>
+      </p:sp>
+      <p:sp>
+        <p:nvSpPr>
+          <p:cNvPr id="8" name="Shape 6"/>
+          <p:cNvSpPr/>
+          <p:nvPr/>
+        </p:nvSpPr>
+        <p:spPr>
+          <a:xfrm>
+            <a:off x="3383280" y="1737360"/>
+            <a:ext cx="2606040" cy="2194560"/>
+          </a:xfrm>
+          <a:prstGeom prst="roundRect">
+            <a:avLst>
+              <a:gd name="adj" fmla="val 5000"/>
+            </a:avLst>
+          </a:prstGeom>
+          <a:solidFill>
+            <a:srgbClr val="EEF3F4"/>
+          </a:solidFill>
+          <a:ln/>
+        </p:spPr>
+      </p:sp>
+      <p:sp>
+        <p:nvSpPr>
+          <p:cNvPr id="9" name="Shape 7"/>
+          <p:cNvSpPr/>
+          <p:nvPr/>
+        </p:nvSpPr>
+        <p:spPr>
+          <a:xfrm>
+            <a:off x="3657600" y="2011680"/>
+            <a:ext cx="640080" cy="640080"/>
+          </a:xfrm>
+          <a:prstGeom prst="ellipse">
+            <a:avLst/>
+          </a:prstGeom>
+          <a:solidFill>
+            <a:srgbClr val="E09F3E"/>
+          </a:solidFill>
+          <a:ln/>
+        </p:spPr>
+      </p:sp>
+      <p:sp>
+        <p:nvSpPr>
+          <p:cNvPr id="10" name="Text 8"/>
+          <p:cNvSpPr txBox="1"/>
+          <p:nvPr/>
+        </p:nvSpPr>
+        <p:spPr>
+          <a:xfrm>
+            <a:off x="3657600" y="2011680"/>
+            <a:ext cx="640080" cy="640080"/>
+          </a:xfrm>
+          <a:prstGeom prst="rect">
+            <a:avLst/>
+          </a:prstGeom>
+          <a:noFill/>
+          <a:ln/>
+        </p:spPr>
+        <p:txBody>
+          <a:bodyPr wrap="square" lIns="0" tIns="0" rIns="0" bIns="0" rtlCol="0" anchor="ctr"/>
+          <a:lstStyle/>
+          <a:p>
+            <a:pPr algn="ctr" indent="0" marL="0">
+              <a:buNone/>
+            </a:pPr>
+            <a:r>
+              <a:rPr lang="en-US" sz="1820" b="1" dirty="0">
+                <a:solidFill>
+                  <a:srgbClr val="1F2A30"/>
+                </a:solidFill>
+              </a:rPr>
+              <a:t>2</a:t>
+            </a:r>
+            <a:endParaRPr lang="en-US" sz="1820" dirty="0"/>
+          </a:p>
+        </p:txBody>
+      </p:sp>
+      <p:sp>
+        <p:nvSpPr>
+          <p:cNvPr id="11" name="Text 9"/>
+          <p:cNvSpPr txBox="1"/>
+          <p:nvPr/>
+        </p:nvSpPr>
+        <p:spPr>
+          <a:xfrm>
+            <a:off x="3657600" y="2788920"/>
+            <a:ext cx="2148840" cy="457200"/>
+          </a:xfrm>
+          <a:prstGeom prst="rect">
+            <a:avLst/>
+          </a:prstGeom>
+          <a:noFill/>
+          <a:ln/>
+        </p:spPr>
+        <p:txBody>
+          <a:bodyPr wrap="square" lIns="0" tIns="0" rIns="0" bIns="0" rtlCol="0" anchor="ctr"/>
+          <a:lstStyle/>
+          <a:p>
+            <a:pPr indent="0" marL="0">
+              <a:buNone/>
+            </a:pPr>
+            <a:r>
+              <a:rPr lang="en-US" sz="1900" b="1" dirty="0">
+                <a:solidFill>
+                  <a:srgbClr val="1F2A30"/>
+                </a:solidFill>
+              </a:rPr>
+              <a:t>Apri il repository</a:t>
+            </a:r>
+            <a:endParaRPr lang="en-US" sz="1900" dirty="0"/>
+          </a:p>
+        </p:txBody>
+      </p:sp>
+      <p:sp>
+        <p:nvSpPr>
+          <p:cNvPr id="12" name="Text 10"/>
+          <p:cNvSpPr txBox="1"/>
+          <p:nvPr/>
+        </p:nvSpPr>
+        <p:spPr>
+          <a:xfrm>
+            <a:off x="3657600" y="3246120"/>
+            <a:ext cx="2148840" cy="594360"/>
+          </a:xfrm>
+          <a:prstGeom prst="rect">
+            <a:avLst/>
+          </a:prstGeom>
+          <a:noFill/>
+          <a:ln/>
+        </p:spPr>
+        <p:txBody>
+          <a:bodyPr wrap="square" lIns="0" tIns="0" rIns="0" bIns="0" rtlCol="0" anchor="t"/>
+          <a:lstStyle/>
+          <a:p>
+            <a:pPr indent="0" marL="0">
+              <a:buNone/>
+            </a:pPr>
+            <a:r>
+              <a:rPr lang="en-US" sz="1300" dirty="0">
+                <a:solidFill>
+                  <a:srgbClr val="5C6F7B"/>
+                </a:solidFill>
+              </a:rPr>
+              <a:t>github.com/andrealorenzon/SIMA2026</a:t>
+            </a:r>
+            <a:endParaRPr lang="en-US" sz="1300" dirty="0"/>
+          </a:p>
+        </p:txBody>
+      </p:sp>
+      <p:sp>
+        <p:nvSpPr>
+          <p:cNvPr id="13" name="Shape 11"/>
+          <p:cNvSpPr/>
+          <p:nvPr/>
+        </p:nvSpPr>
+        <p:spPr>
+          <a:xfrm>
+            <a:off x="6217920" y="1737360"/>
+            <a:ext cx="2606040" cy="2194560"/>
+          </a:xfrm>
+          <a:prstGeom prst="roundRect">
+            <a:avLst>
+              <a:gd name="adj" fmla="val 5000"/>
+            </a:avLst>
+          </a:prstGeom>
+          <a:solidFill>
+            <a:srgbClr val="EEF3F4"/>
+          </a:solidFill>
+          <a:ln/>
+        </p:spPr>
+      </p:sp>
+      <p:sp>
+        <p:nvSpPr>
+          <p:cNvPr id="14" name="Shape 12"/>
+          <p:cNvSpPr/>
+          <p:nvPr/>
+        </p:nvSpPr>
+        <p:spPr>
+          <a:xfrm>
+            <a:off x="6492240" y="2011680"/>
+            <a:ext cx="640080" cy="640080"/>
+          </a:xfrm>
+          <a:prstGeom prst="ellipse">
+            <a:avLst/>
+          </a:prstGeom>
+          <a:solidFill>
+            <a:srgbClr val="E09F3E"/>
+          </a:solidFill>
+          <a:ln/>
+        </p:spPr>
+      </p:sp>
+      <p:sp>
+        <p:nvSpPr>
+          <p:cNvPr id="15" name="Text 13"/>
+          <p:cNvSpPr txBox="1"/>
+          <p:nvPr/>
+        </p:nvSpPr>
+        <p:spPr>
+          <a:xfrm>
+            <a:off x="6492240" y="2011680"/>
+            <a:ext cx="640080" cy="640080"/>
+          </a:xfrm>
+          <a:prstGeom prst="rect">
+            <a:avLst/>
+          </a:prstGeom>
+          <a:noFill/>
+          <a:ln/>
+        </p:spPr>
+        <p:txBody>
+          <a:bodyPr wrap="square" lIns="0" tIns="0" rIns="0" bIns="0" rtlCol="0" anchor="ctr"/>
+          <a:lstStyle/>
+          <a:p>
+            <a:pPr algn="ctr" indent="0" marL="0">
+              <a:buNone/>
+            </a:pPr>
+            <a:r>
+              <a:rPr lang="en-US" sz="1820" b="1" dirty="0">
+                <a:solidFill>
+                  <a:srgbClr val="1F2A30"/>
+                </a:solidFill>
+              </a:rPr>
+              <a:t>3</a:t>
+            </a:r>
+            <a:endParaRPr lang="en-US" sz="1820" dirty="0"/>
+          </a:p>
+        </p:txBody>
+      </p:sp>
+      <p:sp>
+        <p:nvSpPr>
+          <p:cNvPr id="16" name="Text 14"/>
+          <p:cNvSpPr txBox="1"/>
+          <p:nvPr/>
+        </p:nvSpPr>
+        <p:spPr>
+          <a:xfrm>
+            <a:off x="6492240" y="2788920"/>
+            <a:ext cx="2148840" cy="457200"/>
+          </a:xfrm>
+          <a:prstGeom prst="rect">
+            <a:avLst/>
+          </a:prstGeom>
+          <a:noFill/>
+          <a:ln/>
+        </p:spPr>
+        <p:txBody>
+          <a:bodyPr wrap="square" lIns="0" tIns="0" rIns="0" bIns="0" rtlCol="0" anchor="ctr"/>
+          <a:lstStyle/>
+          <a:p>
+            <a:pPr indent="0" marL="0">
+              <a:buNone/>
+            </a:pPr>
+            <a:r>
+              <a:rPr lang="en-US" sz="1900" b="1" dirty="0">
+                <a:solidFill>
+                  <a:srgbClr val="1F2A30"/>
+                </a:solidFill>
+              </a:rPr>
+              <a:t>Clicca «Fork»</a:t>
+            </a:r>
+            <a:endParaRPr lang="en-US" sz="1900" dirty="0"/>
+          </a:p>
+        </p:txBody>
+      </p:sp>
+      <p:sp>
+        <p:nvSpPr>
+          <p:cNvPr id="17" name="Text 15"/>
+          <p:cNvSpPr txBox="1"/>
+          <p:nvPr/>
+        </p:nvSpPr>
+        <p:spPr>
+          <a:xfrm>
+            <a:off x="6492240" y="3246120"/>
+            <a:ext cx="2148840" cy="594360"/>
+          </a:xfrm>
+          <a:prstGeom prst="rect">
+            <a:avLst/>
+          </a:prstGeom>
+          <a:noFill/>
+          <a:ln/>
+        </p:spPr>
+        <p:txBody>
+          <a:bodyPr wrap="square" lIns="0" tIns="0" rIns="0" bIns="0" rtlCol="0" anchor="t"/>
+          <a:lstStyle/>
+          <a:p>
+            <a:pPr indent="0" marL="0">
+              <a:buNone/>
+            </a:pPr>
+            <a:r>
+              <a:rPr lang="en-US" sz="1300" dirty="0">
+                <a:solidFill>
+                  <a:srgbClr val="5C6F7B"/>
+                </a:solidFill>
+              </a:rPr>
+              <a:t>in alto a destra, poi «Create fork»</a:t>
+            </a:r>
+            <a:endParaRPr lang="en-US" sz="1300" dirty="0"/>
+          </a:p>
+        </p:txBody>
+      </p:sp>
+      <p:sp>
+        <p:nvSpPr>
+          <p:cNvPr id="18" name="Shape 16"/>
+          <p:cNvSpPr/>
+          <p:nvPr/>
+        </p:nvSpPr>
+        <p:spPr>
+          <a:xfrm>
+            <a:off x="9052560" y="1737360"/>
+            <a:ext cx="2606040" cy="2194560"/>
+          </a:xfrm>
+          <a:prstGeom prst="roundRect">
+            <a:avLst>
+              <a:gd name="adj" fmla="val 5000"/>
+            </a:avLst>
+          </a:prstGeom>
+          <a:solidFill>
+            <a:srgbClr val="0F4C5C"/>
+          </a:solidFill>
+          <a:ln/>
+        </p:spPr>
+      </p:sp>
+      <p:sp>
+        <p:nvSpPr>
+          <p:cNvPr id="19" name="Shape 17"/>
+          <p:cNvSpPr/>
+          <p:nvPr/>
+        </p:nvSpPr>
+        <p:spPr>
+          <a:xfrm>
+            <a:off x="9326880" y="2011680"/>
+            <a:ext cx="640080" cy="640080"/>
+          </a:xfrm>
+          <a:prstGeom prst="ellipse">
+            <a:avLst/>
+          </a:prstGeom>
+          <a:solidFill>
+            <a:srgbClr val="E09F3E"/>
+          </a:solidFill>
+          <a:ln/>
+        </p:spPr>
+      </p:sp>
+      <p:sp>
+        <p:nvSpPr>
+          <p:cNvPr id="20" name="Text 18"/>
+          <p:cNvSpPr txBox="1"/>
+          <p:nvPr/>
+        </p:nvSpPr>
+        <p:spPr>
+          <a:xfrm>
+            <a:off x="9326880" y="2011680"/>
+            <a:ext cx="640080" cy="640080"/>
+          </a:xfrm>
+          <a:prstGeom prst="rect">
+            <a:avLst/>
+          </a:prstGeom>
+          <a:noFill/>
+          <a:ln/>
+        </p:spPr>
+        <p:txBody>
+          <a:bodyPr wrap="square" lIns="0" tIns="0" rIns="0" bIns="0" rtlCol="0" anchor="ctr"/>
+          <a:lstStyle/>
+          <a:p>
+            <a:pPr algn="ctr" indent="0" marL="0">
+              <a:buNone/>
+            </a:pPr>
+            <a:r>
+              <a:rPr lang="en-US" sz="1820" b="1" dirty="0">
+                <a:solidFill>
+                  <a:srgbClr val="1F2A30"/>
+                </a:solidFill>
+              </a:rPr>
+              <a:t>4</a:t>
+            </a:r>
+            <a:endParaRPr lang="en-US" sz="1820" dirty="0"/>
+          </a:p>
+        </p:txBody>
+      </p:sp>
+      <p:sp>
+        <p:nvSpPr>
+          <p:cNvPr id="21" name="Text 19"/>
+          <p:cNvSpPr txBox="1"/>
+          <p:nvPr/>
+        </p:nvSpPr>
+        <p:spPr>
+          <a:xfrm>
+            <a:off x="9326880" y="2788920"/>
+            <a:ext cx="2148840" cy="457200"/>
+          </a:xfrm>
+          <a:prstGeom prst="rect">
+            <a:avLst/>
+          </a:prstGeom>
+          <a:noFill/>
+          <a:ln/>
+        </p:spPr>
+        <p:txBody>
+          <a:bodyPr wrap="square" lIns="0" tIns="0" rIns="0" bIns="0" rtlCol="0" anchor="ctr"/>
+          <a:lstStyle/>
+          <a:p>
+            <a:pPr indent="0" marL="0">
+              <a:buNone/>
+            </a:pPr>
+            <a:r>
+              <a:rPr lang="en-US" sz="1900" b="1" dirty="0">
+                <a:solidFill>
+                  <a:srgbClr val="FFFFFF"/>
+                </a:solidFill>
+              </a:rPr>
+              <a:t>È tuo</a:t>
+            </a:r>
+            <a:endParaRPr lang="en-US" sz="1900" dirty="0"/>
+          </a:p>
+        </p:txBody>
+      </p:sp>
+      <p:sp>
+        <p:nvSpPr>
+          <p:cNvPr id="22" name="Text 20"/>
+          <p:cNvSpPr txBox="1"/>
+          <p:nvPr/>
+        </p:nvSpPr>
+        <p:spPr>
+          <a:xfrm>
+            <a:off x="9326880" y="3246120"/>
+            <a:ext cx="2148840" cy="594360"/>
+          </a:xfrm>
+          <a:prstGeom prst="rect">
+            <a:avLst/>
+          </a:prstGeom>
+          <a:noFill/>
+          <a:ln/>
+        </p:spPr>
+        <p:txBody>
+          <a:bodyPr wrap="square" lIns="0" tIns="0" rIns="0" bIns="0" rtlCol="0" anchor="t"/>
+          <a:lstStyle/>
+          <a:p>
+            <a:pPr indent="0" marL="0">
+              <a:buNone/>
+            </a:pPr>
+            <a:r>
+              <a:rPr lang="en-US" sz="1300" dirty="0">
+                <a:solidFill>
+                  <a:srgbClr val="B8C4CB"/>
+                </a:solidFill>
+              </a:rPr>
+              <a:t>github.com/&lt;tuo-nome&gt;/SIMA2026</a:t>
+            </a:r>
+            <a:endParaRPr lang="en-US" sz="1300" dirty="0"/>
+          </a:p>
+        </p:txBody>
+      </p:sp>
+      <p:sp>
+        <p:nvSpPr>
+          <p:cNvPr id="23" name="Text 21"/>
+          <p:cNvSpPr txBox="1"/>
+          <p:nvPr/>
+        </p:nvSpPr>
+        <p:spPr>
+          <a:xfrm>
+            <a:off x="548640" y="4251960"/>
+            <a:ext cx="11064240" cy="1554480"/>
+          </a:xfrm>
+          <a:prstGeom prst="rect">
+            <a:avLst/>
+          </a:prstGeom>
+          <a:noFill/>
+          <a:ln/>
+        </p:spPr>
+        <p:txBody>
+          <a:bodyPr wrap="square" lIns="0" tIns="0" rIns="0" bIns="0" rtlCol="0" anchor="t"/>
+          <a:lstStyle/>
+          <a:p>
+            <a:pPr marL="342900" indent="-342900">
+              <a:spcAft>
+                <a:spcPts val="1000"/>
+              </a:spcAft>
+              <a:buSzPct val="100000"/>
+              <a:buChar char="•"/>
+            </a:pPr>
+            <a:r>
+              <a:rPr lang="en-US" sz="1700" dirty="0">
+                <a:solidFill>
+                  <a:srgbClr val="1F2A30"/>
+                </a:solidFill>
+              </a:rPr>
+              <a:t>Un fork è una copia del repository nel tuo account: puoi modificarla senza toccare l'originale.</a:t>
+            </a:r>
+            <a:endParaRPr lang="en-US" sz="1700" dirty="0"/>
+          </a:p>
+          <a:p>
+            <a:pPr marL="342900" indent="-342900">
+              <a:spcAft>
+                <a:spcPts val="1000"/>
+              </a:spcAft>
+              <a:buSzPct val="100000"/>
+              <a:buChar char="•"/>
+            </a:pPr>
+            <a:r>
+              <a:rPr lang="en-US" sz="1700" dirty="0">
+                <a:solidFill>
+                  <a:srgbClr val="1F2A30"/>
+                </a:solidFill>
+              </a:rPr>
+              <a:t>Da Colab salvi i notebook direttamente lì: File → Salva una copia in GitHub.</a:t>
+            </a:r>
+            <a:endParaRPr lang="en-US" sz="1700" dirty="0"/>
+          </a:p>
+          <a:p>
+            <a:pPr marL="342900" indent="-342900">
+              <a:spcAft>
+                <a:spcPts val="1000"/>
+              </a:spcAft>
+              <a:buSzPct val="100000"/>
+              <a:buChar char="•"/>
+            </a:pPr>
+            <a:r>
+              <a:rPr lang="en-US" sz="1700" dirty="0">
+                <a:solidFill>
+                  <a:srgbClr val="1F2A30"/>
+                </a:solidFill>
+              </a:rPr>
+              <a:t>Quando il corso si aggiorna, sul tuo fork clicca «Sync fork» per ricevere le novità.</a:t>
+            </a:r>
+            <a:endParaRPr lang="en-US" sz="1700" dirty="0"/>
+          </a:p>
+        </p:txBody>
+      </p:sp>
+      <p:sp>
+        <p:nvSpPr>
+          <p:cNvPr id="25" name="Slide Number Placeholder 0"/>
+          <p:cNvSpPr>
+            <a:spLocks noGrp="1"/>
+          </p:cNvSpPr>
+          <p:nvPr>
+            <p:ph type="sldNum" sz="quarter" idx="4294967295"/>
+          </p:nvPr>
+        </p:nvSpPr>
+        <p:spPr>
+          <a:xfrm>
+            <a:off x="11155680" y="6400800"/>
+            <a:ext cx="457200" cy="274320"/>
+          </a:xfrm>
+          <a:prstGeom prst="rect">
+            <a:avLst/>
+          </a:prstGeom>
+          <a:extLst>
+            <a:ext uri="{C572A759-6A51-4108-AA02-DFA0A04FC94B}">
+              <ma14:wrappingTextBoxFlag xmlns:ma14="http://schemas.microsoft.com/office/mac/drawingml/2011/main" val="0"/>
+            </a:ext>
+          </a:extLst>
+        </p:spPr>
+        <p:txBody>
+          <a:bodyPr/>
+          <a:lstStyle>
+            <a:lvl1pPr>
+              <a:defRPr sz="1000">
+                <a:solidFill>
+                  <a:srgbClr val="5C6F7B"/>
+                </a:solidFill>
+              </a:defRPr>
+            </a:lvl1pPr>
+          </a:lstStyle>
+          <a:p>
+            <a:pPr algn="r"/>
+            <a:fld id="{F7021451-1387-4CA6-816F-3879F97B5CBC}" type="slidenum">
+              <a:rPr b="0" lang="en-US"/>
+              <a:t>11</a:t>
+            </a:fld>
+            <a:endParaRPr lang="en-US"/>
+          </a:p>
+        </p:txBody>
+      </p:sp>
+    </p:spTree>
+  </p:cSld>
+  <p:clrMapOvr>
+    <a:masterClrMapping/>
+  </p:clrMapOvr>
+</p:sld>
+</file>
+
+<file path=ppt/slides/slide12.xml><?xml version="1.0" encoding="utf-8"?>
+<p:sld xmlns:a="http://schemas.openxmlformats.org/drawingml/2006/main" xmlns:r="http://schemas.openxmlformats.org/officeDocument/2006/relationships" xmlns:p="http://schemas.openxmlformats.org/presentationml/2006/main">
+  <p:cSld name="Slide 12">
+    <p:spTree>
+      <p:nvGrpSpPr>
+        <p:cNvPr id="1" name=""/>
+        <p:cNvGrpSpPr/>
+        <p:nvPr/>
+      </p:nvGrpSpPr>
+      <p:grpSpPr>
+        <a:xfrm>
+          <a:off x="0" y="0"/>
+          <a:ext cx="0" cy="0"/>
+          <a:chOff x="0" y="0"/>
+          <a:chExt cx="0" cy="0"/>
+        </a:xfrm>
+      </p:grpSpPr>
+      <p:sp>
+        <p:nvSpPr>
+          <p:cNvPr id="2" name="Text 0"/>
+          <p:cNvSpPr/>
+          <p:nvPr>
+            <p:ph idx="100" type="title" hasCustomPrompt="1"/>
+          </p:nvPr>
+        </p:nvSpPr>
+        <p:spPr>
+          <a:xfrm>
             <a:off x="731520" y="2103120"/>
             <a:ext cx="10698480" cy="1463040"/>
           </a:xfrm>
@@ -6842,7 +7047,7 @@
                   <a:srgbClr val="0F4C5C"/>
                 </a:solidFill>
               </a:rPr>
-              <a:t>In gruppi da 3, con tre ruoli</a:t>
+              <a:t>Se siete bloccati</a:t>
             </a:r>
             <a:endParaRPr lang="en-US" sz="3600" dirty="0"/>
           </a:p>
@@ -6857,11 +7062,11 @@
         <p:spPr>
           <a:xfrm>
             <a:off x="548640" y="1737360"/>
-            <a:ext cx="3474720" cy="2926080"/>
+            <a:ext cx="5440680" cy="3108960"/>
           </a:xfrm>
           <a:prstGeom prst="roundRect">
             <a:avLst>
-              <a:gd name="adj" fmla="val 3750"/>
+              <a:gd name="adj" fmla="val 3529"/>
             </a:avLst>
           </a:prstGeom>
           <a:solidFill>
@@ -6923,7 +7128,7 @@
         <p:spPr>
           <a:xfrm>
             <a:off x="868680" y="3200400"/>
-            <a:ext cx="2834640" cy="502920"/>
+            <a:ext cx="4846320" cy="502920"/>
           </a:xfrm>
           <a:prstGeom prst="rect">
             <a:avLst/>
@@ -6944,7 +7149,7 @@
                   <a:srgbClr val="1F2A30"/>
                 </a:solidFill>
               </a:rPr>
-              <a:t>Chi scrive</a:t>
+              <a:t>Durante la lezione</a:t>
             </a:r>
             <a:endParaRPr lang="en-US" sz="2400" dirty="0"/>
           </a:p>
@@ -6959,7 +7164,7 @@
         <p:spPr>
           <a:xfrm>
             <a:off x="868680" y="3749040"/>
-            <a:ext cx="2834640" cy="731520"/>
+            <a:ext cx="4846320" cy="1005840"/>
           </a:xfrm>
           <a:prstGeom prst="rect">
             <a:avLst/>
@@ -6975,14 +7180,14 @@
               <a:buNone/>
             </a:pPr>
             <a:r>
-              <a:rPr lang="en-US" sz="1600" dirty="0">
+              <a:rPr lang="en-US" sz="1700" dirty="0">
                 <a:solidFill>
                   <a:srgbClr val="5C6F7B"/>
                 </a:solidFill>
               </a:rPr>
-              <a:t>condivide lo schermo e scrive il codice nel suo notebook</a:t>
-            </a:r>
-            <a:endParaRPr lang="en-US" sz="1600" dirty="0"/>
+              <a:t>Scrivete nella chat di Zoom, o usate «Chiedi aiuto» nella stanza: entro io.</a:t>
+            </a:r>
+            <a:endParaRPr lang="en-US" sz="1700" dirty="0"/>
           </a:p>
         </p:txBody>
       </p:sp>
@@ -6994,16 +7199,16 @@
         </p:nvSpPr>
         <p:spPr>
           <a:xfrm>
-            <a:off x="4343400" y="1737360"/>
-            <a:ext cx="3474720" cy="2926080"/>
+            <a:off x="6172200" y="1737360"/>
+            <a:ext cx="5440680" cy="3108960"/>
           </a:xfrm>
           <a:prstGeom prst="roundRect">
             <a:avLst>
-              <a:gd name="adj" fmla="val 3750"/>
+              <a:gd name="adj" fmla="val 3529"/>
             </a:avLst>
           </a:prstGeom>
           <a:solidFill>
-            <a:srgbClr val="EEF3F4"/>
+            <a:srgbClr val="0F4C5C"/>
           </a:solidFill>
           <a:ln/>
         </p:spPr>
@@ -7016,7 +7221,7 @@
         </p:nvSpPr>
         <p:spPr>
           <a:xfrm>
-            <a:off x="4663440" y="2057400"/>
+            <a:off x="6492240" y="2057400"/>
             <a:ext cx="914400" cy="914400"/>
           </a:xfrm>
           <a:prstGeom prst="ellipse">
@@ -7044,7 +7249,7 @@
         </p:blipFill>
         <p:spPr>
           <a:xfrm>
-            <a:off x="4910328" y="2304288"/>
+            <a:off x="6739128" y="2304288"/>
             <a:ext cx="420624" cy="420624"/>
           </a:xfrm>
           <a:prstGeom prst="rect">
@@ -7060,8 +7265,8 @@
         </p:nvSpPr>
         <p:spPr>
           <a:xfrm>
-            <a:off x="4663440" y="3200400"/>
-            <a:ext cx="2834640" cy="502920"/>
+            <a:off x="6492240" y="3200400"/>
+            <a:ext cx="4846320" cy="502920"/>
           </a:xfrm>
           <a:prstGeom prst="rect">
             <a:avLst/>
@@ -7079,10 +7284,10 @@
             <a:r>
               <a:rPr lang="en-US" sz="2400" b="1" dirty="0">
                 <a:solidFill>
-                  <a:srgbClr val="1F2A30"/>
-                </a:solidFill>
-              </a:rPr>
-              <a:t>Chi cerca</a:t>
+                  <a:srgbClr val="FFFFFF"/>
+                </a:solidFill>
+              </a:rPr>
+              <a:t>A casa</a:t>
             </a:r>
             <a:endParaRPr lang="en-US" sz="2400" dirty="0"/>
           </a:p>
@@ -7096,8 +7301,8 @@
         </p:nvSpPr>
         <p:spPr>
           <a:xfrm>
-            <a:off x="4663440" y="3749040"/>
-            <a:ext cx="2834640" cy="731520"/>
+            <a:off x="6492240" y="3749040"/>
+            <a:ext cx="4846320" cy="1005840"/>
           </a:xfrm>
           <a:prstGeom prst="rect">
             <a:avLst/>
@@ -7113,186 +7318,48 @@
               <a:buNone/>
             </a:pPr>
             <a:r>
-              <a:rPr lang="en-US" sz="1600" dirty="0">
-                <a:solidFill>
-                  <a:srgbClr val="5C6F7B"/>
-                </a:solidFill>
-              </a:rPr>
-              <a:t>Google, Gemini, dispense: trova cosa serve</a:t>
-            </a:r>
-            <a:endParaRPr lang="en-US" sz="1600" dirty="0"/>
-          </a:p>
-        </p:txBody>
-      </p:sp>
-      <p:sp>
-        <p:nvSpPr>
-          <p:cNvPr id="13" name="Shape 9"/>
-          <p:cNvSpPr/>
-          <p:nvPr/>
-        </p:nvSpPr>
-        <p:spPr>
-          <a:xfrm>
-            <a:off x="8138160" y="1737360"/>
-            <a:ext cx="3474720" cy="2926080"/>
-          </a:xfrm>
-          <a:prstGeom prst="roundRect">
-            <a:avLst>
-              <a:gd name="adj" fmla="val 3750"/>
-            </a:avLst>
-          </a:prstGeom>
-          <a:solidFill>
-            <a:srgbClr val="0F4C5C"/>
-          </a:solidFill>
-          <a:ln/>
-        </p:spPr>
-      </p:sp>
-      <p:sp>
-        <p:nvSpPr>
-          <p:cNvPr id="14" name="Shape 10"/>
-          <p:cNvSpPr/>
-          <p:nvPr/>
-        </p:nvSpPr>
-        <p:spPr>
-          <a:xfrm>
-            <a:off x="8458200" y="2057400"/>
-            <a:ext cx="914400" cy="914400"/>
-          </a:xfrm>
-          <a:prstGeom prst="ellipse">
-            <a:avLst/>
-          </a:prstGeom>
-          <a:solidFill>
-            <a:srgbClr val="FFFFFF"/>
-          </a:solidFill>
-          <a:ln/>
-        </p:spPr>
-      </p:sp>
-      <p:pic>
-        <p:nvPicPr>
-          <p:cNvPr id="15" name="Image 2" descr="preencoded.png">    </p:cNvPr>
-          <p:cNvPicPr>
-            <a:picLocks noChangeAspect="1"/>
-          </p:cNvPicPr>
-          <p:nvPr/>
-        </p:nvPicPr>
-        <p:blipFill>
-          <a:blip r:embed="rId3"/>
-          <a:stretch>
-            <a:fillRect/>
-          </a:stretch>
-        </p:blipFill>
-        <p:spPr>
-          <a:xfrm>
-            <a:off x="8705088" y="2304288"/>
-            <a:ext cx="420624" cy="420624"/>
-          </a:xfrm>
-          <a:prstGeom prst="rect">
-            <a:avLst/>
-          </a:prstGeom>
-        </p:spPr>
-      </p:pic>
-      <p:sp>
-        <p:nvSpPr>
-          <p:cNvPr id="16" name="Text 11"/>
+              <a:rPr lang="en-US" sz="1700" dirty="0">
+                <a:solidFill>
+                  <a:srgbClr val="B8C4CB"/>
+                </a:solidFill>
+              </a:rPr>
+              <a:t>In Colab: Condividi → aggiungete il mio indirizzo (è nella mail) come Editor. Poi scrivetemi quale passo non torna.</a:t>
+            </a:r>
+            <a:endParaRPr lang="en-US" sz="1700" dirty="0"/>
+          </a:p>
+        </p:txBody>
+      </p:sp>
+      <p:sp>
+        <p:nvSpPr>
+          <p:cNvPr id="13" name="Text 9"/>
           <p:cNvSpPr txBox="1"/>
           <p:nvPr/>
         </p:nvSpPr>
         <p:spPr>
           <a:xfrm>
-            <a:off x="8458200" y="3200400"/>
-            <a:ext cx="2834640" cy="502920"/>
-          </a:xfrm>
-          <a:prstGeom prst="rect">
-            <a:avLst/>
-          </a:prstGeom>
-          <a:noFill/>
-          <a:ln/>
-        </p:spPr>
-        <p:txBody>
-          <a:bodyPr wrap="square" lIns="0" tIns="0" rIns="0" bIns="0" rtlCol="0" anchor="ctr"/>
+            <a:off x="548640" y="5120640"/>
+            <a:ext cx="11064240" cy="731520"/>
+          </a:xfrm>
+          <a:prstGeom prst="rect">
+            <a:avLst/>
+          </a:prstGeom>
+          <a:noFill/>
+          <a:ln/>
+        </p:spPr>
+        <p:txBody>
+          <a:bodyPr wrap="square" lIns="0" tIns="0" rIns="0" bIns="0" rtlCol="0" anchor="t"/>
           <a:lstStyle/>
           <a:p>
             <a:pPr indent="0" marL="0">
               <a:buNone/>
             </a:pPr>
             <a:r>
-              <a:rPr lang="en-US" sz="2400" b="1" dirty="0">
-                <a:solidFill>
-                  <a:srgbClr val="FFFFFF"/>
-                </a:solidFill>
-              </a:rPr>
-              <a:t>Chi controlla</a:t>
-            </a:r>
-            <a:endParaRPr lang="en-US" sz="2400" dirty="0"/>
-          </a:p>
-        </p:txBody>
-      </p:sp>
-      <p:sp>
-        <p:nvSpPr>
-          <p:cNvPr id="17" name="Text 12"/>
-          <p:cNvSpPr txBox="1"/>
-          <p:nvPr/>
-        </p:nvSpPr>
-        <p:spPr>
-          <a:xfrm>
-            <a:off x="8458200" y="3749040"/>
-            <a:ext cx="2834640" cy="731520"/>
-          </a:xfrm>
-          <a:prstGeom prst="rect">
-            <a:avLst/>
-          </a:prstGeom>
-          <a:noFill/>
-          <a:ln/>
-        </p:spPr>
-        <p:txBody>
-          <a:bodyPr wrap="square" lIns="0" tIns="0" rIns="0" bIns="0" rtlCol="0" anchor="t"/>
-          <a:lstStyle/>
-          <a:p>
-            <a:pPr indent="0" marL="0">
-              <a:buNone/>
-            </a:pPr>
-            <a:r>
-              <a:rPr lang="en-US" sz="1600" dirty="0">
-                <a:solidFill>
-                  <a:srgbClr val="B8C4CB"/>
-                </a:solidFill>
-              </a:rPr>
-              <a:t>il risultato ha senso? il numero torna?</a:t>
-            </a:r>
-            <a:endParaRPr lang="en-US" sz="1600" dirty="0"/>
-          </a:p>
-        </p:txBody>
-      </p:sp>
-      <p:sp>
-        <p:nvSpPr>
-          <p:cNvPr id="18" name="Text 13"/>
-          <p:cNvSpPr txBox="1"/>
-          <p:nvPr/>
-        </p:nvSpPr>
-        <p:spPr>
-          <a:xfrm>
-            <a:off x="548640" y="5029200"/>
-            <a:ext cx="11064240" cy="731520"/>
-          </a:xfrm>
-          <a:prstGeom prst="rect">
-            <a:avLst/>
-          </a:prstGeom>
-          <a:noFill/>
-          <a:ln/>
-        </p:spPr>
-        <p:txBody>
-          <a:bodyPr wrap="square" lIns="0" tIns="0" rIns="0" bIns="0" rtlCol="0" anchor="t"/>
-          <a:lstStyle/>
-          <a:p>
-            <a:pPr indent="0" marL="0">
-              <a:buNone/>
-            </a:pPr>
-            <a:r>
               <a:rPr lang="en-US" sz="1800" i="1" dirty="0">
                 <a:solidFill>
                   <a:srgbClr val="0F4C5C"/>
                 </a:solidFill>
               </a:rPr>
-              <a:t>I ruoli ruotano a ogni incontro. Il più importante è chi controlla: è il mestiere che il corso vuole allenare.</a:t>
+              <a:t>Con il permesso di Editor posso leggere il vostro codice e correggerlo direttamente nel vostro notebook.</a:t>
             </a:r>
             <a:endParaRPr lang="en-US" sz="1800" dirty="0"/>
           </a:p>
@@ -7378,83 +7445,526 @@
         </p:nvSpPr>
         <p:spPr>
           <a:xfrm>
-            <a:off x="731520" y="2194560"/>
-            <a:ext cx="10698480" cy="1280160"/>
-          </a:xfrm>
-          <a:prstGeom prst="rect">
-            <a:avLst/>
-          </a:prstGeom>
-          <a:noFill/>
-          <a:ln/>
-        </p:spPr>
-        <p:txBody>
-          <a:bodyPr wrap="square" lIns="0" tIns="0" rIns="0" bIns="0" rtlCol="0" anchor="b"/>
+            <a:off x="548640" y="365760"/>
+            <a:ext cx="11064240" cy="822960"/>
+          </a:xfrm>
+          <a:prstGeom prst="rect">
+            <a:avLst/>
+          </a:prstGeom>
+          <a:noFill/>
+          <a:ln/>
+        </p:spPr>
+        <p:txBody>
+          <a:bodyPr wrap="square" lIns="0" tIns="0" rIns="0" bIns="0" rtlCol="0" anchor="ctr"/>
           <a:lstStyle/>
           <a:p>
             <a:pPr algn="l" indent="0" marL="0">
               <a:buNone/>
             </a:pPr>
             <a:r>
-              <a:rPr lang="en-US" sz="5400" b="1" dirty="0">
+              <a:rPr lang="en-US" sz="3600" b="1" dirty="0">
+                <a:solidFill>
+                  <a:srgbClr val="0F4C5C"/>
+                </a:solidFill>
+              </a:rPr>
+              <a:t>In gruppi da 3, con tre ruoli</a:t>
+            </a:r>
+            <a:endParaRPr lang="en-US" sz="3600" dirty="0"/>
+          </a:p>
+        </p:txBody>
+      </p:sp>
+      <p:sp>
+        <p:nvSpPr>
+          <p:cNvPr id="3" name="Shape 1"/>
+          <p:cNvSpPr/>
+          <p:nvPr/>
+        </p:nvSpPr>
+        <p:spPr>
+          <a:xfrm>
+            <a:off x="548640" y="1737360"/>
+            <a:ext cx="3474720" cy="2926080"/>
+          </a:xfrm>
+          <a:prstGeom prst="roundRect">
+            <a:avLst>
+              <a:gd name="adj" fmla="val 3750"/>
+            </a:avLst>
+          </a:prstGeom>
+          <a:solidFill>
+            <a:srgbClr val="EEF3F4"/>
+          </a:solidFill>
+          <a:ln/>
+        </p:spPr>
+      </p:sp>
+      <p:sp>
+        <p:nvSpPr>
+          <p:cNvPr id="4" name="Shape 2"/>
+          <p:cNvSpPr/>
+          <p:nvPr/>
+        </p:nvSpPr>
+        <p:spPr>
+          <a:xfrm>
+            <a:off x="868680" y="2057400"/>
+            <a:ext cx="914400" cy="914400"/>
+          </a:xfrm>
+          <a:prstGeom prst="ellipse">
+            <a:avLst/>
+          </a:prstGeom>
+          <a:solidFill>
+            <a:srgbClr val="FFFFFF"/>
+          </a:solidFill>
+          <a:ln/>
+        </p:spPr>
+      </p:sp>
+      <p:pic>
+        <p:nvPicPr>
+          <p:cNvPr id="5" name="Image 0" descr="preencoded.png">    </p:cNvPr>
+          <p:cNvPicPr>
+            <a:picLocks noChangeAspect="1"/>
+          </p:cNvPicPr>
+          <p:nvPr/>
+        </p:nvPicPr>
+        <p:blipFill>
+          <a:blip r:embed="rId1"/>
+          <a:stretch>
+            <a:fillRect/>
+          </a:stretch>
+        </p:blipFill>
+        <p:spPr>
+          <a:xfrm>
+            <a:off x="1115568" y="2304288"/>
+            <a:ext cx="420624" cy="420624"/>
+          </a:xfrm>
+          <a:prstGeom prst="rect">
+            <a:avLst/>
+          </a:prstGeom>
+        </p:spPr>
+      </p:pic>
+      <p:sp>
+        <p:nvSpPr>
+          <p:cNvPr id="6" name="Text 3"/>
+          <p:cNvSpPr txBox="1"/>
+          <p:nvPr/>
+        </p:nvSpPr>
+        <p:spPr>
+          <a:xfrm>
+            <a:off x="868680" y="3200400"/>
+            <a:ext cx="2834640" cy="502920"/>
+          </a:xfrm>
+          <a:prstGeom prst="rect">
+            <a:avLst/>
+          </a:prstGeom>
+          <a:noFill/>
+          <a:ln/>
+        </p:spPr>
+        <p:txBody>
+          <a:bodyPr wrap="square" lIns="0" tIns="0" rIns="0" bIns="0" rtlCol="0" anchor="ctr"/>
+          <a:lstStyle/>
+          <a:p>
+            <a:pPr indent="0" marL="0">
+              <a:buNone/>
+            </a:pPr>
+            <a:r>
+              <a:rPr lang="en-US" sz="2400" b="1" dirty="0">
+                <a:solidFill>
+                  <a:srgbClr val="1F2A30"/>
+                </a:solidFill>
+              </a:rPr>
+              <a:t>Chi scrive</a:t>
+            </a:r>
+            <a:endParaRPr lang="en-US" sz="2400" dirty="0"/>
+          </a:p>
+        </p:txBody>
+      </p:sp>
+      <p:sp>
+        <p:nvSpPr>
+          <p:cNvPr id="7" name="Text 4"/>
+          <p:cNvSpPr txBox="1"/>
+          <p:nvPr/>
+        </p:nvSpPr>
+        <p:spPr>
+          <a:xfrm>
+            <a:off x="868680" y="3749040"/>
+            <a:ext cx="2834640" cy="731520"/>
+          </a:xfrm>
+          <a:prstGeom prst="rect">
+            <a:avLst/>
+          </a:prstGeom>
+          <a:noFill/>
+          <a:ln/>
+        </p:spPr>
+        <p:txBody>
+          <a:bodyPr wrap="square" lIns="0" tIns="0" rIns="0" bIns="0" rtlCol="0" anchor="t"/>
+          <a:lstStyle/>
+          <a:p>
+            <a:pPr indent="0" marL="0">
+              <a:buNone/>
+            </a:pPr>
+            <a:r>
+              <a:rPr lang="en-US" sz="1600" dirty="0">
+                <a:solidFill>
+                  <a:srgbClr val="5C6F7B"/>
+                </a:solidFill>
+              </a:rPr>
+              <a:t>condivide lo schermo e scrive il codice nel suo notebook</a:t>
+            </a:r>
+            <a:endParaRPr lang="en-US" sz="1600" dirty="0"/>
+          </a:p>
+        </p:txBody>
+      </p:sp>
+      <p:sp>
+        <p:nvSpPr>
+          <p:cNvPr id="8" name="Shape 5"/>
+          <p:cNvSpPr/>
+          <p:nvPr/>
+        </p:nvSpPr>
+        <p:spPr>
+          <a:xfrm>
+            <a:off x="4343400" y="1737360"/>
+            <a:ext cx="3474720" cy="2926080"/>
+          </a:xfrm>
+          <a:prstGeom prst="roundRect">
+            <a:avLst>
+              <a:gd name="adj" fmla="val 3750"/>
+            </a:avLst>
+          </a:prstGeom>
+          <a:solidFill>
+            <a:srgbClr val="EEF3F4"/>
+          </a:solidFill>
+          <a:ln/>
+        </p:spPr>
+      </p:sp>
+      <p:sp>
+        <p:nvSpPr>
+          <p:cNvPr id="9" name="Shape 6"/>
+          <p:cNvSpPr/>
+          <p:nvPr/>
+        </p:nvSpPr>
+        <p:spPr>
+          <a:xfrm>
+            <a:off x="4663440" y="2057400"/>
+            <a:ext cx="914400" cy="914400"/>
+          </a:xfrm>
+          <a:prstGeom prst="ellipse">
+            <a:avLst/>
+          </a:prstGeom>
+          <a:solidFill>
+            <a:srgbClr val="FFFFFF"/>
+          </a:solidFill>
+          <a:ln/>
+        </p:spPr>
+      </p:sp>
+      <p:pic>
+        <p:nvPicPr>
+          <p:cNvPr id="10" name="Image 1" descr="preencoded.png">    </p:cNvPr>
+          <p:cNvPicPr>
+            <a:picLocks noChangeAspect="1"/>
+          </p:cNvPicPr>
+          <p:nvPr/>
+        </p:nvPicPr>
+        <p:blipFill>
+          <a:blip r:embed="rId2"/>
+          <a:stretch>
+            <a:fillRect/>
+          </a:stretch>
+        </p:blipFill>
+        <p:spPr>
+          <a:xfrm>
+            <a:off x="4910328" y="2304288"/>
+            <a:ext cx="420624" cy="420624"/>
+          </a:xfrm>
+          <a:prstGeom prst="rect">
+            <a:avLst/>
+          </a:prstGeom>
+        </p:spPr>
+      </p:pic>
+      <p:sp>
+        <p:nvSpPr>
+          <p:cNvPr id="11" name="Text 7"/>
+          <p:cNvSpPr txBox="1"/>
+          <p:nvPr/>
+        </p:nvSpPr>
+        <p:spPr>
+          <a:xfrm>
+            <a:off x="4663440" y="3200400"/>
+            <a:ext cx="2834640" cy="502920"/>
+          </a:xfrm>
+          <a:prstGeom prst="rect">
+            <a:avLst/>
+          </a:prstGeom>
+          <a:noFill/>
+          <a:ln/>
+        </p:spPr>
+        <p:txBody>
+          <a:bodyPr wrap="square" lIns="0" tIns="0" rIns="0" bIns="0" rtlCol="0" anchor="ctr"/>
+          <a:lstStyle/>
+          <a:p>
+            <a:pPr indent="0" marL="0">
+              <a:buNone/>
+            </a:pPr>
+            <a:r>
+              <a:rPr lang="en-US" sz="2400" b="1" dirty="0">
+                <a:solidFill>
+                  <a:srgbClr val="1F2A30"/>
+                </a:solidFill>
+              </a:rPr>
+              <a:t>Chi cerca</a:t>
+            </a:r>
+            <a:endParaRPr lang="en-US" sz="2400" dirty="0"/>
+          </a:p>
+        </p:txBody>
+      </p:sp>
+      <p:sp>
+        <p:nvSpPr>
+          <p:cNvPr id="12" name="Text 8"/>
+          <p:cNvSpPr txBox="1"/>
+          <p:nvPr/>
+        </p:nvSpPr>
+        <p:spPr>
+          <a:xfrm>
+            <a:off x="4663440" y="3749040"/>
+            <a:ext cx="2834640" cy="731520"/>
+          </a:xfrm>
+          <a:prstGeom prst="rect">
+            <a:avLst/>
+          </a:prstGeom>
+          <a:noFill/>
+          <a:ln/>
+        </p:spPr>
+        <p:txBody>
+          <a:bodyPr wrap="square" lIns="0" tIns="0" rIns="0" bIns="0" rtlCol="0" anchor="t"/>
+          <a:lstStyle/>
+          <a:p>
+            <a:pPr indent="0" marL="0">
+              <a:buNone/>
+            </a:pPr>
+            <a:r>
+              <a:rPr lang="en-US" sz="1600" dirty="0">
+                <a:solidFill>
+                  <a:srgbClr val="5C6F7B"/>
+                </a:solidFill>
+              </a:rPr>
+              <a:t>Google, Gemini, dispense: trova cosa serve</a:t>
+            </a:r>
+            <a:endParaRPr lang="en-US" sz="1600" dirty="0"/>
+          </a:p>
+        </p:txBody>
+      </p:sp>
+      <p:sp>
+        <p:nvSpPr>
+          <p:cNvPr id="13" name="Shape 9"/>
+          <p:cNvSpPr/>
+          <p:nvPr/>
+        </p:nvSpPr>
+        <p:spPr>
+          <a:xfrm>
+            <a:off x="8138160" y="1737360"/>
+            <a:ext cx="3474720" cy="2926080"/>
+          </a:xfrm>
+          <a:prstGeom prst="roundRect">
+            <a:avLst>
+              <a:gd name="adj" fmla="val 3750"/>
+            </a:avLst>
+          </a:prstGeom>
+          <a:solidFill>
+            <a:srgbClr val="0F4C5C"/>
+          </a:solidFill>
+          <a:ln/>
+        </p:spPr>
+      </p:sp>
+      <p:sp>
+        <p:nvSpPr>
+          <p:cNvPr id="14" name="Shape 10"/>
+          <p:cNvSpPr/>
+          <p:nvPr/>
+        </p:nvSpPr>
+        <p:spPr>
+          <a:xfrm>
+            <a:off x="8458200" y="2057400"/>
+            <a:ext cx="914400" cy="914400"/>
+          </a:xfrm>
+          <a:prstGeom prst="ellipse">
+            <a:avLst/>
+          </a:prstGeom>
+          <a:solidFill>
+            <a:srgbClr val="FFFFFF"/>
+          </a:solidFill>
+          <a:ln/>
+        </p:spPr>
+      </p:sp>
+      <p:pic>
+        <p:nvPicPr>
+          <p:cNvPr id="15" name="Image 2" descr="preencoded.png">    </p:cNvPr>
+          <p:cNvPicPr>
+            <a:picLocks noChangeAspect="1"/>
+          </p:cNvPicPr>
+          <p:nvPr/>
+        </p:nvPicPr>
+        <p:blipFill>
+          <a:blip r:embed="rId3"/>
+          <a:stretch>
+            <a:fillRect/>
+          </a:stretch>
+        </p:blipFill>
+        <p:spPr>
+          <a:xfrm>
+            <a:off x="8705088" y="2304288"/>
+            <a:ext cx="420624" cy="420624"/>
+          </a:xfrm>
+          <a:prstGeom prst="rect">
+            <a:avLst/>
+          </a:prstGeom>
+        </p:spPr>
+      </p:pic>
+      <p:sp>
+        <p:nvSpPr>
+          <p:cNvPr id="16" name="Text 11"/>
+          <p:cNvSpPr txBox="1"/>
+          <p:nvPr/>
+        </p:nvSpPr>
+        <p:spPr>
+          <a:xfrm>
+            <a:off x="8458200" y="3200400"/>
+            <a:ext cx="2834640" cy="502920"/>
+          </a:xfrm>
+          <a:prstGeom prst="rect">
+            <a:avLst/>
+          </a:prstGeom>
+          <a:noFill/>
+          <a:ln/>
+        </p:spPr>
+        <p:txBody>
+          <a:bodyPr wrap="square" lIns="0" tIns="0" rIns="0" bIns="0" rtlCol="0" anchor="ctr"/>
+          <a:lstStyle/>
+          <a:p>
+            <a:pPr indent="0" marL="0">
+              <a:buNone/>
+            </a:pPr>
+            <a:r>
+              <a:rPr lang="en-US" sz="2400" b="1" dirty="0">
                 <a:solidFill>
                   <a:srgbClr val="FFFFFF"/>
                 </a:solidFill>
               </a:rPr>
-              <a:t>Task: il risparmio di Marco</a:t>
-            </a:r>
-            <a:endParaRPr lang="en-US" sz="5400" dirty="0"/>
-          </a:p>
-        </p:txBody>
-      </p:sp>
-      <p:sp>
-        <p:nvSpPr>
-          <p:cNvPr id="3" name="Text 0"/>
-          <p:cNvSpPr/>
+              <a:t>Chi controlla</a:t>
+            </a:r>
+            <a:endParaRPr lang="en-US" sz="2400" dirty="0"/>
+          </a:p>
+        </p:txBody>
+      </p:sp>
+      <p:sp>
+        <p:nvSpPr>
+          <p:cNvPr id="17" name="Text 12"/>
+          <p:cNvSpPr txBox="1"/>
+          <p:nvPr/>
+        </p:nvSpPr>
+        <p:spPr>
+          <a:xfrm>
+            <a:off x="8458200" y="3749040"/>
+            <a:ext cx="2834640" cy="731520"/>
+          </a:xfrm>
+          <a:prstGeom prst="rect">
+            <a:avLst/>
+          </a:prstGeom>
+          <a:noFill/>
+          <a:ln/>
+        </p:spPr>
+        <p:txBody>
+          <a:bodyPr wrap="square" lIns="0" tIns="0" rIns="0" bIns="0" rtlCol="0" anchor="t"/>
+          <a:lstStyle/>
+          <a:p>
+            <a:pPr indent="0" marL="0">
+              <a:buNone/>
+            </a:pPr>
+            <a:r>
+              <a:rPr lang="en-US" sz="1600" dirty="0">
+                <a:solidFill>
+                  <a:srgbClr val="B8C4CB"/>
+                </a:solidFill>
+              </a:rPr>
+              <a:t>il risultato ha senso? il numero torna?</a:t>
+            </a:r>
+            <a:endParaRPr lang="en-US" sz="1600" dirty="0"/>
+          </a:p>
+        </p:txBody>
+      </p:sp>
+      <p:sp>
+        <p:nvSpPr>
+          <p:cNvPr id="18" name="Text 13"/>
+          <p:cNvSpPr txBox="1"/>
+          <p:nvPr/>
+        </p:nvSpPr>
+        <p:spPr>
+          <a:xfrm>
+            <a:off x="548640" y="5029200"/>
+            <a:ext cx="11064240" cy="731520"/>
+          </a:xfrm>
+          <a:prstGeom prst="rect">
+            <a:avLst/>
+          </a:prstGeom>
+          <a:noFill/>
+          <a:ln/>
+        </p:spPr>
+        <p:txBody>
+          <a:bodyPr wrap="square" lIns="0" tIns="0" rIns="0" bIns="0" rtlCol="0" anchor="t"/>
+          <a:lstStyle/>
+          <a:p>
+            <a:pPr indent="0" marL="0">
+              <a:buNone/>
+            </a:pPr>
+            <a:r>
+              <a:rPr lang="en-US" sz="1800" i="1" dirty="0">
+                <a:solidFill>
+                  <a:srgbClr val="0F4C5C"/>
+                </a:solidFill>
+              </a:rPr>
+              <a:t>I ruoli ruotano a ogni incontro. Il più importante è chi controlla: è il mestiere che il corso vuole allenare.</a:t>
+            </a:r>
+            <a:endParaRPr lang="en-US" sz="1800" dirty="0"/>
+          </a:p>
+        </p:txBody>
+      </p:sp>
+      <p:sp>
+        <p:nvSpPr>
+          <p:cNvPr id="25" name="Slide Number Placeholder 0"/>
+          <p:cNvSpPr>
+            <a:spLocks noGrp="1"/>
+          </p:cNvSpPr>
           <p:nvPr>
-            <p:ph idx="101" type="body" hasCustomPrompt="1"/>
+            <p:ph type="sldNum" sz="quarter" idx="4294967295"/>
           </p:nvPr>
         </p:nvSpPr>
         <p:spPr>
           <a:xfrm>
-            <a:off x="731520" y="3657600"/>
-            <a:ext cx="10698480" cy="1463040"/>
-          </a:xfrm>
-          <a:prstGeom prst="rect">
-            <a:avLst/>
-          </a:prstGeom>
-          <a:noFill/>
-          <a:ln/>
-        </p:spPr>
-        <p:txBody>
-          <a:bodyPr wrap="square" lIns="0" tIns="0" rIns="0" bIns="0" rtlCol="0" anchor="t"/>
-          <a:lstStyle/>
-          <a:p>
-            <a:pPr indent="0" marL="0">
-              <a:buNone/>
-            </a:pPr>
-            <a:r>
-              <a:rPr lang="en-US" sz="2200" dirty="0">
-                <a:solidFill>
-                  <a:srgbClr val="B8C4CB"/>
-                </a:solidFill>
-              </a:rPr>
-              <a:t>Marco ha 5.000 € e li investe al 2,5% annuo.</a:t>
-            </a:r>
-            <a:endParaRPr lang="en-US" sz="2200" dirty="0"/>
-          </a:p>
-          <a:p>
-            <a:pPr indent="0" marL="0">
-              <a:buNone/>
-            </a:pPr>
-            <a:r>
-              <a:rPr lang="en-US" sz="2200" dirty="0">
-                <a:solidFill>
-                  <a:srgbClr val="B8C4CB"/>
-                </a:solidFill>
-              </a:rPr>
-              <a:t>60 minuti · apri il notebook dal README</a:t>
-            </a:r>
-            <a:endParaRPr lang="en-US" sz="2200" dirty="0"/>
+            <a:off x="11155680" y="6400800"/>
+            <a:ext cx="457200" cy="274320"/>
+          </a:xfrm>
+          <a:prstGeom prst="rect">
+            <a:avLst/>
+          </a:prstGeom>
+          <a:extLst>
+            <a:ext uri="{C572A759-6A51-4108-AA02-DFA0A04FC94B}">
+              <ma14:wrappingTextBoxFlag xmlns:ma14="http://schemas.microsoft.com/office/mac/drawingml/2011/main" val="0"/>
+            </a:ext>
+          </a:extLst>
+        </p:spPr>
+        <p:txBody>
+          <a:bodyPr/>
+          <a:lstStyle>
+            <a:lvl1pPr>
+              <a:defRPr sz="1000">
+                <a:solidFill>
+                  <a:srgbClr val="5C6F7B"/>
+                </a:solidFill>
+              </a:defRPr>
+            </a:lvl1pPr>
+          </a:lstStyle>
+          <a:p>
+            <a:pPr algn="r"/>
+            <a:fld id="{F7021451-1387-4CA6-816F-3879F97B5CBC}" type="slidenum">
+              <a:rPr b="0" lang="en-US"/>
+              <a:t>9</a:t>
+            </a:fld>
+            <a:endParaRPr lang="en-US"/>
           </a:p>
         </p:txBody>
       </p:sp>

</xml_diff>

<commit_message>
Numerazione progressiva degli incontri (1-12) e indirizzo per chiedere aiuto
- L1 L2 L3 E4 L5 L6 E7 L8 L9 E10 L11 E12: cartelle, file, riferimenti, slide
- indirizzo andrelorenzon+sima2026@gmail.com nelle istruzioni per chiedere aiuto

Co-Authored-By: Claude Opus 5.5 <noreply@anthropic.com>
Claude-Session: https://claude.ai/code/session_014CzWDFXvYNxqLeD99LSN3G
</commit_message>
<xml_diff>
--- a/lezioni/L01_python_calcolatrice/slide.pptx
+++ b/lezioni/L01_python_calcolatrice/slide.pptx
@@ -118,13 +118,13 @@
   <p:extLst>
     <p:ext uri="{521415D9-36F7-43E2-AB2F-B90AF26B5E84}">
       <p14:sectionLst xmlns:p14="http://schemas.microsoft.com/office/powerpoint/2010/main">
-        <p14:section name="Apertura" id="{a6c14c39-b7fb-3912-6f98-b8f250657934}">
+        <p14:section name="Apertura" id="{18c44a12-b00c-a8bb-0b22-4b4e4efcf748}">
           <p14:sldIdLst>
             <p14:sldId id="256"/>
             <p14:sldId id="257"/>
           </p14:sldIdLst>
         </p14:section>
-        <p14:section name="Spiegazione" id="{a8fdfc7f-1cf9-b850-0ee6-84bd3399be3f}">
+        <p14:section name="Spiegazione" id="{6c436a58-c882-f16b-28a5-444e4c0e38f4}">
           <p14:sldIdLst>
             <p14:sldId id="258"/>
             <p14:sldId id="259"/>
@@ -135,17 +135,17 @@
             <p14:sldId id="264"/>
           </p14:sldIdLst>
         </p14:section>
-        <p14:section name="Task" id="{c5c8236b-a038-baa8-0a19-1eb4e175316e}">
+        <p14:section name="Task" id="{e84d7b15-2528-ebcc-6e8f-0cc8bf0a352e}">
           <p14:sldIdLst>
             <p14:sldId id="265"/>
           </p14:sldIdLst>
         </p14:section>
-        <p14:section name="Extra" id="{398cbccb-da8e-d17c-a929-8cc6b5162a12}">
+        <p14:section name="Extra" id="{084967ae-1b98-ac80-480d-51d72dee96d2}">
           <p14:sldIdLst>
             <p14:sldId id="266"/>
           </p14:sldIdLst>
         </p14:section>
-        <p14:section name="Chiusura" id="{7d4144e8-64ae-01dd-8fe6-f27e63ebd15a}">
+        <p14:section name="Chiusura" id="{fe700800-be21-c4a4-00ad-6dd1b76349cc}">
           <p14:sldIdLst>
             <p14:sldId id="267"/>
           </p14:sldIdLst>
@@ -1434,7 +1434,7 @@
           <a:p>
             <a:r>
               <a:rPr lang="en-US" dirty="0"/>
-              <a:t>Mostrare dal vivo: Condividi in alto a destra, aggiungere un indirizzo, scegliere Editor. L'indirizzo vero è solo nella mail, non nei materiali pubblici.</a:t>
+              <a:t>Mostrare dal vivo: Condividi in alto a destra, aggiungere un indirizzo, scegliere Editor. L'indirizzo con +sima2026 arriva nella casella normale ma permette di filtrare lo spam.</a:t>
             </a:r>
             <a:endParaRPr lang="en-US" dirty="0"/>
           </a:p>
@@ -7323,7 +7323,7 @@
                   <a:srgbClr val="B8C4CB"/>
                 </a:solidFill>
               </a:rPr>
-              <a:t>In Colab: Condividi → aggiungete il mio indirizzo (è nella mail) come Editor. Poi scrivetemi quale passo non torna.</a:t>
+              <a:t>In Colab: Condividi → aggiungete andrelorenzon+sima2026@gmail.com come Editor. Poi scrivetemi quale passo non torna.</a:t>
             </a:r>
             <a:endParaRPr lang="en-US" sz="1700" dirty="0"/>
           </a:p>

</xml_diff>

<commit_message>
Indirizzo per chiedere aiuto: si torna all'alias +sima2026 (verificato)
Co-Authored-By: Claude Opus 5.5 <noreply@anthropic.com>
Claude-Session: https://claude.ai/code/session_014CzWDFXvYNxqLeD99LSN3G
</commit_message>
<xml_diff>
--- a/lezioni/L01_python_calcolatrice/slide.pptx
+++ b/lezioni/L01_python_calcolatrice/slide.pptx
@@ -118,13 +118,13 @@
   <p:extLst>
     <p:ext uri="{521415D9-36F7-43E2-AB2F-B90AF26B5E84}">
       <p14:sectionLst xmlns:p14="http://schemas.microsoft.com/office/powerpoint/2010/main">
-        <p14:section name="Apertura" id="{18c44a12-b00c-a8bb-0b22-4b4e4efcf748}">
+        <p14:section name="Apertura" id="{72784d80-f857-8001-f61a-20058b58b260}">
           <p14:sldIdLst>
             <p14:sldId id="256"/>
             <p14:sldId id="257"/>
           </p14:sldIdLst>
         </p14:section>
-        <p14:section name="Spiegazione" id="{6c436a58-c882-f16b-28a5-444e4c0e38f4}">
+        <p14:section name="Spiegazione" id="{cf063086-192b-7944-7995-67e5ce40ad81}">
           <p14:sldIdLst>
             <p14:sldId id="258"/>
             <p14:sldId id="259"/>
@@ -135,17 +135,17 @@
             <p14:sldId id="264"/>
           </p14:sldIdLst>
         </p14:section>
-        <p14:section name="Task" id="{e84d7b15-2528-ebcc-6e8f-0cc8bf0a352e}">
+        <p14:section name="Task" id="{eb81fd89-f716-92ae-df98-d3c8be57fc6a}">
           <p14:sldIdLst>
             <p14:sldId id="265"/>
           </p14:sldIdLst>
         </p14:section>
-        <p14:section name="Extra" id="{084967ae-1b98-ac80-480d-51d72dee96d2}">
+        <p14:section name="Extra" id="{0409a9a9-3006-cce3-7d3c-a04b2ed67fdd}">
           <p14:sldIdLst>
             <p14:sldId id="266"/>
           </p14:sldIdLst>
         </p14:section>
-        <p14:section name="Chiusura" id="{fe700800-be21-c4a4-00ad-6dd1b76349cc}">
+        <p14:section name="Chiusura" id="{660184d0-ca7a-cbbe-335e-8931127fba36}">
           <p14:sldIdLst>
             <p14:sldId id="267"/>
           </p14:sldIdLst>
@@ -1434,7 +1434,7 @@
           <a:p>
             <a:r>
               <a:rPr lang="en-US" dirty="0"/>
-              <a:t>Mostrare dal vivo: Condividi in alto a destra, aggiungere un indirizzo, scegliere Editor. L'indirizzo con +sima2026 arriva nella casella normale ma permette di filtrare lo spam.</a:t>
+              <a:t>Mostrare dal vivo: Condividi in alto a destra, aggiungere un indirizzo, scegliere Editor. Far vedere dove si trova l'indirizzo: nel promemoria in cima a ogni notebook e nel README.</a:t>
             </a:r>
             <a:endParaRPr lang="en-US" dirty="0"/>
           </a:p>

</xml_diff>